<commit_message>
feat: publish hardened course decks and accessible web player
</commit_message>
<xml_diff>
--- a/docs/public/course-assets/course-pptx/ag-001.pptx
+++ b/docs/public/course-assets/course-pptx/ag-001.pptx
@@ -2,25 +2,25 @@
 <file path=ppt/presentation.xml><?xml version="1.0" encoding="utf-8"?>
 <p:presentation xmlns:p="http://schemas.openxmlformats.org/presentationml/2006/main">
   <p:sldMasterIdLst>
-    <p:sldMasterId xmlns:r="http://schemas.openxmlformats.org/officeDocument/2006/relationships" id="2147483648" r:id="R6ba98cf5526a4561"/>
+    <p:sldMasterId xmlns:r="http://schemas.openxmlformats.org/officeDocument/2006/relationships" id="2147483648" r:id="R941da0e79b934335"/>
   </p:sldMasterIdLst>
   <p:notesMasterIdLst>
-    <p:notesMasterId xmlns:r="http://schemas.openxmlformats.org/officeDocument/2006/relationships" r:id="R8e33b65c2b4143b7"/>
+    <p:notesMasterId xmlns:r="http://schemas.openxmlformats.org/officeDocument/2006/relationships" r:id="R813d89a5f2a3444a"/>
   </p:notesMasterIdLst>
   <p:sldIdLst>
-    <p:sldId xmlns:r="http://schemas.openxmlformats.org/officeDocument/2006/relationships" id="256" r:id="R68698cec71a84bf4"/>
-    <p:sldId xmlns:r="http://schemas.openxmlformats.org/officeDocument/2006/relationships" id="257" r:id="Re8db4c4f95de4ab4"/>
-    <p:sldId xmlns:r="http://schemas.openxmlformats.org/officeDocument/2006/relationships" id="258" r:id="R2da46a082f8c4874"/>
-    <p:sldId xmlns:r="http://schemas.openxmlformats.org/officeDocument/2006/relationships" id="259" r:id="R83b324448b8545b5"/>
-    <p:sldId xmlns:r="http://schemas.openxmlformats.org/officeDocument/2006/relationships" id="260" r:id="Rfdc6a69582a046b9"/>
-    <p:sldId xmlns:r="http://schemas.openxmlformats.org/officeDocument/2006/relationships" id="261" r:id="R5da50f95606e40fc"/>
-    <p:sldId xmlns:r="http://schemas.openxmlformats.org/officeDocument/2006/relationships" id="262" r:id="R2d5ed7acbae042ad"/>
-    <p:sldId xmlns:r="http://schemas.openxmlformats.org/officeDocument/2006/relationships" id="263" r:id="Ra0af275c38a044c7"/>
-    <p:sldId xmlns:r="http://schemas.openxmlformats.org/officeDocument/2006/relationships" id="264" r:id="Rba72f6a0e1e74696"/>
-    <p:sldId xmlns:r="http://schemas.openxmlformats.org/officeDocument/2006/relationships" id="265" r:id="Rae8defa79ff74d60"/>
-    <p:sldId xmlns:r="http://schemas.openxmlformats.org/officeDocument/2006/relationships" id="266" r:id="R290601ecc53f4567"/>
-    <p:sldId xmlns:r="http://schemas.openxmlformats.org/officeDocument/2006/relationships" id="267" r:id="R430a99fa97ee45da"/>
-    <p:sldId xmlns:r="http://schemas.openxmlformats.org/officeDocument/2006/relationships" id="268" r:id="R304e2512d45349bb"/>
+    <p:sldId xmlns:r="http://schemas.openxmlformats.org/officeDocument/2006/relationships" id="256" r:id="R5b6ee71562724a66"/>
+    <p:sldId xmlns:r="http://schemas.openxmlformats.org/officeDocument/2006/relationships" id="257" r:id="R7c1bd8ddbe384a7e"/>
+    <p:sldId xmlns:r="http://schemas.openxmlformats.org/officeDocument/2006/relationships" id="258" r:id="R6bfee5906579453d"/>
+    <p:sldId xmlns:r="http://schemas.openxmlformats.org/officeDocument/2006/relationships" id="259" r:id="Rfdf448ac361c420e"/>
+    <p:sldId xmlns:r="http://schemas.openxmlformats.org/officeDocument/2006/relationships" id="260" r:id="R84b26d842c334179"/>
+    <p:sldId xmlns:r="http://schemas.openxmlformats.org/officeDocument/2006/relationships" id="261" r:id="Rf56c01b682bb4cb7"/>
+    <p:sldId xmlns:r="http://schemas.openxmlformats.org/officeDocument/2006/relationships" id="262" r:id="R17cf719642bf4579"/>
+    <p:sldId xmlns:r="http://schemas.openxmlformats.org/officeDocument/2006/relationships" id="263" r:id="Ra91570bc655045fc"/>
+    <p:sldId xmlns:r="http://schemas.openxmlformats.org/officeDocument/2006/relationships" id="264" r:id="R557ab6139e014b9b"/>
+    <p:sldId xmlns:r="http://schemas.openxmlformats.org/officeDocument/2006/relationships" id="265" r:id="R4ab167ef5bfb4bd4"/>
+    <p:sldId xmlns:r="http://schemas.openxmlformats.org/officeDocument/2006/relationships" id="266" r:id="R302302e706814573"/>
+    <p:sldId xmlns:r="http://schemas.openxmlformats.org/officeDocument/2006/relationships" id="267" r:id="Re3d96bb364ac4153"/>
+    <p:sldId xmlns:r="http://schemas.openxmlformats.org/officeDocument/2006/relationships" id="268" r:id="R8ba4e9711a014d95"/>
   </p:sldIdLst>
   <p:sldSz cx="12192000" cy="6858000"/>
   <p:notesSz cx="6858000" cy="9144000"/>
@@ -1405,7 +1405,7 @@
   </p:cSld>
   <p:clrMap bg1="lt1" tx1="dk1" bg2="lt2" tx2="dk2" accent1="accent1" accent2="accent2" accent3="accent3" accent4="accent4" accent5="accent5" accent6="accent6" hlink="hlink" folHlink="folHlink"/>
   <p:sldLayoutIdLst>
-    <p:sldLayoutId xmlns:r="http://schemas.openxmlformats.org/officeDocument/2006/relationships" id="2147483649" r:id="R75b1831f623b48e0"/>
+    <p:sldLayoutId xmlns:r="http://schemas.openxmlformats.org/officeDocument/2006/relationships" id="2147483649" r:id="R40b8673f318f4427"/>
   </p:sldLayoutIdLst>
   <p:txStyles>
     <p:titleStyle>
@@ -1956,7 +1956,7 @@
           <p:cNvPr id="1" name="cover-rule">
             <a:extLst xmlns:a="http://schemas.openxmlformats.org/drawingml/2006/main">
               <a:ext uri="{FF2B5EF4-FFF2-40B4-BE49-F238E27FC236}">
-                <a16:creationId xmlns:a16="http://schemas.microsoft.com/office/drawing/2014/main" id="{65153C84-9349-4476-B9C0-A728C7B11022}"/>
+                <a16:creationId xmlns:a16="http://schemas.microsoft.com/office/drawing/2014/main" id="{2D42A7CE-0032-4B48-8F99-B4FB27455BE2}"/>
               </a:ext>
             </a:extLst>
           </p:cNvPr>
@@ -1989,7 +1989,7 @@
           <p:cNvPr id="2" name="cover-ring-1">
             <a:extLst xmlns:a="http://schemas.openxmlformats.org/drawingml/2006/main">
               <a:ext uri="{FF2B5EF4-FFF2-40B4-BE49-F238E27FC236}">
-                <a16:creationId xmlns:a16="http://schemas.microsoft.com/office/drawing/2014/main" id="{9A208FA0-3E68-4073-B562-E7E54C634823}"/>
+                <a16:creationId xmlns:a16="http://schemas.microsoft.com/office/drawing/2014/main" id="{F1C39FA7-65D7-4801-8AE9-F13C1F437D80}"/>
               </a:ext>
             </a:extLst>
           </p:cNvPr>
@@ -2020,7 +2020,7 @@
           <p:cNvPr id="3" name="cover-ring-2">
             <a:extLst xmlns:a="http://schemas.openxmlformats.org/drawingml/2006/main">
               <a:ext uri="{FF2B5EF4-FFF2-40B4-BE49-F238E27FC236}">
-                <a16:creationId xmlns:a16="http://schemas.microsoft.com/office/drawing/2014/main" id="{DBE64C88-8708-44DD-AA2C-A73F9BA719BF}"/>
+                <a16:creationId xmlns:a16="http://schemas.microsoft.com/office/drawing/2014/main" id="{91F3B885-3D7B-4CE6-A163-B3610707B226}"/>
               </a:ext>
             </a:extLst>
           </p:cNvPr>
@@ -2051,7 +2051,7 @@
           <p:cNvPr id="4" name="cover-core">
             <a:extLst xmlns:a="http://schemas.openxmlformats.org/drawingml/2006/main">
               <a:ext uri="{FF2B5EF4-FFF2-40B4-BE49-F238E27FC236}">
-                <a16:creationId xmlns:a16="http://schemas.microsoft.com/office/drawing/2014/main" id="{61CF45BB-C0BE-478C-889C-FEBCA47FE1BA}"/>
+                <a16:creationId xmlns:a16="http://schemas.microsoft.com/office/drawing/2014/main" id="{EE5BD32E-519B-4FB7-A443-52FA8171E31A}"/>
               </a:ext>
             </a:extLst>
           </p:cNvPr>
@@ -2084,7 +2084,7 @@
           <p:cNvPr id="5" name="cover-line-1">
             <a:extLst xmlns:a="http://schemas.openxmlformats.org/drawingml/2006/main">
               <a:ext uri="{FF2B5EF4-FFF2-40B4-BE49-F238E27FC236}">
-                <a16:creationId xmlns:a16="http://schemas.microsoft.com/office/drawing/2014/main" id="{AD548E01-20B4-410E-971B-B476104F9486}"/>
+                <a16:creationId xmlns:a16="http://schemas.microsoft.com/office/drawing/2014/main" id="{49F51B01-D5A5-49BE-83D1-B5099345F1FB}"/>
               </a:ext>
             </a:extLst>
           </p:cNvPr>
@@ -2115,7 +2115,7 @@
           <p:cNvPr id="6" name="cover-line-2">
             <a:extLst xmlns:a="http://schemas.openxmlformats.org/drawingml/2006/main">
               <a:ext uri="{FF2B5EF4-FFF2-40B4-BE49-F238E27FC236}">
-                <a16:creationId xmlns:a16="http://schemas.microsoft.com/office/drawing/2014/main" id="{9E905466-4124-4134-8D64-6879173C04D0}"/>
+                <a16:creationId xmlns:a16="http://schemas.microsoft.com/office/drawing/2014/main" id="{1DE6C797-7E71-41C8-A0E9-EB5D4170BC0C}"/>
               </a:ext>
             </a:extLst>
           </p:cNvPr>
@@ -2146,7 +2146,7 @@
           <p:cNvPr id="7" name="cover-eyebrow">
             <a:extLst xmlns:a="http://schemas.openxmlformats.org/drawingml/2006/main">
               <a:ext uri="{FF2B5EF4-FFF2-40B4-BE49-F238E27FC236}">
-                <a16:creationId xmlns:a16="http://schemas.microsoft.com/office/drawing/2014/main" id="{8AC4B280-E176-4A1A-A27D-B24A886E9A34}"/>
+                <a16:creationId xmlns:a16="http://schemas.microsoft.com/office/drawing/2014/main" id="{5DC38BEA-F864-48E6-B10E-CCE83E4D2B83}"/>
               </a:ext>
             </a:extLst>
           </p:cNvPr>
@@ -2204,7 +2204,7 @@
           <p:cNvPr id="8" name="cover-title">
             <a:extLst xmlns:a="http://schemas.openxmlformats.org/drawingml/2006/main">
               <a:ext uri="{FF2B5EF4-FFF2-40B4-BE49-F238E27FC236}">
-                <a16:creationId xmlns:a16="http://schemas.microsoft.com/office/drawing/2014/main" id="{D4C0654C-1CBB-4E6E-AD0D-6AC450E86EBB}"/>
+                <a16:creationId xmlns:a16="http://schemas.microsoft.com/office/drawing/2014/main" id="{7E54617C-A3B6-4542-B987-96F57F9977DA}"/>
               </a:ext>
             </a:extLst>
           </p:cNvPr>
@@ -2262,7 +2262,7 @@
           <p:cNvPr id="9" name="cover-subtitle">
             <a:extLst xmlns:a="http://schemas.openxmlformats.org/drawingml/2006/main">
               <a:ext uri="{FF2B5EF4-FFF2-40B4-BE49-F238E27FC236}">
-                <a16:creationId xmlns:a16="http://schemas.microsoft.com/office/drawing/2014/main" id="{8E748785-18DA-4165-91C5-86720A37F898}"/>
+                <a16:creationId xmlns:a16="http://schemas.microsoft.com/office/drawing/2014/main" id="{88385B43-F321-4D59-9B9B-78725A7AABC0}"/>
               </a:ext>
             </a:extLst>
           </p:cNvPr>
@@ -2324,7 +2324,7 @@
           <p:cNvPr id="10" name="cover-lead">
             <a:extLst xmlns:a="http://schemas.openxmlformats.org/drawingml/2006/main">
               <a:ext uri="{FF2B5EF4-FFF2-40B4-BE49-F238E27FC236}">
-                <a16:creationId xmlns:a16="http://schemas.microsoft.com/office/drawing/2014/main" id="{A4B66066-27B5-40A7-A126-373300D2BFFE}"/>
+                <a16:creationId xmlns:a16="http://schemas.microsoft.com/office/drawing/2014/main" id="{B85B7D63-6900-433F-86B1-6363B8E5DC94}"/>
               </a:ext>
             </a:extLst>
           </p:cNvPr>
@@ -2372,7 +2372,7 @@
                 <a:ea typeface="PingFang SC"/>
                 <a:cs typeface="PingFang SC"/>
               </a:rPr>
-              <a:t>一次大模型调用通常是“给出输入，得到输出”。智能体则要在变化的环境中持续工作：它读取当前状态，选择一个动作，取得新证据，再决定继续、改道还是停止。因此…</a:t>
+              <a:t>一次大模型调用通常是“给出输入；得到输出”，智能体则要在变化的环境中持续工作；它读取当前状态，选择一个动作；取得新证据，再决定继续、改道还是停止</a:t>
             </a:r>
           </a:p>
         </p:txBody>
@@ -2382,7 +2382,7 @@
           <p:cNvPr id="11" name="cover-course">
             <a:extLst xmlns:a="http://schemas.openxmlformats.org/drawingml/2006/main">
               <a:ext uri="{FF2B5EF4-FFF2-40B4-BE49-F238E27FC236}">
-                <a16:creationId xmlns:a16="http://schemas.microsoft.com/office/drawing/2014/main" id="{37669CA3-4FF2-4D79-B938-CCF6DD397127}"/>
+                <a16:creationId xmlns:a16="http://schemas.microsoft.com/office/drawing/2014/main" id="{3C15C792-C7B4-4EDA-B674-96C5897E1BA3}"/>
               </a:ext>
             </a:extLst>
           </p:cNvPr>
@@ -2440,7 +2440,7 @@
           <p:cNvPr id="12" name="cover-id">
             <a:extLst xmlns:a="http://schemas.openxmlformats.org/drawingml/2006/main">
               <a:ext uri="{FF2B5EF4-FFF2-40B4-BE49-F238E27FC236}">
-                <a16:creationId xmlns:a16="http://schemas.microsoft.com/office/drawing/2014/main" id="{BFEB5AD1-3F51-40A5-9AF1-3E79AFD64595}"/>
+                <a16:creationId xmlns:a16="http://schemas.microsoft.com/office/drawing/2014/main" id="{E8C6B144-7DCE-4E42-A355-D5ACAA244F80}"/>
               </a:ext>
             </a:extLst>
           </p:cNvPr>
@@ -2496,7 +2496,7 @@
     </p:spTree>
     <p:extLst>
       <p:ext uri="{BB962C8B-B14F-4D97-AF65-F5344CB8AC3E}">
-        <p14:creationId xmlns:p14="http://schemas.microsoft.com/office/powerpoint/2010/main" val="436237047"/>
+        <p14:creationId xmlns:p14="http://schemas.microsoft.com/office/powerpoint/2010/main" val="149824733"/>
       </p:ext>
     </p:extLst>
   </p:cSld>
@@ -2527,7 +2527,7 @@
           <p:cNvPr id="1" name="s10-rule">
             <a:extLst xmlns:a="http://schemas.openxmlformats.org/drawingml/2006/main">
               <a:ext uri="{FF2B5EF4-FFF2-40B4-BE49-F238E27FC236}">
-                <a16:creationId xmlns:a16="http://schemas.microsoft.com/office/drawing/2014/main" id="{B93EEB72-984C-49DE-8D85-CFE718841A4B}"/>
+                <a16:creationId xmlns:a16="http://schemas.microsoft.com/office/drawing/2014/main" id="{2B0BC80C-C811-418E-BC5D-D776152715E1}"/>
               </a:ext>
             </a:extLst>
           </p:cNvPr>
@@ -2560,7 +2560,7 @@
           <p:cNvPr id="2" name="s10-eyebrow">
             <a:extLst xmlns:a="http://schemas.openxmlformats.org/drawingml/2006/main">
               <a:ext uri="{FF2B5EF4-FFF2-40B4-BE49-F238E27FC236}">
-                <a16:creationId xmlns:a16="http://schemas.microsoft.com/office/drawing/2014/main" id="{C32A1A06-E2A5-4AA5-8B26-F21002ACECC2}"/>
+                <a16:creationId xmlns:a16="http://schemas.microsoft.com/office/drawing/2014/main" id="{6A92845C-DCE3-4284-864B-6EFBF5D4B0D5}"/>
               </a:ext>
             </a:extLst>
           </p:cNvPr>
@@ -2618,7 +2618,7 @@
           <p:cNvPr id="3" name="s10-title">
             <a:extLst xmlns:a="http://schemas.openxmlformats.org/drawingml/2006/main">
               <a:ext uri="{FF2B5EF4-FFF2-40B4-BE49-F238E27FC236}">
-                <a16:creationId xmlns:a16="http://schemas.microsoft.com/office/drawing/2014/main" id="{081BEF71-2567-4A76-A6FB-7A43A2F17364}"/>
+                <a16:creationId xmlns:a16="http://schemas.microsoft.com/office/drawing/2014/main" id="{4F74F366-9066-4E67-999D-ECC897C5D352}"/>
               </a:ext>
             </a:extLst>
           </p:cNvPr>
@@ -2666,7 +2666,7 @@
                 <a:ea typeface="PingFang SC"/>
                 <a:cs typeface="PingFang SC"/>
               </a:rPr>
-              <a:t>从“整理会议纪要”看一次完整循环必须经过边界验证</a:t>
+              <a:t>缺失字段要显式待确认，不能由模型补齐</a:t>
             </a:r>
           </a:p>
         </p:txBody>
@@ -2676,7 +2676,7 @@
           <p:cNvPr id="4" name="s10-footer">
             <a:extLst xmlns:a="http://schemas.openxmlformats.org/drawingml/2006/main">
               <a:ext uri="{FF2B5EF4-FFF2-40B4-BE49-F238E27FC236}">
-                <a16:creationId xmlns:a16="http://schemas.microsoft.com/office/drawing/2014/main" id="{0E2A5557-28B8-43C3-B0A3-1C3266560FA7}"/>
+                <a16:creationId xmlns:a16="http://schemas.microsoft.com/office/drawing/2014/main" id="{6846EE2F-0FFA-4394-9D8A-77619EBE1D53}"/>
               </a:ext>
             </a:extLst>
           </p:cNvPr>
@@ -2707,7 +2707,7 @@
           <p:cNvPr id="5" name="s10-identity">
             <a:extLst xmlns:a="http://schemas.openxmlformats.org/drawingml/2006/main">
               <a:ext uri="{FF2B5EF4-FFF2-40B4-BE49-F238E27FC236}">
-                <a16:creationId xmlns:a16="http://schemas.microsoft.com/office/drawing/2014/main" id="{7462AE36-FE28-4388-91D6-F20987410753}"/>
+                <a16:creationId xmlns:a16="http://schemas.microsoft.com/office/drawing/2014/main" id="{D2E06C87-2E7B-4E07-BC02-3EF2F62F5DBB}"/>
               </a:ext>
             </a:extLst>
           </p:cNvPr>
@@ -2765,7 +2765,7 @@
           <p:cNvPr id="6" name="case-title">
             <a:extLst xmlns:a="http://schemas.openxmlformats.org/drawingml/2006/main">
               <a:ext uri="{FF2B5EF4-FFF2-40B4-BE49-F238E27FC236}">
-                <a16:creationId xmlns:a16="http://schemas.microsoft.com/office/drawing/2014/main" id="{9C08BCD6-8F86-4553-AFDA-9C7F0A7125A3}"/>
+                <a16:creationId xmlns:a16="http://schemas.microsoft.com/office/drawing/2014/main" id="{F37DDCFE-07E2-43AB-8054-017C02F3B4AD}"/>
               </a:ext>
             </a:extLst>
           </p:cNvPr>
@@ -2829,7 +2829,7 @@
           <p:cNvPr id="7" name="case-row-0">
             <a:extLst xmlns:a="http://schemas.openxmlformats.org/drawingml/2006/main">
               <a:ext uri="{FF2B5EF4-FFF2-40B4-BE49-F238E27FC236}">
-                <a16:creationId xmlns:a16="http://schemas.microsoft.com/office/drawing/2014/main" id="{56DDE428-E321-44EB-AE52-AACA159EA89E}"/>
+                <a16:creationId xmlns:a16="http://schemas.microsoft.com/office/drawing/2014/main" id="{72820906-2F13-4FEC-9816-11A3410FBA0D}"/>
               </a:ext>
             </a:extLst>
           </p:cNvPr>
@@ -2893,7 +2893,7 @@
           <p:cNvPr id="8" name="case-row-1">
             <a:extLst xmlns:a="http://schemas.openxmlformats.org/drawingml/2006/main">
               <a:ext uri="{FF2B5EF4-FFF2-40B4-BE49-F238E27FC236}">
-                <a16:creationId xmlns:a16="http://schemas.microsoft.com/office/drawing/2014/main" id="{A9105031-6B4B-493D-8E3B-7488E5F7266D}"/>
+                <a16:creationId xmlns:a16="http://schemas.microsoft.com/office/drawing/2014/main" id="{4CFA2C64-7D52-41E0-B1B7-CAE7B8865B2D}"/>
               </a:ext>
             </a:extLst>
           </p:cNvPr>
@@ -2947,7 +2947,7 @@
                 <a:ea typeface="PingFang SC"/>
                 <a:cs typeface="PingFang SC"/>
               </a:rPr>
-              <a:t>机制｜Observe： 确认三份文件均可读取，记录输出格式，并发现其中一份纪要没有明确截止时间</a:t>
+              <a:t>结果｜Observe： 确认三份文件均可读取，记录输出格式，并发现其中一份纪要没有明确截止时间</a:t>
             </a:r>
           </a:p>
         </p:txBody>
@@ -2957,7 +2957,7 @@
           <p:cNvPr id="9" name="case-row-2">
             <a:extLst xmlns:a="http://schemas.openxmlformats.org/drawingml/2006/main">
               <a:ext uri="{FF2B5EF4-FFF2-40B4-BE49-F238E27FC236}">
-                <a16:creationId xmlns:a16="http://schemas.microsoft.com/office/drawing/2014/main" id="{565CBCF1-A676-49A8-B796-05837165A474}"/>
+                <a16:creationId xmlns:a16="http://schemas.microsoft.com/office/drawing/2014/main" id="{D9660449-D1A0-415A-9882-87C1F8249491}"/>
               </a:ext>
             </a:extLst>
           </p:cNvPr>
@@ -3011,7 +3011,7 @@
                 <a:ea typeface="PingFang SC"/>
                 <a:cs typeface="PingFang SC"/>
               </a:rPr>
-              <a:t>结果｜Reason / Plan： 先抽取可确认的任务，再把缺失字段列为待澄清项，不凭空补日期</a:t>
+              <a:t>方法｜Reason / Plan： 先抽取可确认的任务，再把缺失字段列为待澄清项，不凭空补日期</a:t>
             </a:r>
           </a:p>
         </p:txBody>
@@ -3021,7 +3021,7 @@
           <p:cNvPr id="10" name="case-row-3">
             <a:extLst xmlns:a="http://schemas.openxmlformats.org/drawingml/2006/main">
               <a:ext uri="{FF2B5EF4-FFF2-40B4-BE49-F238E27FC236}">
-                <a16:creationId xmlns:a16="http://schemas.microsoft.com/office/drawing/2014/main" id="{401A03C8-B458-4B0E-99E3-D92F8652A27B}"/>
+                <a16:creationId xmlns:a16="http://schemas.microsoft.com/office/drawing/2014/main" id="{75C78A2B-3FDE-427B-858E-94841F2EBDDB}"/>
               </a:ext>
             </a:extLst>
           </p:cNvPr>
@@ -3033,6 +3033,70 @@
         <p:spPr>
           <a:xfrm xmlns:a="http://schemas.openxmlformats.org/drawingml/2006/main">
             <a:off x="4286250" y="3924300"/>
+            <a:ext cx="6534150" cy="514350"/>
+          </a:xfrm>
+          <a:prstGeom xmlns:a="http://schemas.openxmlformats.org/drawingml/2006/main" prst="roundRect">
+            <a:avLst>
+              <a:gd name="adj" fmla="val 24074"/>
+            </a:avLst>
+          </a:prstGeom>
+          <a:solidFill xmlns:a="http://schemas.openxmlformats.org/drawingml/2006/main">
+            <a:srgbClr val="FFFFFF"/>
+          </a:solidFill>
+          <a:ln xmlns:a="http://schemas.openxmlformats.org/drawingml/2006/main" w="9525">
+            <a:solidFill>
+              <a:srgbClr val="D8E0E8"/>
+            </a:solidFill>
+            <a:prstDash val="solid"/>
+          </a:ln>
+        </p:spPr>
+        <p:txBody>
+          <a:bodyPr xmlns:a="http://schemas.openxmlformats.org/drawingml/2006/main" lIns="152400" tIns="133350" rIns="152400" bIns="133350" anchor="ctr">
+            <a:normAutofit fontScale="72956"/>
+          </a:bodyPr>
+          <a:lstStyle xmlns:a="http://schemas.openxmlformats.org/drawingml/2006/main"/>
+          <a:p xmlns:a="http://schemas.openxmlformats.org/drawingml/2006/main">
+            <a:pPr algn="l">
+              <a:defRPr sz="1575" b="0">
+                <a:solidFill>
+                  <a:srgbClr val="10233F"/>
+                </a:solidFill>
+                <a:latin typeface="PingFang SC"/>
+                <a:ea typeface="PingFang SC"/>
+                <a:cs typeface="PingFang SC"/>
+              </a:defRPr>
+            </a:pPr>
+            <a:r>
+              <a:rPr sz="1575" b="0">
+                <a:solidFill>
+                  <a:srgbClr val="10233F"/>
+                </a:solidFill>
+                <a:latin typeface="PingFang SC"/>
+                <a:ea typeface="PingFang SC"/>
+                <a:cs typeface="PingFang SC"/>
+              </a:rPr>
+              <a:t>方法｜Act： 调用文档读取工具，逐份提取“事项—负责人—截止时间—原文位置”</a:t>
+            </a:r>
+          </a:p>
+        </p:txBody>
+      </p:sp>
+      <p:sp>
+        <p:nvSpPr>
+          <p:cNvPr id="11" name="case-row-4">
+            <a:extLst xmlns:a="http://schemas.openxmlformats.org/drawingml/2006/main">
+              <a:ext uri="{FF2B5EF4-FFF2-40B4-BE49-F238E27FC236}">
+                <a16:creationId xmlns:a16="http://schemas.microsoft.com/office/drawing/2014/main" id="{2CBEA6A9-EFA9-4908-8B2A-0098B821601C}"/>
+              </a:ext>
+            </a:extLst>
+          </p:cNvPr>
+          <p:cNvSpPr>
+            <a:spLocks xmlns:a="http://schemas.openxmlformats.org/drawingml/2006/main" noGrp="1"/>
+          </p:cNvSpPr>
+          <p:nvPr/>
+        </p:nvSpPr>
+        <p:spPr>
+          <a:xfrm xmlns:a="http://schemas.openxmlformats.org/drawingml/2006/main">
+            <a:off x="4286250" y="4552950"/>
             <a:ext cx="6534150" cy="514350"/>
           </a:xfrm>
           <a:prstGeom xmlns:a="http://schemas.openxmlformats.org/drawingml/2006/main" prst="roundRect">
@@ -3045,14 +3109,14 @@
           </a:solidFill>
           <a:ln xmlns:a="http://schemas.openxmlformats.org/drawingml/2006/main" w="9525">
             <a:solidFill>
-              <a:srgbClr val="17A6C8"/>
+              <a:srgbClr val="006B80"/>
             </a:solidFill>
             <a:prstDash val="solid"/>
           </a:ln>
         </p:spPr>
         <p:txBody>
           <a:bodyPr xmlns:a="http://schemas.openxmlformats.org/drawingml/2006/main" lIns="152400" tIns="133350" rIns="152400" bIns="133350" anchor="ctr">
-            <a:normAutofit fontScale="72956"/>
+            <a:normAutofit fontScale="71250"/>
           </a:bodyPr>
           <a:lstStyle xmlns:a="http://schemas.openxmlformats.org/drawingml/2006/main"/>
           <a:p xmlns:a="http://schemas.openxmlformats.org/drawingml/2006/main">
@@ -3075,17 +3139,17 @@
                 <a:ea typeface="PingFang SC"/>
                 <a:cs typeface="PingFang SC"/>
               </a:rPr>
-              <a:t>边界｜Act： 调用文档读取工具，逐份提取“事项—负责人—截止时间—原文位置”</a:t>
-            </a:r>
-          </a:p>
-        </p:txBody>
-      </p:sp>
-      <p:sp>
-        <p:nvSpPr>
-          <p:cNvPr id="11" name="s10-takeaway-rule">
-            <a:extLst xmlns:a="http://schemas.openxmlformats.org/drawingml/2006/main">
-              <a:ext uri="{FF2B5EF4-FFF2-40B4-BE49-F238E27FC236}">
-                <a16:creationId xmlns:a16="http://schemas.microsoft.com/office/drawing/2014/main" id="{51AACFFC-3B54-47A7-8530-22F8D24837A8}"/>
+              <a:t>启示｜Observe again： 工具成功读取三份文件，共得到八条候选事项，其中两条负责人表述冲突</a:t>
+            </a:r>
+          </a:p>
+        </p:txBody>
+      </p:sp>
+      <p:sp>
+        <p:nvSpPr>
+          <p:cNvPr id="12" name="s10-takeaway-rule">
+            <a:extLst xmlns:a="http://schemas.openxmlformats.org/drawingml/2006/main">
+              <a:ext uri="{FF2B5EF4-FFF2-40B4-BE49-F238E27FC236}">
+                <a16:creationId xmlns:a16="http://schemas.microsoft.com/office/drawing/2014/main" id="{0C223A0C-C8B9-4575-AC36-A74B95A9E72B}"/>
               </a:ext>
             </a:extLst>
           </p:cNvPr>
@@ -3115,10 +3179,10 @@
       </p:sp>
       <p:sp>
         <p:nvSpPr>
-          <p:cNvPr id="12" name="s10-takeaway">
-            <a:extLst xmlns:a="http://schemas.openxmlformats.org/drawingml/2006/main">
-              <a:ext uri="{FF2B5EF4-FFF2-40B4-BE49-F238E27FC236}">
-                <a16:creationId xmlns:a16="http://schemas.microsoft.com/office/drawing/2014/main" id="{382249A0-732B-41C3-80D7-7895D2A48039}"/>
+          <p:cNvPr id="13" name="s10-takeaway">
+            <a:extLst xmlns:a="http://schemas.openxmlformats.org/drawingml/2006/main">
+              <a:ext uri="{FF2B5EF4-FFF2-40B4-BE49-F238E27FC236}">
+                <a16:creationId xmlns:a16="http://schemas.microsoft.com/office/drawing/2014/main" id="{B8486D21-36CA-4A78-B6F9-7C3CD65909AD}"/>
               </a:ext>
             </a:extLst>
           </p:cNvPr>
@@ -3166,7 +3230,7 @@
                 <a:ea typeface="PingFang SC"/>
                 <a:cs typeface="PingFang SC"/>
               </a:rPr>
-              <a:t>从“整理会议纪要”看一次完整循环必须经过边界验证</a:t>
+              <a:t>缺失字段要显式待确认，不能由模型补齐</a:t>
             </a:r>
           </a:p>
         </p:txBody>
@@ -3174,7 +3238,7 @@
     </p:spTree>
     <p:extLst>
       <p:ext uri="{BB962C8B-B14F-4D97-AF65-F5344CB8AC3E}">
-        <p14:creationId xmlns:p14="http://schemas.microsoft.com/office/powerpoint/2010/main" val="17723004"/>
+        <p14:creationId xmlns:p14="http://schemas.microsoft.com/office/powerpoint/2010/main" val="1530385802"/>
       </p:ext>
     </p:extLst>
   </p:cSld>
@@ -3205,7 +3269,7 @@
           <p:cNvPr id="1" name="s11-rule">
             <a:extLst xmlns:a="http://schemas.openxmlformats.org/drawingml/2006/main">
               <a:ext uri="{FF2B5EF4-FFF2-40B4-BE49-F238E27FC236}">
-                <a16:creationId xmlns:a16="http://schemas.microsoft.com/office/drawing/2014/main" id="{53776B89-4C5C-4ACF-A5FE-F849CA91FA78}"/>
+                <a16:creationId xmlns:a16="http://schemas.microsoft.com/office/drawing/2014/main" id="{24C9BDED-2B2A-42F2-ABB4-B1DB9A257700}"/>
               </a:ext>
             </a:extLst>
           </p:cNvPr>
@@ -3238,7 +3302,7 @@
           <p:cNvPr id="2" name="s11-eyebrow">
             <a:extLst xmlns:a="http://schemas.openxmlformats.org/drawingml/2006/main">
               <a:ext uri="{FF2B5EF4-FFF2-40B4-BE49-F238E27FC236}">
-                <a16:creationId xmlns:a16="http://schemas.microsoft.com/office/drawing/2014/main" id="{DB7FD82F-DC2E-42BA-BA9A-090C1BDFE125}"/>
+                <a16:creationId xmlns:a16="http://schemas.microsoft.com/office/drawing/2014/main" id="{E49C07AE-4C5E-4208-BD26-E0CE6F615220}"/>
               </a:ext>
             </a:extLst>
           </p:cNvPr>
@@ -3296,7 +3360,7 @@
           <p:cNvPr id="3" name="s11-title">
             <a:extLst xmlns:a="http://schemas.openxmlformats.org/drawingml/2006/main">
               <a:ext uri="{FF2B5EF4-FFF2-40B4-BE49-F238E27FC236}">
-                <a16:creationId xmlns:a16="http://schemas.microsoft.com/office/drawing/2014/main" id="{B83082F5-16DB-4D52-AF42-2EF1B5C87276}"/>
+                <a16:creationId xmlns:a16="http://schemas.microsoft.com/office/drawing/2014/main" id="{2148F562-6D32-4775-ADC4-FD0E2312828C}"/>
               </a:ext>
             </a:extLst>
           </p:cNvPr>
@@ -3344,7 +3408,7 @@
                 <a:ea typeface="PingFang SC"/>
                 <a:cs typeface="PingFang SC"/>
               </a:rPr>
-              <a:t>把方法落实为可验证的行动</a:t>
+              <a:t>Agent Loop 与 ReAct：一次可验收练习</a:t>
             </a:r>
           </a:p>
         </p:txBody>
@@ -3354,7 +3418,7 @@
           <p:cNvPr id="4" name="s11-footer">
             <a:extLst xmlns:a="http://schemas.openxmlformats.org/drawingml/2006/main">
               <a:ext uri="{FF2B5EF4-FFF2-40B4-BE49-F238E27FC236}">
-                <a16:creationId xmlns:a16="http://schemas.microsoft.com/office/drawing/2014/main" id="{324568A9-A437-4702-8BCC-0B2853F69B87}"/>
+                <a16:creationId xmlns:a16="http://schemas.microsoft.com/office/drawing/2014/main" id="{7C55290F-C6C9-4034-8E6A-F97F4AE97AA9}"/>
               </a:ext>
             </a:extLst>
           </p:cNvPr>
@@ -3385,7 +3449,7 @@
           <p:cNvPr id="5" name="s11-identity">
             <a:extLst xmlns:a="http://schemas.openxmlformats.org/drawingml/2006/main">
               <a:ext uri="{FF2B5EF4-FFF2-40B4-BE49-F238E27FC236}">
-                <a16:creationId xmlns:a16="http://schemas.microsoft.com/office/drawing/2014/main" id="{501F235D-29C8-4923-B0AC-51C34E8EF421}"/>
+                <a16:creationId xmlns:a16="http://schemas.microsoft.com/office/drawing/2014/main" id="{88D5A237-E859-4238-9C4D-807B0B4CD936}"/>
               </a:ext>
             </a:extLst>
           </p:cNvPr>
@@ -3443,7 +3507,7 @@
           <p:cNvPr id="6" name="practice-circle-0">
             <a:extLst xmlns:a="http://schemas.openxmlformats.org/drawingml/2006/main">
               <a:ext uri="{FF2B5EF4-FFF2-40B4-BE49-F238E27FC236}">
-                <a16:creationId xmlns:a16="http://schemas.microsoft.com/office/drawing/2014/main" id="{00964C36-9003-4520-855F-F88C3D45F51C}"/>
+                <a16:creationId xmlns:a16="http://schemas.microsoft.com/office/drawing/2014/main" id="{23013BAF-4730-4B96-92CA-41AF6439C99A}"/>
               </a:ext>
             </a:extLst>
           </p:cNvPr>
@@ -3476,7 +3540,7 @@
           <p:cNvPr id="7" name="practice-number-0">
             <a:extLst xmlns:a="http://schemas.openxmlformats.org/drawingml/2006/main">
               <a:ext uri="{FF2B5EF4-FFF2-40B4-BE49-F238E27FC236}">
-                <a16:creationId xmlns:a16="http://schemas.microsoft.com/office/drawing/2014/main" id="{EBA6C839-3FD9-4F61-B9F4-DD7B5CA3355B}"/>
+                <a16:creationId xmlns:a16="http://schemas.microsoft.com/office/drawing/2014/main" id="{E3766496-314E-46E9-92ED-DC3778CCBC49}"/>
               </a:ext>
             </a:extLst>
           </p:cNvPr>
@@ -3534,7 +3598,7 @@
           <p:cNvPr id="8" name="practice-item-0">
             <a:extLst xmlns:a="http://schemas.openxmlformats.org/drawingml/2006/main">
               <a:ext uri="{FF2B5EF4-FFF2-40B4-BE49-F238E27FC236}">
-                <a16:creationId xmlns:a16="http://schemas.microsoft.com/office/drawing/2014/main" id="{E68699B5-3DFB-4BE6-9888-7032C68B50A1}"/>
+                <a16:creationId xmlns:a16="http://schemas.microsoft.com/office/drawing/2014/main" id="{310C94FA-E8F1-4FC5-8592-875FB3D38B84}"/>
               </a:ext>
             </a:extLst>
           </p:cNvPr>
@@ -3588,7 +3652,7 @@
                 <a:ea typeface="PingFang SC"/>
                 <a:cs typeface="PingFang SC"/>
               </a:rPr>
-              <a:t>选择一个“查询两天内的天气并给出出行建议”或“检查一份表格中的缺失字段”任务，完成以下练习：；写出初始观察清单，至少区分三项事实和两项待验证假设</a:t>
+              <a:t>选择一个“查询两天内的天气并给出出行建议”或“检查一份表格中的缺失字段”任务，完成以下练习；写出初始观察清单，至少区分三项事实和两项待验证假设</a:t>
             </a:r>
           </a:p>
         </p:txBody>
@@ -3598,7 +3662,7 @@
           <p:cNvPr id="9" name="practice-connector-0">
             <a:extLst xmlns:a="http://schemas.openxmlformats.org/drawingml/2006/main">
               <a:ext uri="{FF2B5EF4-FFF2-40B4-BE49-F238E27FC236}">
-                <a16:creationId xmlns:a16="http://schemas.microsoft.com/office/drawing/2014/main" id="{5408A30B-48EA-4369-AA0E-2106CB812240}"/>
+                <a16:creationId xmlns:a16="http://schemas.microsoft.com/office/drawing/2014/main" id="{5025A727-6985-4DCD-8BDD-1452EE445F1F}"/>
               </a:ext>
             </a:extLst>
           </p:cNvPr>
@@ -3618,7 +3682,7 @@
           <a:noFill xmlns:a="http://schemas.openxmlformats.org/drawingml/2006/main"/>
           <a:ln xmlns:a="http://schemas.openxmlformats.org/drawingml/2006/main" w="28575">
             <a:solidFill>
-              <a:srgbClr val="17A6C8"/>
+              <a:srgbClr val="006B80"/>
             </a:solidFill>
             <a:prstDash val="solid"/>
           </a:ln>
@@ -3629,7 +3693,7 @@
           <p:cNvPr id="10" name="practice-circle-1">
             <a:extLst xmlns:a="http://schemas.openxmlformats.org/drawingml/2006/main">
               <a:ext uri="{FF2B5EF4-FFF2-40B4-BE49-F238E27FC236}">
-                <a16:creationId xmlns:a16="http://schemas.microsoft.com/office/drawing/2014/main" id="{7FEC7494-1130-456E-9E13-628243C4F881}"/>
+                <a16:creationId xmlns:a16="http://schemas.microsoft.com/office/drawing/2014/main" id="{5117A799-8508-41DD-96AC-086792E86793}"/>
               </a:ext>
             </a:extLst>
           </p:cNvPr>
@@ -3662,7 +3726,7 @@
           <p:cNvPr id="11" name="practice-number-1">
             <a:extLst xmlns:a="http://schemas.openxmlformats.org/drawingml/2006/main">
               <a:ext uri="{FF2B5EF4-FFF2-40B4-BE49-F238E27FC236}">
-                <a16:creationId xmlns:a16="http://schemas.microsoft.com/office/drawing/2014/main" id="{EE8E69BE-A16D-4FE6-813B-394434A23DA1}"/>
+                <a16:creationId xmlns:a16="http://schemas.microsoft.com/office/drawing/2014/main" id="{E65ED49E-095F-4CB2-8A11-3EFE8CE5CDC8}"/>
               </a:ext>
             </a:extLst>
           </p:cNvPr>
@@ -3720,7 +3784,7 @@
           <p:cNvPr id="12" name="practice-item-1">
             <a:extLst xmlns:a="http://schemas.openxmlformats.org/drawingml/2006/main">
               <a:ext uri="{FF2B5EF4-FFF2-40B4-BE49-F238E27FC236}">
-                <a16:creationId xmlns:a16="http://schemas.microsoft.com/office/drawing/2014/main" id="{ED292234-E3D8-4F14-9105-A999400006C1}"/>
+                <a16:creationId xmlns:a16="http://schemas.microsoft.com/office/drawing/2014/main" id="{62CF4578-1897-4A89-9A37-4DF5339D453A}"/>
               </a:ext>
             </a:extLst>
           </p:cNvPr>
@@ -3774,7 +3838,7 @@
                 <a:ea typeface="PingFang SC"/>
                 <a:cs typeface="PingFang SC"/>
               </a:rPr>
-              <a:t>把任务画成 Observe—Reason/Plan—Act—Observe—Evaluate 循环，并为每个动作写出预期证据。；设计至少四类停止条件，其中必须包括成功停止、受阻停止和风险升级</a:t>
+              <a:t>把任务画成 Observe—Reason/Plan—Act—Observe—Evaluate 循环，并为每个动作写出预期证据；设计至少四类停止条件，其中必须包括成功停止、受阻停止和风险升级</a:t>
             </a:r>
           </a:p>
         </p:txBody>
@@ -3784,7 +3848,7 @@
           <p:cNvPr id="13" name="practice-connector-1">
             <a:extLst xmlns:a="http://schemas.openxmlformats.org/drawingml/2006/main">
               <a:ext uri="{FF2B5EF4-FFF2-40B4-BE49-F238E27FC236}">
-                <a16:creationId xmlns:a16="http://schemas.microsoft.com/office/drawing/2014/main" id="{924BCBEF-4B9D-4144-ADC0-F3729ADDFA03}"/>
+                <a16:creationId xmlns:a16="http://schemas.microsoft.com/office/drawing/2014/main" id="{9EC5FB49-0D26-4487-B99C-61CA9F9684E0}"/>
               </a:ext>
             </a:extLst>
           </p:cNvPr>
@@ -3804,7 +3868,7 @@
           <a:noFill xmlns:a="http://schemas.openxmlformats.org/drawingml/2006/main"/>
           <a:ln xmlns:a="http://schemas.openxmlformats.org/drawingml/2006/main" w="28575">
             <a:solidFill>
-              <a:srgbClr val="17A6C8"/>
+              <a:srgbClr val="006B80"/>
             </a:solidFill>
             <a:prstDash val="solid"/>
           </a:ln>
@@ -3815,7 +3879,7 @@
           <p:cNvPr id="14" name="practice-circle-2">
             <a:extLst xmlns:a="http://schemas.openxmlformats.org/drawingml/2006/main">
               <a:ext uri="{FF2B5EF4-FFF2-40B4-BE49-F238E27FC236}">
-                <a16:creationId xmlns:a16="http://schemas.microsoft.com/office/drawing/2014/main" id="{06FCB92A-63CD-4F2A-9D45-1D4AD8A8C1AB}"/>
+                <a16:creationId xmlns:a16="http://schemas.microsoft.com/office/drawing/2014/main" id="{A89363AA-B04B-483F-B815-D95B8B377388}"/>
               </a:ext>
             </a:extLst>
           </p:cNvPr>
@@ -3833,7 +3897,7 @@
             <a:avLst/>
           </a:prstGeom>
           <a:solidFill xmlns:a="http://schemas.openxmlformats.org/drawingml/2006/main">
-            <a:srgbClr val="17A6C8"/>
+            <a:srgbClr val="006B80"/>
           </a:solidFill>
           <a:ln xmlns:a="http://schemas.openxmlformats.org/drawingml/2006/main" w="28575">
             <a:solidFill>
@@ -3848,7 +3912,7 @@
           <p:cNvPr id="15" name="practice-number-2">
             <a:extLst xmlns:a="http://schemas.openxmlformats.org/drawingml/2006/main">
               <a:ext uri="{FF2B5EF4-FFF2-40B4-BE49-F238E27FC236}">
-                <a16:creationId xmlns:a16="http://schemas.microsoft.com/office/drawing/2014/main" id="{5484720D-AAB1-4DE5-9847-029848C64908}"/>
+                <a16:creationId xmlns:a16="http://schemas.microsoft.com/office/drawing/2014/main" id="{8F0420F1-E85E-4325-AAFA-724ADD4B0BFC}"/>
               </a:ext>
             </a:extLst>
           </p:cNvPr>
@@ -3906,7 +3970,7 @@
           <p:cNvPr id="16" name="practice-item-2">
             <a:extLst xmlns:a="http://schemas.openxmlformats.org/drawingml/2006/main">
               <a:ext uri="{FF2B5EF4-FFF2-40B4-BE49-F238E27FC236}">
-                <a16:creationId xmlns:a16="http://schemas.microsoft.com/office/drawing/2014/main" id="{2BD51C32-346E-4FE9-8D7F-03C66D760BBC}"/>
+                <a16:creationId xmlns:a16="http://schemas.microsoft.com/office/drawing/2014/main" id="{8048D186-D52E-43B2-801C-BB17ABCE37B9}"/>
               </a:ext>
             </a:extLst>
           </p:cNvPr>
@@ -3930,14 +3994,14 @@
           </a:solidFill>
           <a:ln xmlns:a="http://schemas.openxmlformats.org/drawingml/2006/main" w="19050">
             <a:solidFill>
-              <a:srgbClr val="17A6C8"/>
+              <a:srgbClr val="006B80"/>
             </a:solidFill>
             <a:prstDash val="solid"/>
           </a:ln>
         </p:spPr>
         <p:txBody>
           <a:bodyPr xmlns:a="http://schemas.openxmlformats.org/drawingml/2006/main" lIns="152400" tIns="133350" rIns="152400" bIns="133350" anchor="ctr">
-            <a:normAutofit fontScale="85750"/>
+            <a:normAutofit fontScale="92359"/>
           </a:bodyPr>
           <a:lstStyle xmlns:a="http://schemas.openxmlformats.org/drawingml/2006/main"/>
           <a:p xmlns:a="http://schemas.openxmlformats.org/drawingml/2006/main">
@@ -3960,7 +4024,7 @@
                 <a:ea typeface="PingFang SC"/>
                 <a:cs typeface="PingFang SC"/>
               </a:rPr>
-              <a:t>用表格模拟五条 trace 记录，故意加入一次工具失败，再标出系统应如何恢复。；验收时，不只检查最终答案，还要检查每个结论能否回到观察证据，失败是否被如实记录，达到停止条件后是否立即结束</a:t>
+              <a:t>用表格模拟五条 trace 记录，故意加入一次工具失败，再标出系统应如何恢复；验收时，不只检查最终答案，还要检查每个结论能否回到观察证据，失败是否被如实记录，达到停止条件后是否立即结束</a:t>
             </a:r>
           </a:p>
         </p:txBody>
@@ -3968,7 +4032,7 @@
     </p:spTree>
     <p:extLst>
       <p:ext uri="{BB962C8B-B14F-4D97-AF65-F5344CB8AC3E}">
-        <p14:creationId xmlns:p14="http://schemas.microsoft.com/office/powerpoint/2010/main" val="728814180"/>
+        <p14:creationId xmlns:p14="http://schemas.microsoft.com/office/powerpoint/2010/main" val="766065132"/>
       </p:ext>
     </p:extLst>
   </p:cSld>
@@ -3999,7 +4063,7 @@
           <p:cNvPr id="1" name="s12-rule">
             <a:extLst xmlns:a="http://schemas.openxmlformats.org/drawingml/2006/main">
               <a:ext uri="{FF2B5EF4-FFF2-40B4-BE49-F238E27FC236}">
-                <a16:creationId xmlns:a16="http://schemas.microsoft.com/office/drawing/2014/main" id="{EB943743-FF9F-4AC5-B790-F3A5EFC15A4F}"/>
+                <a16:creationId xmlns:a16="http://schemas.microsoft.com/office/drawing/2014/main" id="{6FDC74B7-B200-4D09-AE27-287F566CEABC}"/>
               </a:ext>
             </a:extLst>
           </p:cNvPr>
@@ -4032,7 +4096,7 @@
           <p:cNvPr id="2" name="s12-eyebrow">
             <a:extLst xmlns:a="http://schemas.openxmlformats.org/drawingml/2006/main">
               <a:ext uri="{FF2B5EF4-FFF2-40B4-BE49-F238E27FC236}">
-                <a16:creationId xmlns:a16="http://schemas.microsoft.com/office/drawing/2014/main" id="{BDEFD0C3-FF6A-4E75-A016-98B6E40C8F08}"/>
+                <a16:creationId xmlns:a16="http://schemas.microsoft.com/office/drawing/2014/main" id="{2CC6A3C0-58CE-4EC0-8C58-BF6310C391D0}"/>
               </a:ext>
             </a:extLst>
           </p:cNvPr>
@@ -4090,7 +4154,7 @@
           <p:cNvPr id="3" name="s12-title">
             <a:extLst xmlns:a="http://schemas.openxmlformats.org/drawingml/2006/main">
               <a:ext uri="{FF2B5EF4-FFF2-40B4-BE49-F238E27FC236}">
-                <a16:creationId xmlns:a16="http://schemas.microsoft.com/office/drawing/2014/main" id="{CB444553-9186-4E3F-A6AC-C68A019B5E7B}"/>
+                <a16:creationId xmlns:a16="http://schemas.microsoft.com/office/drawing/2014/main" id="{97463BB0-3B91-4EDE-942A-8073ADC31B3A}"/>
               </a:ext>
             </a:extLst>
           </p:cNvPr>
@@ -4138,7 +4202,7 @@
                 <a:ea typeface="PingFang SC"/>
                 <a:cs typeface="PingFang SC"/>
               </a:rPr>
-              <a:t>带走三条可复用的判断原则</a:t>
+              <a:t>Agent Loop 与 ReAct：判断时先抓住三点</a:t>
             </a:r>
           </a:p>
         </p:txBody>
@@ -4148,7 +4212,7 @@
           <p:cNvPr id="4" name="s12-footer">
             <a:extLst xmlns:a="http://schemas.openxmlformats.org/drawingml/2006/main">
               <a:ext uri="{FF2B5EF4-FFF2-40B4-BE49-F238E27FC236}">
-                <a16:creationId xmlns:a16="http://schemas.microsoft.com/office/drawing/2014/main" id="{EF8B9F15-0034-4E23-AD30-240E5C223B8E}"/>
+                <a16:creationId xmlns:a16="http://schemas.microsoft.com/office/drawing/2014/main" id="{4C514CD0-4123-484D-9E26-F33DBC54241C}"/>
               </a:ext>
             </a:extLst>
           </p:cNvPr>
@@ -4179,7 +4243,7 @@
           <p:cNvPr id="5" name="s12-identity">
             <a:extLst xmlns:a="http://schemas.openxmlformats.org/drawingml/2006/main">
               <a:ext uri="{FF2B5EF4-FFF2-40B4-BE49-F238E27FC236}">
-                <a16:creationId xmlns:a16="http://schemas.microsoft.com/office/drawing/2014/main" id="{FEACB714-6D6B-458C-8764-B20CB22BC134}"/>
+                <a16:creationId xmlns:a16="http://schemas.microsoft.com/office/drawing/2014/main" id="{0945D464-5D5B-4AE2-B1EB-3D720BF225AA}"/>
               </a:ext>
             </a:extLst>
           </p:cNvPr>
@@ -4237,7 +4301,7 @@
           <p:cNvPr id="6" name="recap-circle-0">
             <a:extLst xmlns:a="http://schemas.openxmlformats.org/drawingml/2006/main">
               <a:ext uri="{FF2B5EF4-FFF2-40B4-BE49-F238E27FC236}">
-                <a16:creationId xmlns:a16="http://schemas.microsoft.com/office/drawing/2014/main" id="{83245E0A-7781-4AE1-9015-CD780DF201E5}"/>
+                <a16:creationId xmlns:a16="http://schemas.microsoft.com/office/drawing/2014/main" id="{5818F847-CD56-421A-9B96-B8C9E94ADBF6}"/>
               </a:ext>
             </a:extLst>
           </p:cNvPr>
@@ -4270,7 +4334,7 @@
           <p:cNvPr id="7" name="recap-number-0">
             <a:extLst xmlns:a="http://schemas.openxmlformats.org/drawingml/2006/main">
               <a:ext uri="{FF2B5EF4-FFF2-40B4-BE49-F238E27FC236}">
-                <a16:creationId xmlns:a16="http://schemas.microsoft.com/office/drawing/2014/main" id="{58C9217E-8C2B-4205-A88E-9B7E775C5989}"/>
+                <a16:creationId xmlns:a16="http://schemas.microsoft.com/office/drawing/2014/main" id="{906B470F-DDD6-412F-BCE7-F85478374F9E}"/>
               </a:ext>
             </a:extLst>
           </p:cNvPr>
@@ -4328,7 +4392,7 @@
           <p:cNvPr id="8" name="recap-item-0">
             <a:extLst xmlns:a="http://schemas.openxmlformats.org/drawingml/2006/main">
               <a:ext uri="{FF2B5EF4-FFF2-40B4-BE49-F238E27FC236}">
-                <a16:creationId xmlns:a16="http://schemas.microsoft.com/office/drawing/2014/main" id="{FE7226D7-A172-4588-9A58-5D8B0DF18240}"/>
+                <a16:creationId xmlns:a16="http://schemas.microsoft.com/office/drawing/2014/main" id="{802AF1C1-CC2E-4CA8-916A-7607B6ED3B93}"/>
               </a:ext>
             </a:extLst>
           </p:cNvPr>
@@ -4382,7 +4446,7 @@
                 <a:ea typeface="PingFang SC"/>
                 <a:cs typeface="PingFang SC"/>
               </a:rPr>
-              <a:t>并非所有问题都需要智能体</a:t>
+              <a:t>智能体与工作流的分界在于持续观察并行动</a:t>
             </a:r>
           </a:p>
         </p:txBody>
@@ -4392,7 +4456,7 @@
           <p:cNvPr id="9" name="recap-connector-0">
             <a:extLst xmlns:a="http://schemas.openxmlformats.org/drawingml/2006/main">
               <a:ext uri="{FF2B5EF4-FFF2-40B4-BE49-F238E27FC236}">
-                <a16:creationId xmlns:a16="http://schemas.microsoft.com/office/drawing/2014/main" id="{4CB73A32-CD1B-4120-AF2A-003AC8E2B775}"/>
+                <a16:creationId xmlns:a16="http://schemas.microsoft.com/office/drawing/2014/main" id="{C43E4C9A-2E12-4FE3-AC11-D1255CCB8A2B}"/>
               </a:ext>
             </a:extLst>
           </p:cNvPr>
@@ -4412,7 +4476,7 @@
           <a:noFill xmlns:a="http://schemas.openxmlformats.org/drawingml/2006/main"/>
           <a:ln xmlns:a="http://schemas.openxmlformats.org/drawingml/2006/main" w="28575">
             <a:solidFill>
-              <a:srgbClr val="17A6C8"/>
+              <a:srgbClr val="006B80"/>
             </a:solidFill>
             <a:prstDash val="solid"/>
           </a:ln>
@@ -4423,7 +4487,7 @@
           <p:cNvPr id="10" name="recap-circle-1">
             <a:extLst xmlns:a="http://schemas.openxmlformats.org/drawingml/2006/main">
               <a:ext uri="{FF2B5EF4-FFF2-40B4-BE49-F238E27FC236}">
-                <a16:creationId xmlns:a16="http://schemas.microsoft.com/office/drawing/2014/main" id="{FC7C9032-544A-4E24-8556-92877986DEC9}"/>
+                <a16:creationId xmlns:a16="http://schemas.microsoft.com/office/drawing/2014/main" id="{6804AE4C-55A5-4430-8A19-B69B68EA2E7D}"/>
               </a:ext>
             </a:extLst>
           </p:cNvPr>
@@ -4456,7 +4520,7 @@
           <p:cNvPr id="11" name="recap-number-1">
             <a:extLst xmlns:a="http://schemas.openxmlformats.org/drawingml/2006/main">
               <a:ext uri="{FF2B5EF4-FFF2-40B4-BE49-F238E27FC236}">
-                <a16:creationId xmlns:a16="http://schemas.microsoft.com/office/drawing/2014/main" id="{83CB8949-B45C-46C0-B758-AFFEDB8273C2}"/>
+                <a16:creationId xmlns:a16="http://schemas.microsoft.com/office/drawing/2014/main" id="{EB6FE491-D994-499B-A7C4-281A01D8AA43}"/>
               </a:ext>
             </a:extLst>
           </p:cNvPr>
@@ -4514,7 +4578,7 @@
           <p:cNvPr id="12" name="recap-item-1">
             <a:extLst xmlns:a="http://schemas.openxmlformats.org/drawingml/2006/main">
               <a:ext uri="{FF2B5EF4-FFF2-40B4-BE49-F238E27FC236}">
-                <a16:creationId xmlns:a16="http://schemas.microsoft.com/office/drawing/2014/main" id="{CB744C59-BEEA-4CEE-AE11-650491E25B18}"/>
+                <a16:creationId xmlns:a16="http://schemas.microsoft.com/office/drawing/2014/main" id="{55349167-3D5F-4B7F-8793-E4B20198161C}"/>
               </a:ext>
             </a:extLst>
           </p:cNvPr>
@@ -4578,7 +4642,7 @@
           <p:cNvPr id="13" name="recap-connector-1">
             <a:extLst xmlns:a="http://schemas.openxmlformats.org/drawingml/2006/main">
               <a:ext uri="{FF2B5EF4-FFF2-40B4-BE49-F238E27FC236}">
-                <a16:creationId xmlns:a16="http://schemas.microsoft.com/office/drawing/2014/main" id="{F7A1735C-A2FD-4EFD-AB1B-4B44DCD0B406}"/>
+                <a16:creationId xmlns:a16="http://schemas.microsoft.com/office/drawing/2014/main" id="{AA620BC2-CC94-40D4-BAC6-8735DBC09939}"/>
               </a:ext>
             </a:extLst>
           </p:cNvPr>
@@ -4598,7 +4662,7 @@
           <a:noFill xmlns:a="http://schemas.openxmlformats.org/drawingml/2006/main"/>
           <a:ln xmlns:a="http://schemas.openxmlformats.org/drawingml/2006/main" w="28575">
             <a:solidFill>
-              <a:srgbClr val="17A6C8"/>
+              <a:srgbClr val="006B80"/>
             </a:solidFill>
             <a:prstDash val="solid"/>
           </a:ln>
@@ -4609,7 +4673,7 @@
           <p:cNvPr id="14" name="recap-circle-2">
             <a:extLst xmlns:a="http://schemas.openxmlformats.org/drawingml/2006/main">
               <a:ext uri="{FF2B5EF4-FFF2-40B4-BE49-F238E27FC236}">
-                <a16:creationId xmlns:a16="http://schemas.microsoft.com/office/drawing/2014/main" id="{CFBB2955-1A6C-4D5E-969A-F924C3A30599}"/>
+                <a16:creationId xmlns:a16="http://schemas.microsoft.com/office/drawing/2014/main" id="{E900F891-FC03-4A4C-94FC-DCC6539E4497}"/>
               </a:ext>
             </a:extLst>
           </p:cNvPr>
@@ -4627,7 +4691,7 @@
             <a:avLst/>
           </a:prstGeom>
           <a:solidFill xmlns:a="http://schemas.openxmlformats.org/drawingml/2006/main">
-            <a:srgbClr val="17A6C8"/>
+            <a:srgbClr val="006B80"/>
           </a:solidFill>
           <a:ln xmlns:a="http://schemas.openxmlformats.org/drawingml/2006/main" w="28575">
             <a:solidFill>
@@ -4642,7 +4706,7 @@
           <p:cNvPr id="15" name="recap-number-2">
             <a:extLst xmlns:a="http://schemas.openxmlformats.org/drawingml/2006/main">
               <a:ext uri="{FF2B5EF4-FFF2-40B4-BE49-F238E27FC236}">
-                <a16:creationId xmlns:a16="http://schemas.microsoft.com/office/drawing/2014/main" id="{95C6A4A6-EC3D-49D6-8FF6-E58A2086D514}"/>
+                <a16:creationId xmlns:a16="http://schemas.microsoft.com/office/drawing/2014/main" id="{B68A3D19-CC27-47C0-8C31-DE9463A4C94A}"/>
               </a:ext>
             </a:extLst>
           </p:cNvPr>
@@ -4700,7 +4764,7 @@
           <p:cNvPr id="16" name="recap-item-2">
             <a:extLst xmlns:a="http://schemas.openxmlformats.org/drawingml/2006/main">
               <a:ext uri="{FF2B5EF4-FFF2-40B4-BE49-F238E27FC236}">
-                <a16:creationId xmlns:a16="http://schemas.microsoft.com/office/drawing/2014/main" id="{7DCC9280-801F-4C29-8D38-9C785BFCF2B8}"/>
+                <a16:creationId xmlns:a16="http://schemas.microsoft.com/office/drawing/2014/main" id="{B6509A6E-11CA-4473-9118-3AF9740C57CF}"/>
               </a:ext>
             </a:extLst>
           </p:cNvPr>
@@ -4724,7 +4788,7 @@
           </a:solidFill>
           <a:ln xmlns:a="http://schemas.openxmlformats.org/drawingml/2006/main" w="19050">
             <a:solidFill>
-              <a:srgbClr val="17A6C8"/>
+              <a:srgbClr val="006B80"/>
             </a:solidFill>
             <a:prstDash val="solid"/>
           </a:ln>
@@ -4762,7 +4826,7 @@
     </p:spTree>
     <p:extLst>
       <p:ext uri="{BB962C8B-B14F-4D97-AF65-F5344CB8AC3E}">
-        <p14:creationId xmlns:p14="http://schemas.microsoft.com/office/powerpoint/2010/main" val="1106716690"/>
+        <p14:creationId xmlns:p14="http://schemas.microsoft.com/office/powerpoint/2010/main" val="417828205"/>
       </p:ext>
     </p:extLst>
   </p:cSld>
@@ -4793,7 +4857,7 @@
           <p:cNvPr id="1" name="s13-rule">
             <a:extLst xmlns:a="http://schemas.openxmlformats.org/drawingml/2006/main">
               <a:ext uri="{FF2B5EF4-FFF2-40B4-BE49-F238E27FC236}">
-                <a16:creationId xmlns:a16="http://schemas.microsoft.com/office/drawing/2014/main" id="{31F0CCC0-E8CF-4361-BD47-435BE68B6AB5}"/>
+                <a16:creationId xmlns:a16="http://schemas.microsoft.com/office/drawing/2014/main" id="{65A3990C-C778-4E82-B697-38E0AC968406}"/>
               </a:ext>
             </a:extLst>
           </p:cNvPr>
@@ -4826,7 +4890,7 @@
           <p:cNvPr id="2" name="s13-eyebrow">
             <a:extLst xmlns:a="http://schemas.openxmlformats.org/drawingml/2006/main">
               <a:ext uri="{FF2B5EF4-FFF2-40B4-BE49-F238E27FC236}">
-                <a16:creationId xmlns:a16="http://schemas.microsoft.com/office/drawing/2014/main" id="{85C4EE08-7609-4A07-8C69-77E2EC2261E0}"/>
+                <a16:creationId xmlns:a16="http://schemas.microsoft.com/office/drawing/2014/main" id="{10BBB40F-6EE4-40EF-B73A-04F4C664123C}"/>
               </a:ext>
             </a:extLst>
           </p:cNvPr>
@@ -4884,7 +4948,7 @@
           <p:cNvPr id="3" name="s13-title">
             <a:extLst xmlns:a="http://schemas.openxmlformats.org/drawingml/2006/main">
               <a:ext uri="{FF2B5EF4-FFF2-40B4-BE49-F238E27FC236}">
-                <a16:creationId xmlns:a16="http://schemas.microsoft.com/office/drawing/2014/main" id="{0A11EF96-BCD0-4626-AABF-00CB26F6A483}"/>
+                <a16:creationId xmlns:a16="http://schemas.microsoft.com/office/drawing/2014/main" id="{996CD768-DCB0-4AE0-9350-CB3C7BF584B3}"/>
               </a:ext>
             </a:extLst>
           </p:cNvPr>
@@ -4932,7 +4996,7 @@
                 <a:ea typeface="PingFang SC"/>
                 <a:cs typeface="PingFang SC"/>
               </a:rPr>
-              <a:t>从公开重制课件回到可核对的学习资料</a:t>
+              <a:t>Agent Loop 与 ReAct：依据、边界与延伸</a:t>
             </a:r>
           </a:p>
         </p:txBody>
@@ -4942,7 +5006,7 @@
           <p:cNvPr id="4" name="s13-footer">
             <a:extLst xmlns:a="http://schemas.openxmlformats.org/drawingml/2006/main">
               <a:ext uri="{FF2B5EF4-FFF2-40B4-BE49-F238E27FC236}">
-                <a16:creationId xmlns:a16="http://schemas.microsoft.com/office/drawing/2014/main" id="{0E4948A9-1C12-4B72-A7F3-A694D01602AB}"/>
+                <a16:creationId xmlns:a16="http://schemas.microsoft.com/office/drawing/2014/main" id="{E77B22A0-775A-4F8C-AE68-36074D8ABC73}"/>
               </a:ext>
             </a:extLst>
           </p:cNvPr>
@@ -4973,7 +5037,7 @@
           <p:cNvPr id="5" name="s13-identity">
             <a:extLst xmlns:a="http://schemas.openxmlformats.org/drawingml/2006/main">
               <a:ext uri="{FF2B5EF4-FFF2-40B4-BE49-F238E27FC236}">
-                <a16:creationId xmlns:a16="http://schemas.microsoft.com/office/drawing/2014/main" id="{F26CD5AC-B0ED-4D9E-9AAF-8A5899529A90}"/>
+                <a16:creationId xmlns:a16="http://schemas.microsoft.com/office/drawing/2014/main" id="{19DA1E47-E0B3-4B6E-B572-5CBA4D62D753}"/>
               </a:ext>
             </a:extLst>
           </p:cNvPr>
@@ -5031,7 +5095,7 @@
           <p:cNvPr id="6" name="source-0">
             <a:extLst xmlns:a="http://schemas.openxmlformats.org/drawingml/2006/main">
               <a:ext uri="{FF2B5EF4-FFF2-40B4-BE49-F238E27FC236}">
-                <a16:creationId xmlns:a16="http://schemas.microsoft.com/office/drawing/2014/main" id="{2DC343E0-E00B-4346-BBE1-2606D7590766}"/>
+                <a16:creationId xmlns:a16="http://schemas.microsoft.com/office/drawing/2014/main" id="{78984A93-B898-46D5-B724-2B9354F2C967}"/>
               </a:ext>
             </a:extLst>
           </p:cNvPr>
@@ -5055,7 +5119,7 @@
           </a:solidFill>
           <a:ln xmlns:a="http://schemas.openxmlformats.org/drawingml/2006/main" w="9525">
             <a:solidFill>
-              <a:srgbClr val="17A6C8"/>
+              <a:srgbClr val="006B80"/>
             </a:solidFill>
             <a:prstDash val="solid"/>
           </a:ln>
@@ -5095,7 +5159,7 @@
           <p:cNvPr id="7" name="source-1">
             <a:extLst xmlns:a="http://schemas.openxmlformats.org/drawingml/2006/main">
               <a:ext uri="{FF2B5EF4-FFF2-40B4-BE49-F238E27FC236}">
-                <a16:creationId xmlns:a16="http://schemas.microsoft.com/office/drawing/2014/main" id="{4F886E39-E45F-46A1-BF43-FF08D59E109A}"/>
+                <a16:creationId xmlns:a16="http://schemas.microsoft.com/office/drawing/2014/main" id="{EF0A3629-ED61-4322-821F-1D71D051FDEB}"/>
               </a:ext>
             </a:extLst>
           </p:cNvPr>
@@ -5159,7 +5223,7 @@
           <p:cNvPr id="8" name="s13-takeaway-rule">
             <a:extLst xmlns:a="http://schemas.openxmlformats.org/drawingml/2006/main">
               <a:ext uri="{FF2B5EF4-FFF2-40B4-BE49-F238E27FC236}">
-                <a16:creationId xmlns:a16="http://schemas.microsoft.com/office/drawing/2014/main" id="{20112D2B-7FA2-47B9-AB24-9BF6728CAC94}"/>
+                <a16:creationId xmlns:a16="http://schemas.microsoft.com/office/drawing/2014/main" id="{A13D0C60-A9D2-43CE-9ECD-633310D21B98}"/>
               </a:ext>
             </a:extLst>
           </p:cNvPr>
@@ -5192,7 +5256,7 @@
           <p:cNvPr id="9" name="s13-takeaway">
             <a:extLst xmlns:a="http://schemas.openxmlformats.org/drawingml/2006/main">
               <a:ext uri="{FF2B5EF4-FFF2-40B4-BE49-F238E27FC236}">
-                <a16:creationId xmlns:a16="http://schemas.microsoft.com/office/drawing/2014/main" id="{9DD263F2-7866-426F-BB3A-887E216502AB}"/>
+                <a16:creationId xmlns:a16="http://schemas.microsoft.com/office/drawing/2014/main" id="{97CE24B0-9ABA-4839-9684-46D92CED0409}"/>
               </a:ext>
             </a:extLst>
           </p:cNvPr>
@@ -5248,7 +5312,7 @@
     </p:spTree>
     <p:extLst>
       <p:ext uri="{BB962C8B-B14F-4D97-AF65-F5344CB8AC3E}">
-        <p14:creationId xmlns:p14="http://schemas.microsoft.com/office/powerpoint/2010/main" val="1162313369"/>
+        <p14:creationId xmlns:p14="http://schemas.microsoft.com/office/powerpoint/2010/main" val="729204351"/>
       </p:ext>
     </p:extLst>
   </p:cSld>
@@ -5279,7 +5343,7 @@
           <p:cNvPr id="1" name="s2-rule">
             <a:extLst xmlns:a="http://schemas.openxmlformats.org/drawingml/2006/main">
               <a:ext uri="{FF2B5EF4-FFF2-40B4-BE49-F238E27FC236}">
-                <a16:creationId xmlns:a16="http://schemas.microsoft.com/office/drawing/2014/main" id="{96382224-4181-4019-80D4-96DB79F5F327}"/>
+                <a16:creationId xmlns:a16="http://schemas.microsoft.com/office/drawing/2014/main" id="{D06E4E61-AF05-415F-8FDC-0AEAB7C18287}"/>
               </a:ext>
             </a:extLst>
           </p:cNvPr>
@@ -5312,7 +5376,7 @@
           <p:cNvPr id="2" name="s2-eyebrow">
             <a:extLst xmlns:a="http://schemas.openxmlformats.org/drawingml/2006/main">
               <a:ext uri="{FF2B5EF4-FFF2-40B4-BE49-F238E27FC236}">
-                <a16:creationId xmlns:a16="http://schemas.microsoft.com/office/drawing/2014/main" id="{C29E9BDD-C0B8-4030-BE24-1DA2DF62F1FA}"/>
+                <a16:creationId xmlns:a16="http://schemas.microsoft.com/office/drawing/2014/main" id="{1481AB3F-3732-43A0-A881-ADBC8F9895B9}"/>
               </a:ext>
             </a:extLst>
           </p:cNvPr>
@@ -5370,7 +5434,7 @@
           <p:cNvPr id="3" name="s2-title">
             <a:extLst xmlns:a="http://schemas.openxmlformats.org/drawingml/2006/main">
               <a:ext uri="{FF2B5EF4-FFF2-40B4-BE49-F238E27FC236}">
-                <a16:creationId xmlns:a16="http://schemas.microsoft.com/office/drawing/2014/main" id="{DCF2289C-78CF-4247-A63B-0112925E0C9A}"/>
+                <a16:creationId xmlns:a16="http://schemas.microsoft.com/office/drawing/2014/main" id="{DF50E1BC-857A-4728-A30C-A195D5EED103}"/>
               </a:ext>
             </a:extLst>
           </p:cNvPr>
@@ -5418,7 +5482,7 @@
                 <a:ea typeface="PingFang SC"/>
                 <a:cs typeface="PingFang SC"/>
               </a:rPr>
-              <a:t>学完这一节，你能完成这些判断与行动</a:t>
+              <a:t>Agent Loop 与 ReAct：4项学习结果</a:t>
             </a:r>
           </a:p>
         </p:txBody>
@@ -5428,7 +5492,7 @@
           <p:cNvPr id="4" name="s2-footer">
             <a:extLst xmlns:a="http://schemas.openxmlformats.org/drawingml/2006/main">
               <a:ext uri="{FF2B5EF4-FFF2-40B4-BE49-F238E27FC236}">
-                <a16:creationId xmlns:a16="http://schemas.microsoft.com/office/drawing/2014/main" id="{AC898B0D-D458-490A-A9E5-8EDE7D7F5664}"/>
+                <a16:creationId xmlns:a16="http://schemas.microsoft.com/office/drawing/2014/main" id="{30E506BB-71D8-40A4-B167-D4D37DCCFECB}"/>
               </a:ext>
             </a:extLst>
           </p:cNvPr>
@@ -5459,7 +5523,7 @@
           <p:cNvPr id="5" name="s2-identity">
             <a:extLst xmlns:a="http://schemas.openxmlformats.org/drawingml/2006/main">
               <a:ext uri="{FF2B5EF4-FFF2-40B4-BE49-F238E27FC236}">
-                <a16:creationId xmlns:a16="http://schemas.microsoft.com/office/drawing/2014/main" id="{FCCFE620-1E85-4545-B0CF-278CFB6A41C8}"/>
+                <a16:creationId xmlns:a16="http://schemas.microsoft.com/office/drawing/2014/main" id="{88BACEDB-0C48-4453-844B-3A8648EB8927}"/>
               </a:ext>
             </a:extLst>
           </p:cNvPr>
@@ -5517,7 +5581,7 @@
           <p:cNvPr id="6" name="objective-1">
             <a:extLst xmlns:a="http://schemas.openxmlformats.org/drawingml/2006/main">
               <a:ext uri="{FF2B5EF4-FFF2-40B4-BE49-F238E27FC236}">
-                <a16:creationId xmlns:a16="http://schemas.microsoft.com/office/drawing/2014/main" id="{0080100A-E098-4A2D-93AE-261B53F07B5F}"/>
+                <a16:creationId xmlns:a16="http://schemas.microsoft.com/office/drawing/2014/main" id="{9B3FF68E-C0AF-4F31-BC68-72CB22DEA8BF}"/>
               </a:ext>
             </a:extLst>
           </p:cNvPr>
@@ -5604,7 +5668,7 @@
           <p:cNvPr id="7" name="objective-2">
             <a:extLst xmlns:a="http://schemas.openxmlformats.org/drawingml/2006/main">
               <a:ext uri="{FF2B5EF4-FFF2-40B4-BE49-F238E27FC236}">
-                <a16:creationId xmlns:a16="http://schemas.microsoft.com/office/drawing/2014/main" id="{7DEAE995-ADF0-4A65-8167-8E3D8D20590A}"/>
+                <a16:creationId xmlns:a16="http://schemas.microsoft.com/office/drawing/2014/main" id="{E2B48CEA-795C-4A9F-9243-48C658873287}"/>
               </a:ext>
             </a:extLst>
           </p:cNvPr>
@@ -5691,7 +5755,7 @@
           <p:cNvPr id="8" name="objective-3">
             <a:extLst xmlns:a="http://schemas.openxmlformats.org/drawingml/2006/main">
               <a:ext uri="{FF2B5EF4-FFF2-40B4-BE49-F238E27FC236}">
-                <a16:creationId xmlns:a16="http://schemas.microsoft.com/office/drawing/2014/main" id="{CC3DA80D-9E06-4CEC-859D-A260D3370BC1}"/>
+                <a16:creationId xmlns:a16="http://schemas.microsoft.com/office/drawing/2014/main" id="{F7DFE80D-F2B9-49F5-BD5E-34BF4DB723FB}"/>
               </a:ext>
             </a:extLst>
           </p:cNvPr>
@@ -5778,7 +5842,7 @@
           <p:cNvPr id="9" name="objective-4">
             <a:extLst xmlns:a="http://schemas.openxmlformats.org/drawingml/2006/main">
               <a:ext uri="{FF2B5EF4-FFF2-40B4-BE49-F238E27FC236}">
-                <a16:creationId xmlns:a16="http://schemas.microsoft.com/office/drawing/2014/main" id="{0ADBA28A-49D5-46AD-8F4E-FB5363E6ED34}"/>
+                <a16:creationId xmlns:a16="http://schemas.microsoft.com/office/drawing/2014/main" id="{77C390B1-5D86-4076-BFCA-EEE5F50C8AE4}"/>
               </a:ext>
             </a:extLst>
           </p:cNvPr>
@@ -5802,7 +5866,7 @@
           </a:solidFill>
           <a:ln xmlns:a="http://schemas.openxmlformats.org/drawingml/2006/main" w="19050">
             <a:solidFill>
-              <a:srgbClr val="17A6C8"/>
+              <a:srgbClr val="006B80"/>
             </a:solidFill>
             <a:prstDash val="solid"/>
           </a:ln>
@@ -5863,7 +5927,7 @@
     </p:spTree>
     <p:extLst>
       <p:ext uri="{BB962C8B-B14F-4D97-AF65-F5344CB8AC3E}">
-        <p14:creationId xmlns:p14="http://schemas.microsoft.com/office/powerpoint/2010/main" val="401555821"/>
+        <p14:creationId xmlns:p14="http://schemas.microsoft.com/office/powerpoint/2010/main" val="1075660512"/>
       </p:ext>
     </p:extLst>
   </p:cSld>
@@ -5894,7 +5958,7 @@
           <p:cNvPr id="1" name="s3-rule">
             <a:extLst xmlns:a="http://schemas.openxmlformats.org/drawingml/2006/main">
               <a:ext uri="{FF2B5EF4-FFF2-40B4-BE49-F238E27FC236}">
-                <a16:creationId xmlns:a16="http://schemas.microsoft.com/office/drawing/2014/main" id="{04E7FBE6-F3A7-4FD4-A407-01E479F0FA73}"/>
+                <a16:creationId xmlns:a16="http://schemas.microsoft.com/office/drawing/2014/main" id="{3E6034AD-6530-4B66-8485-3DBD0352CAD1}"/>
               </a:ext>
             </a:extLst>
           </p:cNvPr>
@@ -5927,7 +5991,7 @@
           <p:cNvPr id="2" name="s3-eyebrow">
             <a:extLst xmlns:a="http://schemas.openxmlformats.org/drawingml/2006/main">
               <a:ext uri="{FF2B5EF4-FFF2-40B4-BE49-F238E27FC236}">
-                <a16:creationId xmlns:a16="http://schemas.microsoft.com/office/drawing/2014/main" id="{41EDE8F5-F0C9-4AAC-8EF9-F082754A2D8B}"/>
+                <a16:creationId xmlns:a16="http://schemas.microsoft.com/office/drawing/2014/main" id="{9F7F8499-131E-4E63-95B4-EBBD170AD42A}"/>
               </a:ext>
             </a:extLst>
           </p:cNvPr>
@@ -5985,7 +6049,7 @@
           <p:cNvPr id="3" name="s3-title">
             <a:extLst xmlns:a="http://schemas.openxmlformats.org/drawingml/2006/main">
               <a:ext uri="{FF2B5EF4-FFF2-40B4-BE49-F238E27FC236}">
-                <a16:creationId xmlns:a16="http://schemas.microsoft.com/office/drawing/2014/main" id="{3B7C1D8F-3445-4EE6-93CB-ED063E962535}"/>
+                <a16:creationId xmlns:a16="http://schemas.microsoft.com/office/drawing/2014/main" id="{9FB81894-B6A3-4EB8-B2E6-A24C1184C19D}"/>
               </a:ext>
             </a:extLst>
           </p:cNvPr>
@@ -6033,7 +6097,7 @@
                 <a:ea typeface="PingFang SC"/>
                 <a:cs typeface="PingFang SC"/>
               </a:rPr>
-              <a:t>并非所有问题都需要智能体</a:t>
+              <a:t>智能体与工作流的分界在于持续观察并行动</a:t>
             </a:r>
           </a:p>
         </p:txBody>
@@ -6043,7 +6107,7 @@
           <p:cNvPr id="4" name="s3-footer">
             <a:extLst xmlns:a="http://schemas.openxmlformats.org/drawingml/2006/main">
               <a:ext uri="{FF2B5EF4-FFF2-40B4-BE49-F238E27FC236}">
-                <a16:creationId xmlns:a16="http://schemas.microsoft.com/office/drawing/2014/main" id="{44B1DDAC-F6A0-4256-84D3-AD969128106D}"/>
+                <a16:creationId xmlns:a16="http://schemas.microsoft.com/office/drawing/2014/main" id="{0E363CBA-E80D-4F06-ABF3-7109DE4E156D}"/>
               </a:ext>
             </a:extLst>
           </p:cNvPr>
@@ -6074,7 +6138,7 @@
           <p:cNvPr id="5" name="s3-identity">
             <a:extLst xmlns:a="http://schemas.openxmlformats.org/drawingml/2006/main">
               <a:ext uri="{FF2B5EF4-FFF2-40B4-BE49-F238E27FC236}">
-                <a16:creationId xmlns:a16="http://schemas.microsoft.com/office/drawing/2014/main" id="{720ED139-FDBB-4A13-ACBF-7325F7E68676}"/>
+                <a16:creationId xmlns:a16="http://schemas.microsoft.com/office/drawing/2014/main" id="{2B03FD2E-D5C6-4BC3-B2F8-4B1737952D8F}"/>
               </a:ext>
             </a:extLst>
           </p:cNvPr>
@@ -6132,7 +6196,7 @@
           <p:cNvPr id="6" name="core-no-0">
             <a:extLst xmlns:a="http://schemas.openxmlformats.org/drawingml/2006/main">
               <a:ext uri="{FF2B5EF4-FFF2-40B4-BE49-F238E27FC236}">
-                <a16:creationId xmlns:a16="http://schemas.microsoft.com/office/drawing/2014/main" id="{909CDF4A-7D50-4574-93CE-E3957219720E}"/>
+                <a16:creationId xmlns:a16="http://schemas.microsoft.com/office/drawing/2014/main" id="{837E721C-2D89-4587-8D17-7CD9F2007809}"/>
               </a:ext>
             </a:extLst>
           </p:cNvPr>
@@ -6164,7 +6228,7 @@
             <a:pPr algn="l">
               <a:defRPr sz="2250" b="1">
                 <a:solidFill>
-                  <a:srgbClr val="17A6C8"/>
+                  <a:srgbClr val="006B80"/>
                 </a:solidFill>
                 <a:latin typeface="PingFang SC"/>
                 <a:ea typeface="PingFang SC"/>
@@ -6174,7 +6238,7 @@
             <a:r>
               <a:rPr sz="2250" b="1">
                 <a:solidFill>
-                  <a:srgbClr val="17A6C8"/>
+                  <a:srgbClr val="006B80"/>
                 </a:solidFill>
                 <a:latin typeface="PingFang SC"/>
                 <a:ea typeface="PingFang SC"/>
@@ -6190,7 +6254,7 @@
           <p:cNvPr id="7" name="core-label-0">
             <a:extLst xmlns:a="http://schemas.openxmlformats.org/drawingml/2006/main">
               <a:ext uri="{FF2B5EF4-FFF2-40B4-BE49-F238E27FC236}">
-                <a16:creationId xmlns:a16="http://schemas.microsoft.com/office/drawing/2014/main" id="{214A6DCC-D288-4036-BFE7-75B9555F0F24}"/>
+                <a16:creationId xmlns:a16="http://schemas.microsoft.com/office/drawing/2014/main" id="{F7E7F752-0D57-4DF4-85AC-A0BB9E7D9B75}"/>
               </a:ext>
             </a:extLst>
           </p:cNvPr>
@@ -6248,7 +6312,7 @@
           <p:cNvPr id="8" name="core-body-0">
             <a:extLst xmlns:a="http://schemas.openxmlformats.org/drawingml/2006/main">
               <a:ext uri="{FF2B5EF4-FFF2-40B4-BE49-F238E27FC236}">
-                <a16:creationId xmlns:a16="http://schemas.microsoft.com/office/drawing/2014/main" id="{24D5A676-F3B8-4F7E-ADE8-CD610BA2427B}"/>
+                <a16:creationId xmlns:a16="http://schemas.microsoft.com/office/drawing/2014/main" id="{712AD8A2-5EBC-42A2-93AB-99E540077040}"/>
               </a:ext>
             </a:extLst>
           </p:cNvPr>
@@ -6272,7 +6336,7 @@
           </a:solidFill>
           <a:ln xmlns:a="http://schemas.openxmlformats.org/drawingml/2006/main" w="19050">
             <a:solidFill>
-              <a:srgbClr val="17A6C8"/>
+              <a:srgbClr val="006B80"/>
             </a:solidFill>
             <a:prstDash val="solid"/>
           </a:ln>
@@ -6302,7 +6366,7 @@
                 <a:ea typeface="PingFang SC"/>
                 <a:cs typeface="PingFang SC"/>
               </a:rPr>
-              <a:t>并非所有问题都需要智能体。固定流程能稳定解决的任务，使用工作流通常更便宜、更容易测试。只有当任务需要根据中间结果选择路径、调用不同工具或处理开放环境时…</a:t>
+              <a:t>并非所有问题都需要智能体；固定流程能稳定解决的任务；使用工作流通常更便宜、更容易测试；只有当任务需要根据中间结果选择路径、调用不同工具或处理开放环境时</a:t>
             </a:r>
           </a:p>
         </p:txBody>
@@ -6312,7 +6376,7 @@
           <p:cNvPr id="9" name="core-no-1">
             <a:extLst xmlns:a="http://schemas.openxmlformats.org/drawingml/2006/main">
               <a:ext uri="{FF2B5EF4-FFF2-40B4-BE49-F238E27FC236}">
-                <a16:creationId xmlns:a16="http://schemas.microsoft.com/office/drawing/2014/main" id="{9BA87F66-C004-4CDB-A60A-64E33F0F0D28}"/>
+                <a16:creationId xmlns:a16="http://schemas.microsoft.com/office/drawing/2014/main" id="{35F145BC-39AA-4052-97CD-305B39B9EDF7}"/>
               </a:ext>
             </a:extLst>
           </p:cNvPr>
@@ -6344,7 +6408,7 @@
             <a:pPr algn="l">
               <a:defRPr sz="2250" b="1">
                 <a:solidFill>
-                  <a:srgbClr val="17A6C8"/>
+                  <a:srgbClr val="006B80"/>
                 </a:solidFill>
                 <a:latin typeface="PingFang SC"/>
                 <a:ea typeface="PingFang SC"/>
@@ -6354,7 +6418,7 @@
             <a:r>
               <a:rPr sz="2250" b="1">
                 <a:solidFill>
-                  <a:srgbClr val="17A6C8"/>
+                  <a:srgbClr val="006B80"/>
                 </a:solidFill>
                 <a:latin typeface="PingFang SC"/>
                 <a:ea typeface="PingFang SC"/>
@@ -6370,7 +6434,7 @@
           <p:cNvPr id="10" name="core-label-1">
             <a:extLst xmlns:a="http://schemas.openxmlformats.org/drawingml/2006/main">
               <a:ext uri="{FF2B5EF4-FFF2-40B4-BE49-F238E27FC236}">
-                <a16:creationId xmlns:a16="http://schemas.microsoft.com/office/drawing/2014/main" id="{AACE6D78-077D-4E28-81D5-D1342BF3436C}"/>
+                <a16:creationId xmlns:a16="http://schemas.microsoft.com/office/drawing/2014/main" id="{7BB2EAC3-61CB-48C0-9FB0-1966E099B8A3}"/>
               </a:ext>
             </a:extLst>
           </p:cNvPr>
@@ -6428,7 +6492,7 @@
           <p:cNvPr id="11" name="core-body-1">
             <a:extLst xmlns:a="http://schemas.openxmlformats.org/drawingml/2006/main">
               <a:ext uri="{FF2B5EF4-FFF2-40B4-BE49-F238E27FC236}">
-                <a16:creationId xmlns:a16="http://schemas.microsoft.com/office/drawing/2014/main" id="{968E2979-9394-4AC9-BC22-0EABC0026848}"/>
+                <a16:creationId xmlns:a16="http://schemas.microsoft.com/office/drawing/2014/main" id="{B0F5CB41-7B5D-4AD2-8CD0-EADB4B01DDBE}"/>
               </a:ext>
             </a:extLst>
           </p:cNvPr>
@@ -6482,7 +6546,7 @@
                 <a:ea typeface="PingFang SC"/>
                 <a:cs typeface="PingFang SC"/>
               </a:rPr>
-              <a:t>观察不是把所有上下文一次性塞给模型，而是获取当前决策所需的证据。一次可靠观察至少回答五个问题：目标是什么、已经完成什么、仍缺什么、可以使用哪些工具、当前有哪些约束。工具返回值、文件内容…</a:t>
+              <a:t>观察不是把所有上下文一次性塞给模型；而是获取当前决策所需的证据；一次可靠观察至少回答五个问题；目标是什么、已经完成什么、仍缺什么、可以使用哪些工具、当前有哪些约束</a:t>
             </a:r>
           </a:p>
         </p:txBody>
@@ -6492,7 +6556,7 @@
           <p:cNvPr id="12" name="s3-takeaway-rule">
             <a:extLst xmlns:a="http://schemas.openxmlformats.org/drawingml/2006/main">
               <a:ext uri="{FF2B5EF4-FFF2-40B4-BE49-F238E27FC236}">
-                <a16:creationId xmlns:a16="http://schemas.microsoft.com/office/drawing/2014/main" id="{20EF349A-EFAB-4B5E-9BCD-71CB761B1E91}"/>
+                <a16:creationId xmlns:a16="http://schemas.microsoft.com/office/drawing/2014/main" id="{B4A61D14-FD92-47CB-AC75-FCEC419E6199}"/>
               </a:ext>
             </a:extLst>
           </p:cNvPr>
@@ -6525,7 +6589,7 @@
           <p:cNvPr id="13" name="s3-takeaway">
             <a:extLst xmlns:a="http://schemas.openxmlformats.org/drawingml/2006/main">
               <a:ext uri="{FF2B5EF4-FFF2-40B4-BE49-F238E27FC236}">
-                <a16:creationId xmlns:a16="http://schemas.microsoft.com/office/drawing/2014/main" id="{E3D0DE04-8905-472D-A700-C0914962BABE}"/>
+                <a16:creationId xmlns:a16="http://schemas.microsoft.com/office/drawing/2014/main" id="{DB9C8713-DF59-4011-974F-D04C82005E90}"/>
               </a:ext>
             </a:extLst>
           </p:cNvPr>
@@ -6573,7 +6637,7 @@
                 <a:ea typeface="PingFang SC"/>
                 <a:cs typeface="PingFang SC"/>
               </a:rPr>
-              <a:t>并非所有问题都需要智能体</a:t>
+              <a:t>智能体与工作流的分界在于持续观察并行动</a:t>
             </a:r>
           </a:p>
         </p:txBody>
@@ -6581,7 +6645,7 @@
     </p:spTree>
     <p:extLst>
       <p:ext uri="{BB962C8B-B14F-4D97-AF65-F5344CB8AC3E}">
-        <p14:creationId xmlns:p14="http://schemas.microsoft.com/office/powerpoint/2010/main" val="818108057"/>
+        <p14:creationId xmlns:p14="http://schemas.microsoft.com/office/powerpoint/2010/main" val="686005788"/>
       </p:ext>
     </p:extLst>
   </p:cSld>
@@ -6612,7 +6676,7 @@
           <p:cNvPr id="1" name="s4-rule">
             <a:extLst xmlns:a="http://schemas.openxmlformats.org/drawingml/2006/main">
               <a:ext uri="{FF2B5EF4-FFF2-40B4-BE49-F238E27FC236}">
-                <a16:creationId xmlns:a16="http://schemas.microsoft.com/office/drawing/2014/main" id="{E5412D72-6919-4689-9E10-185556DF0CA7}"/>
+                <a16:creationId xmlns:a16="http://schemas.microsoft.com/office/drawing/2014/main" id="{23793310-83EA-4AE3-B250-B32CCFD3F880}"/>
               </a:ext>
             </a:extLst>
           </p:cNvPr>
@@ -6645,7 +6709,7 @@
           <p:cNvPr id="2" name="s4-eyebrow">
             <a:extLst xmlns:a="http://schemas.openxmlformats.org/drawingml/2006/main">
               <a:ext uri="{FF2B5EF4-FFF2-40B4-BE49-F238E27FC236}">
-                <a16:creationId xmlns:a16="http://schemas.microsoft.com/office/drawing/2014/main" id="{C9282C3C-1421-4B8F-BE51-CC39EF488F6A}"/>
+                <a16:creationId xmlns:a16="http://schemas.microsoft.com/office/drawing/2014/main" id="{4649E085-8687-4564-8857-091187042DBF}"/>
               </a:ext>
             </a:extLst>
           </p:cNvPr>
@@ -6703,7 +6767,7 @@
           <p:cNvPr id="3" name="s4-title">
             <a:extLst xmlns:a="http://schemas.openxmlformats.org/drawingml/2006/main">
               <a:ext uri="{FF2B5EF4-FFF2-40B4-BE49-F238E27FC236}">
-                <a16:creationId xmlns:a16="http://schemas.microsoft.com/office/drawing/2014/main" id="{15575931-B3AE-4AD1-A14E-604B76DDBCB8}"/>
+                <a16:creationId xmlns:a16="http://schemas.microsoft.com/office/drawing/2014/main" id="{99784D35-2B94-42BF-BC4D-409CDE888ECE}"/>
               </a:ext>
             </a:extLst>
           </p:cNvPr>
@@ -6751,7 +6815,7 @@
                 <a:ea typeface="PingFang SC"/>
                 <a:cs typeface="PingFang SC"/>
               </a:rPr>
-              <a:t>Reason 关注“当前证据说明什么”</a:t>
+              <a:t>推理、规划与行动都要指向下一份证据</a:t>
             </a:r>
           </a:p>
         </p:txBody>
@@ -6761,7 +6825,7 @@
           <p:cNvPr id="4" name="s4-footer">
             <a:extLst xmlns:a="http://schemas.openxmlformats.org/drawingml/2006/main">
               <a:ext uri="{FF2B5EF4-FFF2-40B4-BE49-F238E27FC236}">
-                <a16:creationId xmlns:a16="http://schemas.microsoft.com/office/drawing/2014/main" id="{546887D5-67D3-45C1-95EA-8FA4874A4B56}"/>
+                <a16:creationId xmlns:a16="http://schemas.microsoft.com/office/drawing/2014/main" id="{E3586119-478B-4052-ADDA-E2C4BD637806}"/>
               </a:ext>
             </a:extLst>
           </p:cNvPr>
@@ -6792,7 +6856,7 @@
           <p:cNvPr id="5" name="s4-identity">
             <a:extLst xmlns:a="http://schemas.openxmlformats.org/drawingml/2006/main">
               <a:ext uri="{FF2B5EF4-FFF2-40B4-BE49-F238E27FC236}">
-                <a16:creationId xmlns:a16="http://schemas.microsoft.com/office/drawing/2014/main" id="{497369C9-BF9E-4488-8F7B-BD66DA405666}"/>
+                <a16:creationId xmlns:a16="http://schemas.microsoft.com/office/drawing/2014/main" id="{740F1014-3A9C-4B90-B64F-63A5AA2A5DFD}"/>
               </a:ext>
             </a:extLst>
           </p:cNvPr>
@@ -6850,7 +6914,7 @@
           <p:cNvPr id="6" name="core-no-0">
             <a:extLst xmlns:a="http://schemas.openxmlformats.org/drawingml/2006/main">
               <a:ext uri="{FF2B5EF4-FFF2-40B4-BE49-F238E27FC236}">
-                <a16:creationId xmlns:a16="http://schemas.microsoft.com/office/drawing/2014/main" id="{03844271-976A-44E5-9B9B-038A39BDB94A}"/>
+                <a16:creationId xmlns:a16="http://schemas.microsoft.com/office/drawing/2014/main" id="{37C5F235-D7D4-4E28-A5C9-347C9FCA8CD3}"/>
               </a:ext>
             </a:extLst>
           </p:cNvPr>
@@ -6882,7 +6946,7 @@
             <a:pPr algn="l">
               <a:defRPr sz="2250" b="1">
                 <a:solidFill>
-                  <a:srgbClr val="17A6C8"/>
+                  <a:srgbClr val="006B80"/>
                 </a:solidFill>
                 <a:latin typeface="PingFang SC"/>
                 <a:ea typeface="PingFang SC"/>
@@ -6892,7 +6956,7 @@
             <a:r>
               <a:rPr sz="2250" b="1">
                 <a:solidFill>
-                  <a:srgbClr val="17A6C8"/>
+                  <a:srgbClr val="006B80"/>
                 </a:solidFill>
                 <a:latin typeface="PingFang SC"/>
                 <a:ea typeface="PingFang SC"/>
@@ -6908,7 +6972,7 @@
           <p:cNvPr id="7" name="core-label-0">
             <a:extLst xmlns:a="http://schemas.openxmlformats.org/drawingml/2006/main">
               <a:ext uri="{FF2B5EF4-FFF2-40B4-BE49-F238E27FC236}">
-                <a16:creationId xmlns:a16="http://schemas.microsoft.com/office/drawing/2014/main" id="{F3A2FB36-96B8-447B-A326-D5B017870EF7}"/>
+                <a16:creationId xmlns:a16="http://schemas.microsoft.com/office/drawing/2014/main" id="{68662708-15DE-48A1-A2E9-18D9D3D841AC}"/>
               </a:ext>
             </a:extLst>
           </p:cNvPr>
@@ -6966,7 +7030,7 @@
           <p:cNvPr id="8" name="core-body-0">
             <a:extLst xmlns:a="http://schemas.openxmlformats.org/drawingml/2006/main">
               <a:ext uri="{FF2B5EF4-FFF2-40B4-BE49-F238E27FC236}">
-                <a16:creationId xmlns:a16="http://schemas.microsoft.com/office/drawing/2014/main" id="{2A924A0F-777C-46C9-BC42-49F6062B8EC7}"/>
+                <a16:creationId xmlns:a16="http://schemas.microsoft.com/office/drawing/2014/main" id="{11D446C1-F8A4-43B8-BFDD-E3990D4A949E}"/>
               </a:ext>
             </a:extLst>
           </p:cNvPr>
@@ -6990,7 +7054,7 @@
           </a:solidFill>
           <a:ln xmlns:a="http://schemas.openxmlformats.org/drawingml/2006/main" w="19050">
             <a:solidFill>
-              <a:srgbClr val="17A6C8"/>
+              <a:srgbClr val="006B80"/>
             </a:solidFill>
             <a:prstDash val="solid"/>
           </a:ln>
@@ -7020,7 +7084,7 @@
                 <a:ea typeface="PingFang SC"/>
                 <a:cs typeface="PingFang SC"/>
               </a:rPr>
-              <a:t>Reason 关注“当前证据说明什么”，Plan 关注“接下来做什么”。简单任务可以只选择一个下一动作；长任务则需要把目标拆成阶段、依赖和验收点。计划不是不可修改的剧本…</a:t>
+              <a:t>Reason 关注“当前证据说明什么”；Plan 关注“接下来做什么”；简单任务可以只选择一个下一动作；长任务则需要把目标拆成阶段、依赖和验收点；计划不是不可修改的剧本</a:t>
             </a:r>
           </a:p>
         </p:txBody>
@@ -7030,7 +7094,7 @@
           <p:cNvPr id="9" name="core-no-1">
             <a:extLst xmlns:a="http://schemas.openxmlformats.org/drawingml/2006/main">
               <a:ext uri="{FF2B5EF4-FFF2-40B4-BE49-F238E27FC236}">
-                <a16:creationId xmlns:a16="http://schemas.microsoft.com/office/drawing/2014/main" id="{324F68D2-7084-434B-AFC5-B64075844433}"/>
+                <a16:creationId xmlns:a16="http://schemas.microsoft.com/office/drawing/2014/main" id="{2B4A5FC6-66FF-49AD-8C08-855D8FED80FA}"/>
               </a:ext>
             </a:extLst>
           </p:cNvPr>
@@ -7062,7 +7126,7 @@
             <a:pPr algn="l">
               <a:defRPr sz="2250" b="1">
                 <a:solidFill>
-                  <a:srgbClr val="17A6C8"/>
+                  <a:srgbClr val="006B80"/>
                 </a:solidFill>
                 <a:latin typeface="PingFang SC"/>
                 <a:ea typeface="PingFang SC"/>
@@ -7072,7 +7136,7 @@
             <a:r>
               <a:rPr sz="2250" b="1">
                 <a:solidFill>
-                  <a:srgbClr val="17A6C8"/>
+                  <a:srgbClr val="006B80"/>
                 </a:solidFill>
                 <a:latin typeface="PingFang SC"/>
                 <a:ea typeface="PingFang SC"/>
@@ -7088,7 +7152,7 @@
           <p:cNvPr id="10" name="core-label-1">
             <a:extLst xmlns:a="http://schemas.openxmlformats.org/drawingml/2006/main">
               <a:ext uri="{FF2B5EF4-FFF2-40B4-BE49-F238E27FC236}">
-                <a16:creationId xmlns:a16="http://schemas.microsoft.com/office/drawing/2014/main" id="{AF06CB8C-6BCD-420D-92E7-ED6D0ACA5A63}"/>
+                <a16:creationId xmlns:a16="http://schemas.microsoft.com/office/drawing/2014/main" id="{186475B3-869A-4B9E-B602-09581DF7B0FC}"/>
               </a:ext>
             </a:extLst>
           </p:cNvPr>
@@ -7146,7 +7210,7 @@
           <p:cNvPr id="11" name="core-body-1">
             <a:extLst xmlns:a="http://schemas.openxmlformats.org/drawingml/2006/main">
               <a:ext uri="{FF2B5EF4-FFF2-40B4-BE49-F238E27FC236}">
-                <a16:creationId xmlns:a16="http://schemas.microsoft.com/office/drawing/2014/main" id="{52E2BEA3-C9DB-40A9-827B-26273A61B60B}"/>
+                <a16:creationId xmlns:a16="http://schemas.microsoft.com/office/drawing/2014/main" id="{DB92157C-719B-4A3B-866C-DE9EB0E371B6}"/>
               </a:ext>
             </a:extLst>
           </p:cNvPr>
@@ -7177,7 +7241,7 @@
         </p:spPr>
         <p:txBody>
           <a:bodyPr xmlns:a="http://schemas.openxmlformats.org/drawingml/2006/main" lIns="152400" tIns="133350" rIns="152400" bIns="133350" anchor="ctr">
-            <a:normAutofit fontScale="98233"/>
+            <a:normAutofit fontScale="100000"/>
           </a:bodyPr>
           <a:lstStyle xmlns:a="http://schemas.openxmlformats.org/drawingml/2006/main"/>
           <a:p xmlns:a="http://schemas.openxmlformats.org/drawingml/2006/main">
@@ -7200,7 +7264,7 @@
                 <a:ea typeface="PingFang SC"/>
                 <a:cs typeface="PingFang SC"/>
               </a:rPr>
-              <a:t>行动通过工具发生，例如查询资料、读取文件、调用接口、运行测试或修改记录。每个动作都应带有明确参数、预期结果、权限级别和失败处理。只读动作与写入动作要分开；可逆修改与外发、删除…</a:t>
+              <a:t>行动通过工具发生，例如查询资料、读取文件、调用接口、运行测试或修改记录；每个动作都应带有明确参数、预期结果、权限级别和失败处理；只读动作与写入动作要分开</a:t>
             </a:r>
           </a:p>
         </p:txBody>
@@ -7210,7 +7274,7 @@
           <p:cNvPr id="12" name="s4-takeaway-rule">
             <a:extLst xmlns:a="http://schemas.openxmlformats.org/drawingml/2006/main">
               <a:ext uri="{FF2B5EF4-FFF2-40B4-BE49-F238E27FC236}">
-                <a16:creationId xmlns:a16="http://schemas.microsoft.com/office/drawing/2014/main" id="{FD297F20-96F1-490E-821B-47F507B3FCBE}"/>
+                <a16:creationId xmlns:a16="http://schemas.microsoft.com/office/drawing/2014/main" id="{08A1A500-AB30-4924-B023-62752957C3CF}"/>
               </a:ext>
             </a:extLst>
           </p:cNvPr>
@@ -7243,7 +7307,7 @@
           <p:cNvPr id="13" name="s4-takeaway">
             <a:extLst xmlns:a="http://schemas.openxmlformats.org/drawingml/2006/main">
               <a:ext uri="{FF2B5EF4-FFF2-40B4-BE49-F238E27FC236}">
-                <a16:creationId xmlns:a16="http://schemas.microsoft.com/office/drawing/2014/main" id="{638AAB6B-9156-4371-99C9-11E35F118AD6}"/>
+                <a16:creationId xmlns:a16="http://schemas.microsoft.com/office/drawing/2014/main" id="{E2104934-B45C-4AF5-A014-4C77871AF7BF}"/>
               </a:ext>
             </a:extLst>
           </p:cNvPr>
@@ -7291,7 +7355,7 @@
                 <a:ea typeface="PingFang SC"/>
                 <a:cs typeface="PingFang SC"/>
               </a:rPr>
-              <a:t>Reason 关注“当前证据说明什么”</a:t>
+              <a:t>推理、规划与行动都要指向下一份证据</a:t>
             </a:r>
           </a:p>
         </p:txBody>
@@ -7299,7 +7363,7 @@
     </p:spTree>
     <p:extLst>
       <p:ext uri="{BB962C8B-B14F-4D97-AF65-F5344CB8AC3E}">
-        <p14:creationId xmlns:p14="http://schemas.microsoft.com/office/powerpoint/2010/main" val="1658884011"/>
+        <p14:creationId xmlns:p14="http://schemas.microsoft.com/office/powerpoint/2010/main" val="1192532674"/>
       </p:ext>
     </p:extLst>
   </p:cSld>
@@ -7330,7 +7394,7 @@
           <p:cNvPr id="1" name="s5-rule">
             <a:extLst xmlns:a="http://schemas.openxmlformats.org/drawingml/2006/main">
               <a:ext uri="{FF2B5EF4-FFF2-40B4-BE49-F238E27FC236}">
-                <a16:creationId xmlns:a16="http://schemas.microsoft.com/office/drawing/2014/main" id="{CEB05BEA-84D7-48BA-9D82-300011E7E39B}"/>
+                <a16:creationId xmlns:a16="http://schemas.microsoft.com/office/drawing/2014/main" id="{4F6C68C8-BD95-4384-8686-8D405F4FEADB}"/>
               </a:ext>
             </a:extLst>
           </p:cNvPr>
@@ -7363,7 +7427,7 @@
           <p:cNvPr id="2" name="s5-eyebrow">
             <a:extLst xmlns:a="http://schemas.openxmlformats.org/drawingml/2006/main">
               <a:ext uri="{FF2B5EF4-FFF2-40B4-BE49-F238E27FC236}">
-                <a16:creationId xmlns:a16="http://schemas.microsoft.com/office/drawing/2014/main" id="{2FD7A4EA-C942-4BB3-AD20-12A3FB2E766A}"/>
+                <a16:creationId xmlns:a16="http://schemas.microsoft.com/office/drawing/2014/main" id="{AB79F631-C1E8-4527-BCF7-CF4071EC3D5A}"/>
               </a:ext>
             </a:extLst>
           </p:cNvPr>
@@ -7421,7 +7485,7 @@
           <p:cNvPr id="3" name="s5-title">
             <a:extLst xmlns:a="http://schemas.openxmlformats.org/drawingml/2006/main">
               <a:ext uri="{FF2B5EF4-FFF2-40B4-BE49-F238E27FC236}">
-                <a16:creationId xmlns:a16="http://schemas.microsoft.com/office/drawing/2014/main" id="{01B0E0D7-7630-4AB4-BA31-A0965499356E}"/>
+                <a16:creationId xmlns:a16="http://schemas.microsoft.com/office/drawing/2014/main" id="{C43ED081-5577-40BC-9B61-B19A3C8F90BD}"/>
               </a:ext>
             </a:extLst>
           </p:cNvPr>
@@ -7479,7 +7543,7 @@
           <p:cNvPr id="4" name="s5-footer">
             <a:extLst xmlns:a="http://schemas.openxmlformats.org/drawingml/2006/main">
               <a:ext uri="{FF2B5EF4-FFF2-40B4-BE49-F238E27FC236}">
-                <a16:creationId xmlns:a16="http://schemas.microsoft.com/office/drawing/2014/main" id="{161871A0-BDD8-4FA7-939C-499CCEA08BE4}"/>
+                <a16:creationId xmlns:a16="http://schemas.microsoft.com/office/drawing/2014/main" id="{5404694E-A3A3-4E76-8BE4-DE378D0A9E10}"/>
               </a:ext>
             </a:extLst>
           </p:cNvPr>
@@ -7510,7 +7574,7 @@
           <p:cNvPr id="5" name="s5-identity">
             <a:extLst xmlns:a="http://schemas.openxmlformats.org/drawingml/2006/main">
               <a:ext uri="{FF2B5EF4-FFF2-40B4-BE49-F238E27FC236}">
-                <a16:creationId xmlns:a16="http://schemas.microsoft.com/office/drawing/2014/main" id="{8EF079C8-00A6-4EEC-BD67-88D96E67284D}"/>
+                <a16:creationId xmlns:a16="http://schemas.microsoft.com/office/drawing/2014/main" id="{AF2A715C-C8C8-48DB-88A4-992897B210EB}"/>
               </a:ext>
             </a:extLst>
           </p:cNvPr>
@@ -7568,7 +7632,7 @@
           <p:cNvPr id="6" name="core-no-0">
             <a:extLst xmlns:a="http://schemas.openxmlformats.org/drawingml/2006/main">
               <a:ext uri="{FF2B5EF4-FFF2-40B4-BE49-F238E27FC236}">
-                <a16:creationId xmlns:a16="http://schemas.microsoft.com/office/drawing/2014/main" id="{2AB143D4-866E-4CB3-A6CE-F74098479B00}"/>
+                <a16:creationId xmlns:a16="http://schemas.microsoft.com/office/drawing/2014/main" id="{72143334-AF57-4C95-9596-629553ED50C0}"/>
               </a:ext>
             </a:extLst>
           </p:cNvPr>
@@ -7600,7 +7664,7 @@
             <a:pPr algn="l">
               <a:defRPr sz="2250" b="1">
                 <a:solidFill>
-                  <a:srgbClr val="17A6C8"/>
+                  <a:srgbClr val="006B80"/>
                 </a:solidFill>
                 <a:latin typeface="PingFang SC"/>
                 <a:ea typeface="PingFang SC"/>
@@ -7610,7 +7674,7 @@
             <a:r>
               <a:rPr sz="2250" b="1">
                 <a:solidFill>
-                  <a:srgbClr val="17A6C8"/>
+                  <a:srgbClr val="006B80"/>
                 </a:solidFill>
                 <a:latin typeface="PingFang SC"/>
                 <a:ea typeface="PingFang SC"/>
@@ -7626,7 +7690,7 @@
           <p:cNvPr id="7" name="core-label-0">
             <a:extLst xmlns:a="http://schemas.openxmlformats.org/drawingml/2006/main">
               <a:ext uri="{FF2B5EF4-FFF2-40B4-BE49-F238E27FC236}">
-                <a16:creationId xmlns:a16="http://schemas.microsoft.com/office/drawing/2014/main" id="{E0E9C873-6957-47A5-B207-62148472B681}"/>
+                <a16:creationId xmlns:a16="http://schemas.microsoft.com/office/drawing/2014/main" id="{BDBFCF65-ECCA-4804-B6DA-F0707573012F}"/>
               </a:ext>
             </a:extLst>
           </p:cNvPr>
@@ -7684,7 +7748,7 @@
           <p:cNvPr id="8" name="core-body-0">
             <a:extLst xmlns:a="http://schemas.openxmlformats.org/drawingml/2006/main">
               <a:ext uri="{FF2B5EF4-FFF2-40B4-BE49-F238E27FC236}">
-                <a16:creationId xmlns:a16="http://schemas.microsoft.com/office/drawing/2014/main" id="{0641E160-3BF5-489A-AD31-B73BBA5E32A9}"/>
+                <a16:creationId xmlns:a16="http://schemas.microsoft.com/office/drawing/2014/main" id="{39146087-9BA9-482F-B325-F4A7BF2B7903}"/>
               </a:ext>
             </a:extLst>
           </p:cNvPr>
@@ -7708,7 +7772,7 @@
           </a:solidFill>
           <a:ln xmlns:a="http://schemas.openxmlformats.org/drawingml/2006/main" w="19050">
             <a:solidFill>
-              <a:srgbClr val="17A6C8"/>
+              <a:srgbClr val="006B80"/>
             </a:solidFill>
             <a:prstDash val="solid"/>
           </a:ln>
@@ -7738,7 +7802,7 @@
                 <a:ea typeface="PingFang SC"/>
                 <a:cs typeface="PingFang SC"/>
               </a:rPr>
-              <a:t>工具调用完成不等于任务完成。智能体要读取真实返回：是否成功、返回了什么、是否只完成一部分、是否出现警告、环境是否被改变。超时不能被解释为成功，空结果也不能被自动补写成“没有问题”…</a:t>
+              <a:t>工具调用完成不等于任务完成；智能体要读取真实返回；是否成功、返回了什么、是否只完成一部分、是否出现警告、环境是否被改变；超时不能被解释为成功；空结果也不能被自动补写成“没有问题”</a:t>
             </a:r>
           </a:p>
         </p:txBody>
@@ -7748,7 +7812,7 @@
           <p:cNvPr id="9" name="s5-takeaway-rule">
             <a:extLst xmlns:a="http://schemas.openxmlformats.org/drawingml/2006/main">
               <a:ext uri="{FF2B5EF4-FFF2-40B4-BE49-F238E27FC236}">
-                <a16:creationId xmlns:a16="http://schemas.microsoft.com/office/drawing/2014/main" id="{B77EEB7A-24A6-420A-95A8-3000E280F494}"/>
+                <a16:creationId xmlns:a16="http://schemas.microsoft.com/office/drawing/2014/main" id="{2F8AC2F8-6F2F-4123-B1D8-94FE7274400E}"/>
               </a:ext>
             </a:extLst>
           </p:cNvPr>
@@ -7781,7 +7845,7 @@
           <p:cNvPr id="10" name="s5-takeaway">
             <a:extLst xmlns:a="http://schemas.openxmlformats.org/drawingml/2006/main">
               <a:ext uri="{FF2B5EF4-FFF2-40B4-BE49-F238E27FC236}">
-                <a16:creationId xmlns:a16="http://schemas.microsoft.com/office/drawing/2014/main" id="{CD77ACE5-2D3C-4FEC-8743-31BE56F4B72F}"/>
+                <a16:creationId xmlns:a16="http://schemas.microsoft.com/office/drawing/2014/main" id="{C907EDAC-B663-4EEA-9C35-064D6F49400F}"/>
               </a:ext>
             </a:extLst>
           </p:cNvPr>
@@ -7837,7 +7901,7 @@
     </p:spTree>
     <p:extLst>
       <p:ext uri="{BB962C8B-B14F-4D97-AF65-F5344CB8AC3E}">
-        <p14:creationId xmlns:p14="http://schemas.microsoft.com/office/powerpoint/2010/main" val="1844509303"/>
+        <p14:creationId xmlns:p14="http://schemas.microsoft.com/office/powerpoint/2010/main" val="95156816"/>
       </p:ext>
     </p:extLst>
   </p:cSld>
@@ -7868,7 +7932,7 @@
           <p:cNvPr id="1" name="s6-rule">
             <a:extLst xmlns:a="http://schemas.openxmlformats.org/drawingml/2006/main">
               <a:ext uri="{FF2B5EF4-FFF2-40B4-BE49-F238E27FC236}">
-                <a16:creationId xmlns:a16="http://schemas.microsoft.com/office/drawing/2014/main" id="{BFAB87FE-2A74-40A8-993B-ACD931CC4D59}"/>
+                <a16:creationId xmlns:a16="http://schemas.microsoft.com/office/drawing/2014/main" id="{307CA866-E552-485D-AE4F-2D925EF2814B}"/>
               </a:ext>
             </a:extLst>
           </p:cNvPr>
@@ -7901,7 +7965,7 @@
           <p:cNvPr id="2" name="s6-eyebrow">
             <a:extLst xmlns:a="http://schemas.openxmlformats.org/drawingml/2006/main">
               <a:ext uri="{FF2B5EF4-FFF2-40B4-BE49-F238E27FC236}">
-                <a16:creationId xmlns:a16="http://schemas.microsoft.com/office/drawing/2014/main" id="{78A5BA04-3596-405C-993A-E773EF951E04}"/>
+                <a16:creationId xmlns:a16="http://schemas.microsoft.com/office/drawing/2014/main" id="{8DC7F3AE-9E19-45C7-9228-6600C78FFF2D}"/>
               </a:ext>
             </a:extLst>
           </p:cNvPr>
@@ -7959,7 +8023,7 @@
           <p:cNvPr id="3" name="s6-title">
             <a:extLst xmlns:a="http://schemas.openxmlformats.org/drawingml/2006/main">
               <a:ext uri="{FF2B5EF4-FFF2-40B4-BE49-F238E27FC236}">
-                <a16:creationId xmlns:a16="http://schemas.microsoft.com/office/drawing/2014/main" id="{510053B6-5A55-40C4-B375-E7F9C7CC70F6}"/>
+                <a16:creationId xmlns:a16="http://schemas.microsoft.com/office/drawing/2014/main" id="{1B78C618-0690-40A7-8FFA-DADA8AC4DA47}"/>
               </a:ext>
             </a:extLst>
           </p:cNvPr>
@@ -8017,7 +8081,7 @@
           <p:cNvPr id="4" name="s6-footer">
             <a:extLst xmlns:a="http://schemas.openxmlformats.org/drawingml/2006/main">
               <a:ext uri="{FF2B5EF4-FFF2-40B4-BE49-F238E27FC236}">
-                <a16:creationId xmlns:a16="http://schemas.microsoft.com/office/drawing/2014/main" id="{51D172A8-063C-45F9-A2E5-8B46E0A1AF3A}"/>
+                <a16:creationId xmlns:a16="http://schemas.microsoft.com/office/drawing/2014/main" id="{EEDCFB98-BF40-49C0-874E-423B5D4AF635}"/>
               </a:ext>
             </a:extLst>
           </p:cNvPr>
@@ -8048,7 +8112,7 @@
           <p:cNvPr id="5" name="s6-identity">
             <a:extLst xmlns:a="http://schemas.openxmlformats.org/drawingml/2006/main">
               <a:ext uri="{FF2B5EF4-FFF2-40B4-BE49-F238E27FC236}">
-                <a16:creationId xmlns:a16="http://schemas.microsoft.com/office/drawing/2014/main" id="{B16E7EC8-9B5E-4194-BB5E-1FA81A65D14F}"/>
+                <a16:creationId xmlns:a16="http://schemas.microsoft.com/office/drawing/2014/main" id="{9CC71D13-429C-4C77-8E6E-A5F010CA1DE3}"/>
               </a:ext>
             </a:extLst>
           </p:cNvPr>
@@ -8106,7 +8170,7 @@
           <p:cNvPr id="6" name="core-no-0">
             <a:extLst xmlns:a="http://schemas.openxmlformats.org/drawingml/2006/main">
               <a:ext uri="{FF2B5EF4-FFF2-40B4-BE49-F238E27FC236}">
-                <a16:creationId xmlns:a16="http://schemas.microsoft.com/office/drawing/2014/main" id="{99126D21-3942-40E9-B6D5-4FBD8744925C}"/>
+                <a16:creationId xmlns:a16="http://schemas.microsoft.com/office/drawing/2014/main" id="{550EF425-901B-4140-8031-0C6A949A6D91}"/>
               </a:ext>
             </a:extLst>
           </p:cNvPr>
@@ -8138,7 +8202,7 @@
             <a:pPr algn="l">
               <a:defRPr sz="2250" b="1">
                 <a:solidFill>
-                  <a:srgbClr val="17A6C8"/>
+                  <a:srgbClr val="006B80"/>
                 </a:solidFill>
                 <a:latin typeface="PingFang SC"/>
                 <a:ea typeface="PingFang SC"/>
@@ -8148,7 +8212,7 @@
             <a:r>
               <a:rPr sz="2250" b="1">
                 <a:solidFill>
-                  <a:srgbClr val="17A6C8"/>
+                  <a:srgbClr val="006B80"/>
                 </a:solidFill>
                 <a:latin typeface="PingFang SC"/>
                 <a:ea typeface="PingFang SC"/>
@@ -8164,7 +8228,7 @@
           <p:cNvPr id="7" name="core-label-0">
             <a:extLst xmlns:a="http://schemas.openxmlformats.org/drawingml/2006/main">
               <a:ext uri="{FF2B5EF4-FFF2-40B4-BE49-F238E27FC236}">
-                <a16:creationId xmlns:a16="http://schemas.microsoft.com/office/drawing/2014/main" id="{D977B522-B033-4F2F-8C92-C84BC33A59FA}"/>
+                <a16:creationId xmlns:a16="http://schemas.microsoft.com/office/drawing/2014/main" id="{59CA97DF-5450-41D1-B473-CFECE5EC5438}"/>
               </a:ext>
             </a:extLst>
           </p:cNvPr>
@@ -8222,7 +8286,7 @@
           <p:cNvPr id="8" name="core-body-0">
             <a:extLst xmlns:a="http://schemas.openxmlformats.org/drawingml/2006/main">
               <a:ext uri="{FF2B5EF4-FFF2-40B4-BE49-F238E27FC236}">
-                <a16:creationId xmlns:a16="http://schemas.microsoft.com/office/drawing/2014/main" id="{6C04B4E6-CF64-4EAD-BEF5-D4F2FFB61EEC}"/>
+                <a16:creationId xmlns:a16="http://schemas.microsoft.com/office/drawing/2014/main" id="{CFA3CE73-A5EC-46B3-9DD3-5F8B95587ADB}"/>
               </a:ext>
             </a:extLst>
           </p:cNvPr>
@@ -8246,7 +8310,7 @@
           </a:solidFill>
           <a:ln xmlns:a="http://schemas.openxmlformats.org/drawingml/2006/main" w="19050">
             <a:solidFill>
-              <a:srgbClr val="17A6C8"/>
+              <a:srgbClr val="006B80"/>
             </a:solidFill>
             <a:prstDash val="solid"/>
           </a:ln>
@@ -8276,7 +8340,7 @@
                 <a:ea typeface="PingFang SC"/>
                 <a:cs typeface="PingFang SC"/>
               </a:rPr>
-              <a:t>Evaluate 把当前结果与验收标准比较。它既检查最终目标，也检查过程约束：结果是否完整，证据是否足够，是否使用了允许的数据和权限，是否引入新的风险。如果不满足标准…</a:t>
+              <a:t>Evaluate 把当前结果与验收标准比较；它既检查最终目标，也检查过程约束；结果是否完整，证据是否足够；是否使用了允许的数据和权限；是否引入新的风险，如果不满足标准</a:t>
             </a:r>
           </a:p>
         </p:txBody>
@@ -8286,7 +8350,7 @@
           <p:cNvPr id="9" name="s6-takeaway-rule">
             <a:extLst xmlns:a="http://schemas.openxmlformats.org/drawingml/2006/main">
               <a:ext uri="{FF2B5EF4-FFF2-40B4-BE49-F238E27FC236}">
-                <a16:creationId xmlns:a16="http://schemas.microsoft.com/office/drawing/2014/main" id="{D704756E-F274-489F-9F95-6437DF79E04C}"/>
+                <a16:creationId xmlns:a16="http://schemas.microsoft.com/office/drawing/2014/main" id="{B549A2EF-576D-46B6-BB13-C4915CECD509}"/>
               </a:ext>
             </a:extLst>
           </p:cNvPr>
@@ -8319,7 +8383,7 @@
           <p:cNvPr id="10" name="s6-takeaway">
             <a:extLst xmlns:a="http://schemas.openxmlformats.org/drawingml/2006/main">
               <a:ext uri="{FF2B5EF4-FFF2-40B4-BE49-F238E27FC236}">
-                <a16:creationId xmlns:a16="http://schemas.microsoft.com/office/drawing/2014/main" id="{5573EE45-E2FF-41F9-ACC4-ED9228F45850}"/>
+                <a16:creationId xmlns:a16="http://schemas.microsoft.com/office/drawing/2014/main" id="{949A9016-E3A7-4C21-8AB1-DC9AD8E2C769}"/>
               </a:ext>
             </a:extLst>
           </p:cNvPr>
@@ -8375,7 +8439,7 @@
     </p:spTree>
     <p:extLst>
       <p:ext uri="{BB962C8B-B14F-4D97-AF65-F5344CB8AC3E}">
-        <p14:creationId xmlns:p14="http://schemas.microsoft.com/office/powerpoint/2010/main" val="1650152591"/>
+        <p14:creationId xmlns:p14="http://schemas.microsoft.com/office/powerpoint/2010/main" val="1688683979"/>
       </p:ext>
     </p:extLst>
   </p:cSld>
@@ -8406,7 +8470,7 @@
           <p:cNvPr id="1" name="s7-rule">
             <a:extLst xmlns:a="http://schemas.openxmlformats.org/drawingml/2006/main">
               <a:ext uri="{FF2B5EF4-FFF2-40B4-BE49-F238E27FC236}">
-                <a16:creationId xmlns:a16="http://schemas.microsoft.com/office/drawing/2014/main" id="{31C3BE5E-931D-4B5E-9753-81020432C82D}"/>
+                <a16:creationId xmlns:a16="http://schemas.microsoft.com/office/drawing/2014/main" id="{6A995D1F-0BD7-42F4-A23B-71B29700AD68}"/>
               </a:ext>
             </a:extLst>
           </p:cNvPr>
@@ -8439,7 +8503,7 @@
           <p:cNvPr id="2" name="s7-eyebrow">
             <a:extLst xmlns:a="http://schemas.openxmlformats.org/drawingml/2006/main">
               <a:ext uri="{FF2B5EF4-FFF2-40B4-BE49-F238E27FC236}">
-                <a16:creationId xmlns:a16="http://schemas.microsoft.com/office/drawing/2014/main" id="{CE3FD163-AB5B-4E5A-8B4B-B17254997298}"/>
+                <a16:creationId xmlns:a16="http://schemas.microsoft.com/office/drawing/2014/main" id="{81D0001E-5109-4C62-9029-5E9A51A5E622}"/>
               </a:ext>
             </a:extLst>
           </p:cNvPr>
@@ -8497,7 +8561,7 @@
           <p:cNvPr id="3" name="s7-title">
             <a:extLst xmlns:a="http://schemas.openxmlformats.org/drawingml/2006/main">
               <a:ext uri="{FF2B5EF4-FFF2-40B4-BE49-F238E27FC236}">
-                <a16:creationId xmlns:a16="http://schemas.microsoft.com/office/drawing/2014/main" id="{97E35E40-946F-4477-8DD4-32B608A2F391}"/>
+                <a16:creationId xmlns:a16="http://schemas.microsoft.com/office/drawing/2014/main" id="{8E4AF6E5-FCBC-4CAE-8C52-99883A6E837F}"/>
               </a:ext>
             </a:extLst>
           </p:cNvPr>
@@ -8555,7 +8619,7 @@
           <p:cNvPr id="4" name="s7-footer">
             <a:extLst xmlns:a="http://schemas.openxmlformats.org/drawingml/2006/main">
               <a:ext uri="{FF2B5EF4-FFF2-40B4-BE49-F238E27FC236}">
-                <a16:creationId xmlns:a16="http://schemas.microsoft.com/office/drawing/2014/main" id="{BD40CA84-41A6-437E-BB8E-D7EA349C24FB}"/>
+                <a16:creationId xmlns:a16="http://schemas.microsoft.com/office/drawing/2014/main" id="{CE1E8C2D-1B5B-43A4-BB91-842B772E9092}"/>
               </a:ext>
             </a:extLst>
           </p:cNvPr>
@@ -8586,7 +8650,7 @@
           <p:cNvPr id="5" name="s7-identity">
             <a:extLst xmlns:a="http://schemas.openxmlformats.org/drawingml/2006/main">
               <a:ext uri="{FF2B5EF4-FFF2-40B4-BE49-F238E27FC236}">
-                <a16:creationId xmlns:a16="http://schemas.microsoft.com/office/drawing/2014/main" id="{33FD43DD-9C8D-4D91-A642-A2BC98274033}"/>
+                <a16:creationId xmlns:a16="http://schemas.microsoft.com/office/drawing/2014/main" id="{59C7ACBD-BE10-4ACF-9CBF-6455248D6739}"/>
               </a:ext>
             </a:extLst>
           </p:cNvPr>
@@ -8644,7 +8708,7 @@
           <p:cNvPr id="6" name="core-no-0">
             <a:extLst xmlns:a="http://schemas.openxmlformats.org/drawingml/2006/main">
               <a:ext uri="{FF2B5EF4-FFF2-40B4-BE49-F238E27FC236}">
-                <a16:creationId xmlns:a16="http://schemas.microsoft.com/office/drawing/2014/main" id="{60728A89-959D-4241-A2B1-6CDA238EA8DF}"/>
+                <a16:creationId xmlns:a16="http://schemas.microsoft.com/office/drawing/2014/main" id="{D2C9B90E-6178-4DA5-BE29-5EE8255C5A1E}"/>
               </a:ext>
             </a:extLst>
           </p:cNvPr>
@@ -8676,7 +8740,7 @@
             <a:pPr algn="l">
               <a:defRPr sz="2250" b="1">
                 <a:solidFill>
-                  <a:srgbClr val="17A6C8"/>
+                  <a:srgbClr val="006B80"/>
                 </a:solidFill>
                 <a:latin typeface="PingFang SC"/>
                 <a:ea typeface="PingFang SC"/>
@@ -8686,7 +8750,7 @@
             <a:r>
               <a:rPr sz="2250" b="1">
                 <a:solidFill>
-                  <a:srgbClr val="17A6C8"/>
+                  <a:srgbClr val="006B80"/>
                 </a:solidFill>
                 <a:latin typeface="PingFang SC"/>
                 <a:ea typeface="PingFang SC"/>
@@ -8702,7 +8766,7 @@
           <p:cNvPr id="7" name="core-label-0">
             <a:extLst xmlns:a="http://schemas.openxmlformats.org/drawingml/2006/main">
               <a:ext uri="{FF2B5EF4-FFF2-40B4-BE49-F238E27FC236}">
-                <a16:creationId xmlns:a16="http://schemas.microsoft.com/office/drawing/2014/main" id="{2F85421A-E110-4181-8B15-62B266729571}"/>
+                <a16:creationId xmlns:a16="http://schemas.microsoft.com/office/drawing/2014/main" id="{98270346-42B8-4F11-8F88-A2D4AF9F2D65}"/>
               </a:ext>
             </a:extLst>
           </p:cNvPr>
@@ -8760,7 +8824,7 @@
           <p:cNvPr id="8" name="core-body-0">
             <a:extLst xmlns:a="http://schemas.openxmlformats.org/drawingml/2006/main">
               <a:ext uri="{FF2B5EF4-FFF2-40B4-BE49-F238E27FC236}">
-                <a16:creationId xmlns:a16="http://schemas.microsoft.com/office/drawing/2014/main" id="{F5AD033D-D421-4D01-8DFA-505A9A55652F}"/>
+                <a16:creationId xmlns:a16="http://schemas.microsoft.com/office/drawing/2014/main" id="{44FF4B79-011A-4862-8638-5E2F8909A36B}"/>
               </a:ext>
             </a:extLst>
           </p:cNvPr>
@@ -8784,14 +8848,14 @@
           </a:solidFill>
           <a:ln xmlns:a="http://schemas.openxmlformats.org/drawingml/2006/main" w="19050">
             <a:solidFill>
-              <a:srgbClr val="17A6C8"/>
+              <a:srgbClr val="006B80"/>
             </a:solidFill>
             <a:prstDash val="solid"/>
           </a:ln>
         </p:spPr>
         <p:txBody>
           <a:bodyPr xmlns:a="http://schemas.openxmlformats.org/drawingml/2006/main" lIns="152400" tIns="133350" rIns="152400" bIns="133350" anchor="ctr">
-            <a:normAutofit fontScale="92156"/>
+            <a:normAutofit fontScale="98233"/>
           </a:bodyPr>
           <a:lstStyle xmlns:a="http://schemas.openxmlformats.org/drawingml/2006/main"/>
           <a:p xmlns:a="http://schemas.openxmlformats.org/drawingml/2006/main">
@@ -8814,7 +8878,7 @@
                 <a:ea typeface="PingFang SC"/>
                 <a:cs typeface="PingFang SC"/>
               </a:rPr>
-              <a:t>ReAct 的关键思想，是让任务求解在“形成行动依据—采取行动—读取观察”之间交错进行。模型不必在一开始猜出全部步骤，而是用环境反馈更新判断。例如，检索未找到目标资料时，它可以调整关键词…</a:t>
+              <a:t>ReAct 的关键思想；是让任务求解在“形成行动依据—采取行动—读取观察”之间交错进行；模型不必在一开始猜出全部步骤；而是用环境反馈更新判断；例如，检索未找到目标资料时</a:t>
             </a:r>
           </a:p>
         </p:txBody>
@@ -8824,7 +8888,7 @@
           <p:cNvPr id="9" name="core-no-1">
             <a:extLst xmlns:a="http://schemas.openxmlformats.org/drawingml/2006/main">
               <a:ext uri="{FF2B5EF4-FFF2-40B4-BE49-F238E27FC236}">
-                <a16:creationId xmlns:a16="http://schemas.microsoft.com/office/drawing/2014/main" id="{523AD0FD-5EED-413C-BEB5-3D9B497EC83E}"/>
+                <a16:creationId xmlns:a16="http://schemas.microsoft.com/office/drawing/2014/main" id="{C7CFE545-9C15-434F-85A6-CE16D079F7A7}"/>
               </a:ext>
             </a:extLst>
           </p:cNvPr>
@@ -8856,7 +8920,7 @@
             <a:pPr algn="l">
               <a:defRPr sz="2250" b="1">
                 <a:solidFill>
-                  <a:srgbClr val="17A6C8"/>
+                  <a:srgbClr val="006B80"/>
                 </a:solidFill>
                 <a:latin typeface="PingFang SC"/>
                 <a:ea typeface="PingFang SC"/>
@@ -8866,7 +8930,7 @@
             <a:r>
               <a:rPr sz="2250" b="1">
                 <a:solidFill>
-                  <a:srgbClr val="17A6C8"/>
+                  <a:srgbClr val="006B80"/>
                 </a:solidFill>
                 <a:latin typeface="PingFang SC"/>
                 <a:ea typeface="PingFang SC"/>
@@ -8882,7 +8946,7 @@
           <p:cNvPr id="10" name="core-body-1">
             <a:extLst xmlns:a="http://schemas.openxmlformats.org/drawingml/2006/main">
               <a:ext uri="{FF2B5EF4-FFF2-40B4-BE49-F238E27FC236}">
-                <a16:creationId xmlns:a16="http://schemas.microsoft.com/office/drawing/2014/main" id="{D88DEDDA-2CFE-428D-950F-D026E4556ED9}"/>
+                <a16:creationId xmlns:a16="http://schemas.microsoft.com/office/drawing/2014/main" id="{6FEBA8A3-0025-49D4-87CE-08C16F44ED0F}"/>
               </a:ext>
             </a:extLst>
           </p:cNvPr>
@@ -8946,7 +9010,7 @@
           <p:cNvPr id="11" name="s7-takeaway-rule">
             <a:extLst xmlns:a="http://schemas.openxmlformats.org/drawingml/2006/main">
               <a:ext uri="{FF2B5EF4-FFF2-40B4-BE49-F238E27FC236}">
-                <a16:creationId xmlns:a16="http://schemas.microsoft.com/office/drawing/2014/main" id="{491E22CE-6EB5-46E2-8FB8-00281E687653}"/>
+                <a16:creationId xmlns:a16="http://schemas.microsoft.com/office/drawing/2014/main" id="{74247376-8CCC-453C-A22B-3F4167717C75}"/>
               </a:ext>
             </a:extLst>
           </p:cNvPr>
@@ -8979,7 +9043,7 @@
           <p:cNvPr id="12" name="s7-takeaway">
             <a:extLst xmlns:a="http://schemas.openxmlformats.org/drawingml/2006/main">
               <a:ext uri="{FF2B5EF4-FFF2-40B4-BE49-F238E27FC236}">
-                <a16:creationId xmlns:a16="http://schemas.microsoft.com/office/drawing/2014/main" id="{4B17A508-9D67-45B2-AD0B-4C9B3D5F78D7}"/>
+                <a16:creationId xmlns:a16="http://schemas.microsoft.com/office/drawing/2014/main" id="{86D4B413-9BFD-4119-8090-6C81080A0EA8}"/>
               </a:ext>
             </a:extLst>
           </p:cNvPr>
@@ -9035,7 +9099,7 @@
     </p:spTree>
     <p:extLst>
       <p:ext uri="{BB962C8B-B14F-4D97-AF65-F5344CB8AC3E}">
-        <p14:creationId xmlns:p14="http://schemas.microsoft.com/office/powerpoint/2010/main" val="1421404608"/>
+        <p14:creationId xmlns:p14="http://schemas.microsoft.com/office/powerpoint/2010/main" val="1600800767"/>
       </p:ext>
     </p:extLst>
   </p:cSld>
@@ -9066,7 +9130,7 @@
           <p:cNvPr id="1" name="s8-rule">
             <a:extLst xmlns:a="http://schemas.openxmlformats.org/drawingml/2006/main">
               <a:ext uri="{FF2B5EF4-FFF2-40B4-BE49-F238E27FC236}">
-                <a16:creationId xmlns:a16="http://schemas.microsoft.com/office/drawing/2014/main" id="{9136E5FB-C1C2-41BC-85CF-0D2A91389372}"/>
+                <a16:creationId xmlns:a16="http://schemas.microsoft.com/office/drawing/2014/main" id="{60779FD2-088A-4BE1-A270-CAA4A5D10721}"/>
               </a:ext>
             </a:extLst>
           </p:cNvPr>
@@ -9099,7 +9163,7 @@
           <p:cNvPr id="2" name="s8-eyebrow">
             <a:extLst xmlns:a="http://schemas.openxmlformats.org/drawingml/2006/main">
               <a:ext uri="{FF2B5EF4-FFF2-40B4-BE49-F238E27FC236}">
-                <a16:creationId xmlns:a16="http://schemas.microsoft.com/office/drawing/2014/main" id="{13EC27FA-DAF1-4D20-9FA9-97DA2905244A}"/>
+                <a16:creationId xmlns:a16="http://schemas.microsoft.com/office/drawing/2014/main" id="{A0CB59E0-09A1-4537-8713-CE8D3E1385DC}"/>
               </a:ext>
             </a:extLst>
           </p:cNvPr>
@@ -9157,7 +9221,7 @@
           <p:cNvPr id="3" name="s8-title">
             <a:extLst xmlns:a="http://schemas.openxmlformats.org/drawingml/2006/main">
               <a:ext uri="{FF2B5EF4-FFF2-40B4-BE49-F238E27FC236}">
-                <a16:creationId xmlns:a16="http://schemas.microsoft.com/office/drawing/2014/main" id="{C8BEC25E-FDFD-495A-A27C-E45C5ADDE154}"/>
+                <a16:creationId xmlns:a16="http://schemas.microsoft.com/office/drawing/2014/main" id="{CDE49A52-B015-43BE-A8AE-5F85D9C1E41B}"/>
               </a:ext>
             </a:extLst>
           </p:cNvPr>
@@ -9215,7 +9279,7 @@
           <p:cNvPr id="4" name="s8-footer">
             <a:extLst xmlns:a="http://schemas.openxmlformats.org/drawingml/2006/main">
               <a:ext uri="{FF2B5EF4-FFF2-40B4-BE49-F238E27FC236}">
-                <a16:creationId xmlns:a16="http://schemas.microsoft.com/office/drawing/2014/main" id="{BA02B88F-AB82-44CF-BC5D-1057B63EF516}"/>
+                <a16:creationId xmlns:a16="http://schemas.microsoft.com/office/drawing/2014/main" id="{AD5482F7-6FEF-42D9-800B-97BD7A508162}"/>
               </a:ext>
             </a:extLst>
           </p:cNvPr>
@@ -9246,7 +9310,7 @@
           <p:cNvPr id="5" name="s8-identity">
             <a:extLst xmlns:a="http://schemas.openxmlformats.org/drawingml/2006/main">
               <a:ext uri="{FF2B5EF4-FFF2-40B4-BE49-F238E27FC236}">
-                <a16:creationId xmlns:a16="http://schemas.microsoft.com/office/drawing/2014/main" id="{0BBCC222-8FFC-47C7-8A81-A0EEF3B721EA}"/>
+                <a16:creationId xmlns:a16="http://schemas.microsoft.com/office/drawing/2014/main" id="{469649F4-A242-4CA9-A628-81F2C3458F14}"/>
               </a:ext>
             </a:extLst>
           </p:cNvPr>
@@ -9304,7 +9368,7 @@
           <p:cNvPr id="6" name="core-no-0">
             <a:extLst xmlns:a="http://schemas.openxmlformats.org/drawingml/2006/main">
               <a:ext uri="{FF2B5EF4-FFF2-40B4-BE49-F238E27FC236}">
-                <a16:creationId xmlns:a16="http://schemas.microsoft.com/office/drawing/2014/main" id="{FE477900-84B2-4260-BB75-441C2F9126C0}"/>
+                <a16:creationId xmlns:a16="http://schemas.microsoft.com/office/drawing/2014/main" id="{7D4122D9-D231-42D5-BC51-ECEFFBA11502}"/>
               </a:ext>
             </a:extLst>
           </p:cNvPr>
@@ -9336,7 +9400,7 @@
             <a:pPr algn="l">
               <a:defRPr sz="2250" b="1">
                 <a:solidFill>
-                  <a:srgbClr val="17A6C8"/>
+                  <a:srgbClr val="006B80"/>
                 </a:solidFill>
                 <a:latin typeface="PingFang SC"/>
                 <a:ea typeface="PingFang SC"/>
@@ -9346,7 +9410,7 @@
             <a:r>
               <a:rPr sz="2250" b="1">
                 <a:solidFill>
-                  <a:srgbClr val="17A6C8"/>
+                  <a:srgbClr val="006B80"/>
                 </a:solidFill>
                 <a:latin typeface="PingFang SC"/>
                 <a:ea typeface="PingFang SC"/>
@@ -9362,7 +9426,7 @@
           <p:cNvPr id="7" name="core-label-0">
             <a:extLst xmlns:a="http://schemas.openxmlformats.org/drawingml/2006/main">
               <a:ext uri="{FF2B5EF4-FFF2-40B4-BE49-F238E27FC236}">
-                <a16:creationId xmlns:a16="http://schemas.microsoft.com/office/drawing/2014/main" id="{45BB3305-CDAD-477F-9EB2-7A0F08B24456}"/>
+                <a16:creationId xmlns:a16="http://schemas.microsoft.com/office/drawing/2014/main" id="{2C66B7C3-EBB2-47EF-AF8E-348E954493AF}"/>
               </a:ext>
             </a:extLst>
           </p:cNvPr>
@@ -9420,7 +9484,7 @@
           <p:cNvPr id="8" name="core-body-0">
             <a:extLst xmlns:a="http://schemas.openxmlformats.org/drawingml/2006/main">
               <a:ext uri="{FF2B5EF4-FFF2-40B4-BE49-F238E27FC236}">
-                <a16:creationId xmlns:a16="http://schemas.microsoft.com/office/drawing/2014/main" id="{558DCA33-33FF-4D5E-9549-FB5C3324B308}"/>
+                <a16:creationId xmlns:a16="http://schemas.microsoft.com/office/drawing/2014/main" id="{CF786D3A-516A-490C-AFEC-825501C9CE38}"/>
               </a:ext>
             </a:extLst>
           </p:cNvPr>
@@ -9444,7 +9508,7 @@
           </a:solidFill>
           <a:ln xmlns:a="http://schemas.openxmlformats.org/drawingml/2006/main" w="19050">
             <a:solidFill>
-              <a:srgbClr val="17A6C8"/>
+              <a:srgbClr val="006B80"/>
             </a:solidFill>
             <a:prstDash val="solid"/>
           </a:ln>
@@ -9484,7 +9548,7 @@
           <p:cNvPr id="9" name="s8-takeaway-rule">
             <a:extLst xmlns:a="http://schemas.openxmlformats.org/drawingml/2006/main">
               <a:ext uri="{FF2B5EF4-FFF2-40B4-BE49-F238E27FC236}">
-                <a16:creationId xmlns:a16="http://schemas.microsoft.com/office/drawing/2014/main" id="{332E6ED6-8787-4A74-920E-4432F25B20F4}"/>
+                <a16:creationId xmlns:a16="http://schemas.microsoft.com/office/drawing/2014/main" id="{2CF16262-6BD9-4C4B-9386-6AEF9CF2E3B5}"/>
               </a:ext>
             </a:extLst>
           </p:cNvPr>
@@ -9517,7 +9581,7 @@
           <p:cNvPr id="10" name="s8-takeaway">
             <a:extLst xmlns:a="http://schemas.openxmlformats.org/drawingml/2006/main">
               <a:ext uri="{FF2B5EF4-FFF2-40B4-BE49-F238E27FC236}">
-                <a16:creationId xmlns:a16="http://schemas.microsoft.com/office/drawing/2014/main" id="{44245B26-9A25-45B5-92FC-21B3A075AAEC}"/>
+                <a16:creationId xmlns:a16="http://schemas.microsoft.com/office/drawing/2014/main" id="{779834FC-E1C7-41AB-B888-71B800951B70}"/>
               </a:ext>
             </a:extLst>
           </p:cNvPr>
@@ -9573,7 +9637,7 @@
     </p:spTree>
     <p:extLst>
       <p:ext uri="{BB962C8B-B14F-4D97-AF65-F5344CB8AC3E}">
-        <p14:creationId xmlns:p14="http://schemas.microsoft.com/office/powerpoint/2010/main" val="1607435228"/>
+        <p14:creationId xmlns:p14="http://schemas.microsoft.com/office/powerpoint/2010/main" val="638321961"/>
       </p:ext>
     </p:extLst>
   </p:cSld>
@@ -9604,7 +9668,7 @@
           <p:cNvPr id="1" name="s9-rule">
             <a:extLst xmlns:a="http://schemas.openxmlformats.org/drawingml/2006/main">
               <a:ext uri="{FF2B5EF4-FFF2-40B4-BE49-F238E27FC236}">
-                <a16:creationId xmlns:a16="http://schemas.microsoft.com/office/drawing/2014/main" id="{9DB8C90C-A001-425B-8405-02A23A10C3C1}"/>
+                <a16:creationId xmlns:a16="http://schemas.microsoft.com/office/drawing/2014/main" id="{8F213729-BBFD-45C3-B098-144B82162F8B}"/>
               </a:ext>
             </a:extLst>
           </p:cNvPr>
@@ -9637,7 +9701,7 @@
           <p:cNvPr id="2" name="s9-eyebrow">
             <a:extLst xmlns:a="http://schemas.openxmlformats.org/drawingml/2006/main">
               <a:ext uri="{FF2B5EF4-FFF2-40B4-BE49-F238E27FC236}">
-                <a16:creationId xmlns:a16="http://schemas.microsoft.com/office/drawing/2014/main" id="{4A57543B-F5E0-4368-A582-354C7A61AFC5}"/>
+                <a16:creationId xmlns:a16="http://schemas.microsoft.com/office/drawing/2014/main" id="{A2A02F6E-F704-43F7-B7AB-BA2864569733}"/>
               </a:ext>
             </a:extLst>
           </p:cNvPr>
@@ -9695,7 +9759,7 @@
           <p:cNvPr id="3" name="s9-title">
             <a:extLst xmlns:a="http://schemas.openxmlformats.org/drawingml/2006/main">
               <a:ext uri="{FF2B5EF4-FFF2-40B4-BE49-F238E27FC236}">
-                <a16:creationId xmlns:a16="http://schemas.microsoft.com/office/drawing/2014/main" id="{DA902362-994C-40E8-8F98-4D977CC53C68}"/>
+                <a16:creationId xmlns:a16="http://schemas.microsoft.com/office/drawing/2014/main" id="{5B59A48F-ABE0-472C-9293-2F78E5059B21}"/>
               </a:ext>
             </a:extLst>
           </p:cNvPr>
@@ -9753,7 +9817,7 @@
           <p:cNvPr id="4" name="s9-footer">
             <a:extLst xmlns:a="http://schemas.openxmlformats.org/drawingml/2006/main">
               <a:ext uri="{FF2B5EF4-FFF2-40B4-BE49-F238E27FC236}">
-                <a16:creationId xmlns:a16="http://schemas.microsoft.com/office/drawing/2014/main" id="{8E7C5E50-E8EB-4379-9018-C52095AE4BCA}"/>
+                <a16:creationId xmlns:a16="http://schemas.microsoft.com/office/drawing/2014/main" id="{6EF3D767-B544-4A45-8279-4DDDD81FDF46}"/>
               </a:ext>
             </a:extLst>
           </p:cNvPr>
@@ -9784,7 +9848,7 @@
           <p:cNvPr id="5" name="s9-identity">
             <a:extLst xmlns:a="http://schemas.openxmlformats.org/drawingml/2006/main">
               <a:ext uri="{FF2B5EF4-FFF2-40B4-BE49-F238E27FC236}">
-                <a16:creationId xmlns:a16="http://schemas.microsoft.com/office/drawing/2014/main" id="{499E62BC-8294-47E9-AE5A-42DA84ED6F8A}"/>
+                <a16:creationId xmlns:a16="http://schemas.microsoft.com/office/drawing/2014/main" id="{848DA474-E06B-4100-81C3-54073A8A9471}"/>
               </a:ext>
             </a:extLst>
           </p:cNvPr>
@@ -9842,7 +9906,7 @@
           <p:cNvPr id="6" name="core-no-0">
             <a:extLst xmlns:a="http://schemas.openxmlformats.org/drawingml/2006/main">
               <a:ext uri="{FF2B5EF4-FFF2-40B4-BE49-F238E27FC236}">
-                <a16:creationId xmlns:a16="http://schemas.microsoft.com/office/drawing/2014/main" id="{36B0CA39-491F-4E5A-9AFD-DA580D77C3CD}"/>
+                <a16:creationId xmlns:a16="http://schemas.microsoft.com/office/drawing/2014/main" id="{402CDAE5-9E00-4A83-8DD3-33F753509D1C}"/>
               </a:ext>
             </a:extLst>
           </p:cNvPr>
@@ -9874,7 +9938,7 @@
             <a:pPr algn="l">
               <a:defRPr sz="2250" b="1">
                 <a:solidFill>
-                  <a:srgbClr val="17A6C8"/>
+                  <a:srgbClr val="006B80"/>
                 </a:solidFill>
                 <a:latin typeface="PingFang SC"/>
                 <a:ea typeface="PingFang SC"/>
@@ -9884,7 +9948,7 @@
             <a:r>
               <a:rPr sz="2250" b="1">
                 <a:solidFill>
-                  <a:srgbClr val="17A6C8"/>
+                  <a:srgbClr val="006B80"/>
                 </a:solidFill>
                 <a:latin typeface="PingFang SC"/>
                 <a:ea typeface="PingFang SC"/>
@@ -9900,7 +9964,7 @@
           <p:cNvPr id="7" name="core-label-0">
             <a:extLst xmlns:a="http://schemas.openxmlformats.org/drawingml/2006/main">
               <a:ext uri="{FF2B5EF4-FFF2-40B4-BE49-F238E27FC236}">
-                <a16:creationId xmlns:a16="http://schemas.microsoft.com/office/drawing/2014/main" id="{CB58AEA3-7349-4A44-A85B-63E5C8394165}"/>
+                <a16:creationId xmlns:a16="http://schemas.microsoft.com/office/drawing/2014/main" id="{59370E4B-B6EE-45F5-A160-11E9576E16F9}"/>
               </a:ext>
             </a:extLst>
           </p:cNvPr>
@@ -9958,7 +10022,7 @@
           <p:cNvPr id="8" name="core-body-0">
             <a:extLst xmlns:a="http://schemas.openxmlformats.org/drawingml/2006/main">
               <a:ext uri="{FF2B5EF4-FFF2-40B4-BE49-F238E27FC236}">
-                <a16:creationId xmlns:a16="http://schemas.microsoft.com/office/drawing/2014/main" id="{F55A9E94-861E-4AF3-B7E3-7F6A0D069982}"/>
+                <a16:creationId xmlns:a16="http://schemas.microsoft.com/office/drawing/2014/main" id="{A547298F-39BB-4320-953C-40CE80EB1800}"/>
               </a:ext>
             </a:extLst>
           </p:cNvPr>
@@ -9982,14 +10046,14 @@
           </a:solidFill>
           <a:ln xmlns:a="http://schemas.openxmlformats.org/drawingml/2006/main" w="19050">
             <a:solidFill>
-              <a:srgbClr val="17A6C8"/>
+              <a:srgbClr val="006B80"/>
             </a:solidFill>
             <a:prstDash val="solid"/>
           </a:ln>
         </p:spPr>
         <p:txBody>
           <a:bodyPr xmlns:a="http://schemas.openxmlformats.org/drawingml/2006/main" lIns="152400" tIns="133350" rIns="152400" bIns="133350" anchor="ctr">
-            <a:normAutofit fontScale="99635"/>
+            <a:normAutofit fontScale="99619"/>
           </a:bodyPr>
           <a:lstStyle xmlns:a="http://schemas.openxmlformats.org/drawingml/2006/main"/>
           <a:p xmlns:a="http://schemas.openxmlformats.org/drawingml/2006/main">
@@ -10012,7 +10076,7 @@
                 <a:ea typeface="PingFang SC"/>
                 <a:cs typeface="PingFang SC"/>
               </a:rPr>
-              <a:t>一条最小 trace 可以包含： task id 、 step id 、时间、当前目标、观察来源、决策摘要、动作名称、输入参数摘要、权限级别、工具结果、评测结论、状态变化、下一步和停止原因…</a:t>
+              <a:t>一条最小 trace 可以包含；task_id 、 step_id 、时间、当前目标、观察来源、决策摘要、动作名称、输入参数摘要、权限级别、工具结果、评测结论、状态变化、下一步和停止原因</a:t>
             </a:r>
           </a:p>
         </p:txBody>
@@ -10022,7 +10086,7 @@
           <p:cNvPr id="9" name="core-no-1">
             <a:extLst xmlns:a="http://schemas.openxmlformats.org/drawingml/2006/main">
               <a:ext uri="{FF2B5EF4-FFF2-40B4-BE49-F238E27FC236}">
-                <a16:creationId xmlns:a16="http://schemas.microsoft.com/office/drawing/2014/main" id="{4DF0A32E-2289-4651-826F-8AB6329BC1AC}"/>
+                <a16:creationId xmlns:a16="http://schemas.microsoft.com/office/drawing/2014/main" id="{512A328E-892C-4C06-9DB9-30296BE8B1AB}"/>
               </a:ext>
             </a:extLst>
           </p:cNvPr>
@@ -10054,7 +10118,7 @@
             <a:pPr algn="l">
               <a:defRPr sz="2250" b="1">
                 <a:solidFill>
-                  <a:srgbClr val="17A6C8"/>
+                  <a:srgbClr val="006B80"/>
                 </a:solidFill>
                 <a:latin typeface="PingFang SC"/>
                 <a:ea typeface="PingFang SC"/>
@@ -10064,7 +10128,7 @@
             <a:r>
               <a:rPr sz="2250" b="1">
                 <a:solidFill>
-                  <a:srgbClr val="17A6C8"/>
+                  <a:srgbClr val="006B80"/>
                 </a:solidFill>
                 <a:latin typeface="PingFang SC"/>
                 <a:ea typeface="PingFang SC"/>
@@ -10080,7 +10144,7 @@
           <p:cNvPr id="10" name="core-body-1">
             <a:extLst xmlns:a="http://schemas.openxmlformats.org/drawingml/2006/main">
               <a:ext uri="{FF2B5EF4-FFF2-40B4-BE49-F238E27FC236}">
-                <a16:creationId xmlns:a16="http://schemas.microsoft.com/office/drawing/2014/main" id="{ED54F449-D721-47C8-BDD6-7823C644397F}"/>
+                <a16:creationId xmlns:a16="http://schemas.microsoft.com/office/drawing/2014/main" id="{DBCADC59-FEE3-4DBF-BF4E-FCDA91CC7FCB}"/>
               </a:ext>
             </a:extLst>
           </p:cNvPr>
@@ -10144,7 +10208,7 @@
           <p:cNvPr id="11" name="s9-takeaway-rule">
             <a:extLst xmlns:a="http://schemas.openxmlformats.org/drawingml/2006/main">
               <a:ext uri="{FF2B5EF4-FFF2-40B4-BE49-F238E27FC236}">
-                <a16:creationId xmlns:a16="http://schemas.microsoft.com/office/drawing/2014/main" id="{57AE2516-85CF-48A8-8050-00F2508959DA}"/>
+                <a16:creationId xmlns:a16="http://schemas.microsoft.com/office/drawing/2014/main" id="{1A598DBD-C468-40FB-AD99-A4C2E7395C57}"/>
               </a:ext>
             </a:extLst>
           </p:cNvPr>
@@ -10177,7 +10241,7 @@
           <p:cNvPr id="12" name="s9-takeaway">
             <a:extLst xmlns:a="http://schemas.openxmlformats.org/drawingml/2006/main">
               <a:ext uri="{FF2B5EF4-FFF2-40B4-BE49-F238E27FC236}">
-                <a16:creationId xmlns:a16="http://schemas.microsoft.com/office/drawing/2014/main" id="{C0E32487-86B9-476E-8675-8AB0490DF7C3}"/>
+                <a16:creationId xmlns:a16="http://schemas.microsoft.com/office/drawing/2014/main" id="{B0C02A8A-2AEF-4D08-88D5-6451CA3CBCCD}"/>
               </a:ext>
             </a:extLst>
           </p:cNvPr>
@@ -10233,7 +10297,7 @@
     </p:spTree>
     <p:extLst>
       <p:ext uri="{BB962C8B-B14F-4D97-AF65-F5344CB8AC3E}">
-        <p14:creationId xmlns:p14="http://schemas.microsoft.com/office/powerpoint/2010/main" val="587817551"/>
+        <p14:creationId xmlns:p14="http://schemas.microsoft.com/office/powerpoint/2010/main" val="935662469"/>
       </p:ext>
     </p:extLst>
   </p:cSld>

</xml_diff>

<commit_message>
feat: add original PowerPoint media to the course
</commit_message>
<xml_diff>
--- a/docs/public/course-assets/course-pptx/ag-001.pptx
+++ b/docs/public/course-assets/course-pptx/ag-001.pptx
@@ -2,25 +2,25 @@
 <file path=ppt/presentation.xml><?xml version="1.0" encoding="utf-8"?>
 <p:presentation xmlns:p="http://schemas.openxmlformats.org/presentationml/2006/main">
   <p:sldMasterIdLst>
-    <p:sldMasterId xmlns:r="http://schemas.openxmlformats.org/officeDocument/2006/relationships" id="2147483648" r:id="R941da0e79b934335"/>
+    <p:sldMasterId xmlns:r="http://schemas.openxmlformats.org/officeDocument/2006/relationships" id="2147483648" r:id="R4bf1ffa8d94a4a34"/>
   </p:sldMasterIdLst>
   <p:notesMasterIdLst>
-    <p:notesMasterId xmlns:r="http://schemas.openxmlformats.org/officeDocument/2006/relationships" r:id="R813d89a5f2a3444a"/>
+    <p:notesMasterId xmlns:r="http://schemas.openxmlformats.org/officeDocument/2006/relationships" r:id="Rc701fbafc93946ee"/>
   </p:notesMasterIdLst>
   <p:sldIdLst>
-    <p:sldId xmlns:r="http://schemas.openxmlformats.org/officeDocument/2006/relationships" id="256" r:id="R5b6ee71562724a66"/>
-    <p:sldId xmlns:r="http://schemas.openxmlformats.org/officeDocument/2006/relationships" id="257" r:id="R7c1bd8ddbe384a7e"/>
-    <p:sldId xmlns:r="http://schemas.openxmlformats.org/officeDocument/2006/relationships" id="258" r:id="R6bfee5906579453d"/>
-    <p:sldId xmlns:r="http://schemas.openxmlformats.org/officeDocument/2006/relationships" id="259" r:id="Rfdf448ac361c420e"/>
-    <p:sldId xmlns:r="http://schemas.openxmlformats.org/officeDocument/2006/relationships" id="260" r:id="R84b26d842c334179"/>
-    <p:sldId xmlns:r="http://schemas.openxmlformats.org/officeDocument/2006/relationships" id="261" r:id="Rf56c01b682bb4cb7"/>
-    <p:sldId xmlns:r="http://schemas.openxmlformats.org/officeDocument/2006/relationships" id="262" r:id="R17cf719642bf4579"/>
-    <p:sldId xmlns:r="http://schemas.openxmlformats.org/officeDocument/2006/relationships" id="263" r:id="Ra91570bc655045fc"/>
-    <p:sldId xmlns:r="http://schemas.openxmlformats.org/officeDocument/2006/relationships" id="264" r:id="R557ab6139e014b9b"/>
-    <p:sldId xmlns:r="http://schemas.openxmlformats.org/officeDocument/2006/relationships" id="265" r:id="R4ab167ef5bfb4bd4"/>
-    <p:sldId xmlns:r="http://schemas.openxmlformats.org/officeDocument/2006/relationships" id="266" r:id="R302302e706814573"/>
-    <p:sldId xmlns:r="http://schemas.openxmlformats.org/officeDocument/2006/relationships" id="267" r:id="Re3d96bb364ac4153"/>
-    <p:sldId xmlns:r="http://schemas.openxmlformats.org/officeDocument/2006/relationships" id="268" r:id="R8ba4e9711a014d95"/>
+    <p:sldId xmlns:r="http://schemas.openxmlformats.org/officeDocument/2006/relationships" id="256" r:id="R19c50a27e4694c2f"/>
+    <p:sldId xmlns:r="http://schemas.openxmlformats.org/officeDocument/2006/relationships" id="257" r:id="R0ba009364cef4c7b"/>
+    <p:sldId xmlns:r="http://schemas.openxmlformats.org/officeDocument/2006/relationships" id="258" r:id="Rad36857ffbe84e4c"/>
+    <p:sldId xmlns:r="http://schemas.openxmlformats.org/officeDocument/2006/relationships" id="259" r:id="R8440704baeef4022"/>
+    <p:sldId xmlns:r="http://schemas.openxmlformats.org/officeDocument/2006/relationships" id="260" r:id="R718cbd2d95a5463e"/>
+    <p:sldId xmlns:r="http://schemas.openxmlformats.org/officeDocument/2006/relationships" id="261" r:id="R3a989866d8ad46bc"/>
+    <p:sldId xmlns:r="http://schemas.openxmlformats.org/officeDocument/2006/relationships" id="262" r:id="R327d0fc8cca94489"/>
+    <p:sldId xmlns:r="http://schemas.openxmlformats.org/officeDocument/2006/relationships" id="263" r:id="Rde1ff60cd0fa444b"/>
+    <p:sldId xmlns:r="http://schemas.openxmlformats.org/officeDocument/2006/relationships" id="264" r:id="R940f867b97754f05"/>
+    <p:sldId xmlns:r="http://schemas.openxmlformats.org/officeDocument/2006/relationships" id="265" r:id="R9ad05a6eb26c48e7"/>
+    <p:sldId xmlns:r="http://schemas.openxmlformats.org/officeDocument/2006/relationships" id="266" r:id="R84187b19d1c04739"/>
+    <p:sldId xmlns:r="http://schemas.openxmlformats.org/officeDocument/2006/relationships" id="267" r:id="R98422a42c0154700"/>
+    <p:sldId xmlns:r="http://schemas.openxmlformats.org/officeDocument/2006/relationships" id="268" r:id="Rdac1818703704aac"/>
   </p:sldIdLst>
   <p:sldSz cx="12192000" cy="6858000"/>
   <p:notesSz cx="6858000" cy="9144000"/>
@@ -1405,7 +1405,7 @@
   </p:cSld>
   <p:clrMap bg1="lt1" tx1="dk1" bg2="lt2" tx2="dk2" accent1="accent1" accent2="accent2" accent3="accent3" accent4="accent4" accent5="accent5" accent6="accent6" hlink="hlink" folHlink="folHlink"/>
   <p:sldLayoutIdLst>
-    <p:sldLayoutId xmlns:r="http://schemas.openxmlformats.org/officeDocument/2006/relationships" id="2147483649" r:id="R40b8673f318f4427"/>
+    <p:sldLayoutId xmlns:r="http://schemas.openxmlformats.org/officeDocument/2006/relationships" id="2147483649" r:id="R5e25b6a1164b423e"/>
   </p:sldLayoutIdLst>
   <p:txStyles>
     <p:titleStyle>
@@ -1956,7 +1956,7 @@
           <p:cNvPr id="1" name="cover-rule">
             <a:extLst xmlns:a="http://schemas.openxmlformats.org/drawingml/2006/main">
               <a:ext uri="{FF2B5EF4-FFF2-40B4-BE49-F238E27FC236}">
-                <a16:creationId xmlns:a16="http://schemas.microsoft.com/office/drawing/2014/main" id="{2D42A7CE-0032-4B48-8F99-B4FB27455BE2}"/>
+                <a16:creationId xmlns:a16="http://schemas.microsoft.com/office/drawing/2014/main" id="{886F89DA-A577-4D65-8032-8226C173210A}"/>
               </a:ext>
             </a:extLst>
           </p:cNvPr>
@@ -1989,7 +1989,7 @@
           <p:cNvPr id="2" name="cover-ring-1">
             <a:extLst xmlns:a="http://schemas.openxmlformats.org/drawingml/2006/main">
               <a:ext uri="{FF2B5EF4-FFF2-40B4-BE49-F238E27FC236}">
-                <a16:creationId xmlns:a16="http://schemas.microsoft.com/office/drawing/2014/main" id="{F1C39FA7-65D7-4801-8AE9-F13C1F437D80}"/>
+                <a16:creationId xmlns:a16="http://schemas.microsoft.com/office/drawing/2014/main" id="{87E3BF4C-EE5D-470D-AE90-65A37A3A7024}"/>
               </a:ext>
             </a:extLst>
           </p:cNvPr>
@@ -2020,7 +2020,7 @@
           <p:cNvPr id="3" name="cover-ring-2">
             <a:extLst xmlns:a="http://schemas.openxmlformats.org/drawingml/2006/main">
               <a:ext uri="{FF2B5EF4-FFF2-40B4-BE49-F238E27FC236}">
-                <a16:creationId xmlns:a16="http://schemas.microsoft.com/office/drawing/2014/main" id="{91F3B885-3D7B-4CE6-A163-B3610707B226}"/>
+                <a16:creationId xmlns:a16="http://schemas.microsoft.com/office/drawing/2014/main" id="{8E11E332-DB95-49A8-9B4C-098E7F1F6E13}"/>
               </a:ext>
             </a:extLst>
           </p:cNvPr>
@@ -2051,7 +2051,7 @@
           <p:cNvPr id="4" name="cover-core">
             <a:extLst xmlns:a="http://schemas.openxmlformats.org/drawingml/2006/main">
               <a:ext uri="{FF2B5EF4-FFF2-40B4-BE49-F238E27FC236}">
-                <a16:creationId xmlns:a16="http://schemas.microsoft.com/office/drawing/2014/main" id="{EE5BD32E-519B-4FB7-A443-52FA8171E31A}"/>
+                <a16:creationId xmlns:a16="http://schemas.microsoft.com/office/drawing/2014/main" id="{873BEB72-A2F5-4ABB-AF52-143E41F99856}"/>
               </a:ext>
             </a:extLst>
           </p:cNvPr>
@@ -2084,7 +2084,7 @@
           <p:cNvPr id="5" name="cover-line-1">
             <a:extLst xmlns:a="http://schemas.openxmlformats.org/drawingml/2006/main">
               <a:ext uri="{FF2B5EF4-FFF2-40B4-BE49-F238E27FC236}">
-                <a16:creationId xmlns:a16="http://schemas.microsoft.com/office/drawing/2014/main" id="{49F51B01-D5A5-49BE-83D1-B5099345F1FB}"/>
+                <a16:creationId xmlns:a16="http://schemas.microsoft.com/office/drawing/2014/main" id="{F2187AD4-7866-4C48-9764-E0C44B992DFA}"/>
               </a:ext>
             </a:extLst>
           </p:cNvPr>
@@ -2115,7 +2115,7 @@
           <p:cNvPr id="6" name="cover-line-2">
             <a:extLst xmlns:a="http://schemas.openxmlformats.org/drawingml/2006/main">
               <a:ext uri="{FF2B5EF4-FFF2-40B4-BE49-F238E27FC236}">
-                <a16:creationId xmlns:a16="http://schemas.microsoft.com/office/drawing/2014/main" id="{1DE6C797-7E71-41C8-A0E9-EB5D4170BC0C}"/>
+                <a16:creationId xmlns:a16="http://schemas.microsoft.com/office/drawing/2014/main" id="{D93EF0FC-9D57-4184-941D-039CE53B15EF}"/>
               </a:ext>
             </a:extLst>
           </p:cNvPr>
@@ -2146,7 +2146,7 @@
           <p:cNvPr id="7" name="cover-eyebrow">
             <a:extLst xmlns:a="http://schemas.openxmlformats.org/drawingml/2006/main">
               <a:ext uri="{FF2B5EF4-FFF2-40B4-BE49-F238E27FC236}">
-                <a16:creationId xmlns:a16="http://schemas.microsoft.com/office/drawing/2014/main" id="{5DC38BEA-F864-48E6-B10E-CCE83E4D2B83}"/>
+                <a16:creationId xmlns:a16="http://schemas.microsoft.com/office/drawing/2014/main" id="{7ABA49EA-D822-4BCC-A1BF-1E752D01E9D5}"/>
               </a:ext>
             </a:extLst>
           </p:cNvPr>
@@ -2204,7 +2204,7 @@
           <p:cNvPr id="8" name="cover-title">
             <a:extLst xmlns:a="http://schemas.openxmlformats.org/drawingml/2006/main">
               <a:ext uri="{FF2B5EF4-FFF2-40B4-BE49-F238E27FC236}">
-                <a16:creationId xmlns:a16="http://schemas.microsoft.com/office/drawing/2014/main" id="{7E54617C-A3B6-4542-B987-96F57F9977DA}"/>
+                <a16:creationId xmlns:a16="http://schemas.microsoft.com/office/drawing/2014/main" id="{FE68B107-D85B-4FCD-A8D4-01BE95669C4E}"/>
               </a:ext>
             </a:extLst>
           </p:cNvPr>
@@ -2262,7 +2262,7 @@
           <p:cNvPr id="9" name="cover-subtitle">
             <a:extLst xmlns:a="http://schemas.openxmlformats.org/drawingml/2006/main">
               <a:ext uri="{FF2B5EF4-FFF2-40B4-BE49-F238E27FC236}">
-                <a16:creationId xmlns:a16="http://schemas.microsoft.com/office/drawing/2014/main" id="{88385B43-F321-4D59-9B9B-78725A7AABC0}"/>
+                <a16:creationId xmlns:a16="http://schemas.microsoft.com/office/drawing/2014/main" id="{C42CF796-BBA0-492A-A5C1-F30D141868F2}"/>
               </a:ext>
             </a:extLst>
           </p:cNvPr>
@@ -2324,7 +2324,7 @@
           <p:cNvPr id="10" name="cover-lead">
             <a:extLst xmlns:a="http://schemas.openxmlformats.org/drawingml/2006/main">
               <a:ext uri="{FF2B5EF4-FFF2-40B4-BE49-F238E27FC236}">
-                <a16:creationId xmlns:a16="http://schemas.microsoft.com/office/drawing/2014/main" id="{B85B7D63-6900-433F-86B1-6363B8E5DC94}"/>
+                <a16:creationId xmlns:a16="http://schemas.microsoft.com/office/drawing/2014/main" id="{5676F0F0-15B0-4E6C-8AB3-2B2582B45CFE}"/>
               </a:ext>
             </a:extLst>
           </p:cNvPr>
@@ -2382,7 +2382,7 @@
           <p:cNvPr id="11" name="cover-course">
             <a:extLst xmlns:a="http://schemas.openxmlformats.org/drawingml/2006/main">
               <a:ext uri="{FF2B5EF4-FFF2-40B4-BE49-F238E27FC236}">
-                <a16:creationId xmlns:a16="http://schemas.microsoft.com/office/drawing/2014/main" id="{3C15C792-C7B4-4EDA-B674-96C5897E1BA3}"/>
+                <a16:creationId xmlns:a16="http://schemas.microsoft.com/office/drawing/2014/main" id="{0D3D0E01-C033-4590-8398-2EC485F12B3A}"/>
               </a:ext>
             </a:extLst>
           </p:cNvPr>
@@ -2440,7 +2440,7 @@
           <p:cNvPr id="12" name="cover-id">
             <a:extLst xmlns:a="http://schemas.openxmlformats.org/drawingml/2006/main">
               <a:ext uri="{FF2B5EF4-FFF2-40B4-BE49-F238E27FC236}">
-                <a16:creationId xmlns:a16="http://schemas.microsoft.com/office/drawing/2014/main" id="{E8C6B144-7DCE-4E42-A355-D5ACAA244F80}"/>
+                <a16:creationId xmlns:a16="http://schemas.microsoft.com/office/drawing/2014/main" id="{093530F2-8FEA-4180-92F4-3C577081460F}"/>
               </a:ext>
             </a:extLst>
           </p:cNvPr>
@@ -2496,7 +2496,7 @@
     </p:spTree>
     <p:extLst>
       <p:ext uri="{BB962C8B-B14F-4D97-AF65-F5344CB8AC3E}">
-        <p14:creationId xmlns:p14="http://schemas.microsoft.com/office/powerpoint/2010/main" val="149824733"/>
+        <p14:creationId xmlns:p14="http://schemas.microsoft.com/office/powerpoint/2010/main" val="2029273535"/>
       </p:ext>
     </p:extLst>
   </p:cSld>
@@ -2527,7 +2527,7 @@
           <p:cNvPr id="1" name="s10-rule">
             <a:extLst xmlns:a="http://schemas.openxmlformats.org/drawingml/2006/main">
               <a:ext uri="{FF2B5EF4-FFF2-40B4-BE49-F238E27FC236}">
-                <a16:creationId xmlns:a16="http://schemas.microsoft.com/office/drawing/2014/main" id="{2B0BC80C-C811-418E-BC5D-D776152715E1}"/>
+                <a16:creationId xmlns:a16="http://schemas.microsoft.com/office/drawing/2014/main" id="{8AE0D0EC-84B2-4CAE-8F2D-1F9873977B15}"/>
               </a:ext>
             </a:extLst>
           </p:cNvPr>
@@ -2560,7 +2560,7 @@
           <p:cNvPr id="2" name="s10-eyebrow">
             <a:extLst xmlns:a="http://schemas.openxmlformats.org/drawingml/2006/main">
               <a:ext uri="{FF2B5EF4-FFF2-40B4-BE49-F238E27FC236}">
-                <a16:creationId xmlns:a16="http://schemas.microsoft.com/office/drawing/2014/main" id="{6A92845C-DCE3-4284-864B-6EFBF5D4B0D5}"/>
+                <a16:creationId xmlns:a16="http://schemas.microsoft.com/office/drawing/2014/main" id="{4D1CAAF8-6B74-4608-8C5E-BBCAB635F3B1}"/>
               </a:ext>
             </a:extLst>
           </p:cNvPr>
@@ -2618,7 +2618,7 @@
           <p:cNvPr id="3" name="s10-title">
             <a:extLst xmlns:a="http://schemas.openxmlformats.org/drawingml/2006/main">
               <a:ext uri="{FF2B5EF4-FFF2-40B4-BE49-F238E27FC236}">
-                <a16:creationId xmlns:a16="http://schemas.microsoft.com/office/drawing/2014/main" id="{4F74F366-9066-4E67-999D-ECC897C5D352}"/>
+                <a16:creationId xmlns:a16="http://schemas.microsoft.com/office/drawing/2014/main" id="{22061400-BABB-4941-84F7-5620F290852D}"/>
               </a:ext>
             </a:extLst>
           </p:cNvPr>
@@ -2676,7 +2676,7 @@
           <p:cNvPr id="4" name="s10-footer">
             <a:extLst xmlns:a="http://schemas.openxmlformats.org/drawingml/2006/main">
               <a:ext uri="{FF2B5EF4-FFF2-40B4-BE49-F238E27FC236}">
-                <a16:creationId xmlns:a16="http://schemas.microsoft.com/office/drawing/2014/main" id="{6846EE2F-0FFA-4394-9D8A-77619EBE1D53}"/>
+                <a16:creationId xmlns:a16="http://schemas.microsoft.com/office/drawing/2014/main" id="{49231C82-6E32-415E-93F5-DB7BE5C00002}"/>
               </a:ext>
             </a:extLst>
           </p:cNvPr>
@@ -2707,7 +2707,7 @@
           <p:cNvPr id="5" name="s10-identity">
             <a:extLst xmlns:a="http://schemas.openxmlformats.org/drawingml/2006/main">
               <a:ext uri="{FF2B5EF4-FFF2-40B4-BE49-F238E27FC236}">
-                <a16:creationId xmlns:a16="http://schemas.microsoft.com/office/drawing/2014/main" id="{D2E06C87-2E7B-4E07-BC02-3EF2F62F5DBB}"/>
+                <a16:creationId xmlns:a16="http://schemas.microsoft.com/office/drawing/2014/main" id="{BD3BBF9E-5C7A-476A-B1B6-7A67FFA61988}"/>
               </a:ext>
             </a:extLst>
           </p:cNvPr>
@@ -2765,7 +2765,7 @@
           <p:cNvPr id="6" name="case-title">
             <a:extLst xmlns:a="http://schemas.openxmlformats.org/drawingml/2006/main">
               <a:ext uri="{FF2B5EF4-FFF2-40B4-BE49-F238E27FC236}">
-                <a16:creationId xmlns:a16="http://schemas.microsoft.com/office/drawing/2014/main" id="{F37DDCFE-07E2-43AB-8054-017C02F3B4AD}"/>
+                <a16:creationId xmlns:a16="http://schemas.microsoft.com/office/drawing/2014/main" id="{6C3EDDCE-6918-41D0-80FC-EB6B8C1032F2}"/>
               </a:ext>
             </a:extLst>
           </p:cNvPr>
@@ -2829,7 +2829,7 @@
           <p:cNvPr id="7" name="case-row-0">
             <a:extLst xmlns:a="http://schemas.openxmlformats.org/drawingml/2006/main">
               <a:ext uri="{FF2B5EF4-FFF2-40B4-BE49-F238E27FC236}">
-                <a16:creationId xmlns:a16="http://schemas.microsoft.com/office/drawing/2014/main" id="{72820906-2F13-4FEC-9816-11A3410FBA0D}"/>
+                <a16:creationId xmlns:a16="http://schemas.microsoft.com/office/drawing/2014/main" id="{6B080B5A-0C44-4743-A130-09E2EE714F5C}"/>
               </a:ext>
             </a:extLst>
           </p:cNvPr>
@@ -2893,7 +2893,7 @@
           <p:cNvPr id="8" name="case-row-1">
             <a:extLst xmlns:a="http://schemas.openxmlformats.org/drawingml/2006/main">
               <a:ext uri="{FF2B5EF4-FFF2-40B4-BE49-F238E27FC236}">
-                <a16:creationId xmlns:a16="http://schemas.microsoft.com/office/drawing/2014/main" id="{4CFA2C64-7D52-41E0-B1B7-CAE7B8865B2D}"/>
+                <a16:creationId xmlns:a16="http://schemas.microsoft.com/office/drawing/2014/main" id="{A69F3799-11A8-49A7-96CD-299BB658C0BF}"/>
               </a:ext>
             </a:extLst>
           </p:cNvPr>
@@ -2957,7 +2957,7 @@
           <p:cNvPr id="9" name="case-row-2">
             <a:extLst xmlns:a="http://schemas.openxmlformats.org/drawingml/2006/main">
               <a:ext uri="{FF2B5EF4-FFF2-40B4-BE49-F238E27FC236}">
-                <a16:creationId xmlns:a16="http://schemas.microsoft.com/office/drawing/2014/main" id="{D9660449-D1A0-415A-9882-87C1F8249491}"/>
+                <a16:creationId xmlns:a16="http://schemas.microsoft.com/office/drawing/2014/main" id="{5C9E311A-810E-444C-A8AD-32F9D7C7936F}"/>
               </a:ext>
             </a:extLst>
           </p:cNvPr>
@@ -3021,7 +3021,7 @@
           <p:cNvPr id="10" name="case-row-3">
             <a:extLst xmlns:a="http://schemas.openxmlformats.org/drawingml/2006/main">
               <a:ext uri="{FF2B5EF4-FFF2-40B4-BE49-F238E27FC236}">
-                <a16:creationId xmlns:a16="http://schemas.microsoft.com/office/drawing/2014/main" id="{75C78A2B-3FDE-427B-858E-94841F2EBDDB}"/>
+                <a16:creationId xmlns:a16="http://schemas.microsoft.com/office/drawing/2014/main" id="{55BB2168-BB1B-4308-8275-5CF39228A11C}"/>
               </a:ext>
             </a:extLst>
           </p:cNvPr>
@@ -3085,7 +3085,7 @@
           <p:cNvPr id="11" name="case-row-4">
             <a:extLst xmlns:a="http://schemas.openxmlformats.org/drawingml/2006/main">
               <a:ext uri="{FF2B5EF4-FFF2-40B4-BE49-F238E27FC236}">
-                <a16:creationId xmlns:a16="http://schemas.microsoft.com/office/drawing/2014/main" id="{2CBEA6A9-EFA9-4908-8B2A-0098B821601C}"/>
+                <a16:creationId xmlns:a16="http://schemas.microsoft.com/office/drawing/2014/main" id="{BEF97C5A-8544-4F9F-BB0E-43DD4B363553}"/>
               </a:ext>
             </a:extLst>
           </p:cNvPr>
@@ -3149,7 +3149,7 @@
           <p:cNvPr id="12" name="s10-takeaway-rule">
             <a:extLst xmlns:a="http://schemas.openxmlformats.org/drawingml/2006/main">
               <a:ext uri="{FF2B5EF4-FFF2-40B4-BE49-F238E27FC236}">
-                <a16:creationId xmlns:a16="http://schemas.microsoft.com/office/drawing/2014/main" id="{0C223A0C-C8B9-4575-AC36-A74B95A9E72B}"/>
+                <a16:creationId xmlns:a16="http://schemas.microsoft.com/office/drawing/2014/main" id="{5BB7C4AF-6F8A-488E-90E3-0EE1ED737BDE}"/>
               </a:ext>
             </a:extLst>
           </p:cNvPr>
@@ -3182,7 +3182,7 @@
           <p:cNvPr id="13" name="s10-takeaway">
             <a:extLst xmlns:a="http://schemas.openxmlformats.org/drawingml/2006/main">
               <a:ext uri="{FF2B5EF4-FFF2-40B4-BE49-F238E27FC236}">
-                <a16:creationId xmlns:a16="http://schemas.microsoft.com/office/drawing/2014/main" id="{B8486D21-36CA-4A78-B6F9-7C3CD65909AD}"/>
+                <a16:creationId xmlns:a16="http://schemas.microsoft.com/office/drawing/2014/main" id="{44AEDCC0-13C4-473F-9879-C2197D3ADA78}"/>
               </a:ext>
             </a:extLst>
           </p:cNvPr>
@@ -3238,7 +3238,7 @@
     </p:spTree>
     <p:extLst>
       <p:ext uri="{BB962C8B-B14F-4D97-AF65-F5344CB8AC3E}">
-        <p14:creationId xmlns:p14="http://schemas.microsoft.com/office/powerpoint/2010/main" val="1530385802"/>
+        <p14:creationId xmlns:p14="http://schemas.microsoft.com/office/powerpoint/2010/main" val="821425182"/>
       </p:ext>
     </p:extLst>
   </p:cSld>
@@ -3269,7 +3269,7 @@
           <p:cNvPr id="1" name="s11-rule">
             <a:extLst xmlns:a="http://schemas.openxmlformats.org/drawingml/2006/main">
               <a:ext uri="{FF2B5EF4-FFF2-40B4-BE49-F238E27FC236}">
-                <a16:creationId xmlns:a16="http://schemas.microsoft.com/office/drawing/2014/main" id="{24C9BDED-2B2A-42F2-ABB4-B1DB9A257700}"/>
+                <a16:creationId xmlns:a16="http://schemas.microsoft.com/office/drawing/2014/main" id="{7BD3A138-82B5-47C2-918D-EB60369B9132}"/>
               </a:ext>
             </a:extLst>
           </p:cNvPr>
@@ -3302,7 +3302,7 @@
           <p:cNvPr id="2" name="s11-eyebrow">
             <a:extLst xmlns:a="http://schemas.openxmlformats.org/drawingml/2006/main">
               <a:ext uri="{FF2B5EF4-FFF2-40B4-BE49-F238E27FC236}">
-                <a16:creationId xmlns:a16="http://schemas.microsoft.com/office/drawing/2014/main" id="{E49C07AE-4C5E-4208-BD26-E0CE6F615220}"/>
+                <a16:creationId xmlns:a16="http://schemas.microsoft.com/office/drawing/2014/main" id="{7694AFA6-6A8D-4D97-B601-666FD8839015}"/>
               </a:ext>
             </a:extLst>
           </p:cNvPr>
@@ -3360,7 +3360,7 @@
           <p:cNvPr id="3" name="s11-title">
             <a:extLst xmlns:a="http://schemas.openxmlformats.org/drawingml/2006/main">
               <a:ext uri="{FF2B5EF4-FFF2-40B4-BE49-F238E27FC236}">
-                <a16:creationId xmlns:a16="http://schemas.microsoft.com/office/drawing/2014/main" id="{2148F562-6D32-4775-ADC4-FD0E2312828C}"/>
+                <a16:creationId xmlns:a16="http://schemas.microsoft.com/office/drawing/2014/main" id="{BF623E25-978F-44FA-93ED-9A8A53C9850E}"/>
               </a:ext>
             </a:extLst>
           </p:cNvPr>
@@ -3418,7 +3418,7 @@
           <p:cNvPr id="4" name="s11-footer">
             <a:extLst xmlns:a="http://schemas.openxmlformats.org/drawingml/2006/main">
               <a:ext uri="{FF2B5EF4-FFF2-40B4-BE49-F238E27FC236}">
-                <a16:creationId xmlns:a16="http://schemas.microsoft.com/office/drawing/2014/main" id="{7C55290F-C6C9-4034-8E6A-F97F4AE97AA9}"/>
+                <a16:creationId xmlns:a16="http://schemas.microsoft.com/office/drawing/2014/main" id="{C69F762F-1F34-470D-94B5-0100C4B21931}"/>
               </a:ext>
             </a:extLst>
           </p:cNvPr>
@@ -3449,7 +3449,7 @@
           <p:cNvPr id="5" name="s11-identity">
             <a:extLst xmlns:a="http://schemas.openxmlformats.org/drawingml/2006/main">
               <a:ext uri="{FF2B5EF4-FFF2-40B4-BE49-F238E27FC236}">
-                <a16:creationId xmlns:a16="http://schemas.microsoft.com/office/drawing/2014/main" id="{88D5A237-E859-4238-9C4D-807B0B4CD936}"/>
+                <a16:creationId xmlns:a16="http://schemas.microsoft.com/office/drawing/2014/main" id="{7A47D41F-988A-4868-85EA-585778AAE4FB}"/>
               </a:ext>
             </a:extLst>
           </p:cNvPr>
@@ -3507,7 +3507,7 @@
           <p:cNvPr id="6" name="practice-circle-0">
             <a:extLst xmlns:a="http://schemas.openxmlformats.org/drawingml/2006/main">
               <a:ext uri="{FF2B5EF4-FFF2-40B4-BE49-F238E27FC236}">
-                <a16:creationId xmlns:a16="http://schemas.microsoft.com/office/drawing/2014/main" id="{23013BAF-4730-4B96-92CA-41AF6439C99A}"/>
+                <a16:creationId xmlns:a16="http://schemas.microsoft.com/office/drawing/2014/main" id="{C683E406-38C3-4EE0-8860-745D7B05B7FC}"/>
               </a:ext>
             </a:extLst>
           </p:cNvPr>
@@ -3540,7 +3540,7 @@
           <p:cNvPr id="7" name="practice-number-0">
             <a:extLst xmlns:a="http://schemas.openxmlformats.org/drawingml/2006/main">
               <a:ext uri="{FF2B5EF4-FFF2-40B4-BE49-F238E27FC236}">
-                <a16:creationId xmlns:a16="http://schemas.microsoft.com/office/drawing/2014/main" id="{E3766496-314E-46E9-92ED-DC3778CCBC49}"/>
+                <a16:creationId xmlns:a16="http://schemas.microsoft.com/office/drawing/2014/main" id="{8213ABEB-FF27-4833-8BCE-C9FAEDB15559}"/>
               </a:ext>
             </a:extLst>
           </p:cNvPr>
@@ -3598,7 +3598,7 @@
           <p:cNvPr id="8" name="practice-item-0">
             <a:extLst xmlns:a="http://schemas.openxmlformats.org/drawingml/2006/main">
               <a:ext uri="{FF2B5EF4-FFF2-40B4-BE49-F238E27FC236}">
-                <a16:creationId xmlns:a16="http://schemas.microsoft.com/office/drawing/2014/main" id="{310C94FA-E8F1-4FC5-8592-875FB3D38B84}"/>
+                <a16:creationId xmlns:a16="http://schemas.microsoft.com/office/drawing/2014/main" id="{D69BB4D2-172A-4D33-8507-B3A3539DB5C9}"/>
               </a:ext>
             </a:extLst>
           </p:cNvPr>
@@ -3662,7 +3662,7 @@
           <p:cNvPr id="9" name="practice-connector-0">
             <a:extLst xmlns:a="http://schemas.openxmlformats.org/drawingml/2006/main">
               <a:ext uri="{FF2B5EF4-FFF2-40B4-BE49-F238E27FC236}">
-                <a16:creationId xmlns:a16="http://schemas.microsoft.com/office/drawing/2014/main" id="{5025A727-6985-4DCD-8BDD-1452EE445F1F}"/>
+                <a16:creationId xmlns:a16="http://schemas.microsoft.com/office/drawing/2014/main" id="{B243A5B6-A6DD-4869-B2B9-075951C74D37}"/>
               </a:ext>
             </a:extLst>
           </p:cNvPr>
@@ -3693,7 +3693,7 @@
           <p:cNvPr id="10" name="practice-circle-1">
             <a:extLst xmlns:a="http://schemas.openxmlformats.org/drawingml/2006/main">
               <a:ext uri="{FF2B5EF4-FFF2-40B4-BE49-F238E27FC236}">
-                <a16:creationId xmlns:a16="http://schemas.microsoft.com/office/drawing/2014/main" id="{5117A799-8508-41DD-96AC-086792E86793}"/>
+                <a16:creationId xmlns:a16="http://schemas.microsoft.com/office/drawing/2014/main" id="{CF89C25D-25DD-4994-824B-DAD83C93D520}"/>
               </a:ext>
             </a:extLst>
           </p:cNvPr>
@@ -3726,7 +3726,7 @@
           <p:cNvPr id="11" name="practice-number-1">
             <a:extLst xmlns:a="http://schemas.openxmlformats.org/drawingml/2006/main">
               <a:ext uri="{FF2B5EF4-FFF2-40B4-BE49-F238E27FC236}">
-                <a16:creationId xmlns:a16="http://schemas.microsoft.com/office/drawing/2014/main" id="{E65ED49E-095F-4CB2-8A11-3EFE8CE5CDC8}"/>
+                <a16:creationId xmlns:a16="http://schemas.microsoft.com/office/drawing/2014/main" id="{3CD372B4-9462-4921-9B52-6884B17C3C0C}"/>
               </a:ext>
             </a:extLst>
           </p:cNvPr>
@@ -3784,7 +3784,7 @@
           <p:cNvPr id="12" name="practice-item-1">
             <a:extLst xmlns:a="http://schemas.openxmlformats.org/drawingml/2006/main">
               <a:ext uri="{FF2B5EF4-FFF2-40B4-BE49-F238E27FC236}">
-                <a16:creationId xmlns:a16="http://schemas.microsoft.com/office/drawing/2014/main" id="{62CF4578-1897-4A89-9A37-4DF5339D453A}"/>
+                <a16:creationId xmlns:a16="http://schemas.microsoft.com/office/drawing/2014/main" id="{E4FF16ED-7D68-4FD8-B5AD-BCF2968B3B4A}"/>
               </a:ext>
             </a:extLst>
           </p:cNvPr>
@@ -3848,7 +3848,7 @@
           <p:cNvPr id="13" name="practice-connector-1">
             <a:extLst xmlns:a="http://schemas.openxmlformats.org/drawingml/2006/main">
               <a:ext uri="{FF2B5EF4-FFF2-40B4-BE49-F238E27FC236}">
-                <a16:creationId xmlns:a16="http://schemas.microsoft.com/office/drawing/2014/main" id="{9EC5FB49-0D26-4487-B99C-61CA9F9684E0}"/>
+                <a16:creationId xmlns:a16="http://schemas.microsoft.com/office/drawing/2014/main" id="{4AAA9C64-644B-48E5-9300-371F17A6EB6E}"/>
               </a:ext>
             </a:extLst>
           </p:cNvPr>
@@ -3879,7 +3879,7 @@
           <p:cNvPr id="14" name="practice-circle-2">
             <a:extLst xmlns:a="http://schemas.openxmlformats.org/drawingml/2006/main">
               <a:ext uri="{FF2B5EF4-FFF2-40B4-BE49-F238E27FC236}">
-                <a16:creationId xmlns:a16="http://schemas.microsoft.com/office/drawing/2014/main" id="{A89363AA-B04B-483F-B815-D95B8B377388}"/>
+                <a16:creationId xmlns:a16="http://schemas.microsoft.com/office/drawing/2014/main" id="{4EB132D1-BDEF-4797-92A0-7ECE1405F1AF}"/>
               </a:ext>
             </a:extLst>
           </p:cNvPr>
@@ -3912,7 +3912,7 @@
           <p:cNvPr id="15" name="practice-number-2">
             <a:extLst xmlns:a="http://schemas.openxmlformats.org/drawingml/2006/main">
               <a:ext uri="{FF2B5EF4-FFF2-40B4-BE49-F238E27FC236}">
-                <a16:creationId xmlns:a16="http://schemas.microsoft.com/office/drawing/2014/main" id="{8F0420F1-E85E-4325-AAFA-724ADD4B0BFC}"/>
+                <a16:creationId xmlns:a16="http://schemas.microsoft.com/office/drawing/2014/main" id="{050320CA-8241-4A9F-AB52-8B6ED4F01650}"/>
               </a:ext>
             </a:extLst>
           </p:cNvPr>
@@ -3970,7 +3970,7 @@
           <p:cNvPr id="16" name="practice-item-2">
             <a:extLst xmlns:a="http://schemas.openxmlformats.org/drawingml/2006/main">
               <a:ext uri="{FF2B5EF4-FFF2-40B4-BE49-F238E27FC236}">
-                <a16:creationId xmlns:a16="http://schemas.microsoft.com/office/drawing/2014/main" id="{8048D186-D52E-43B2-801C-BB17ABCE37B9}"/>
+                <a16:creationId xmlns:a16="http://schemas.microsoft.com/office/drawing/2014/main" id="{4777650D-0958-41D4-A6B9-79E97AD85C5B}"/>
               </a:ext>
             </a:extLst>
           </p:cNvPr>
@@ -4032,7 +4032,7 @@
     </p:spTree>
     <p:extLst>
       <p:ext uri="{BB962C8B-B14F-4D97-AF65-F5344CB8AC3E}">
-        <p14:creationId xmlns:p14="http://schemas.microsoft.com/office/powerpoint/2010/main" val="766065132"/>
+        <p14:creationId xmlns:p14="http://schemas.microsoft.com/office/powerpoint/2010/main" val="2138593163"/>
       </p:ext>
     </p:extLst>
   </p:cSld>
@@ -4063,7 +4063,7 @@
           <p:cNvPr id="1" name="s12-rule">
             <a:extLst xmlns:a="http://schemas.openxmlformats.org/drawingml/2006/main">
               <a:ext uri="{FF2B5EF4-FFF2-40B4-BE49-F238E27FC236}">
-                <a16:creationId xmlns:a16="http://schemas.microsoft.com/office/drawing/2014/main" id="{6FDC74B7-B200-4D09-AE27-287F566CEABC}"/>
+                <a16:creationId xmlns:a16="http://schemas.microsoft.com/office/drawing/2014/main" id="{8A025250-E0D2-45F6-B94D-C3646B50CDF2}"/>
               </a:ext>
             </a:extLst>
           </p:cNvPr>
@@ -4096,7 +4096,7 @@
           <p:cNvPr id="2" name="s12-eyebrow">
             <a:extLst xmlns:a="http://schemas.openxmlformats.org/drawingml/2006/main">
               <a:ext uri="{FF2B5EF4-FFF2-40B4-BE49-F238E27FC236}">
-                <a16:creationId xmlns:a16="http://schemas.microsoft.com/office/drawing/2014/main" id="{2CC6A3C0-58CE-4EC0-8C58-BF6310C391D0}"/>
+                <a16:creationId xmlns:a16="http://schemas.microsoft.com/office/drawing/2014/main" id="{6003A711-F8D3-4B31-B15F-524CA73C1E18}"/>
               </a:ext>
             </a:extLst>
           </p:cNvPr>
@@ -4154,7 +4154,7 @@
           <p:cNvPr id="3" name="s12-title">
             <a:extLst xmlns:a="http://schemas.openxmlformats.org/drawingml/2006/main">
               <a:ext uri="{FF2B5EF4-FFF2-40B4-BE49-F238E27FC236}">
-                <a16:creationId xmlns:a16="http://schemas.microsoft.com/office/drawing/2014/main" id="{97463BB0-3B91-4EDE-942A-8073ADC31B3A}"/>
+                <a16:creationId xmlns:a16="http://schemas.microsoft.com/office/drawing/2014/main" id="{1B6A2FE8-4AB4-4CF0-9955-B223941DDE0A}"/>
               </a:ext>
             </a:extLst>
           </p:cNvPr>
@@ -4212,7 +4212,7 @@
           <p:cNvPr id="4" name="s12-footer">
             <a:extLst xmlns:a="http://schemas.openxmlformats.org/drawingml/2006/main">
               <a:ext uri="{FF2B5EF4-FFF2-40B4-BE49-F238E27FC236}">
-                <a16:creationId xmlns:a16="http://schemas.microsoft.com/office/drawing/2014/main" id="{4C514CD0-4123-484D-9E26-F33DBC54241C}"/>
+                <a16:creationId xmlns:a16="http://schemas.microsoft.com/office/drawing/2014/main" id="{F0C2368D-7B6D-4A88-A9DF-EC11ECA81048}"/>
               </a:ext>
             </a:extLst>
           </p:cNvPr>
@@ -4243,7 +4243,7 @@
           <p:cNvPr id="5" name="s12-identity">
             <a:extLst xmlns:a="http://schemas.openxmlformats.org/drawingml/2006/main">
               <a:ext uri="{FF2B5EF4-FFF2-40B4-BE49-F238E27FC236}">
-                <a16:creationId xmlns:a16="http://schemas.microsoft.com/office/drawing/2014/main" id="{0945D464-5D5B-4AE2-B1EB-3D720BF225AA}"/>
+                <a16:creationId xmlns:a16="http://schemas.microsoft.com/office/drawing/2014/main" id="{CF868FB1-96AE-4EA6-B235-35B4F771522B}"/>
               </a:ext>
             </a:extLst>
           </p:cNvPr>
@@ -4301,7 +4301,7 @@
           <p:cNvPr id="6" name="recap-circle-0">
             <a:extLst xmlns:a="http://schemas.openxmlformats.org/drawingml/2006/main">
               <a:ext uri="{FF2B5EF4-FFF2-40B4-BE49-F238E27FC236}">
-                <a16:creationId xmlns:a16="http://schemas.microsoft.com/office/drawing/2014/main" id="{5818F847-CD56-421A-9B96-B8C9E94ADBF6}"/>
+                <a16:creationId xmlns:a16="http://schemas.microsoft.com/office/drawing/2014/main" id="{5374F282-21DA-4583-B686-15CF43525146}"/>
               </a:ext>
             </a:extLst>
           </p:cNvPr>
@@ -4334,7 +4334,7 @@
           <p:cNvPr id="7" name="recap-number-0">
             <a:extLst xmlns:a="http://schemas.openxmlformats.org/drawingml/2006/main">
               <a:ext uri="{FF2B5EF4-FFF2-40B4-BE49-F238E27FC236}">
-                <a16:creationId xmlns:a16="http://schemas.microsoft.com/office/drawing/2014/main" id="{906B470F-DDD6-412F-BCE7-F85478374F9E}"/>
+                <a16:creationId xmlns:a16="http://schemas.microsoft.com/office/drawing/2014/main" id="{DE30CBBF-A38D-46C5-9195-C98C8D190C32}"/>
               </a:ext>
             </a:extLst>
           </p:cNvPr>
@@ -4392,7 +4392,7 @@
           <p:cNvPr id="8" name="recap-item-0">
             <a:extLst xmlns:a="http://schemas.openxmlformats.org/drawingml/2006/main">
               <a:ext uri="{FF2B5EF4-FFF2-40B4-BE49-F238E27FC236}">
-                <a16:creationId xmlns:a16="http://schemas.microsoft.com/office/drawing/2014/main" id="{802AF1C1-CC2E-4CA8-916A-7607B6ED3B93}"/>
+                <a16:creationId xmlns:a16="http://schemas.microsoft.com/office/drawing/2014/main" id="{B6851A7F-74A3-4049-81F2-8D599AEF0097}"/>
               </a:ext>
             </a:extLst>
           </p:cNvPr>
@@ -4456,7 +4456,7 @@
           <p:cNvPr id="9" name="recap-connector-0">
             <a:extLst xmlns:a="http://schemas.openxmlformats.org/drawingml/2006/main">
               <a:ext uri="{FF2B5EF4-FFF2-40B4-BE49-F238E27FC236}">
-                <a16:creationId xmlns:a16="http://schemas.microsoft.com/office/drawing/2014/main" id="{C43E4C9A-2E12-4FE3-AC11-D1255CCB8A2B}"/>
+                <a16:creationId xmlns:a16="http://schemas.microsoft.com/office/drawing/2014/main" id="{9236B71F-C8FF-42E6-BB71-32CEF98F01B5}"/>
               </a:ext>
             </a:extLst>
           </p:cNvPr>
@@ -4487,7 +4487,7 @@
           <p:cNvPr id="10" name="recap-circle-1">
             <a:extLst xmlns:a="http://schemas.openxmlformats.org/drawingml/2006/main">
               <a:ext uri="{FF2B5EF4-FFF2-40B4-BE49-F238E27FC236}">
-                <a16:creationId xmlns:a16="http://schemas.microsoft.com/office/drawing/2014/main" id="{6804AE4C-55A5-4430-8A19-B69B68EA2E7D}"/>
+                <a16:creationId xmlns:a16="http://schemas.microsoft.com/office/drawing/2014/main" id="{9F02E4A2-087F-4036-838E-FD77563E4337}"/>
               </a:ext>
             </a:extLst>
           </p:cNvPr>
@@ -4520,7 +4520,7 @@
           <p:cNvPr id="11" name="recap-number-1">
             <a:extLst xmlns:a="http://schemas.openxmlformats.org/drawingml/2006/main">
               <a:ext uri="{FF2B5EF4-FFF2-40B4-BE49-F238E27FC236}">
-                <a16:creationId xmlns:a16="http://schemas.microsoft.com/office/drawing/2014/main" id="{EB6FE491-D994-499B-A7C4-281A01D8AA43}"/>
+                <a16:creationId xmlns:a16="http://schemas.microsoft.com/office/drawing/2014/main" id="{2E99638D-1F6D-40D2-A276-A2BDE0A591CD}"/>
               </a:ext>
             </a:extLst>
           </p:cNvPr>
@@ -4578,7 +4578,7 @@
           <p:cNvPr id="12" name="recap-item-1">
             <a:extLst xmlns:a="http://schemas.openxmlformats.org/drawingml/2006/main">
               <a:ext uri="{FF2B5EF4-FFF2-40B4-BE49-F238E27FC236}">
-                <a16:creationId xmlns:a16="http://schemas.microsoft.com/office/drawing/2014/main" id="{55349167-3D5F-4B7F-8793-E4B20198161C}"/>
+                <a16:creationId xmlns:a16="http://schemas.microsoft.com/office/drawing/2014/main" id="{C87296E8-42C1-4733-B833-D35E1E457FA1}"/>
               </a:ext>
             </a:extLst>
           </p:cNvPr>
@@ -4642,7 +4642,7 @@
           <p:cNvPr id="13" name="recap-connector-1">
             <a:extLst xmlns:a="http://schemas.openxmlformats.org/drawingml/2006/main">
               <a:ext uri="{FF2B5EF4-FFF2-40B4-BE49-F238E27FC236}">
-                <a16:creationId xmlns:a16="http://schemas.microsoft.com/office/drawing/2014/main" id="{AA620BC2-CC94-40D4-BAC6-8735DBC09939}"/>
+                <a16:creationId xmlns:a16="http://schemas.microsoft.com/office/drawing/2014/main" id="{6A053692-13FF-4F3C-890C-F5811E24E865}"/>
               </a:ext>
             </a:extLst>
           </p:cNvPr>
@@ -4673,7 +4673,7 @@
           <p:cNvPr id="14" name="recap-circle-2">
             <a:extLst xmlns:a="http://schemas.openxmlformats.org/drawingml/2006/main">
               <a:ext uri="{FF2B5EF4-FFF2-40B4-BE49-F238E27FC236}">
-                <a16:creationId xmlns:a16="http://schemas.microsoft.com/office/drawing/2014/main" id="{E900F891-FC03-4A4C-94FC-DCC6539E4497}"/>
+                <a16:creationId xmlns:a16="http://schemas.microsoft.com/office/drawing/2014/main" id="{3B75C3F1-0058-452A-BE65-EF38B18229FF}"/>
               </a:ext>
             </a:extLst>
           </p:cNvPr>
@@ -4706,7 +4706,7 @@
           <p:cNvPr id="15" name="recap-number-2">
             <a:extLst xmlns:a="http://schemas.openxmlformats.org/drawingml/2006/main">
               <a:ext uri="{FF2B5EF4-FFF2-40B4-BE49-F238E27FC236}">
-                <a16:creationId xmlns:a16="http://schemas.microsoft.com/office/drawing/2014/main" id="{B68A3D19-CC27-47C0-8C31-DE9463A4C94A}"/>
+                <a16:creationId xmlns:a16="http://schemas.microsoft.com/office/drawing/2014/main" id="{EBDCF9BD-669A-4058-941D-F14712842103}"/>
               </a:ext>
             </a:extLst>
           </p:cNvPr>
@@ -4764,7 +4764,7 @@
           <p:cNvPr id="16" name="recap-item-2">
             <a:extLst xmlns:a="http://schemas.openxmlformats.org/drawingml/2006/main">
               <a:ext uri="{FF2B5EF4-FFF2-40B4-BE49-F238E27FC236}">
-                <a16:creationId xmlns:a16="http://schemas.microsoft.com/office/drawing/2014/main" id="{B6509A6E-11CA-4473-9118-3AF9740C57CF}"/>
+                <a16:creationId xmlns:a16="http://schemas.microsoft.com/office/drawing/2014/main" id="{7505CE72-EFD9-4861-B77B-335CDBAAD952}"/>
               </a:ext>
             </a:extLst>
           </p:cNvPr>
@@ -4826,7 +4826,7 @@
     </p:spTree>
     <p:extLst>
       <p:ext uri="{BB962C8B-B14F-4D97-AF65-F5344CB8AC3E}">
-        <p14:creationId xmlns:p14="http://schemas.microsoft.com/office/powerpoint/2010/main" val="417828205"/>
+        <p14:creationId xmlns:p14="http://schemas.microsoft.com/office/powerpoint/2010/main" val="1581158367"/>
       </p:ext>
     </p:extLst>
   </p:cSld>
@@ -4857,7 +4857,7 @@
           <p:cNvPr id="1" name="s13-rule">
             <a:extLst xmlns:a="http://schemas.openxmlformats.org/drawingml/2006/main">
               <a:ext uri="{FF2B5EF4-FFF2-40B4-BE49-F238E27FC236}">
-                <a16:creationId xmlns:a16="http://schemas.microsoft.com/office/drawing/2014/main" id="{65A3990C-C778-4E82-B697-38E0AC968406}"/>
+                <a16:creationId xmlns:a16="http://schemas.microsoft.com/office/drawing/2014/main" id="{0D0B7F87-7417-49B9-848A-F0737A6E2D7F}"/>
               </a:ext>
             </a:extLst>
           </p:cNvPr>
@@ -4890,7 +4890,7 @@
           <p:cNvPr id="2" name="s13-eyebrow">
             <a:extLst xmlns:a="http://schemas.openxmlformats.org/drawingml/2006/main">
               <a:ext uri="{FF2B5EF4-FFF2-40B4-BE49-F238E27FC236}">
-                <a16:creationId xmlns:a16="http://schemas.microsoft.com/office/drawing/2014/main" id="{10BBB40F-6EE4-40EF-B73A-04F4C664123C}"/>
+                <a16:creationId xmlns:a16="http://schemas.microsoft.com/office/drawing/2014/main" id="{5934EF5A-35AD-4DE4-A2EB-A533ECA3458D}"/>
               </a:ext>
             </a:extLst>
           </p:cNvPr>
@@ -4948,7 +4948,7 @@
           <p:cNvPr id="3" name="s13-title">
             <a:extLst xmlns:a="http://schemas.openxmlformats.org/drawingml/2006/main">
               <a:ext uri="{FF2B5EF4-FFF2-40B4-BE49-F238E27FC236}">
-                <a16:creationId xmlns:a16="http://schemas.microsoft.com/office/drawing/2014/main" id="{996CD768-DCB0-4AE0-9350-CB3C7BF584B3}"/>
+                <a16:creationId xmlns:a16="http://schemas.microsoft.com/office/drawing/2014/main" id="{6622C557-9F85-4ED8-952F-99913162E86F}"/>
               </a:ext>
             </a:extLst>
           </p:cNvPr>
@@ -5006,7 +5006,7 @@
           <p:cNvPr id="4" name="s13-footer">
             <a:extLst xmlns:a="http://schemas.openxmlformats.org/drawingml/2006/main">
               <a:ext uri="{FF2B5EF4-FFF2-40B4-BE49-F238E27FC236}">
-                <a16:creationId xmlns:a16="http://schemas.microsoft.com/office/drawing/2014/main" id="{E77B22A0-775A-4F8C-AE68-36074D8ABC73}"/>
+                <a16:creationId xmlns:a16="http://schemas.microsoft.com/office/drawing/2014/main" id="{243A501F-BF98-4E45-A1B0-D36B23A81D7B}"/>
               </a:ext>
             </a:extLst>
           </p:cNvPr>
@@ -5037,7 +5037,7 @@
           <p:cNvPr id="5" name="s13-identity">
             <a:extLst xmlns:a="http://schemas.openxmlformats.org/drawingml/2006/main">
               <a:ext uri="{FF2B5EF4-FFF2-40B4-BE49-F238E27FC236}">
-                <a16:creationId xmlns:a16="http://schemas.microsoft.com/office/drawing/2014/main" id="{19DA1E47-E0B3-4B6E-B572-5CBA4D62D753}"/>
+                <a16:creationId xmlns:a16="http://schemas.microsoft.com/office/drawing/2014/main" id="{241D0412-931C-4591-8055-5DAA7E975193}"/>
               </a:ext>
             </a:extLst>
           </p:cNvPr>
@@ -5095,7 +5095,7 @@
           <p:cNvPr id="6" name="source-0">
             <a:extLst xmlns:a="http://schemas.openxmlformats.org/drawingml/2006/main">
               <a:ext uri="{FF2B5EF4-FFF2-40B4-BE49-F238E27FC236}">
-                <a16:creationId xmlns:a16="http://schemas.microsoft.com/office/drawing/2014/main" id="{78984A93-B898-46D5-B724-2B9354F2C967}"/>
+                <a16:creationId xmlns:a16="http://schemas.microsoft.com/office/drawing/2014/main" id="{058F9FAC-1DBE-488F-9296-F5E289502368}"/>
               </a:ext>
             </a:extLst>
           </p:cNvPr>
@@ -5159,7 +5159,7 @@
           <p:cNvPr id="7" name="source-1">
             <a:extLst xmlns:a="http://schemas.openxmlformats.org/drawingml/2006/main">
               <a:ext uri="{FF2B5EF4-FFF2-40B4-BE49-F238E27FC236}">
-                <a16:creationId xmlns:a16="http://schemas.microsoft.com/office/drawing/2014/main" id="{EF0A3629-ED61-4322-821F-1D71D051FDEB}"/>
+                <a16:creationId xmlns:a16="http://schemas.microsoft.com/office/drawing/2014/main" id="{45F70BA0-1B94-4190-80F1-4A48172437FE}"/>
               </a:ext>
             </a:extLst>
           </p:cNvPr>
@@ -5223,7 +5223,7 @@
           <p:cNvPr id="8" name="s13-takeaway-rule">
             <a:extLst xmlns:a="http://schemas.openxmlformats.org/drawingml/2006/main">
               <a:ext uri="{FF2B5EF4-FFF2-40B4-BE49-F238E27FC236}">
-                <a16:creationId xmlns:a16="http://schemas.microsoft.com/office/drawing/2014/main" id="{A13D0C60-A9D2-43CE-9ECD-633310D21B98}"/>
+                <a16:creationId xmlns:a16="http://schemas.microsoft.com/office/drawing/2014/main" id="{471B7884-59F6-4B86-9594-5FC40DDA21F5}"/>
               </a:ext>
             </a:extLst>
           </p:cNvPr>
@@ -5256,7 +5256,7 @@
           <p:cNvPr id="9" name="s13-takeaway">
             <a:extLst xmlns:a="http://schemas.openxmlformats.org/drawingml/2006/main">
               <a:ext uri="{FF2B5EF4-FFF2-40B4-BE49-F238E27FC236}">
-                <a16:creationId xmlns:a16="http://schemas.microsoft.com/office/drawing/2014/main" id="{97CE24B0-9ABA-4839-9684-46D92CED0409}"/>
+                <a16:creationId xmlns:a16="http://schemas.microsoft.com/office/drawing/2014/main" id="{77E1CD7A-CC1C-4190-A77A-8BBE5CD94D31}"/>
               </a:ext>
             </a:extLst>
           </p:cNvPr>
@@ -5281,7 +5281,7 @@
         </p:spPr>
         <p:txBody>
           <a:bodyPr xmlns:a="http://schemas.openxmlformats.org/drawingml/2006/main" lIns="0" tIns="0" rIns="0" bIns="0" anchor="ctr">
-            <a:normAutofit fontScale="100000"/>
+            <a:normAutofit fontScale="95911"/>
           </a:bodyPr>
           <a:lstStyle xmlns:a="http://schemas.openxmlformats.org/drawingml/2006/main"/>
           <a:p xmlns:a="http://schemas.openxmlformats.org/drawingml/2006/main">
@@ -5304,7 +5304,7 @@
                 <a:ea typeface="PingFang SC"/>
                 <a:cs typeface="PingFang SC"/>
               </a:rPr>
-              <a:t>公开幻灯片只使用课程原创文字与原生图形；完整论证、链接和事实边界请见本节讲义。</a:t>
+              <a:t>课程精编页用于讲授主线；播放器中的“原课件”模式保留团队 PowerPoint 精选页、真实图片和可播放视频。</a:t>
             </a:r>
           </a:p>
         </p:txBody>
@@ -5312,7 +5312,7 @@
     </p:spTree>
     <p:extLst>
       <p:ext uri="{BB962C8B-B14F-4D97-AF65-F5344CB8AC3E}">
-        <p14:creationId xmlns:p14="http://schemas.microsoft.com/office/powerpoint/2010/main" val="729204351"/>
+        <p14:creationId xmlns:p14="http://schemas.microsoft.com/office/powerpoint/2010/main" val="1090357188"/>
       </p:ext>
     </p:extLst>
   </p:cSld>
@@ -5343,7 +5343,7 @@
           <p:cNvPr id="1" name="s2-rule">
             <a:extLst xmlns:a="http://schemas.openxmlformats.org/drawingml/2006/main">
               <a:ext uri="{FF2B5EF4-FFF2-40B4-BE49-F238E27FC236}">
-                <a16:creationId xmlns:a16="http://schemas.microsoft.com/office/drawing/2014/main" id="{D06E4E61-AF05-415F-8FDC-0AEAB7C18287}"/>
+                <a16:creationId xmlns:a16="http://schemas.microsoft.com/office/drawing/2014/main" id="{70F28821-70A1-451D-A05D-CCD9E94F8B6A}"/>
               </a:ext>
             </a:extLst>
           </p:cNvPr>
@@ -5376,7 +5376,7 @@
           <p:cNvPr id="2" name="s2-eyebrow">
             <a:extLst xmlns:a="http://schemas.openxmlformats.org/drawingml/2006/main">
               <a:ext uri="{FF2B5EF4-FFF2-40B4-BE49-F238E27FC236}">
-                <a16:creationId xmlns:a16="http://schemas.microsoft.com/office/drawing/2014/main" id="{1481AB3F-3732-43A0-A881-ADBC8F9895B9}"/>
+                <a16:creationId xmlns:a16="http://schemas.microsoft.com/office/drawing/2014/main" id="{A5DEFC42-3670-4848-B1ED-2E28DF1F03D7}"/>
               </a:ext>
             </a:extLst>
           </p:cNvPr>
@@ -5434,7 +5434,7 @@
           <p:cNvPr id="3" name="s2-title">
             <a:extLst xmlns:a="http://schemas.openxmlformats.org/drawingml/2006/main">
               <a:ext uri="{FF2B5EF4-FFF2-40B4-BE49-F238E27FC236}">
-                <a16:creationId xmlns:a16="http://schemas.microsoft.com/office/drawing/2014/main" id="{DF50E1BC-857A-4728-A30C-A195D5EED103}"/>
+                <a16:creationId xmlns:a16="http://schemas.microsoft.com/office/drawing/2014/main" id="{95E83DF1-88B8-44F8-8D8F-260372EA44DB}"/>
               </a:ext>
             </a:extLst>
           </p:cNvPr>
@@ -5492,7 +5492,7 @@
           <p:cNvPr id="4" name="s2-footer">
             <a:extLst xmlns:a="http://schemas.openxmlformats.org/drawingml/2006/main">
               <a:ext uri="{FF2B5EF4-FFF2-40B4-BE49-F238E27FC236}">
-                <a16:creationId xmlns:a16="http://schemas.microsoft.com/office/drawing/2014/main" id="{30E506BB-71D8-40A4-B167-D4D37DCCFECB}"/>
+                <a16:creationId xmlns:a16="http://schemas.microsoft.com/office/drawing/2014/main" id="{78586641-DEF3-4FA3-8FD8-39BC23A4010E}"/>
               </a:ext>
             </a:extLst>
           </p:cNvPr>
@@ -5523,7 +5523,7 @@
           <p:cNvPr id="5" name="s2-identity">
             <a:extLst xmlns:a="http://schemas.openxmlformats.org/drawingml/2006/main">
               <a:ext uri="{FF2B5EF4-FFF2-40B4-BE49-F238E27FC236}">
-                <a16:creationId xmlns:a16="http://schemas.microsoft.com/office/drawing/2014/main" id="{88BACEDB-0C48-4453-844B-3A8648EB8927}"/>
+                <a16:creationId xmlns:a16="http://schemas.microsoft.com/office/drawing/2014/main" id="{0CA60895-449C-4230-B089-222FA5E0B5B1}"/>
               </a:ext>
             </a:extLst>
           </p:cNvPr>
@@ -5581,7 +5581,7 @@
           <p:cNvPr id="6" name="objective-1">
             <a:extLst xmlns:a="http://schemas.openxmlformats.org/drawingml/2006/main">
               <a:ext uri="{FF2B5EF4-FFF2-40B4-BE49-F238E27FC236}">
-                <a16:creationId xmlns:a16="http://schemas.microsoft.com/office/drawing/2014/main" id="{9B3FF68E-C0AF-4F31-BC68-72CB22DEA8BF}"/>
+                <a16:creationId xmlns:a16="http://schemas.microsoft.com/office/drawing/2014/main" id="{E242E30D-E39F-46B2-B654-30F12040C7D4}"/>
               </a:ext>
             </a:extLst>
           </p:cNvPr>
@@ -5668,7 +5668,7 @@
           <p:cNvPr id="7" name="objective-2">
             <a:extLst xmlns:a="http://schemas.openxmlformats.org/drawingml/2006/main">
               <a:ext uri="{FF2B5EF4-FFF2-40B4-BE49-F238E27FC236}">
-                <a16:creationId xmlns:a16="http://schemas.microsoft.com/office/drawing/2014/main" id="{E2B48CEA-795C-4A9F-9243-48C658873287}"/>
+                <a16:creationId xmlns:a16="http://schemas.microsoft.com/office/drawing/2014/main" id="{0E338C33-EA4F-4790-896F-122575C7EE1D}"/>
               </a:ext>
             </a:extLst>
           </p:cNvPr>
@@ -5755,7 +5755,7 @@
           <p:cNvPr id="8" name="objective-3">
             <a:extLst xmlns:a="http://schemas.openxmlformats.org/drawingml/2006/main">
               <a:ext uri="{FF2B5EF4-FFF2-40B4-BE49-F238E27FC236}">
-                <a16:creationId xmlns:a16="http://schemas.microsoft.com/office/drawing/2014/main" id="{F7DFE80D-F2B9-49F5-BD5E-34BF4DB723FB}"/>
+                <a16:creationId xmlns:a16="http://schemas.microsoft.com/office/drawing/2014/main" id="{7C0AA573-A6DC-40A5-BDBA-4ECA7E01B357}"/>
               </a:ext>
             </a:extLst>
           </p:cNvPr>
@@ -5842,7 +5842,7 @@
           <p:cNvPr id="9" name="objective-4">
             <a:extLst xmlns:a="http://schemas.openxmlformats.org/drawingml/2006/main">
               <a:ext uri="{FF2B5EF4-FFF2-40B4-BE49-F238E27FC236}">
-                <a16:creationId xmlns:a16="http://schemas.microsoft.com/office/drawing/2014/main" id="{77C390B1-5D86-4076-BFCA-EEE5F50C8AE4}"/>
+                <a16:creationId xmlns:a16="http://schemas.microsoft.com/office/drawing/2014/main" id="{A1577789-4B6D-4969-B5D3-5464F6723F37}"/>
               </a:ext>
             </a:extLst>
           </p:cNvPr>
@@ -5927,7 +5927,7 @@
     </p:spTree>
     <p:extLst>
       <p:ext uri="{BB962C8B-B14F-4D97-AF65-F5344CB8AC3E}">
-        <p14:creationId xmlns:p14="http://schemas.microsoft.com/office/powerpoint/2010/main" val="1075660512"/>
+        <p14:creationId xmlns:p14="http://schemas.microsoft.com/office/powerpoint/2010/main" val="819179579"/>
       </p:ext>
     </p:extLst>
   </p:cSld>
@@ -5958,7 +5958,7 @@
           <p:cNvPr id="1" name="s3-rule">
             <a:extLst xmlns:a="http://schemas.openxmlformats.org/drawingml/2006/main">
               <a:ext uri="{FF2B5EF4-FFF2-40B4-BE49-F238E27FC236}">
-                <a16:creationId xmlns:a16="http://schemas.microsoft.com/office/drawing/2014/main" id="{3E6034AD-6530-4B66-8485-3DBD0352CAD1}"/>
+                <a16:creationId xmlns:a16="http://schemas.microsoft.com/office/drawing/2014/main" id="{C900350C-D942-4450-984E-1C0237025D88}"/>
               </a:ext>
             </a:extLst>
           </p:cNvPr>
@@ -5991,7 +5991,7 @@
           <p:cNvPr id="2" name="s3-eyebrow">
             <a:extLst xmlns:a="http://schemas.openxmlformats.org/drawingml/2006/main">
               <a:ext uri="{FF2B5EF4-FFF2-40B4-BE49-F238E27FC236}">
-                <a16:creationId xmlns:a16="http://schemas.microsoft.com/office/drawing/2014/main" id="{9F7F8499-131E-4E63-95B4-EBBD170AD42A}"/>
+                <a16:creationId xmlns:a16="http://schemas.microsoft.com/office/drawing/2014/main" id="{DD59A4AF-EBB3-4A34-9DA1-500374772094}"/>
               </a:ext>
             </a:extLst>
           </p:cNvPr>
@@ -6049,7 +6049,7 @@
           <p:cNvPr id="3" name="s3-title">
             <a:extLst xmlns:a="http://schemas.openxmlformats.org/drawingml/2006/main">
               <a:ext uri="{FF2B5EF4-FFF2-40B4-BE49-F238E27FC236}">
-                <a16:creationId xmlns:a16="http://schemas.microsoft.com/office/drawing/2014/main" id="{9FB81894-B6A3-4EB8-B2E6-A24C1184C19D}"/>
+                <a16:creationId xmlns:a16="http://schemas.microsoft.com/office/drawing/2014/main" id="{F94FBE2F-58D6-4531-B2D7-621932E4E67E}"/>
               </a:ext>
             </a:extLst>
           </p:cNvPr>
@@ -6107,7 +6107,7 @@
           <p:cNvPr id="4" name="s3-footer">
             <a:extLst xmlns:a="http://schemas.openxmlformats.org/drawingml/2006/main">
               <a:ext uri="{FF2B5EF4-FFF2-40B4-BE49-F238E27FC236}">
-                <a16:creationId xmlns:a16="http://schemas.microsoft.com/office/drawing/2014/main" id="{0E363CBA-E80D-4F06-ABF3-7109DE4E156D}"/>
+                <a16:creationId xmlns:a16="http://schemas.microsoft.com/office/drawing/2014/main" id="{A7378D4C-F113-4FDE-BEEB-DD5DCD30345D}"/>
               </a:ext>
             </a:extLst>
           </p:cNvPr>
@@ -6138,7 +6138,7 @@
           <p:cNvPr id="5" name="s3-identity">
             <a:extLst xmlns:a="http://schemas.openxmlformats.org/drawingml/2006/main">
               <a:ext uri="{FF2B5EF4-FFF2-40B4-BE49-F238E27FC236}">
-                <a16:creationId xmlns:a16="http://schemas.microsoft.com/office/drawing/2014/main" id="{2B03FD2E-D5C6-4BC3-B2F8-4B1737952D8F}"/>
+                <a16:creationId xmlns:a16="http://schemas.microsoft.com/office/drawing/2014/main" id="{50B5F6C9-2873-4BF9-A554-5968F59CF106}"/>
               </a:ext>
             </a:extLst>
           </p:cNvPr>
@@ -6196,7 +6196,7 @@
           <p:cNvPr id="6" name="core-no-0">
             <a:extLst xmlns:a="http://schemas.openxmlformats.org/drawingml/2006/main">
               <a:ext uri="{FF2B5EF4-FFF2-40B4-BE49-F238E27FC236}">
-                <a16:creationId xmlns:a16="http://schemas.microsoft.com/office/drawing/2014/main" id="{837E721C-2D89-4587-8D17-7CD9F2007809}"/>
+                <a16:creationId xmlns:a16="http://schemas.microsoft.com/office/drawing/2014/main" id="{B430C714-1911-4DBD-9778-DC92E06C4EB3}"/>
               </a:ext>
             </a:extLst>
           </p:cNvPr>
@@ -6254,7 +6254,7 @@
           <p:cNvPr id="7" name="core-label-0">
             <a:extLst xmlns:a="http://schemas.openxmlformats.org/drawingml/2006/main">
               <a:ext uri="{FF2B5EF4-FFF2-40B4-BE49-F238E27FC236}">
-                <a16:creationId xmlns:a16="http://schemas.microsoft.com/office/drawing/2014/main" id="{F7E7F752-0D57-4DF4-85AC-A0BB9E7D9B75}"/>
+                <a16:creationId xmlns:a16="http://schemas.microsoft.com/office/drawing/2014/main" id="{4D8C620D-8E7D-4E93-995D-680888A65F5E}"/>
               </a:ext>
             </a:extLst>
           </p:cNvPr>
@@ -6312,7 +6312,7 @@
           <p:cNvPr id="8" name="core-body-0">
             <a:extLst xmlns:a="http://schemas.openxmlformats.org/drawingml/2006/main">
               <a:ext uri="{FF2B5EF4-FFF2-40B4-BE49-F238E27FC236}">
-                <a16:creationId xmlns:a16="http://schemas.microsoft.com/office/drawing/2014/main" id="{712AD8A2-5EBC-42A2-93AB-99E540077040}"/>
+                <a16:creationId xmlns:a16="http://schemas.microsoft.com/office/drawing/2014/main" id="{AD5B08DA-F97F-4D1F-A904-5566A8FA7784}"/>
               </a:ext>
             </a:extLst>
           </p:cNvPr>
@@ -6376,7 +6376,7 @@
           <p:cNvPr id="9" name="core-no-1">
             <a:extLst xmlns:a="http://schemas.openxmlformats.org/drawingml/2006/main">
               <a:ext uri="{FF2B5EF4-FFF2-40B4-BE49-F238E27FC236}">
-                <a16:creationId xmlns:a16="http://schemas.microsoft.com/office/drawing/2014/main" id="{35F145BC-39AA-4052-97CD-305B39B9EDF7}"/>
+                <a16:creationId xmlns:a16="http://schemas.microsoft.com/office/drawing/2014/main" id="{6AB2D4AB-7AF5-4811-BFA7-ECE04BEEF85A}"/>
               </a:ext>
             </a:extLst>
           </p:cNvPr>
@@ -6434,7 +6434,7 @@
           <p:cNvPr id="10" name="core-label-1">
             <a:extLst xmlns:a="http://schemas.openxmlformats.org/drawingml/2006/main">
               <a:ext uri="{FF2B5EF4-FFF2-40B4-BE49-F238E27FC236}">
-                <a16:creationId xmlns:a16="http://schemas.microsoft.com/office/drawing/2014/main" id="{7BB2EAC3-61CB-48C0-9FB0-1966E099B8A3}"/>
+                <a16:creationId xmlns:a16="http://schemas.microsoft.com/office/drawing/2014/main" id="{1247B44F-6572-44A9-BD85-55B4B2170F37}"/>
               </a:ext>
             </a:extLst>
           </p:cNvPr>
@@ -6492,7 +6492,7 @@
           <p:cNvPr id="11" name="core-body-1">
             <a:extLst xmlns:a="http://schemas.openxmlformats.org/drawingml/2006/main">
               <a:ext uri="{FF2B5EF4-FFF2-40B4-BE49-F238E27FC236}">
-                <a16:creationId xmlns:a16="http://schemas.microsoft.com/office/drawing/2014/main" id="{B0F5CB41-7B5D-4AD2-8CD0-EADB4B01DDBE}"/>
+                <a16:creationId xmlns:a16="http://schemas.microsoft.com/office/drawing/2014/main" id="{B3440619-FA07-461D-9186-70976EEAFF1E}"/>
               </a:ext>
             </a:extLst>
           </p:cNvPr>
@@ -6556,7 +6556,7 @@
           <p:cNvPr id="12" name="s3-takeaway-rule">
             <a:extLst xmlns:a="http://schemas.openxmlformats.org/drawingml/2006/main">
               <a:ext uri="{FF2B5EF4-FFF2-40B4-BE49-F238E27FC236}">
-                <a16:creationId xmlns:a16="http://schemas.microsoft.com/office/drawing/2014/main" id="{B4A61D14-FD92-47CB-AC75-FCEC419E6199}"/>
+                <a16:creationId xmlns:a16="http://schemas.microsoft.com/office/drawing/2014/main" id="{0B4279F8-5FF5-4C1F-80B4-25C742D084B4}"/>
               </a:ext>
             </a:extLst>
           </p:cNvPr>
@@ -6589,7 +6589,7 @@
           <p:cNvPr id="13" name="s3-takeaway">
             <a:extLst xmlns:a="http://schemas.openxmlformats.org/drawingml/2006/main">
               <a:ext uri="{FF2B5EF4-FFF2-40B4-BE49-F238E27FC236}">
-                <a16:creationId xmlns:a16="http://schemas.microsoft.com/office/drawing/2014/main" id="{DB9C8713-DF59-4011-974F-D04C82005E90}"/>
+                <a16:creationId xmlns:a16="http://schemas.microsoft.com/office/drawing/2014/main" id="{CBA71891-51EB-4875-A80E-0B08E9F72CD3}"/>
               </a:ext>
             </a:extLst>
           </p:cNvPr>
@@ -6645,7 +6645,7 @@
     </p:spTree>
     <p:extLst>
       <p:ext uri="{BB962C8B-B14F-4D97-AF65-F5344CB8AC3E}">
-        <p14:creationId xmlns:p14="http://schemas.microsoft.com/office/powerpoint/2010/main" val="686005788"/>
+        <p14:creationId xmlns:p14="http://schemas.microsoft.com/office/powerpoint/2010/main" val="503803759"/>
       </p:ext>
     </p:extLst>
   </p:cSld>
@@ -6676,7 +6676,7 @@
           <p:cNvPr id="1" name="s4-rule">
             <a:extLst xmlns:a="http://schemas.openxmlformats.org/drawingml/2006/main">
               <a:ext uri="{FF2B5EF4-FFF2-40B4-BE49-F238E27FC236}">
-                <a16:creationId xmlns:a16="http://schemas.microsoft.com/office/drawing/2014/main" id="{23793310-83EA-4AE3-B250-B32CCFD3F880}"/>
+                <a16:creationId xmlns:a16="http://schemas.microsoft.com/office/drawing/2014/main" id="{402338A5-A09D-4A1F-A443-CB24841EE3ED}"/>
               </a:ext>
             </a:extLst>
           </p:cNvPr>
@@ -6709,7 +6709,7 @@
           <p:cNvPr id="2" name="s4-eyebrow">
             <a:extLst xmlns:a="http://schemas.openxmlformats.org/drawingml/2006/main">
               <a:ext uri="{FF2B5EF4-FFF2-40B4-BE49-F238E27FC236}">
-                <a16:creationId xmlns:a16="http://schemas.microsoft.com/office/drawing/2014/main" id="{4649E085-8687-4564-8857-091187042DBF}"/>
+                <a16:creationId xmlns:a16="http://schemas.microsoft.com/office/drawing/2014/main" id="{019C6B27-7C1B-4F6D-A082-508E9A141ED1}"/>
               </a:ext>
             </a:extLst>
           </p:cNvPr>
@@ -6767,7 +6767,7 @@
           <p:cNvPr id="3" name="s4-title">
             <a:extLst xmlns:a="http://schemas.openxmlformats.org/drawingml/2006/main">
               <a:ext uri="{FF2B5EF4-FFF2-40B4-BE49-F238E27FC236}">
-                <a16:creationId xmlns:a16="http://schemas.microsoft.com/office/drawing/2014/main" id="{99784D35-2B94-42BF-BC4D-409CDE888ECE}"/>
+                <a16:creationId xmlns:a16="http://schemas.microsoft.com/office/drawing/2014/main" id="{EA2425A0-2569-4C53-8687-2F7B65CC9200}"/>
               </a:ext>
             </a:extLst>
           </p:cNvPr>
@@ -6825,7 +6825,7 @@
           <p:cNvPr id="4" name="s4-footer">
             <a:extLst xmlns:a="http://schemas.openxmlformats.org/drawingml/2006/main">
               <a:ext uri="{FF2B5EF4-FFF2-40B4-BE49-F238E27FC236}">
-                <a16:creationId xmlns:a16="http://schemas.microsoft.com/office/drawing/2014/main" id="{E3586119-478B-4052-ADDA-E2C4BD637806}"/>
+                <a16:creationId xmlns:a16="http://schemas.microsoft.com/office/drawing/2014/main" id="{9F022D41-4AA7-4D70-A180-621E725EB5CA}"/>
               </a:ext>
             </a:extLst>
           </p:cNvPr>
@@ -6856,7 +6856,7 @@
           <p:cNvPr id="5" name="s4-identity">
             <a:extLst xmlns:a="http://schemas.openxmlformats.org/drawingml/2006/main">
               <a:ext uri="{FF2B5EF4-FFF2-40B4-BE49-F238E27FC236}">
-                <a16:creationId xmlns:a16="http://schemas.microsoft.com/office/drawing/2014/main" id="{740F1014-3A9C-4B90-B64F-63A5AA2A5DFD}"/>
+                <a16:creationId xmlns:a16="http://schemas.microsoft.com/office/drawing/2014/main" id="{8D3CC020-3EC2-4B16-AB81-0F626EC25977}"/>
               </a:ext>
             </a:extLst>
           </p:cNvPr>
@@ -6914,7 +6914,7 @@
           <p:cNvPr id="6" name="core-no-0">
             <a:extLst xmlns:a="http://schemas.openxmlformats.org/drawingml/2006/main">
               <a:ext uri="{FF2B5EF4-FFF2-40B4-BE49-F238E27FC236}">
-                <a16:creationId xmlns:a16="http://schemas.microsoft.com/office/drawing/2014/main" id="{37C5F235-D7D4-4E28-A5C9-347C9FCA8CD3}"/>
+                <a16:creationId xmlns:a16="http://schemas.microsoft.com/office/drawing/2014/main" id="{8DF343E7-FE12-44C2-A30C-8C66FE17BCB8}"/>
               </a:ext>
             </a:extLst>
           </p:cNvPr>
@@ -6972,7 +6972,7 @@
           <p:cNvPr id="7" name="core-label-0">
             <a:extLst xmlns:a="http://schemas.openxmlformats.org/drawingml/2006/main">
               <a:ext uri="{FF2B5EF4-FFF2-40B4-BE49-F238E27FC236}">
-                <a16:creationId xmlns:a16="http://schemas.microsoft.com/office/drawing/2014/main" id="{68662708-15DE-48A1-A2E9-18D9D3D841AC}"/>
+                <a16:creationId xmlns:a16="http://schemas.microsoft.com/office/drawing/2014/main" id="{EC3E2C0D-5D63-42A1-A894-C534A3DA2457}"/>
               </a:ext>
             </a:extLst>
           </p:cNvPr>
@@ -7030,7 +7030,7 @@
           <p:cNvPr id="8" name="core-body-0">
             <a:extLst xmlns:a="http://schemas.openxmlformats.org/drawingml/2006/main">
               <a:ext uri="{FF2B5EF4-FFF2-40B4-BE49-F238E27FC236}">
-                <a16:creationId xmlns:a16="http://schemas.microsoft.com/office/drawing/2014/main" id="{11D446C1-F8A4-43B8-BFDD-E3990D4A949E}"/>
+                <a16:creationId xmlns:a16="http://schemas.microsoft.com/office/drawing/2014/main" id="{041F6BC9-96D9-491A-8B6E-51189C3EC8BA}"/>
               </a:ext>
             </a:extLst>
           </p:cNvPr>
@@ -7094,7 +7094,7 @@
           <p:cNvPr id="9" name="core-no-1">
             <a:extLst xmlns:a="http://schemas.openxmlformats.org/drawingml/2006/main">
               <a:ext uri="{FF2B5EF4-FFF2-40B4-BE49-F238E27FC236}">
-                <a16:creationId xmlns:a16="http://schemas.microsoft.com/office/drawing/2014/main" id="{2B4A5FC6-66FF-49AD-8C08-855D8FED80FA}"/>
+                <a16:creationId xmlns:a16="http://schemas.microsoft.com/office/drawing/2014/main" id="{92E99808-1990-4AD6-B9DA-9390202E8AB8}"/>
               </a:ext>
             </a:extLst>
           </p:cNvPr>
@@ -7152,7 +7152,7 @@
           <p:cNvPr id="10" name="core-label-1">
             <a:extLst xmlns:a="http://schemas.openxmlformats.org/drawingml/2006/main">
               <a:ext uri="{FF2B5EF4-FFF2-40B4-BE49-F238E27FC236}">
-                <a16:creationId xmlns:a16="http://schemas.microsoft.com/office/drawing/2014/main" id="{186475B3-869A-4B9E-B602-09581DF7B0FC}"/>
+                <a16:creationId xmlns:a16="http://schemas.microsoft.com/office/drawing/2014/main" id="{40D0C35B-2D5F-4075-9A52-5CD9581B6008}"/>
               </a:ext>
             </a:extLst>
           </p:cNvPr>
@@ -7210,7 +7210,7 @@
           <p:cNvPr id="11" name="core-body-1">
             <a:extLst xmlns:a="http://schemas.openxmlformats.org/drawingml/2006/main">
               <a:ext uri="{FF2B5EF4-FFF2-40B4-BE49-F238E27FC236}">
-                <a16:creationId xmlns:a16="http://schemas.microsoft.com/office/drawing/2014/main" id="{DB92157C-719B-4A3B-866C-DE9EB0E371B6}"/>
+                <a16:creationId xmlns:a16="http://schemas.microsoft.com/office/drawing/2014/main" id="{97103242-2BEC-49A1-83B2-6FCCAA822D56}"/>
               </a:ext>
             </a:extLst>
           </p:cNvPr>
@@ -7274,7 +7274,7 @@
           <p:cNvPr id="12" name="s4-takeaway-rule">
             <a:extLst xmlns:a="http://schemas.openxmlformats.org/drawingml/2006/main">
               <a:ext uri="{FF2B5EF4-FFF2-40B4-BE49-F238E27FC236}">
-                <a16:creationId xmlns:a16="http://schemas.microsoft.com/office/drawing/2014/main" id="{08A1A500-AB30-4924-B023-62752957C3CF}"/>
+                <a16:creationId xmlns:a16="http://schemas.microsoft.com/office/drawing/2014/main" id="{DC839DC5-DBF3-4486-AE0A-788631564C1E}"/>
               </a:ext>
             </a:extLst>
           </p:cNvPr>
@@ -7307,7 +7307,7 @@
           <p:cNvPr id="13" name="s4-takeaway">
             <a:extLst xmlns:a="http://schemas.openxmlformats.org/drawingml/2006/main">
               <a:ext uri="{FF2B5EF4-FFF2-40B4-BE49-F238E27FC236}">
-                <a16:creationId xmlns:a16="http://schemas.microsoft.com/office/drawing/2014/main" id="{E2104934-B45C-4AF5-A014-4C77871AF7BF}"/>
+                <a16:creationId xmlns:a16="http://schemas.microsoft.com/office/drawing/2014/main" id="{FDB8E975-B5D4-45D3-B256-11AC566CA958}"/>
               </a:ext>
             </a:extLst>
           </p:cNvPr>
@@ -7363,7 +7363,7 @@
     </p:spTree>
     <p:extLst>
       <p:ext uri="{BB962C8B-B14F-4D97-AF65-F5344CB8AC3E}">
-        <p14:creationId xmlns:p14="http://schemas.microsoft.com/office/powerpoint/2010/main" val="1192532674"/>
+        <p14:creationId xmlns:p14="http://schemas.microsoft.com/office/powerpoint/2010/main" val="1842811645"/>
       </p:ext>
     </p:extLst>
   </p:cSld>
@@ -7394,7 +7394,7 @@
           <p:cNvPr id="1" name="s5-rule">
             <a:extLst xmlns:a="http://schemas.openxmlformats.org/drawingml/2006/main">
               <a:ext uri="{FF2B5EF4-FFF2-40B4-BE49-F238E27FC236}">
-                <a16:creationId xmlns:a16="http://schemas.microsoft.com/office/drawing/2014/main" id="{4F6C68C8-BD95-4384-8686-8D405F4FEADB}"/>
+                <a16:creationId xmlns:a16="http://schemas.microsoft.com/office/drawing/2014/main" id="{263788F6-654D-4B73-AEE1-2CDC5170C214}"/>
               </a:ext>
             </a:extLst>
           </p:cNvPr>
@@ -7427,7 +7427,7 @@
           <p:cNvPr id="2" name="s5-eyebrow">
             <a:extLst xmlns:a="http://schemas.openxmlformats.org/drawingml/2006/main">
               <a:ext uri="{FF2B5EF4-FFF2-40B4-BE49-F238E27FC236}">
-                <a16:creationId xmlns:a16="http://schemas.microsoft.com/office/drawing/2014/main" id="{AB79F631-C1E8-4527-BCF7-CF4071EC3D5A}"/>
+                <a16:creationId xmlns:a16="http://schemas.microsoft.com/office/drawing/2014/main" id="{7F761A86-8A60-4D4A-B9F8-53290FA65839}"/>
               </a:ext>
             </a:extLst>
           </p:cNvPr>
@@ -7485,7 +7485,7 @@
           <p:cNvPr id="3" name="s5-title">
             <a:extLst xmlns:a="http://schemas.openxmlformats.org/drawingml/2006/main">
               <a:ext uri="{FF2B5EF4-FFF2-40B4-BE49-F238E27FC236}">
-                <a16:creationId xmlns:a16="http://schemas.microsoft.com/office/drawing/2014/main" id="{C43ED081-5577-40BC-9B61-B19A3C8F90BD}"/>
+                <a16:creationId xmlns:a16="http://schemas.microsoft.com/office/drawing/2014/main" id="{E731FB29-1A62-4730-A993-4114228614B4}"/>
               </a:ext>
             </a:extLst>
           </p:cNvPr>
@@ -7543,7 +7543,7 @@
           <p:cNvPr id="4" name="s5-footer">
             <a:extLst xmlns:a="http://schemas.openxmlformats.org/drawingml/2006/main">
               <a:ext uri="{FF2B5EF4-FFF2-40B4-BE49-F238E27FC236}">
-                <a16:creationId xmlns:a16="http://schemas.microsoft.com/office/drawing/2014/main" id="{5404694E-A3A3-4E76-8BE4-DE378D0A9E10}"/>
+                <a16:creationId xmlns:a16="http://schemas.microsoft.com/office/drawing/2014/main" id="{47EAF6E7-B7E6-4E0C-A286-94B24C1DD4D9}"/>
               </a:ext>
             </a:extLst>
           </p:cNvPr>
@@ -7574,7 +7574,7 @@
           <p:cNvPr id="5" name="s5-identity">
             <a:extLst xmlns:a="http://schemas.openxmlformats.org/drawingml/2006/main">
               <a:ext uri="{FF2B5EF4-FFF2-40B4-BE49-F238E27FC236}">
-                <a16:creationId xmlns:a16="http://schemas.microsoft.com/office/drawing/2014/main" id="{AF2A715C-C8C8-48DB-88A4-992897B210EB}"/>
+                <a16:creationId xmlns:a16="http://schemas.microsoft.com/office/drawing/2014/main" id="{244EE265-4084-41E3-864E-438B9872269D}"/>
               </a:ext>
             </a:extLst>
           </p:cNvPr>
@@ -7632,7 +7632,7 @@
           <p:cNvPr id="6" name="core-no-0">
             <a:extLst xmlns:a="http://schemas.openxmlformats.org/drawingml/2006/main">
               <a:ext uri="{FF2B5EF4-FFF2-40B4-BE49-F238E27FC236}">
-                <a16:creationId xmlns:a16="http://schemas.microsoft.com/office/drawing/2014/main" id="{72143334-AF57-4C95-9596-629553ED50C0}"/>
+                <a16:creationId xmlns:a16="http://schemas.microsoft.com/office/drawing/2014/main" id="{9F0DE45A-CA02-4F97-B9E0-C388AF911373}"/>
               </a:ext>
             </a:extLst>
           </p:cNvPr>
@@ -7690,7 +7690,7 @@
           <p:cNvPr id="7" name="core-label-0">
             <a:extLst xmlns:a="http://schemas.openxmlformats.org/drawingml/2006/main">
               <a:ext uri="{FF2B5EF4-FFF2-40B4-BE49-F238E27FC236}">
-                <a16:creationId xmlns:a16="http://schemas.microsoft.com/office/drawing/2014/main" id="{BDBFCF65-ECCA-4804-B6DA-F0707573012F}"/>
+                <a16:creationId xmlns:a16="http://schemas.microsoft.com/office/drawing/2014/main" id="{DA670605-CA8D-429F-93EE-C862EC487E05}"/>
               </a:ext>
             </a:extLst>
           </p:cNvPr>
@@ -7748,7 +7748,7 @@
           <p:cNvPr id="8" name="core-body-0">
             <a:extLst xmlns:a="http://schemas.openxmlformats.org/drawingml/2006/main">
               <a:ext uri="{FF2B5EF4-FFF2-40B4-BE49-F238E27FC236}">
-                <a16:creationId xmlns:a16="http://schemas.microsoft.com/office/drawing/2014/main" id="{39146087-9BA9-482F-B325-F4A7BF2B7903}"/>
+                <a16:creationId xmlns:a16="http://schemas.microsoft.com/office/drawing/2014/main" id="{32104FD9-E79A-429A-BFD0-4E091BBF2C93}"/>
               </a:ext>
             </a:extLst>
           </p:cNvPr>
@@ -7812,7 +7812,7 @@
           <p:cNvPr id="9" name="s5-takeaway-rule">
             <a:extLst xmlns:a="http://schemas.openxmlformats.org/drawingml/2006/main">
               <a:ext uri="{FF2B5EF4-FFF2-40B4-BE49-F238E27FC236}">
-                <a16:creationId xmlns:a16="http://schemas.microsoft.com/office/drawing/2014/main" id="{2F8AC2F8-6F2F-4123-B1D8-94FE7274400E}"/>
+                <a16:creationId xmlns:a16="http://schemas.microsoft.com/office/drawing/2014/main" id="{093B4BFE-ADD8-4938-882D-958048382DF8}"/>
               </a:ext>
             </a:extLst>
           </p:cNvPr>
@@ -7845,7 +7845,7 @@
           <p:cNvPr id="10" name="s5-takeaway">
             <a:extLst xmlns:a="http://schemas.openxmlformats.org/drawingml/2006/main">
               <a:ext uri="{FF2B5EF4-FFF2-40B4-BE49-F238E27FC236}">
-                <a16:creationId xmlns:a16="http://schemas.microsoft.com/office/drawing/2014/main" id="{C907EDAC-B663-4EEA-9C35-064D6F49400F}"/>
+                <a16:creationId xmlns:a16="http://schemas.microsoft.com/office/drawing/2014/main" id="{7DA354F0-4CFD-4013-95F3-207FAE2DCCFD}"/>
               </a:ext>
             </a:extLst>
           </p:cNvPr>
@@ -7901,7 +7901,7 @@
     </p:spTree>
     <p:extLst>
       <p:ext uri="{BB962C8B-B14F-4D97-AF65-F5344CB8AC3E}">
-        <p14:creationId xmlns:p14="http://schemas.microsoft.com/office/powerpoint/2010/main" val="95156816"/>
+        <p14:creationId xmlns:p14="http://schemas.microsoft.com/office/powerpoint/2010/main" val="46226017"/>
       </p:ext>
     </p:extLst>
   </p:cSld>
@@ -7932,7 +7932,7 @@
           <p:cNvPr id="1" name="s6-rule">
             <a:extLst xmlns:a="http://schemas.openxmlformats.org/drawingml/2006/main">
               <a:ext uri="{FF2B5EF4-FFF2-40B4-BE49-F238E27FC236}">
-                <a16:creationId xmlns:a16="http://schemas.microsoft.com/office/drawing/2014/main" id="{307CA866-E552-485D-AE4F-2D925EF2814B}"/>
+                <a16:creationId xmlns:a16="http://schemas.microsoft.com/office/drawing/2014/main" id="{43487A6A-2A45-4AA5-9984-584F9D22E6BA}"/>
               </a:ext>
             </a:extLst>
           </p:cNvPr>
@@ -7965,7 +7965,7 @@
           <p:cNvPr id="2" name="s6-eyebrow">
             <a:extLst xmlns:a="http://schemas.openxmlformats.org/drawingml/2006/main">
               <a:ext uri="{FF2B5EF4-FFF2-40B4-BE49-F238E27FC236}">
-                <a16:creationId xmlns:a16="http://schemas.microsoft.com/office/drawing/2014/main" id="{8DC7F3AE-9E19-45C7-9228-6600C78FFF2D}"/>
+                <a16:creationId xmlns:a16="http://schemas.microsoft.com/office/drawing/2014/main" id="{73F43377-5806-42F4-B011-ABA9EA9A9003}"/>
               </a:ext>
             </a:extLst>
           </p:cNvPr>
@@ -8023,7 +8023,7 @@
           <p:cNvPr id="3" name="s6-title">
             <a:extLst xmlns:a="http://schemas.openxmlformats.org/drawingml/2006/main">
               <a:ext uri="{FF2B5EF4-FFF2-40B4-BE49-F238E27FC236}">
-                <a16:creationId xmlns:a16="http://schemas.microsoft.com/office/drawing/2014/main" id="{1B78C618-0690-40A7-8FFA-DADA8AC4DA47}"/>
+                <a16:creationId xmlns:a16="http://schemas.microsoft.com/office/drawing/2014/main" id="{E51FA957-DA54-402A-BA12-A034D6D74920}"/>
               </a:ext>
             </a:extLst>
           </p:cNvPr>
@@ -8081,7 +8081,7 @@
           <p:cNvPr id="4" name="s6-footer">
             <a:extLst xmlns:a="http://schemas.openxmlformats.org/drawingml/2006/main">
               <a:ext uri="{FF2B5EF4-FFF2-40B4-BE49-F238E27FC236}">
-                <a16:creationId xmlns:a16="http://schemas.microsoft.com/office/drawing/2014/main" id="{EEDCFB98-BF40-49C0-874E-423B5D4AF635}"/>
+                <a16:creationId xmlns:a16="http://schemas.microsoft.com/office/drawing/2014/main" id="{9B8134DE-427B-4956-A949-683A8A32A9FA}"/>
               </a:ext>
             </a:extLst>
           </p:cNvPr>
@@ -8112,7 +8112,7 @@
           <p:cNvPr id="5" name="s6-identity">
             <a:extLst xmlns:a="http://schemas.openxmlformats.org/drawingml/2006/main">
               <a:ext uri="{FF2B5EF4-FFF2-40B4-BE49-F238E27FC236}">
-                <a16:creationId xmlns:a16="http://schemas.microsoft.com/office/drawing/2014/main" id="{9CC71D13-429C-4C77-8E6E-A5F010CA1DE3}"/>
+                <a16:creationId xmlns:a16="http://schemas.microsoft.com/office/drawing/2014/main" id="{2F82A1DC-284F-4E17-8120-7BA6B74DE570}"/>
               </a:ext>
             </a:extLst>
           </p:cNvPr>
@@ -8170,7 +8170,7 @@
           <p:cNvPr id="6" name="core-no-0">
             <a:extLst xmlns:a="http://schemas.openxmlformats.org/drawingml/2006/main">
               <a:ext uri="{FF2B5EF4-FFF2-40B4-BE49-F238E27FC236}">
-                <a16:creationId xmlns:a16="http://schemas.microsoft.com/office/drawing/2014/main" id="{550EF425-901B-4140-8031-0C6A949A6D91}"/>
+                <a16:creationId xmlns:a16="http://schemas.microsoft.com/office/drawing/2014/main" id="{77046D51-FF14-4583-8C57-C7DA8A03C6AA}"/>
               </a:ext>
             </a:extLst>
           </p:cNvPr>
@@ -8228,7 +8228,7 @@
           <p:cNvPr id="7" name="core-label-0">
             <a:extLst xmlns:a="http://schemas.openxmlformats.org/drawingml/2006/main">
               <a:ext uri="{FF2B5EF4-FFF2-40B4-BE49-F238E27FC236}">
-                <a16:creationId xmlns:a16="http://schemas.microsoft.com/office/drawing/2014/main" id="{59CA97DF-5450-41D1-B473-CFECE5EC5438}"/>
+                <a16:creationId xmlns:a16="http://schemas.microsoft.com/office/drawing/2014/main" id="{8B373034-9CB3-4A51-9D42-308AA180DCE4}"/>
               </a:ext>
             </a:extLst>
           </p:cNvPr>
@@ -8286,7 +8286,7 @@
           <p:cNvPr id="8" name="core-body-0">
             <a:extLst xmlns:a="http://schemas.openxmlformats.org/drawingml/2006/main">
               <a:ext uri="{FF2B5EF4-FFF2-40B4-BE49-F238E27FC236}">
-                <a16:creationId xmlns:a16="http://schemas.microsoft.com/office/drawing/2014/main" id="{CFA3CE73-A5EC-46B3-9DD3-5F8B95587ADB}"/>
+                <a16:creationId xmlns:a16="http://schemas.microsoft.com/office/drawing/2014/main" id="{224D7D66-EC89-470B-9D55-25DC39A34008}"/>
               </a:ext>
             </a:extLst>
           </p:cNvPr>
@@ -8350,7 +8350,7 @@
           <p:cNvPr id="9" name="s6-takeaway-rule">
             <a:extLst xmlns:a="http://schemas.openxmlformats.org/drawingml/2006/main">
               <a:ext uri="{FF2B5EF4-FFF2-40B4-BE49-F238E27FC236}">
-                <a16:creationId xmlns:a16="http://schemas.microsoft.com/office/drawing/2014/main" id="{B549A2EF-576D-46B6-BB13-C4915CECD509}"/>
+                <a16:creationId xmlns:a16="http://schemas.microsoft.com/office/drawing/2014/main" id="{E283020B-972B-4750-BD34-354E1C19EE83}"/>
               </a:ext>
             </a:extLst>
           </p:cNvPr>
@@ -8383,7 +8383,7 @@
           <p:cNvPr id="10" name="s6-takeaway">
             <a:extLst xmlns:a="http://schemas.openxmlformats.org/drawingml/2006/main">
               <a:ext uri="{FF2B5EF4-FFF2-40B4-BE49-F238E27FC236}">
-                <a16:creationId xmlns:a16="http://schemas.microsoft.com/office/drawing/2014/main" id="{949A9016-E3A7-4C21-8AB1-DC9AD8E2C769}"/>
+                <a16:creationId xmlns:a16="http://schemas.microsoft.com/office/drawing/2014/main" id="{CA95E723-7E85-4C87-81E8-BF233C63C93E}"/>
               </a:ext>
             </a:extLst>
           </p:cNvPr>
@@ -8439,7 +8439,7 @@
     </p:spTree>
     <p:extLst>
       <p:ext uri="{BB962C8B-B14F-4D97-AF65-F5344CB8AC3E}">
-        <p14:creationId xmlns:p14="http://schemas.microsoft.com/office/powerpoint/2010/main" val="1688683979"/>
+        <p14:creationId xmlns:p14="http://schemas.microsoft.com/office/powerpoint/2010/main" val="1298974610"/>
       </p:ext>
     </p:extLst>
   </p:cSld>
@@ -8470,7 +8470,7 @@
           <p:cNvPr id="1" name="s7-rule">
             <a:extLst xmlns:a="http://schemas.openxmlformats.org/drawingml/2006/main">
               <a:ext uri="{FF2B5EF4-FFF2-40B4-BE49-F238E27FC236}">
-                <a16:creationId xmlns:a16="http://schemas.microsoft.com/office/drawing/2014/main" id="{6A995D1F-0BD7-42F4-A23B-71B29700AD68}"/>
+                <a16:creationId xmlns:a16="http://schemas.microsoft.com/office/drawing/2014/main" id="{7DAFD1B8-274A-440F-86E5-24C57C48B4EA}"/>
               </a:ext>
             </a:extLst>
           </p:cNvPr>
@@ -8503,7 +8503,7 @@
           <p:cNvPr id="2" name="s7-eyebrow">
             <a:extLst xmlns:a="http://schemas.openxmlformats.org/drawingml/2006/main">
               <a:ext uri="{FF2B5EF4-FFF2-40B4-BE49-F238E27FC236}">
-                <a16:creationId xmlns:a16="http://schemas.microsoft.com/office/drawing/2014/main" id="{81D0001E-5109-4C62-9029-5E9A51A5E622}"/>
+                <a16:creationId xmlns:a16="http://schemas.microsoft.com/office/drawing/2014/main" id="{FE4D602D-6C8B-4C8E-BC6E-94DAFCB08395}"/>
               </a:ext>
             </a:extLst>
           </p:cNvPr>
@@ -8561,7 +8561,7 @@
           <p:cNvPr id="3" name="s7-title">
             <a:extLst xmlns:a="http://schemas.openxmlformats.org/drawingml/2006/main">
               <a:ext uri="{FF2B5EF4-FFF2-40B4-BE49-F238E27FC236}">
-                <a16:creationId xmlns:a16="http://schemas.microsoft.com/office/drawing/2014/main" id="{8E4AF6E5-FCBC-4CAE-8C52-99883A6E837F}"/>
+                <a16:creationId xmlns:a16="http://schemas.microsoft.com/office/drawing/2014/main" id="{33067A6F-2D7C-40B8-9BBA-BE7593E07986}"/>
               </a:ext>
             </a:extLst>
           </p:cNvPr>
@@ -8619,7 +8619,7 @@
           <p:cNvPr id="4" name="s7-footer">
             <a:extLst xmlns:a="http://schemas.openxmlformats.org/drawingml/2006/main">
               <a:ext uri="{FF2B5EF4-FFF2-40B4-BE49-F238E27FC236}">
-                <a16:creationId xmlns:a16="http://schemas.microsoft.com/office/drawing/2014/main" id="{CE1E8C2D-1B5B-43A4-BB91-842B772E9092}"/>
+                <a16:creationId xmlns:a16="http://schemas.microsoft.com/office/drawing/2014/main" id="{E38E5596-A45F-4E87-975E-F0B3D486851E}"/>
               </a:ext>
             </a:extLst>
           </p:cNvPr>
@@ -8650,7 +8650,7 @@
           <p:cNvPr id="5" name="s7-identity">
             <a:extLst xmlns:a="http://schemas.openxmlformats.org/drawingml/2006/main">
               <a:ext uri="{FF2B5EF4-FFF2-40B4-BE49-F238E27FC236}">
-                <a16:creationId xmlns:a16="http://schemas.microsoft.com/office/drawing/2014/main" id="{59C7ACBD-BE10-4ACF-9CBF-6455248D6739}"/>
+                <a16:creationId xmlns:a16="http://schemas.microsoft.com/office/drawing/2014/main" id="{2680DD7B-B8FE-440E-ABBF-772BACA9039E}"/>
               </a:ext>
             </a:extLst>
           </p:cNvPr>
@@ -8708,7 +8708,7 @@
           <p:cNvPr id="6" name="core-no-0">
             <a:extLst xmlns:a="http://schemas.openxmlformats.org/drawingml/2006/main">
               <a:ext uri="{FF2B5EF4-FFF2-40B4-BE49-F238E27FC236}">
-                <a16:creationId xmlns:a16="http://schemas.microsoft.com/office/drawing/2014/main" id="{D2C9B90E-6178-4DA5-BE29-5EE8255C5A1E}"/>
+                <a16:creationId xmlns:a16="http://schemas.microsoft.com/office/drawing/2014/main" id="{D67A9383-5205-495D-AC1B-11CFCC4B6AD8}"/>
               </a:ext>
             </a:extLst>
           </p:cNvPr>
@@ -8766,7 +8766,7 @@
           <p:cNvPr id="7" name="core-label-0">
             <a:extLst xmlns:a="http://schemas.openxmlformats.org/drawingml/2006/main">
               <a:ext uri="{FF2B5EF4-FFF2-40B4-BE49-F238E27FC236}">
-                <a16:creationId xmlns:a16="http://schemas.microsoft.com/office/drawing/2014/main" id="{98270346-42B8-4F11-8F88-A2D4AF9F2D65}"/>
+                <a16:creationId xmlns:a16="http://schemas.microsoft.com/office/drawing/2014/main" id="{70A73789-B9B1-4BCA-8CD4-F1A9069C4835}"/>
               </a:ext>
             </a:extLst>
           </p:cNvPr>
@@ -8824,7 +8824,7 @@
           <p:cNvPr id="8" name="core-body-0">
             <a:extLst xmlns:a="http://schemas.openxmlformats.org/drawingml/2006/main">
               <a:ext uri="{FF2B5EF4-FFF2-40B4-BE49-F238E27FC236}">
-                <a16:creationId xmlns:a16="http://schemas.microsoft.com/office/drawing/2014/main" id="{44FF4B79-011A-4862-8638-5E2F8909A36B}"/>
+                <a16:creationId xmlns:a16="http://schemas.microsoft.com/office/drawing/2014/main" id="{7C0C8297-1F66-4041-A5A8-2F8D050EA5DD}"/>
               </a:ext>
             </a:extLst>
           </p:cNvPr>
@@ -8888,7 +8888,7 @@
           <p:cNvPr id="9" name="core-no-1">
             <a:extLst xmlns:a="http://schemas.openxmlformats.org/drawingml/2006/main">
               <a:ext uri="{FF2B5EF4-FFF2-40B4-BE49-F238E27FC236}">
-                <a16:creationId xmlns:a16="http://schemas.microsoft.com/office/drawing/2014/main" id="{C7CFE545-9C15-434F-85A6-CE16D079F7A7}"/>
+                <a16:creationId xmlns:a16="http://schemas.microsoft.com/office/drawing/2014/main" id="{47F03373-0927-4899-B25A-2D700481AF91}"/>
               </a:ext>
             </a:extLst>
           </p:cNvPr>
@@ -8946,7 +8946,7 @@
           <p:cNvPr id="10" name="core-body-1">
             <a:extLst xmlns:a="http://schemas.openxmlformats.org/drawingml/2006/main">
               <a:ext uri="{FF2B5EF4-FFF2-40B4-BE49-F238E27FC236}">
-                <a16:creationId xmlns:a16="http://schemas.microsoft.com/office/drawing/2014/main" id="{6FEBA8A3-0025-49D4-87CE-08C16F44ED0F}"/>
+                <a16:creationId xmlns:a16="http://schemas.microsoft.com/office/drawing/2014/main" id="{34E30355-A291-4BC5-833D-825B52E8156C}"/>
               </a:ext>
             </a:extLst>
           </p:cNvPr>
@@ -9010,7 +9010,7 @@
           <p:cNvPr id="11" name="s7-takeaway-rule">
             <a:extLst xmlns:a="http://schemas.openxmlformats.org/drawingml/2006/main">
               <a:ext uri="{FF2B5EF4-FFF2-40B4-BE49-F238E27FC236}">
-                <a16:creationId xmlns:a16="http://schemas.microsoft.com/office/drawing/2014/main" id="{74247376-8CCC-453C-A22B-3F4167717C75}"/>
+                <a16:creationId xmlns:a16="http://schemas.microsoft.com/office/drawing/2014/main" id="{6ABA9A3C-D468-4051-A810-9DEE62FB486F}"/>
               </a:ext>
             </a:extLst>
           </p:cNvPr>
@@ -9043,7 +9043,7 @@
           <p:cNvPr id="12" name="s7-takeaway">
             <a:extLst xmlns:a="http://schemas.openxmlformats.org/drawingml/2006/main">
               <a:ext uri="{FF2B5EF4-FFF2-40B4-BE49-F238E27FC236}">
-                <a16:creationId xmlns:a16="http://schemas.microsoft.com/office/drawing/2014/main" id="{86D4B413-9BFD-4119-8090-6C81080A0EA8}"/>
+                <a16:creationId xmlns:a16="http://schemas.microsoft.com/office/drawing/2014/main" id="{BD33B84C-AF1E-4A1E-8599-B98E1AA0B829}"/>
               </a:ext>
             </a:extLst>
           </p:cNvPr>
@@ -9099,7 +9099,7 @@
     </p:spTree>
     <p:extLst>
       <p:ext uri="{BB962C8B-B14F-4D97-AF65-F5344CB8AC3E}">
-        <p14:creationId xmlns:p14="http://schemas.microsoft.com/office/powerpoint/2010/main" val="1600800767"/>
+        <p14:creationId xmlns:p14="http://schemas.microsoft.com/office/powerpoint/2010/main" val="1459684632"/>
       </p:ext>
     </p:extLst>
   </p:cSld>
@@ -9130,7 +9130,7 @@
           <p:cNvPr id="1" name="s8-rule">
             <a:extLst xmlns:a="http://schemas.openxmlformats.org/drawingml/2006/main">
               <a:ext uri="{FF2B5EF4-FFF2-40B4-BE49-F238E27FC236}">
-                <a16:creationId xmlns:a16="http://schemas.microsoft.com/office/drawing/2014/main" id="{60779FD2-088A-4BE1-A270-CAA4A5D10721}"/>
+                <a16:creationId xmlns:a16="http://schemas.microsoft.com/office/drawing/2014/main" id="{0A19EF07-C7B4-42D7-BB91-D66A1BC8CF56}"/>
               </a:ext>
             </a:extLst>
           </p:cNvPr>
@@ -9163,7 +9163,7 @@
           <p:cNvPr id="2" name="s8-eyebrow">
             <a:extLst xmlns:a="http://schemas.openxmlformats.org/drawingml/2006/main">
               <a:ext uri="{FF2B5EF4-FFF2-40B4-BE49-F238E27FC236}">
-                <a16:creationId xmlns:a16="http://schemas.microsoft.com/office/drawing/2014/main" id="{A0CB59E0-09A1-4537-8713-CE8D3E1385DC}"/>
+                <a16:creationId xmlns:a16="http://schemas.microsoft.com/office/drawing/2014/main" id="{6F6BE067-F1AB-4379-94B8-5C3F0D2E6232}"/>
               </a:ext>
             </a:extLst>
           </p:cNvPr>
@@ -9221,7 +9221,7 @@
           <p:cNvPr id="3" name="s8-title">
             <a:extLst xmlns:a="http://schemas.openxmlformats.org/drawingml/2006/main">
               <a:ext uri="{FF2B5EF4-FFF2-40B4-BE49-F238E27FC236}">
-                <a16:creationId xmlns:a16="http://schemas.microsoft.com/office/drawing/2014/main" id="{CDE49A52-B015-43BE-A8AE-5F85D9C1E41B}"/>
+                <a16:creationId xmlns:a16="http://schemas.microsoft.com/office/drawing/2014/main" id="{6853E306-10C7-4F3A-8254-A04976AD4989}"/>
               </a:ext>
             </a:extLst>
           </p:cNvPr>
@@ -9279,7 +9279,7 @@
           <p:cNvPr id="4" name="s8-footer">
             <a:extLst xmlns:a="http://schemas.openxmlformats.org/drawingml/2006/main">
               <a:ext uri="{FF2B5EF4-FFF2-40B4-BE49-F238E27FC236}">
-                <a16:creationId xmlns:a16="http://schemas.microsoft.com/office/drawing/2014/main" id="{AD5482F7-6FEF-42D9-800B-97BD7A508162}"/>
+                <a16:creationId xmlns:a16="http://schemas.microsoft.com/office/drawing/2014/main" id="{12D72A65-48AA-418C-9D32-4A203E90DCD5}"/>
               </a:ext>
             </a:extLst>
           </p:cNvPr>
@@ -9310,7 +9310,7 @@
           <p:cNvPr id="5" name="s8-identity">
             <a:extLst xmlns:a="http://schemas.openxmlformats.org/drawingml/2006/main">
               <a:ext uri="{FF2B5EF4-FFF2-40B4-BE49-F238E27FC236}">
-                <a16:creationId xmlns:a16="http://schemas.microsoft.com/office/drawing/2014/main" id="{469649F4-A242-4CA9-A628-81F2C3458F14}"/>
+                <a16:creationId xmlns:a16="http://schemas.microsoft.com/office/drawing/2014/main" id="{1975602B-234A-4B3F-ADFB-9AEB1523360A}"/>
               </a:ext>
             </a:extLst>
           </p:cNvPr>
@@ -9368,7 +9368,7 @@
           <p:cNvPr id="6" name="core-no-0">
             <a:extLst xmlns:a="http://schemas.openxmlformats.org/drawingml/2006/main">
               <a:ext uri="{FF2B5EF4-FFF2-40B4-BE49-F238E27FC236}">
-                <a16:creationId xmlns:a16="http://schemas.microsoft.com/office/drawing/2014/main" id="{7D4122D9-D231-42D5-BC51-ECEFFBA11502}"/>
+                <a16:creationId xmlns:a16="http://schemas.microsoft.com/office/drawing/2014/main" id="{02702D8D-0254-4673-86D2-6A8CA25933B4}"/>
               </a:ext>
             </a:extLst>
           </p:cNvPr>
@@ -9426,7 +9426,7 @@
           <p:cNvPr id="7" name="core-label-0">
             <a:extLst xmlns:a="http://schemas.openxmlformats.org/drawingml/2006/main">
               <a:ext uri="{FF2B5EF4-FFF2-40B4-BE49-F238E27FC236}">
-                <a16:creationId xmlns:a16="http://schemas.microsoft.com/office/drawing/2014/main" id="{2C66B7C3-EBB2-47EF-AF8E-348E954493AF}"/>
+                <a16:creationId xmlns:a16="http://schemas.microsoft.com/office/drawing/2014/main" id="{5EDDED66-3AC6-47AB-B83A-FA57D38AEC71}"/>
               </a:ext>
             </a:extLst>
           </p:cNvPr>
@@ -9484,7 +9484,7 @@
           <p:cNvPr id="8" name="core-body-0">
             <a:extLst xmlns:a="http://schemas.openxmlformats.org/drawingml/2006/main">
               <a:ext uri="{FF2B5EF4-FFF2-40B4-BE49-F238E27FC236}">
-                <a16:creationId xmlns:a16="http://schemas.microsoft.com/office/drawing/2014/main" id="{CF786D3A-516A-490C-AFEC-825501C9CE38}"/>
+                <a16:creationId xmlns:a16="http://schemas.microsoft.com/office/drawing/2014/main" id="{2A266319-67E5-4804-A8DA-59F935C4C05D}"/>
               </a:ext>
             </a:extLst>
           </p:cNvPr>
@@ -9548,7 +9548,7 @@
           <p:cNvPr id="9" name="s8-takeaway-rule">
             <a:extLst xmlns:a="http://schemas.openxmlformats.org/drawingml/2006/main">
               <a:ext uri="{FF2B5EF4-FFF2-40B4-BE49-F238E27FC236}">
-                <a16:creationId xmlns:a16="http://schemas.microsoft.com/office/drawing/2014/main" id="{2CF16262-6BD9-4C4B-9386-6AEF9CF2E3B5}"/>
+                <a16:creationId xmlns:a16="http://schemas.microsoft.com/office/drawing/2014/main" id="{208E3861-3813-4487-90D3-7A22DF169A0C}"/>
               </a:ext>
             </a:extLst>
           </p:cNvPr>
@@ -9581,7 +9581,7 @@
           <p:cNvPr id="10" name="s8-takeaway">
             <a:extLst xmlns:a="http://schemas.openxmlformats.org/drawingml/2006/main">
               <a:ext uri="{FF2B5EF4-FFF2-40B4-BE49-F238E27FC236}">
-                <a16:creationId xmlns:a16="http://schemas.microsoft.com/office/drawing/2014/main" id="{779834FC-E1C7-41AB-B888-71B800951B70}"/>
+                <a16:creationId xmlns:a16="http://schemas.microsoft.com/office/drawing/2014/main" id="{66004D93-520A-49E7-A74B-EB3446E37D4B}"/>
               </a:ext>
             </a:extLst>
           </p:cNvPr>
@@ -9637,7 +9637,7 @@
     </p:spTree>
     <p:extLst>
       <p:ext uri="{BB962C8B-B14F-4D97-AF65-F5344CB8AC3E}">
-        <p14:creationId xmlns:p14="http://schemas.microsoft.com/office/powerpoint/2010/main" val="638321961"/>
+        <p14:creationId xmlns:p14="http://schemas.microsoft.com/office/powerpoint/2010/main" val="668492839"/>
       </p:ext>
     </p:extLst>
   </p:cSld>
@@ -9668,7 +9668,7 @@
           <p:cNvPr id="1" name="s9-rule">
             <a:extLst xmlns:a="http://schemas.openxmlformats.org/drawingml/2006/main">
               <a:ext uri="{FF2B5EF4-FFF2-40B4-BE49-F238E27FC236}">
-                <a16:creationId xmlns:a16="http://schemas.microsoft.com/office/drawing/2014/main" id="{8F213729-BBFD-45C3-B098-144B82162F8B}"/>
+                <a16:creationId xmlns:a16="http://schemas.microsoft.com/office/drawing/2014/main" id="{DC9C6239-FFD4-4530-B76C-6BB57140009C}"/>
               </a:ext>
             </a:extLst>
           </p:cNvPr>
@@ -9701,7 +9701,7 @@
           <p:cNvPr id="2" name="s9-eyebrow">
             <a:extLst xmlns:a="http://schemas.openxmlformats.org/drawingml/2006/main">
               <a:ext uri="{FF2B5EF4-FFF2-40B4-BE49-F238E27FC236}">
-                <a16:creationId xmlns:a16="http://schemas.microsoft.com/office/drawing/2014/main" id="{A2A02F6E-F704-43F7-B7AB-BA2864569733}"/>
+                <a16:creationId xmlns:a16="http://schemas.microsoft.com/office/drawing/2014/main" id="{4C5AF7E8-4E7D-4565-9BC6-D8E3A370E482}"/>
               </a:ext>
             </a:extLst>
           </p:cNvPr>
@@ -9759,7 +9759,7 @@
           <p:cNvPr id="3" name="s9-title">
             <a:extLst xmlns:a="http://schemas.openxmlformats.org/drawingml/2006/main">
               <a:ext uri="{FF2B5EF4-FFF2-40B4-BE49-F238E27FC236}">
-                <a16:creationId xmlns:a16="http://schemas.microsoft.com/office/drawing/2014/main" id="{5B59A48F-ABE0-472C-9293-2F78E5059B21}"/>
+                <a16:creationId xmlns:a16="http://schemas.microsoft.com/office/drawing/2014/main" id="{6ECC642F-4A1E-474B-96A7-C10F4EB35FC7}"/>
               </a:ext>
             </a:extLst>
           </p:cNvPr>
@@ -9817,7 +9817,7 @@
           <p:cNvPr id="4" name="s9-footer">
             <a:extLst xmlns:a="http://schemas.openxmlformats.org/drawingml/2006/main">
               <a:ext uri="{FF2B5EF4-FFF2-40B4-BE49-F238E27FC236}">
-                <a16:creationId xmlns:a16="http://schemas.microsoft.com/office/drawing/2014/main" id="{6EF3D767-B544-4A45-8279-4DDDD81FDF46}"/>
+                <a16:creationId xmlns:a16="http://schemas.microsoft.com/office/drawing/2014/main" id="{E99337B7-EFAC-4C2A-BFB1-AFC510D6E524}"/>
               </a:ext>
             </a:extLst>
           </p:cNvPr>
@@ -9848,7 +9848,7 @@
           <p:cNvPr id="5" name="s9-identity">
             <a:extLst xmlns:a="http://schemas.openxmlformats.org/drawingml/2006/main">
               <a:ext uri="{FF2B5EF4-FFF2-40B4-BE49-F238E27FC236}">
-                <a16:creationId xmlns:a16="http://schemas.microsoft.com/office/drawing/2014/main" id="{848DA474-E06B-4100-81C3-54073A8A9471}"/>
+                <a16:creationId xmlns:a16="http://schemas.microsoft.com/office/drawing/2014/main" id="{4AFEECE9-06C7-427B-8C9D-9CB162021CD6}"/>
               </a:ext>
             </a:extLst>
           </p:cNvPr>
@@ -9906,7 +9906,7 @@
           <p:cNvPr id="6" name="core-no-0">
             <a:extLst xmlns:a="http://schemas.openxmlformats.org/drawingml/2006/main">
               <a:ext uri="{FF2B5EF4-FFF2-40B4-BE49-F238E27FC236}">
-                <a16:creationId xmlns:a16="http://schemas.microsoft.com/office/drawing/2014/main" id="{402CDAE5-9E00-4A83-8DD3-33F753509D1C}"/>
+                <a16:creationId xmlns:a16="http://schemas.microsoft.com/office/drawing/2014/main" id="{58E64934-7D03-4240-9DC4-D1B452255883}"/>
               </a:ext>
             </a:extLst>
           </p:cNvPr>
@@ -9964,7 +9964,7 @@
           <p:cNvPr id="7" name="core-label-0">
             <a:extLst xmlns:a="http://schemas.openxmlformats.org/drawingml/2006/main">
               <a:ext uri="{FF2B5EF4-FFF2-40B4-BE49-F238E27FC236}">
-                <a16:creationId xmlns:a16="http://schemas.microsoft.com/office/drawing/2014/main" id="{59370E4B-B6EE-45F5-A160-11E9576E16F9}"/>
+                <a16:creationId xmlns:a16="http://schemas.microsoft.com/office/drawing/2014/main" id="{5E038E2E-F366-452A-A98C-3A9704A73CA8}"/>
               </a:ext>
             </a:extLst>
           </p:cNvPr>
@@ -10022,7 +10022,7 @@
           <p:cNvPr id="8" name="core-body-0">
             <a:extLst xmlns:a="http://schemas.openxmlformats.org/drawingml/2006/main">
               <a:ext uri="{FF2B5EF4-FFF2-40B4-BE49-F238E27FC236}">
-                <a16:creationId xmlns:a16="http://schemas.microsoft.com/office/drawing/2014/main" id="{A547298F-39BB-4320-953C-40CE80EB1800}"/>
+                <a16:creationId xmlns:a16="http://schemas.microsoft.com/office/drawing/2014/main" id="{A7D2D375-EE81-45E9-B786-3203DDF058AE}"/>
               </a:ext>
             </a:extLst>
           </p:cNvPr>
@@ -10086,7 +10086,7 @@
           <p:cNvPr id="9" name="core-no-1">
             <a:extLst xmlns:a="http://schemas.openxmlformats.org/drawingml/2006/main">
               <a:ext uri="{FF2B5EF4-FFF2-40B4-BE49-F238E27FC236}">
-                <a16:creationId xmlns:a16="http://schemas.microsoft.com/office/drawing/2014/main" id="{512A328E-892C-4C06-9DB9-30296BE8B1AB}"/>
+                <a16:creationId xmlns:a16="http://schemas.microsoft.com/office/drawing/2014/main" id="{3573E417-7A65-4ED2-91BE-70A458B618D2}"/>
               </a:ext>
             </a:extLst>
           </p:cNvPr>
@@ -10144,7 +10144,7 @@
           <p:cNvPr id="10" name="core-body-1">
             <a:extLst xmlns:a="http://schemas.openxmlformats.org/drawingml/2006/main">
               <a:ext uri="{FF2B5EF4-FFF2-40B4-BE49-F238E27FC236}">
-                <a16:creationId xmlns:a16="http://schemas.microsoft.com/office/drawing/2014/main" id="{DBCADC59-FEE3-4DBF-BF4E-FCDA91CC7FCB}"/>
+                <a16:creationId xmlns:a16="http://schemas.microsoft.com/office/drawing/2014/main" id="{6395DAF6-3F55-4BF0-AABA-02554207802C}"/>
               </a:ext>
             </a:extLst>
           </p:cNvPr>
@@ -10208,7 +10208,7 @@
           <p:cNvPr id="11" name="s9-takeaway-rule">
             <a:extLst xmlns:a="http://schemas.openxmlformats.org/drawingml/2006/main">
               <a:ext uri="{FF2B5EF4-FFF2-40B4-BE49-F238E27FC236}">
-                <a16:creationId xmlns:a16="http://schemas.microsoft.com/office/drawing/2014/main" id="{1A598DBD-C468-40FB-AD99-A4C2E7395C57}"/>
+                <a16:creationId xmlns:a16="http://schemas.microsoft.com/office/drawing/2014/main" id="{75A9649C-4CB6-4D8C-BACD-4561AA60C2E6}"/>
               </a:ext>
             </a:extLst>
           </p:cNvPr>
@@ -10241,7 +10241,7 @@
           <p:cNvPr id="12" name="s9-takeaway">
             <a:extLst xmlns:a="http://schemas.openxmlformats.org/drawingml/2006/main">
               <a:ext uri="{FF2B5EF4-FFF2-40B4-BE49-F238E27FC236}">
-                <a16:creationId xmlns:a16="http://schemas.microsoft.com/office/drawing/2014/main" id="{B0C02A8A-2AEF-4D08-88D5-6451CA3CBCCD}"/>
+                <a16:creationId xmlns:a16="http://schemas.microsoft.com/office/drawing/2014/main" id="{A8A2C236-F32D-42C7-9A0B-2848586F82F8}"/>
               </a:ext>
             </a:extLst>
           </p:cNvPr>
@@ -10297,7 +10297,7 @@
     </p:spTree>
     <p:extLst>
       <p:ext uri="{BB962C8B-B14F-4D97-AF65-F5344CB8AC3E}">
-        <p14:creationId xmlns:p14="http://schemas.microsoft.com/office/powerpoint/2010/main" val="935662469"/>
+        <p14:creationId xmlns:p14="http://schemas.microsoft.com/office/powerpoint/2010/main" val="2001862482"/>
       </p:ext>
     </p:extLst>
   </p:cSld>

</xml_diff>

<commit_message>
feat: publish learner-facing ppt lessons
</commit_message>
<xml_diff>
--- a/docs/public/course-assets/course-pptx/ag-001.pptx
+++ b/docs/public/course-assets/course-pptx/ag-001.pptx
@@ -2,25 +2,25 @@
 <file path=ppt/presentation.xml><?xml version="1.0" encoding="utf-8"?>
 <p:presentation xmlns:p="http://schemas.openxmlformats.org/presentationml/2006/main">
   <p:sldMasterIdLst>
-    <p:sldMasterId xmlns:r="http://schemas.openxmlformats.org/officeDocument/2006/relationships" id="2147483648" r:id="R4bf1ffa8d94a4a34"/>
+    <p:sldMasterId xmlns:r="http://schemas.openxmlformats.org/officeDocument/2006/relationships" id="2147483648" r:id="R2b6af4d1a61b4bcf"/>
   </p:sldMasterIdLst>
   <p:notesMasterIdLst>
-    <p:notesMasterId xmlns:r="http://schemas.openxmlformats.org/officeDocument/2006/relationships" r:id="Rc701fbafc93946ee"/>
+    <p:notesMasterId xmlns:r="http://schemas.openxmlformats.org/officeDocument/2006/relationships" r:id="Rbe2a577cd2b14ca5"/>
   </p:notesMasterIdLst>
   <p:sldIdLst>
-    <p:sldId xmlns:r="http://schemas.openxmlformats.org/officeDocument/2006/relationships" id="256" r:id="R19c50a27e4694c2f"/>
-    <p:sldId xmlns:r="http://schemas.openxmlformats.org/officeDocument/2006/relationships" id="257" r:id="R0ba009364cef4c7b"/>
-    <p:sldId xmlns:r="http://schemas.openxmlformats.org/officeDocument/2006/relationships" id="258" r:id="Rad36857ffbe84e4c"/>
-    <p:sldId xmlns:r="http://schemas.openxmlformats.org/officeDocument/2006/relationships" id="259" r:id="R8440704baeef4022"/>
-    <p:sldId xmlns:r="http://schemas.openxmlformats.org/officeDocument/2006/relationships" id="260" r:id="R718cbd2d95a5463e"/>
-    <p:sldId xmlns:r="http://schemas.openxmlformats.org/officeDocument/2006/relationships" id="261" r:id="R3a989866d8ad46bc"/>
-    <p:sldId xmlns:r="http://schemas.openxmlformats.org/officeDocument/2006/relationships" id="262" r:id="R327d0fc8cca94489"/>
-    <p:sldId xmlns:r="http://schemas.openxmlformats.org/officeDocument/2006/relationships" id="263" r:id="Rde1ff60cd0fa444b"/>
-    <p:sldId xmlns:r="http://schemas.openxmlformats.org/officeDocument/2006/relationships" id="264" r:id="R940f867b97754f05"/>
-    <p:sldId xmlns:r="http://schemas.openxmlformats.org/officeDocument/2006/relationships" id="265" r:id="R9ad05a6eb26c48e7"/>
-    <p:sldId xmlns:r="http://schemas.openxmlformats.org/officeDocument/2006/relationships" id="266" r:id="R84187b19d1c04739"/>
-    <p:sldId xmlns:r="http://schemas.openxmlformats.org/officeDocument/2006/relationships" id="267" r:id="R98422a42c0154700"/>
-    <p:sldId xmlns:r="http://schemas.openxmlformats.org/officeDocument/2006/relationships" id="268" r:id="Rdac1818703704aac"/>
+    <p:sldId xmlns:r="http://schemas.openxmlformats.org/officeDocument/2006/relationships" id="256" r:id="Rd7b215f7ff094cad"/>
+    <p:sldId xmlns:r="http://schemas.openxmlformats.org/officeDocument/2006/relationships" id="257" r:id="R2f74172f37bd4c5a"/>
+    <p:sldId xmlns:r="http://schemas.openxmlformats.org/officeDocument/2006/relationships" id="258" r:id="Ra9e83c8efb86400d"/>
+    <p:sldId xmlns:r="http://schemas.openxmlformats.org/officeDocument/2006/relationships" id="259" r:id="R80d2e21e24fe4ab5"/>
+    <p:sldId xmlns:r="http://schemas.openxmlformats.org/officeDocument/2006/relationships" id="260" r:id="R82c730353a754901"/>
+    <p:sldId xmlns:r="http://schemas.openxmlformats.org/officeDocument/2006/relationships" id="261" r:id="Rcadb59ba42d64a31"/>
+    <p:sldId xmlns:r="http://schemas.openxmlformats.org/officeDocument/2006/relationships" id="262" r:id="Rbbffc18567274473"/>
+    <p:sldId xmlns:r="http://schemas.openxmlformats.org/officeDocument/2006/relationships" id="263" r:id="Rd844a16b4f034dc1"/>
+    <p:sldId xmlns:r="http://schemas.openxmlformats.org/officeDocument/2006/relationships" id="264" r:id="R7c2edfb336c142d9"/>
+    <p:sldId xmlns:r="http://schemas.openxmlformats.org/officeDocument/2006/relationships" id="265" r:id="R35b6e5b9928545d5"/>
+    <p:sldId xmlns:r="http://schemas.openxmlformats.org/officeDocument/2006/relationships" id="266" r:id="R1336c84dbe564ee8"/>
+    <p:sldId xmlns:r="http://schemas.openxmlformats.org/officeDocument/2006/relationships" id="267" r:id="Rfe0fb3e12500434c"/>
+    <p:sldId xmlns:r="http://schemas.openxmlformats.org/officeDocument/2006/relationships" id="268" r:id="Rfe8e9f504a8a499b"/>
   </p:sldIdLst>
   <p:sldSz cx="12192000" cy="6858000"/>
   <p:notesSz cx="6858000" cy="9144000"/>
@@ -1405,7 +1405,7 @@
   </p:cSld>
   <p:clrMap bg1="lt1" tx1="dk1" bg2="lt2" tx2="dk2" accent1="accent1" accent2="accent2" accent3="accent3" accent4="accent4" accent5="accent5" accent6="accent6" hlink="hlink" folHlink="folHlink"/>
   <p:sldLayoutIdLst>
-    <p:sldLayoutId xmlns:r="http://schemas.openxmlformats.org/officeDocument/2006/relationships" id="2147483649" r:id="R5e25b6a1164b423e"/>
+    <p:sldLayoutId xmlns:r="http://schemas.openxmlformats.org/officeDocument/2006/relationships" id="2147483649" r:id="R61af5b7420014472"/>
   </p:sldLayoutIdLst>
   <p:txStyles>
     <p:titleStyle>
@@ -1956,7 +1956,7 @@
           <p:cNvPr id="1" name="cover-rule">
             <a:extLst xmlns:a="http://schemas.openxmlformats.org/drawingml/2006/main">
               <a:ext uri="{FF2B5EF4-FFF2-40B4-BE49-F238E27FC236}">
-                <a16:creationId xmlns:a16="http://schemas.microsoft.com/office/drawing/2014/main" id="{886F89DA-A577-4D65-8032-8226C173210A}"/>
+                <a16:creationId xmlns:a16="http://schemas.microsoft.com/office/drawing/2014/main" id="{AA1E195F-5403-488A-912F-8C22FBF67744}"/>
               </a:ext>
             </a:extLst>
           </p:cNvPr>
@@ -1989,7 +1989,7 @@
           <p:cNvPr id="2" name="cover-ring-1">
             <a:extLst xmlns:a="http://schemas.openxmlformats.org/drawingml/2006/main">
               <a:ext uri="{FF2B5EF4-FFF2-40B4-BE49-F238E27FC236}">
-                <a16:creationId xmlns:a16="http://schemas.microsoft.com/office/drawing/2014/main" id="{87E3BF4C-EE5D-470D-AE90-65A37A3A7024}"/>
+                <a16:creationId xmlns:a16="http://schemas.microsoft.com/office/drawing/2014/main" id="{326622AA-48BF-499E-9F3C-4E816A40380F}"/>
               </a:ext>
             </a:extLst>
           </p:cNvPr>
@@ -2020,7 +2020,7 @@
           <p:cNvPr id="3" name="cover-ring-2">
             <a:extLst xmlns:a="http://schemas.openxmlformats.org/drawingml/2006/main">
               <a:ext uri="{FF2B5EF4-FFF2-40B4-BE49-F238E27FC236}">
-                <a16:creationId xmlns:a16="http://schemas.microsoft.com/office/drawing/2014/main" id="{8E11E332-DB95-49A8-9B4C-098E7F1F6E13}"/>
+                <a16:creationId xmlns:a16="http://schemas.microsoft.com/office/drawing/2014/main" id="{463C051B-095E-4F03-92B4-8F135C129E3D}"/>
               </a:ext>
             </a:extLst>
           </p:cNvPr>
@@ -2051,7 +2051,7 @@
           <p:cNvPr id="4" name="cover-core">
             <a:extLst xmlns:a="http://schemas.openxmlformats.org/drawingml/2006/main">
               <a:ext uri="{FF2B5EF4-FFF2-40B4-BE49-F238E27FC236}">
-                <a16:creationId xmlns:a16="http://schemas.microsoft.com/office/drawing/2014/main" id="{873BEB72-A2F5-4ABB-AF52-143E41F99856}"/>
+                <a16:creationId xmlns:a16="http://schemas.microsoft.com/office/drawing/2014/main" id="{197C64BA-F791-4FDB-92A3-27C2776382DE}"/>
               </a:ext>
             </a:extLst>
           </p:cNvPr>
@@ -2084,7 +2084,7 @@
           <p:cNvPr id="5" name="cover-line-1">
             <a:extLst xmlns:a="http://schemas.openxmlformats.org/drawingml/2006/main">
               <a:ext uri="{FF2B5EF4-FFF2-40B4-BE49-F238E27FC236}">
-                <a16:creationId xmlns:a16="http://schemas.microsoft.com/office/drawing/2014/main" id="{F2187AD4-7866-4C48-9764-E0C44B992DFA}"/>
+                <a16:creationId xmlns:a16="http://schemas.microsoft.com/office/drawing/2014/main" id="{D2B09194-BA9B-4424-9C6B-15E48CEF2083}"/>
               </a:ext>
             </a:extLst>
           </p:cNvPr>
@@ -2115,7 +2115,7 @@
           <p:cNvPr id="6" name="cover-line-2">
             <a:extLst xmlns:a="http://schemas.openxmlformats.org/drawingml/2006/main">
               <a:ext uri="{FF2B5EF4-FFF2-40B4-BE49-F238E27FC236}">
-                <a16:creationId xmlns:a16="http://schemas.microsoft.com/office/drawing/2014/main" id="{D93EF0FC-9D57-4184-941D-039CE53B15EF}"/>
+                <a16:creationId xmlns:a16="http://schemas.microsoft.com/office/drawing/2014/main" id="{021B29AF-9534-4930-8DE8-A519E6D41638}"/>
               </a:ext>
             </a:extLst>
           </p:cNvPr>
@@ -2146,7 +2146,7 @@
           <p:cNvPr id="7" name="cover-eyebrow">
             <a:extLst xmlns:a="http://schemas.openxmlformats.org/drawingml/2006/main">
               <a:ext uri="{FF2B5EF4-FFF2-40B4-BE49-F238E27FC236}">
-                <a16:creationId xmlns:a16="http://schemas.microsoft.com/office/drawing/2014/main" id="{7ABA49EA-D822-4BCC-A1BF-1E752D01E9D5}"/>
+                <a16:creationId xmlns:a16="http://schemas.microsoft.com/office/drawing/2014/main" id="{F2E22946-7CDA-45C8-9D86-F80FAAD8E271}"/>
               </a:ext>
             </a:extLst>
           </p:cNvPr>
@@ -2204,7 +2204,7 @@
           <p:cNvPr id="8" name="cover-title">
             <a:extLst xmlns:a="http://schemas.openxmlformats.org/drawingml/2006/main">
               <a:ext uri="{FF2B5EF4-FFF2-40B4-BE49-F238E27FC236}">
-                <a16:creationId xmlns:a16="http://schemas.microsoft.com/office/drawing/2014/main" id="{FE68B107-D85B-4FCD-A8D4-01BE95669C4E}"/>
+                <a16:creationId xmlns:a16="http://schemas.microsoft.com/office/drawing/2014/main" id="{8BA18743-25DD-48B9-AD6B-21FABF900B7B}"/>
               </a:ext>
             </a:extLst>
           </p:cNvPr>
@@ -2262,7 +2262,7 @@
           <p:cNvPr id="9" name="cover-subtitle">
             <a:extLst xmlns:a="http://schemas.openxmlformats.org/drawingml/2006/main">
               <a:ext uri="{FF2B5EF4-FFF2-40B4-BE49-F238E27FC236}">
-                <a16:creationId xmlns:a16="http://schemas.microsoft.com/office/drawing/2014/main" id="{C42CF796-BBA0-492A-A5C1-F30D141868F2}"/>
+                <a16:creationId xmlns:a16="http://schemas.microsoft.com/office/drawing/2014/main" id="{1FC49D1C-8248-430B-9A81-30095B80C8AF}"/>
               </a:ext>
             </a:extLst>
           </p:cNvPr>
@@ -2324,7 +2324,7 @@
           <p:cNvPr id="10" name="cover-lead">
             <a:extLst xmlns:a="http://schemas.openxmlformats.org/drawingml/2006/main">
               <a:ext uri="{FF2B5EF4-FFF2-40B4-BE49-F238E27FC236}">
-                <a16:creationId xmlns:a16="http://schemas.microsoft.com/office/drawing/2014/main" id="{5676F0F0-15B0-4E6C-8AB3-2B2582B45CFE}"/>
+                <a16:creationId xmlns:a16="http://schemas.microsoft.com/office/drawing/2014/main" id="{46548DA0-D1B4-4E5A-ABB6-7EC4422E6FF9}"/>
               </a:ext>
             </a:extLst>
           </p:cNvPr>
@@ -2382,7 +2382,7 @@
           <p:cNvPr id="11" name="cover-course">
             <a:extLst xmlns:a="http://schemas.openxmlformats.org/drawingml/2006/main">
               <a:ext uri="{FF2B5EF4-FFF2-40B4-BE49-F238E27FC236}">
-                <a16:creationId xmlns:a16="http://schemas.microsoft.com/office/drawing/2014/main" id="{0D3D0E01-C033-4590-8398-2EC485F12B3A}"/>
+                <a16:creationId xmlns:a16="http://schemas.microsoft.com/office/drawing/2014/main" id="{4570282A-8A34-4564-8AD7-17EA92433F94}"/>
               </a:ext>
             </a:extLst>
           </p:cNvPr>
@@ -2440,7 +2440,7 @@
           <p:cNvPr id="12" name="cover-id">
             <a:extLst xmlns:a="http://schemas.openxmlformats.org/drawingml/2006/main">
               <a:ext uri="{FF2B5EF4-FFF2-40B4-BE49-F238E27FC236}">
-                <a16:creationId xmlns:a16="http://schemas.microsoft.com/office/drawing/2014/main" id="{093530F2-8FEA-4180-92F4-3C577081460F}"/>
+                <a16:creationId xmlns:a16="http://schemas.microsoft.com/office/drawing/2014/main" id="{1370FE32-0A7E-4C93-8E37-5777799F57D0}"/>
               </a:ext>
             </a:extLst>
           </p:cNvPr>
@@ -2496,7 +2496,7 @@
     </p:spTree>
     <p:extLst>
       <p:ext uri="{BB962C8B-B14F-4D97-AF65-F5344CB8AC3E}">
-        <p14:creationId xmlns:p14="http://schemas.microsoft.com/office/powerpoint/2010/main" val="2029273535"/>
+        <p14:creationId xmlns:p14="http://schemas.microsoft.com/office/powerpoint/2010/main" val="1720753637"/>
       </p:ext>
     </p:extLst>
   </p:cSld>
@@ -2527,7 +2527,7 @@
           <p:cNvPr id="1" name="s10-rule">
             <a:extLst xmlns:a="http://schemas.openxmlformats.org/drawingml/2006/main">
               <a:ext uri="{FF2B5EF4-FFF2-40B4-BE49-F238E27FC236}">
-                <a16:creationId xmlns:a16="http://schemas.microsoft.com/office/drawing/2014/main" id="{8AE0D0EC-84B2-4CAE-8F2D-1F9873977B15}"/>
+                <a16:creationId xmlns:a16="http://schemas.microsoft.com/office/drawing/2014/main" id="{E6514D7B-87B1-4FAE-9B3E-BE1793A83B8E}"/>
               </a:ext>
             </a:extLst>
           </p:cNvPr>
@@ -2560,7 +2560,7 @@
           <p:cNvPr id="2" name="s10-eyebrow">
             <a:extLst xmlns:a="http://schemas.openxmlformats.org/drawingml/2006/main">
               <a:ext uri="{FF2B5EF4-FFF2-40B4-BE49-F238E27FC236}">
-                <a16:creationId xmlns:a16="http://schemas.microsoft.com/office/drawing/2014/main" id="{4D1CAAF8-6B74-4608-8C5E-BBCAB635F3B1}"/>
+                <a16:creationId xmlns:a16="http://schemas.microsoft.com/office/drawing/2014/main" id="{51CC2862-EEA3-4A5B-830D-59FA8993793A}"/>
               </a:ext>
             </a:extLst>
           </p:cNvPr>
@@ -2618,7 +2618,7 @@
           <p:cNvPr id="3" name="s10-title">
             <a:extLst xmlns:a="http://schemas.openxmlformats.org/drawingml/2006/main">
               <a:ext uri="{FF2B5EF4-FFF2-40B4-BE49-F238E27FC236}">
-                <a16:creationId xmlns:a16="http://schemas.microsoft.com/office/drawing/2014/main" id="{22061400-BABB-4941-84F7-5620F290852D}"/>
+                <a16:creationId xmlns:a16="http://schemas.microsoft.com/office/drawing/2014/main" id="{0BA1B76D-029B-49B4-BBD4-D60D1DD9A719}"/>
               </a:ext>
             </a:extLst>
           </p:cNvPr>
@@ -2676,7 +2676,7 @@
           <p:cNvPr id="4" name="s10-footer">
             <a:extLst xmlns:a="http://schemas.openxmlformats.org/drawingml/2006/main">
               <a:ext uri="{FF2B5EF4-FFF2-40B4-BE49-F238E27FC236}">
-                <a16:creationId xmlns:a16="http://schemas.microsoft.com/office/drawing/2014/main" id="{49231C82-6E32-415E-93F5-DB7BE5C00002}"/>
+                <a16:creationId xmlns:a16="http://schemas.microsoft.com/office/drawing/2014/main" id="{220884F7-86FE-4D34-B1E6-45B10F8F6C6B}"/>
               </a:ext>
             </a:extLst>
           </p:cNvPr>
@@ -2707,7 +2707,7 @@
           <p:cNvPr id="5" name="s10-identity">
             <a:extLst xmlns:a="http://schemas.openxmlformats.org/drawingml/2006/main">
               <a:ext uri="{FF2B5EF4-FFF2-40B4-BE49-F238E27FC236}">
-                <a16:creationId xmlns:a16="http://schemas.microsoft.com/office/drawing/2014/main" id="{BD3BBF9E-5C7A-476A-B1B6-7A67FFA61988}"/>
+                <a16:creationId xmlns:a16="http://schemas.microsoft.com/office/drawing/2014/main" id="{7039700A-3AF6-4F17-B339-4146D4E41A62}"/>
               </a:ext>
             </a:extLst>
           </p:cNvPr>
@@ -2765,7 +2765,7 @@
           <p:cNvPr id="6" name="case-title">
             <a:extLst xmlns:a="http://schemas.openxmlformats.org/drawingml/2006/main">
               <a:ext uri="{FF2B5EF4-FFF2-40B4-BE49-F238E27FC236}">
-                <a16:creationId xmlns:a16="http://schemas.microsoft.com/office/drawing/2014/main" id="{6C3EDDCE-6918-41D0-80FC-EB6B8C1032F2}"/>
+                <a16:creationId xmlns:a16="http://schemas.microsoft.com/office/drawing/2014/main" id="{92BA7088-8E0A-41DB-8FE2-7EBC1701EEE6}"/>
               </a:ext>
             </a:extLst>
           </p:cNvPr>
@@ -2829,7 +2829,7 @@
           <p:cNvPr id="7" name="case-row-0">
             <a:extLst xmlns:a="http://schemas.openxmlformats.org/drawingml/2006/main">
               <a:ext uri="{FF2B5EF4-FFF2-40B4-BE49-F238E27FC236}">
-                <a16:creationId xmlns:a16="http://schemas.microsoft.com/office/drawing/2014/main" id="{6B080B5A-0C44-4743-A130-09E2EE714F5C}"/>
+                <a16:creationId xmlns:a16="http://schemas.microsoft.com/office/drawing/2014/main" id="{18D13A00-590C-4A52-A579-8295FF967FEE}"/>
               </a:ext>
             </a:extLst>
           </p:cNvPr>
@@ -2893,7 +2893,7 @@
           <p:cNvPr id="8" name="case-row-1">
             <a:extLst xmlns:a="http://schemas.openxmlformats.org/drawingml/2006/main">
               <a:ext uri="{FF2B5EF4-FFF2-40B4-BE49-F238E27FC236}">
-                <a16:creationId xmlns:a16="http://schemas.microsoft.com/office/drawing/2014/main" id="{A69F3799-11A8-49A7-96CD-299BB658C0BF}"/>
+                <a16:creationId xmlns:a16="http://schemas.microsoft.com/office/drawing/2014/main" id="{D013910E-F376-4C30-8D6E-62A9E971E8C2}"/>
               </a:ext>
             </a:extLst>
           </p:cNvPr>
@@ -2957,7 +2957,7 @@
           <p:cNvPr id="9" name="case-row-2">
             <a:extLst xmlns:a="http://schemas.openxmlformats.org/drawingml/2006/main">
               <a:ext uri="{FF2B5EF4-FFF2-40B4-BE49-F238E27FC236}">
-                <a16:creationId xmlns:a16="http://schemas.microsoft.com/office/drawing/2014/main" id="{5C9E311A-810E-444C-A8AD-32F9D7C7936F}"/>
+                <a16:creationId xmlns:a16="http://schemas.microsoft.com/office/drawing/2014/main" id="{BD3CAA70-C5C2-477E-93BE-C0922FB8F20B}"/>
               </a:ext>
             </a:extLst>
           </p:cNvPr>
@@ -3021,7 +3021,7 @@
           <p:cNvPr id="10" name="case-row-3">
             <a:extLst xmlns:a="http://schemas.openxmlformats.org/drawingml/2006/main">
               <a:ext uri="{FF2B5EF4-FFF2-40B4-BE49-F238E27FC236}">
-                <a16:creationId xmlns:a16="http://schemas.microsoft.com/office/drawing/2014/main" id="{55BB2168-BB1B-4308-8275-5CF39228A11C}"/>
+                <a16:creationId xmlns:a16="http://schemas.microsoft.com/office/drawing/2014/main" id="{8FCE5E38-E7ED-4F86-9887-3430CFCE8C2C}"/>
               </a:ext>
             </a:extLst>
           </p:cNvPr>
@@ -3085,7 +3085,7 @@
           <p:cNvPr id="11" name="case-row-4">
             <a:extLst xmlns:a="http://schemas.openxmlformats.org/drawingml/2006/main">
               <a:ext uri="{FF2B5EF4-FFF2-40B4-BE49-F238E27FC236}">
-                <a16:creationId xmlns:a16="http://schemas.microsoft.com/office/drawing/2014/main" id="{BEF97C5A-8544-4F9F-BB0E-43DD4B363553}"/>
+                <a16:creationId xmlns:a16="http://schemas.microsoft.com/office/drawing/2014/main" id="{0B22EFCB-5DC5-4DC2-AFA0-09D959395FD1}"/>
               </a:ext>
             </a:extLst>
           </p:cNvPr>
@@ -3149,7 +3149,7 @@
           <p:cNvPr id="12" name="s10-takeaway-rule">
             <a:extLst xmlns:a="http://schemas.openxmlformats.org/drawingml/2006/main">
               <a:ext uri="{FF2B5EF4-FFF2-40B4-BE49-F238E27FC236}">
-                <a16:creationId xmlns:a16="http://schemas.microsoft.com/office/drawing/2014/main" id="{5BB7C4AF-6F8A-488E-90E3-0EE1ED737BDE}"/>
+                <a16:creationId xmlns:a16="http://schemas.microsoft.com/office/drawing/2014/main" id="{88BB5BC7-E1ED-46D9-B179-822C09BDAAC3}"/>
               </a:ext>
             </a:extLst>
           </p:cNvPr>
@@ -3182,7 +3182,7 @@
           <p:cNvPr id="13" name="s10-takeaway">
             <a:extLst xmlns:a="http://schemas.openxmlformats.org/drawingml/2006/main">
               <a:ext uri="{FF2B5EF4-FFF2-40B4-BE49-F238E27FC236}">
-                <a16:creationId xmlns:a16="http://schemas.microsoft.com/office/drawing/2014/main" id="{44AEDCC0-13C4-473F-9879-C2197D3ADA78}"/>
+                <a16:creationId xmlns:a16="http://schemas.microsoft.com/office/drawing/2014/main" id="{76349C85-EA4A-4D04-9B5E-79F30082CEFF}"/>
               </a:ext>
             </a:extLst>
           </p:cNvPr>
@@ -3238,7 +3238,7 @@
     </p:spTree>
     <p:extLst>
       <p:ext uri="{BB962C8B-B14F-4D97-AF65-F5344CB8AC3E}">
-        <p14:creationId xmlns:p14="http://schemas.microsoft.com/office/powerpoint/2010/main" val="821425182"/>
+        <p14:creationId xmlns:p14="http://schemas.microsoft.com/office/powerpoint/2010/main" val="1091443812"/>
       </p:ext>
     </p:extLst>
   </p:cSld>
@@ -3269,7 +3269,7 @@
           <p:cNvPr id="1" name="s11-rule">
             <a:extLst xmlns:a="http://schemas.openxmlformats.org/drawingml/2006/main">
               <a:ext uri="{FF2B5EF4-FFF2-40B4-BE49-F238E27FC236}">
-                <a16:creationId xmlns:a16="http://schemas.microsoft.com/office/drawing/2014/main" id="{7BD3A138-82B5-47C2-918D-EB60369B9132}"/>
+                <a16:creationId xmlns:a16="http://schemas.microsoft.com/office/drawing/2014/main" id="{513547AC-3131-4459-871E-93EEB24A6975}"/>
               </a:ext>
             </a:extLst>
           </p:cNvPr>
@@ -3302,7 +3302,7 @@
           <p:cNvPr id="2" name="s11-eyebrow">
             <a:extLst xmlns:a="http://schemas.openxmlformats.org/drawingml/2006/main">
               <a:ext uri="{FF2B5EF4-FFF2-40B4-BE49-F238E27FC236}">
-                <a16:creationId xmlns:a16="http://schemas.microsoft.com/office/drawing/2014/main" id="{7694AFA6-6A8D-4D97-B601-666FD8839015}"/>
+                <a16:creationId xmlns:a16="http://schemas.microsoft.com/office/drawing/2014/main" id="{0337C608-C70E-4FD1-BC02-F19F56326D0D}"/>
               </a:ext>
             </a:extLst>
           </p:cNvPr>
@@ -3360,7 +3360,7 @@
           <p:cNvPr id="3" name="s11-title">
             <a:extLst xmlns:a="http://schemas.openxmlformats.org/drawingml/2006/main">
               <a:ext uri="{FF2B5EF4-FFF2-40B4-BE49-F238E27FC236}">
-                <a16:creationId xmlns:a16="http://schemas.microsoft.com/office/drawing/2014/main" id="{BF623E25-978F-44FA-93ED-9A8A53C9850E}"/>
+                <a16:creationId xmlns:a16="http://schemas.microsoft.com/office/drawing/2014/main" id="{C98494BF-62D6-4794-BC67-AFC7AB3797D3}"/>
               </a:ext>
             </a:extLst>
           </p:cNvPr>
@@ -3418,7 +3418,7 @@
           <p:cNvPr id="4" name="s11-footer">
             <a:extLst xmlns:a="http://schemas.openxmlformats.org/drawingml/2006/main">
               <a:ext uri="{FF2B5EF4-FFF2-40B4-BE49-F238E27FC236}">
-                <a16:creationId xmlns:a16="http://schemas.microsoft.com/office/drawing/2014/main" id="{C69F762F-1F34-470D-94B5-0100C4B21931}"/>
+                <a16:creationId xmlns:a16="http://schemas.microsoft.com/office/drawing/2014/main" id="{DA879A74-6B7E-467D-905E-032E6392426F}"/>
               </a:ext>
             </a:extLst>
           </p:cNvPr>
@@ -3449,7 +3449,7 @@
           <p:cNvPr id="5" name="s11-identity">
             <a:extLst xmlns:a="http://schemas.openxmlformats.org/drawingml/2006/main">
               <a:ext uri="{FF2B5EF4-FFF2-40B4-BE49-F238E27FC236}">
-                <a16:creationId xmlns:a16="http://schemas.microsoft.com/office/drawing/2014/main" id="{7A47D41F-988A-4868-85EA-585778AAE4FB}"/>
+                <a16:creationId xmlns:a16="http://schemas.microsoft.com/office/drawing/2014/main" id="{F5794CC8-BC8B-4B76-AAD2-75EAAA232BED}"/>
               </a:ext>
             </a:extLst>
           </p:cNvPr>
@@ -3507,7 +3507,7 @@
           <p:cNvPr id="6" name="practice-circle-0">
             <a:extLst xmlns:a="http://schemas.openxmlformats.org/drawingml/2006/main">
               <a:ext uri="{FF2B5EF4-FFF2-40B4-BE49-F238E27FC236}">
-                <a16:creationId xmlns:a16="http://schemas.microsoft.com/office/drawing/2014/main" id="{C683E406-38C3-4EE0-8860-745D7B05B7FC}"/>
+                <a16:creationId xmlns:a16="http://schemas.microsoft.com/office/drawing/2014/main" id="{01CD47B4-A18B-47D8-9F30-CDBD405EBA32}"/>
               </a:ext>
             </a:extLst>
           </p:cNvPr>
@@ -3540,7 +3540,7 @@
           <p:cNvPr id="7" name="practice-number-0">
             <a:extLst xmlns:a="http://schemas.openxmlformats.org/drawingml/2006/main">
               <a:ext uri="{FF2B5EF4-FFF2-40B4-BE49-F238E27FC236}">
-                <a16:creationId xmlns:a16="http://schemas.microsoft.com/office/drawing/2014/main" id="{8213ABEB-FF27-4833-8BCE-C9FAEDB15559}"/>
+                <a16:creationId xmlns:a16="http://schemas.microsoft.com/office/drawing/2014/main" id="{3A32A2BE-54AE-41FF-A9A6-6CC3AB42E5F5}"/>
               </a:ext>
             </a:extLst>
           </p:cNvPr>
@@ -3598,7 +3598,7 @@
           <p:cNvPr id="8" name="practice-item-0">
             <a:extLst xmlns:a="http://schemas.openxmlformats.org/drawingml/2006/main">
               <a:ext uri="{FF2B5EF4-FFF2-40B4-BE49-F238E27FC236}">
-                <a16:creationId xmlns:a16="http://schemas.microsoft.com/office/drawing/2014/main" id="{D69BB4D2-172A-4D33-8507-B3A3539DB5C9}"/>
+                <a16:creationId xmlns:a16="http://schemas.microsoft.com/office/drawing/2014/main" id="{624E2DFA-CECC-47A6-91EB-7BBE2ACE44AE}"/>
               </a:ext>
             </a:extLst>
           </p:cNvPr>
@@ -3662,7 +3662,7 @@
           <p:cNvPr id="9" name="practice-connector-0">
             <a:extLst xmlns:a="http://schemas.openxmlformats.org/drawingml/2006/main">
               <a:ext uri="{FF2B5EF4-FFF2-40B4-BE49-F238E27FC236}">
-                <a16:creationId xmlns:a16="http://schemas.microsoft.com/office/drawing/2014/main" id="{B243A5B6-A6DD-4869-B2B9-075951C74D37}"/>
+                <a16:creationId xmlns:a16="http://schemas.microsoft.com/office/drawing/2014/main" id="{92B86AB7-83E6-464D-815D-44CD69876EA8}"/>
               </a:ext>
             </a:extLst>
           </p:cNvPr>
@@ -3693,7 +3693,7 @@
           <p:cNvPr id="10" name="practice-circle-1">
             <a:extLst xmlns:a="http://schemas.openxmlformats.org/drawingml/2006/main">
               <a:ext uri="{FF2B5EF4-FFF2-40B4-BE49-F238E27FC236}">
-                <a16:creationId xmlns:a16="http://schemas.microsoft.com/office/drawing/2014/main" id="{CF89C25D-25DD-4994-824B-DAD83C93D520}"/>
+                <a16:creationId xmlns:a16="http://schemas.microsoft.com/office/drawing/2014/main" id="{AB901FB2-A851-4101-B797-9F4D1FCD41BB}"/>
               </a:ext>
             </a:extLst>
           </p:cNvPr>
@@ -3726,7 +3726,7 @@
           <p:cNvPr id="11" name="practice-number-1">
             <a:extLst xmlns:a="http://schemas.openxmlformats.org/drawingml/2006/main">
               <a:ext uri="{FF2B5EF4-FFF2-40B4-BE49-F238E27FC236}">
-                <a16:creationId xmlns:a16="http://schemas.microsoft.com/office/drawing/2014/main" id="{3CD372B4-9462-4921-9B52-6884B17C3C0C}"/>
+                <a16:creationId xmlns:a16="http://schemas.microsoft.com/office/drawing/2014/main" id="{3A05C973-1E8E-4B53-98E3-A83745F35C6D}"/>
               </a:ext>
             </a:extLst>
           </p:cNvPr>
@@ -3784,7 +3784,7 @@
           <p:cNvPr id="12" name="practice-item-1">
             <a:extLst xmlns:a="http://schemas.openxmlformats.org/drawingml/2006/main">
               <a:ext uri="{FF2B5EF4-FFF2-40B4-BE49-F238E27FC236}">
-                <a16:creationId xmlns:a16="http://schemas.microsoft.com/office/drawing/2014/main" id="{E4FF16ED-7D68-4FD8-B5AD-BCF2968B3B4A}"/>
+                <a16:creationId xmlns:a16="http://schemas.microsoft.com/office/drawing/2014/main" id="{B9CE6D27-B311-400E-A62F-387BCD935B0C}"/>
               </a:ext>
             </a:extLst>
           </p:cNvPr>
@@ -3848,7 +3848,7 @@
           <p:cNvPr id="13" name="practice-connector-1">
             <a:extLst xmlns:a="http://schemas.openxmlformats.org/drawingml/2006/main">
               <a:ext uri="{FF2B5EF4-FFF2-40B4-BE49-F238E27FC236}">
-                <a16:creationId xmlns:a16="http://schemas.microsoft.com/office/drawing/2014/main" id="{4AAA9C64-644B-48E5-9300-371F17A6EB6E}"/>
+                <a16:creationId xmlns:a16="http://schemas.microsoft.com/office/drawing/2014/main" id="{87A45ACF-B8A8-48E4-814C-9A607AA11187}"/>
               </a:ext>
             </a:extLst>
           </p:cNvPr>
@@ -3879,7 +3879,7 @@
           <p:cNvPr id="14" name="practice-circle-2">
             <a:extLst xmlns:a="http://schemas.openxmlformats.org/drawingml/2006/main">
               <a:ext uri="{FF2B5EF4-FFF2-40B4-BE49-F238E27FC236}">
-                <a16:creationId xmlns:a16="http://schemas.microsoft.com/office/drawing/2014/main" id="{4EB132D1-BDEF-4797-92A0-7ECE1405F1AF}"/>
+                <a16:creationId xmlns:a16="http://schemas.microsoft.com/office/drawing/2014/main" id="{C798F3B3-8CA8-4806-BDAD-BC59F8BF6332}"/>
               </a:ext>
             </a:extLst>
           </p:cNvPr>
@@ -3912,7 +3912,7 @@
           <p:cNvPr id="15" name="practice-number-2">
             <a:extLst xmlns:a="http://schemas.openxmlformats.org/drawingml/2006/main">
               <a:ext uri="{FF2B5EF4-FFF2-40B4-BE49-F238E27FC236}">
-                <a16:creationId xmlns:a16="http://schemas.microsoft.com/office/drawing/2014/main" id="{050320CA-8241-4A9F-AB52-8B6ED4F01650}"/>
+                <a16:creationId xmlns:a16="http://schemas.microsoft.com/office/drawing/2014/main" id="{4C95ED03-01BF-4E6C-BAD6-03CF4860D1F9}"/>
               </a:ext>
             </a:extLst>
           </p:cNvPr>
@@ -3970,7 +3970,7 @@
           <p:cNvPr id="16" name="practice-item-2">
             <a:extLst xmlns:a="http://schemas.openxmlformats.org/drawingml/2006/main">
               <a:ext uri="{FF2B5EF4-FFF2-40B4-BE49-F238E27FC236}">
-                <a16:creationId xmlns:a16="http://schemas.microsoft.com/office/drawing/2014/main" id="{4777650D-0958-41D4-A6B9-79E97AD85C5B}"/>
+                <a16:creationId xmlns:a16="http://schemas.microsoft.com/office/drawing/2014/main" id="{47F8E3A3-76B0-406D-A681-1229B16EBD4F}"/>
               </a:ext>
             </a:extLst>
           </p:cNvPr>
@@ -4032,7 +4032,7 @@
     </p:spTree>
     <p:extLst>
       <p:ext uri="{BB962C8B-B14F-4D97-AF65-F5344CB8AC3E}">
-        <p14:creationId xmlns:p14="http://schemas.microsoft.com/office/powerpoint/2010/main" val="2138593163"/>
+        <p14:creationId xmlns:p14="http://schemas.microsoft.com/office/powerpoint/2010/main" val="697697596"/>
       </p:ext>
     </p:extLst>
   </p:cSld>
@@ -4063,7 +4063,7 @@
           <p:cNvPr id="1" name="s12-rule">
             <a:extLst xmlns:a="http://schemas.openxmlformats.org/drawingml/2006/main">
               <a:ext uri="{FF2B5EF4-FFF2-40B4-BE49-F238E27FC236}">
-                <a16:creationId xmlns:a16="http://schemas.microsoft.com/office/drawing/2014/main" id="{8A025250-E0D2-45F6-B94D-C3646B50CDF2}"/>
+                <a16:creationId xmlns:a16="http://schemas.microsoft.com/office/drawing/2014/main" id="{B9C2C175-ECBF-4256-8469-3230DDFF705B}"/>
               </a:ext>
             </a:extLst>
           </p:cNvPr>
@@ -4096,7 +4096,7 @@
           <p:cNvPr id="2" name="s12-eyebrow">
             <a:extLst xmlns:a="http://schemas.openxmlformats.org/drawingml/2006/main">
               <a:ext uri="{FF2B5EF4-FFF2-40B4-BE49-F238E27FC236}">
-                <a16:creationId xmlns:a16="http://schemas.microsoft.com/office/drawing/2014/main" id="{6003A711-F8D3-4B31-B15F-524CA73C1E18}"/>
+                <a16:creationId xmlns:a16="http://schemas.microsoft.com/office/drawing/2014/main" id="{89A0FA82-65DD-4FCE-8C6D-2A22D66729C8}"/>
               </a:ext>
             </a:extLst>
           </p:cNvPr>
@@ -4154,7 +4154,7 @@
           <p:cNvPr id="3" name="s12-title">
             <a:extLst xmlns:a="http://schemas.openxmlformats.org/drawingml/2006/main">
               <a:ext uri="{FF2B5EF4-FFF2-40B4-BE49-F238E27FC236}">
-                <a16:creationId xmlns:a16="http://schemas.microsoft.com/office/drawing/2014/main" id="{1B6A2FE8-4AB4-4CF0-9955-B223941DDE0A}"/>
+                <a16:creationId xmlns:a16="http://schemas.microsoft.com/office/drawing/2014/main" id="{09C16B96-92F1-4277-8D22-25142F8B2A73}"/>
               </a:ext>
             </a:extLst>
           </p:cNvPr>
@@ -4212,7 +4212,7 @@
           <p:cNvPr id="4" name="s12-footer">
             <a:extLst xmlns:a="http://schemas.openxmlformats.org/drawingml/2006/main">
               <a:ext uri="{FF2B5EF4-FFF2-40B4-BE49-F238E27FC236}">
-                <a16:creationId xmlns:a16="http://schemas.microsoft.com/office/drawing/2014/main" id="{F0C2368D-7B6D-4A88-A9DF-EC11ECA81048}"/>
+                <a16:creationId xmlns:a16="http://schemas.microsoft.com/office/drawing/2014/main" id="{2290D040-A8A2-4690-B7C4-B508CF9057E2}"/>
               </a:ext>
             </a:extLst>
           </p:cNvPr>
@@ -4243,7 +4243,7 @@
           <p:cNvPr id="5" name="s12-identity">
             <a:extLst xmlns:a="http://schemas.openxmlformats.org/drawingml/2006/main">
               <a:ext uri="{FF2B5EF4-FFF2-40B4-BE49-F238E27FC236}">
-                <a16:creationId xmlns:a16="http://schemas.microsoft.com/office/drawing/2014/main" id="{CF868FB1-96AE-4EA6-B235-35B4F771522B}"/>
+                <a16:creationId xmlns:a16="http://schemas.microsoft.com/office/drawing/2014/main" id="{77EBAA30-B578-481E-B353-8E46F89B73EA}"/>
               </a:ext>
             </a:extLst>
           </p:cNvPr>
@@ -4301,7 +4301,7 @@
           <p:cNvPr id="6" name="recap-circle-0">
             <a:extLst xmlns:a="http://schemas.openxmlformats.org/drawingml/2006/main">
               <a:ext uri="{FF2B5EF4-FFF2-40B4-BE49-F238E27FC236}">
-                <a16:creationId xmlns:a16="http://schemas.microsoft.com/office/drawing/2014/main" id="{5374F282-21DA-4583-B686-15CF43525146}"/>
+                <a16:creationId xmlns:a16="http://schemas.microsoft.com/office/drawing/2014/main" id="{4D71CAA9-6406-4BA0-90FB-C6B156916701}"/>
               </a:ext>
             </a:extLst>
           </p:cNvPr>
@@ -4334,7 +4334,7 @@
           <p:cNvPr id="7" name="recap-number-0">
             <a:extLst xmlns:a="http://schemas.openxmlformats.org/drawingml/2006/main">
               <a:ext uri="{FF2B5EF4-FFF2-40B4-BE49-F238E27FC236}">
-                <a16:creationId xmlns:a16="http://schemas.microsoft.com/office/drawing/2014/main" id="{DE30CBBF-A38D-46C5-9195-C98C8D190C32}"/>
+                <a16:creationId xmlns:a16="http://schemas.microsoft.com/office/drawing/2014/main" id="{CFE3A988-74D9-436C-A8B8-6653F262084A}"/>
               </a:ext>
             </a:extLst>
           </p:cNvPr>
@@ -4392,7 +4392,7 @@
           <p:cNvPr id="8" name="recap-item-0">
             <a:extLst xmlns:a="http://schemas.openxmlformats.org/drawingml/2006/main">
               <a:ext uri="{FF2B5EF4-FFF2-40B4-BE49-F238E27FC236}">
-                <a16:creationId xmlns:a16="http://schemas.microsoft.com/office/drawing/2014/main" id="{B6851A7F-74A3-4049-81F2-8D599AEF0097}"/>
+                <a16:creationId xmlns:a16="http://schemas.microsoft.com/office/drawing/2014/main" id="{A57563E9-BC94-4645-B11E-CE0622DDC373}"/>
               </a:ext>
             </a:extLst>
           </p:cNvPr>
@@ -4456,7 +4456,7 @@
           <p:cNvPr id="9" name="recap-connector-0">
             <a:extLst xmlns:a="http://schemas.openxmlformats.org/drawingml/2006/main">
               <a:ext uri="{FF2B5EF4-FFF2-40B4-BE49-F238E27FC236}">
-                <a16:creationId xmlns:a16="http://schemas.microsoft.com/office/drawing/2014/main" id="{9236B71F-C8FF-42E6-BB71-32CEF98F01B5}"/>
+                <a16:creationId xmlns:a16="http://schemas.microsoft.com/office/drawing/2014/main" id="{BFCCB2FC-BED0-47B9-986E-38B3CCCC7B0C}"/>
               </a:ext>
             </a:extLst>
           </p:cNvPr>
@@ -4487,7 +4487,7 @@
           <p:cNvPr id="10" name="recap-circle-1">
             <a:extLst xmlns:a="http://schemas.openxmlformats.org/drawingml/2006/main">
               <a:ext uri="{FF2B5EF4-FFF2-40B4-BE49-F238E27FC236}">
-                <a16:creationId xmlns:a16="http://schemas.microsoft.com/office/drawing/2014/main" id="{9F02E4A2-087F-4036-838E-FD77563E4337}"/>
+                <a16:creationId xmlns:a16="http://schemas.microsoft.com/office/drawing/2014/main" id="{D3725356-4327-4020-B0B4-77B65F7325D7}"/>
               </a:ext>
             </a:extLst>
           </p:cNvPr>
@@ -4520,7 +4520,7 @@
           <p:cNvPr id="11" name="recap-number-1">
             <a:extLst xmlns:a="http://schemas.openxmlformats.org/drawingml/2006/main">
               <a:ext uri="{FF2B5EF4-FFF2-40B4-BE49-F238E27FC236}">
-                <a16:creationId xmlns:a16="http://schemas.microsoft.com/office/drawing/2014/main" id="{2E99638D-1F6D-40D2-A276-A2BDE0A591CD}"/>
+                <a16:creationId xmlns:a16="http://schemas.microsoft.com/office/drawing/2014/main" id="{AA1B89E9-38FC-46D5-A607-A9A39723415A}"/>
               </a:ext>
             </a:extLst>
           </p:cNvPr>
@@ -4578,7 +4578,7 @@
           <p:cNvPr id="12" name="recap-item-1">
             <a:extLst xmlns:a="http://schemas.openxmlformats.org/drawingml/2006/main">
               <a:ext uri="{FF2B5EF4-FFF2-40B4-BE49-F238E27FC236}">
-                <a16:creationId xmlns:a16="http://schemas.microsoft.com/office/drawing/2014/main" id="{C87296E8-42C1-4733-B833-D35E1E457FA1}"/>
+                <a16:creationId xmlns:a16="http://schemas.microsoft.com/office/drawing/2014/main" id="{24EBC207-B1E9-44CF-8073-B21B71D210BC}"/>
               </a:ext>
             </a:extLst>
           </p:cNvPr>
@@ -4642,7 +4642,7 @@
           <p:cNvPr id="13" name="recap-connector-1">
             <a:extLst xmlns:a="http://schemas.openxmlformats.org/drawingml/2006/main">
               <a:ext uri="{FF2B5EF4-FFF2-40B4-BE49-F238E27FC236}">
-                <a16:creationId xmlns:a16="http://schemas.microsoft.com/office/drawing/2014/main" id="{6A053692-13FF-4F3C-890C-F5811E24E865}"/>
+                <a16:creationId xmlns:a16="http://schemas.microsoft.com/office/drawing/2014/main" id="{3AA7FE38-F91A-455C-944F-AE95D2949327}"/>
               </a:ext>
             </a:extLst>
           </p:cNvPr>
@@ -4673,7 +4673,7 @@
           <p:cNvPr id="14" name="recap-circle-2">
             <a:extLst xmlns:a="http://schemas.openxmlformats.org/drawingml/2006/main">
               <a:ext uri="{FF2B5EF4-FFF2-40B4-BE49-F238E27FC236}">
-                <a16:creationId xmlns:a16="http://schemas.microsoft.com/office/drawing/2014/main" id="{3B75C3F1-0058-452A-BE65-EF38B18229FF}"/>
+                <a16:creationId xmlns:a16="http://schemas.microsoft.com/office/drawing/2014/main" id="{FB55CF89-F5A7-4B06-AFE9-A58E594F6D2F}"/>
               </a:ext>
             </a:extLst>
           </p:cNvPr>
@@ -4706,7 +4706,7 @@
           <p:cNvPr id="15" name="recap-number-2">
             <a:extLst xmlns:a="http://schemas.openxmlformats.org/drawingml/2006/main">
               <a:ext uri="{FF2B5EF4-FFF2-40B4-BE49-F238E27FC236}">
-                <a16:creationId xmlns:a16="http://schemas.microsoft.com/office/drawing/2014/main" id="{EBDCF9BD-669A-4058-941D-F14712842103}"/>
+                <a16:creationId xmlns:a16="http://schemas.microsoft.com/office/drawing/2014/main" id="{0023BCD7-9DEC-4278-8329-5EE8CC9BA9CC}"/>
               </a:ext>
             </a:extLst>
           </p:cNvPr>
@@ -4764,7 +4764,7 @@
           <p:cNvPr id="16" name="recap-item-2">
             <a:extLst xmlns:a="http://schemas.openxmlformats.org/drawingml/2006/main">
               <a:ext uri="{FF2B5EF4-FFF2-40B4-BE49-F238E27FC236}">
-                <a16:creationId xmlns:a16="http://schemas.microsoft.com/office/drawing/2014/main" id="{7505CE72-EFD9-4861-B77B-335CDBAAD952}"/>
+                <a16:creationId xmlns:a16="http://schemas.microsoft.com/office/drawing/2014/main" id="{C4351047-C677-4C2E-A5BD-6F7C2352FEEC}"/>
               </a:ext>
             </a:extLst>
           </p:cNvPr>
@@ -4826,7 +4826,7 @@
     </p:spTree>
     <p:extLst>
       <p:ext uri="{BB962C8B-B14F-4D97-AF65-F5344CB8AC3E}">
-        <p14:creationId xmlns:p14="http://schemas.microsoft.com/office/powerpoint/2010/main" val="1581158367"/>
+        <p14:creationId xmlns:p14="http://schemas.microsoft.com/office/powerpoint/2010/main" val="979413412"/>
       </p:ext>
     </p:extLst>
   </p:cSld>
@@ -4857,7 +4857,7 @@
           <p:cNvPr id="1" name="s13-rule">
             <a:extLst xmlns:a="http://schemas.openxmlformats.org/drawingml/2006/main">
               <a:ext uri="{FF2B5EF4-FFF2-40B4-BE49-F238E27FC236}">
-                <a16:creationId xmlns:a16="http://schemas.microsoft.com/office/drawing/2014/main" id="{0D0B7F87-7417-49B9-848A-F0737A6E2D7F}"/>
+                <a16:creationId xmlns:a16="http://schemas.microsoft.com/office/drawing/2014/main" id="{0D5414D1-AF50-4B71-8A6A-80AD23140919}"/>
               </a:ext>
             </a:extLst>
           </p:cNvPr>
@@ -4890,7 +4890,7 @@
           <p:cNvPr id="2" name="s13-eyebrow">
             <a:extLst xmlns:a="http://schemas.openxmlformats.org/drawingml/2006/main">
               <a:ext uri="{FF2B5EF4-FFF2-40B4-BE49-F238E27FC236}">
-                <a16:creationId xmlns:a16="http://schemas.microsoft.com/office/drawing/2014/main" id="{5934EF5A-35AD-4DE4-A2EB-A533ECA3458D}"/>
+                <a16:creationId xmlns:a16="http://schemas.microsoft.com/office/drawing/2014/main" id="{50678C71-852F-48FA-809F-C0CA3585927D}"/>
               </a:ext>
             </a:extLst>
           </p:cNvPr>
@@ -4948,7 +4948,7 @@
           <p:cNvPr id="3" name="s13-title">
             <a:extLst xmlns:a="http://schemas.openxmlformats.org/drawingml/2006/main">
               <a:ext uri="{FF2B5EF4-FFF2-40B4-BE49-F238E27FC236}">
-                <a16:creationId xmlns:a16="http://schemas.microsoft.com/office/drawing/2014/main" id="{6622C557-9F85-4ED8-952F-99913162E86F}"/>
+                <a16:creationId xmlns:a16="http://schemas.microsoft.com/office/drawing/2014/main" id="{EAE8705B-20D9-4368-885A-4E3A6F76E991}"/>
               </a:ext>
             </a:extLst>
           </p:cNvPr>
@@ -5006,7 +5006,7 @@
           <p:cNvPr id="4" name="s13-footer">
             <a:extLst xmlns:a="http://schemas.openxmlformats.org/drawingml/2006/main">
               <a:ext uri="{FF2B5EF4-FFF2-40B4-BE49-F238E27FC236}">
-                <a16:creationId xmlns:a16="http://schemas.microsoft.com/office/drawing/2014/main" id="{243A501F-BF98-4E45-A1B0-D36B23A81D7B}"/>
+                <a16:creationId xmlns:a16="http://schemas.microsoft.com/office/drawing/2014/main" id="{3F06B902-46A2-4C33-830A-59FA3B6C167A}"/>
               </a:ext>
             </a:extLst>
           </p:cNvPr>
@@ -5037,7 +5037,7 @@
           <p:cNvPr id="5" name="s13-identity">
             <a:extLst xmlns:a="http://schemas.openxmlformats.org/drawingml/2006/main">
               <a:ext uri="{FF2B5EF4-FFF2-40B4-BE49-F238E27FC236}">
-                <a16:creationId xmlns:a16="http://schemas.microsoft.com/office/drawing/2014/main" id="{241D0412-931C-4591-8055-5DAA7E975193}"/>
+                <a16:creationId xmlns:a16="http://schemas.microsoft.com/office/drawing/2014/main" id="{3C37190C-0EC8-4674-908F-A16C6D060E54}"/>
               </a:ext>
             </a:extLst>
           </p:cNvPr>
@@ -5095,7 +5095,7 @@
           <p:cNvPr id="6" name="source-0">
             <a:extLst xmlns:a="http://schemas.openxmlformats.org/drawingml/2006/main">
               <a:ext uri="{FF2B5EF4-FFF2-40B4-BE49-F238E27FC236}">
-                <a16:creationId xmlns:a16="http://schemas.microsoft.com/office/drawing/2014/main" id="{058F9FAC-1DBE-488F-9296-F5E289502368}"/>
+                <a16:creationId xmlns:a16="http://schemas.microsoft.com/office/drawing/2014/main" id="{E4225C67-48A2-4255-B0C3-4ED4CA252F61}"/>
               </a:ext>
             </a:extLst>
           </p:cNvPr>
@@ -5159,7 +5159,7 @@
           <p:cNvPr id="7" name="source-1">
             <a:extLst xmlns:a="http://schemas.openxmlformats.org/drawingml/2006/main">
               <a:ext uri="{FF2B5EF4-FFF2-40B4-BE49-F238E27FC236}">
-                <a16:creationId xmlns:a16="http://schemas.microsoft.com/office/drawing/2014/main" id="{45F70BA0-1B94-4190-80F1-4A48172437FE}"/>
+                <a16:creationId xmlns:a16="http://schemas.microsoft.com/office/drawing/2014/main" id="{F9F53300-46A8-41EE-BB7A-6091251DED13}"/>
               </a:ext>
             </a:extLst>
           </p:cNvPr>
@@ -5223,7 +5223,7 @@
           <p:cNvPr id="8" name="s13-takeaway-rule">
             <a:extLst xmlns:a="http://schemas.openxmlformats.org/drawingml/2006/main">
               <a:ext uri="{FF2B5EF4-FFF2-40B4-BE49-F238E27FC236}">
-                <a16:creationId xmlns:a16="http://schemas.microsoft.com/office/drawing/2014/main" id="{471B7884-59F6-4B86-9594-5FC40DDA21F5}"/>
+                <a16:creationId xmlns:a16="http://schemas.microsoft.com/office/drawing/2014/main" id="{8083DAF5-AB71-4973-95E9-910F11A80909}"/>
               </a:ext>
             </a:extLst>
           </p:cNvPr>
@@ -5256,7 +5256,7 @@
           <p:cNvPr id="9" name="s13-takeaway">
             <a:extLst xmlns:a="http://schemas.openxmlformats.org/drawingml/2006/main">
               <a:ext uri="{FF2B5EF4-FFF2-40B4-BE49-F238E27FC236}">
-                <a16:creationId xmlns:a16="http://schemas.microsoft.com/office/drawing/2014/main" id="{77E1CD7A-CC1C-4190-A77A-8BBE5CD94D31}"/>
+                <a16:creationId xmlns:a16="http://schemas.microsoft.com/office/drawing/2014/main" id="{7E25C3C4-9CDD-431D-A5BB-57B3F11AA01B}"/>
               </a:ext>
             </a:extLst>
           </p:cNvPr>
@@ -5281,7 +5281,7 @@
         </p:spPr>
         <p:txBody>
           <a:bodyPr xmlns:a="http://schemas.openxmlformats.org/drawingml/2006/main" lIns="0" tIns="0" rIns="0" bIns="0" anchor="ctr">
-            <a:normAutofit fontScale="95911"/>
+            <a:normAutofit fontScale="100000"/>
           </a:bodyPr>
           <a:lstStyle xmlns:a="http://schemas.openxmlformats.org/drawingml/2006/main"/>
           <a:p xmlns:a="http://schemas.openxmlformats.org/drawingml/2006/main">
@@ -5304,7 +5304,7 @@
                 <a:ea typeface="PingFang SC"/>
                 <a:cs typeface="PingFang SC"/>
               </a:rPr>
-              <a:t>课程精编页用于讲授主线；播放器中的“原课件”模式保留团队 PowerPoint 精选页、真实图片和可播放视频。</a:t>
+              <a:t>课程正文与幻灯片共享同一知识主线，图片和视频用于帮助理解本节概念与案例。</a:t>
             </a:r>
           </a:p>
         </p:txBody>
@@ -5312,7 +5312,7 @@
     </p:spTree>
     <p:extLst>
       <p:ext uri="{BB962C8B-B14F-4D97-AF65-F5344CB8AC3E}">
-        <p14:creationId xmlns:p14="http://schemas.microsoft.com/office/powerpoint/2010/main" val="1090357188"/>
+        <p14:creationId xmlns:p14="http://schemas.microsoft.com/office/powerpoint/2010/main" val="1108486561"/>
       </p:ext>
     </p:extLst>
   </p:cSld>
@@ -5343,7 +5343,7 @@
           <p:cNvPr id="1" name="s2-rule">
             <a:extLst xmlns:a="http://schemas.openxmlformats.org/drawingml/2006/main">
               <a:ext uri="{FF2B5EF4-FFF2-40B4-BE49-F238E27FC236}">
-                <a16:creationId xmlns:a16="http://schemas.microsoft.com/office/drawing/2014/main" id="{70F28821-70A1-451D-A05D-CCD9E94F8B6A}"/>
+                <a16:creationId xmlns:a16="http://schemas.microsoft.com/office/drawing/2014/main" id="{FA6367BA-C258-4470-BBD2-EFAAE84881BE}"/>
               </a:ext>
             </a:extLst>
           </p:cNvPr>
@@ -5376,7 +5376,7 @@
           <p:cNvPr id="2" name="s2-eyebrow">
             <a:extLst xmlns:a="http://schemas.openxmlformats.org/drawingml/2006/main">
               <a:ext uri="{FF2B5EF4-FFF2-40B4-BE49-F238E27FC236}">
-                <a16:creationId xmlns:a16="http://schemas.microsoft.com/office/drawing/2014/main" id="{A5DEFC42-3670-4848-B1ED-2E28DF1F03D7}"/>
+                <a16:creationId xmlns:a16="http://schemas.microsoft.com/office/drawing/2014/main" id="{C26DDF3F-D315-4524-BB62-45D1FF415543}"/>
               </a:ext>
             </a:extLst>
           </p:cNvPr>
@@ -5434,7 +5434,7 @@
           <p:cNvPr id="3" name="s2-title">
             <a:extLst xmlns:a="http://schemas.openxmlformats.org/drawingml/2006/main">
               <a:ext uri="{FF2B5EF4-FFF2-40B4-BE49-F238E27FC236}">
-                <a16:creationId xmlns:a16="http://schemas.microsoft.com/office/drawing/2014/main" id="{95E83DF1-88B8-44F8-8D8F-260372EA44DB}"/>
+                <a16:creationId xmlns:a16="http://schemas.microsoft.com/office/drawing/2014/main" id="{3B910AE9-F1A6-4D59-AB81-E8F62F718A8D}"/>
               </a:ext>
             </a:extLst>
           </p:cNvPr>
@@ -5492,7 +5492,7 @@
           <p:cNvPr id="4" name="s2-footer">
             <a:extLst xmlns:a="http://schemas.openxmlformats.org/drawingml/2006/main">
               <a:ext uri="{FF2B5EF4-FFF2-40B4-BE49-F238E27FC236}">
-                <a16:creationId xmlns:a16="http://schemas.microsoft.com/office/drawing/2014/main" id="{78586641-DEF3-4FA3-8FD8-39BC23A4010E}"/>
+                <a16:creationId xmlns:a16="http://schemas.microsoft.com/office/drawing/2014/main" id="{6AC9DE27-6DB4-48C8-BC03-47E36959DD1C}"/>
               </a:ext>
             </a:extLst>
           </p:cNvPr>
@@ -5523,7 +5523,7 @@
           <p:cNvPr id="5" name="s2-identity">
             <a:extLst xmlns:a="http://schemas.openxmlformats.org/drawingml/2006/main">
               <a:ext uri="{FF2B5EF4-FFF2-40B4-BE49-F238E27FC236}">
-                <a16:creationId xmlns:a16="http://schemas.microsoft.com/office/drawing/2014/main" id="{0CA60895-449C-4230-B089-222FA5E0B5B1}"/>
+                <a16:creationId xmlns:a16="http://schemas.microsoft.com/office/drawing/2014/main" id="{19C23592-7F79-4E91-BA4E-BD6486B4AE7F}"/>
               </a:ext>
             </a:extLst>
           </p:cNvPr>
@@ -5581,7 +5581,7 @@
           <p:cNvPr id="6" name="objective-1">
             <a:extLst xmlns:a="http://schemas.openxmlformats.org/drawingml/2006/main">
               <a:ext uri="{FF2B5EF4-FFF2-40B4-BE49-F238E27FC236}">
-                <a16:creationId xmlns:a16="http://schemas.microsoft.com/office/drawing/2014/main" id="{E242E30D-E39F-46B2-B654-30F12040C7D4}"/>
+                <a16:creationId xmlns:a16="http://schemas.microsoft.com/office/drawing/2014/main" id="{ADD9292A-3323-44EB-A3B4-C529752E341F}"/>
               </a:ext>
             </a:extLst>
           </p:cNvPr>
@@ -5668,7 +5668,7 @@
           <p:cNvPr id="7" name="objective-2">
             <a:extLst xmlns:a="http://schemas.openxmlformats.org/drawingml/2006/main">
               <a:ext uri="{FF2B5EF4-FFF2-40B4-BE49-F238E27FC236}">
-                <a16:creationId xmlns:a16="http://schemas.microsoft.com/office/drawing/2014/main" id="{0E338C33-EA4F-4790-896F-122575C7EE1D}"/>
+                <a16:creationId xmlns:a16="http://schemas.microsoft.com/office/drawing/2014/main" id="{5BDF3551-5057-41EE-9766-1837C89008D8}"/>
               </a:ext>
             </a:extLst>
           </p:cNvPr>
@@ -5755,7 +5755,7 @@
           <p:cNvPr id="8" name="objective-3">
             <a:extLst xmlns:a="http://schemas.openxmlformats.org/drawingml/2006/main">
               <a:ext uri="{FF2B5EF4-FFF2-40B4-BE49-F238E27FC236}">
-                <a16:creationId xmlns:a16="http://schemas.microsoft.com/office/drawing/2014/main" id="{7C0AA573-A6DC-40A5-BDBA-4ECA7E01B357}"/>
+                <a16:creationId xmlns:a16="http://schemas.microsoft.com/office/drawing/2014/main" id="{F52C6A60-4D1E-4A67-90C7-EEFC5AC5E1DE}"/>
               </a:ext>
             </a:extLst>
           </p:cNvPr>
@@ -5842,7 +5842,7 @@
           <p:cNvPr id="9" name="objective-4">
             <a:extLst xmlns:a="http://schemas.openxmlformats.org/drawingml/2006/main">
               <a:ext uri="{FF2B5EF4-FFF2-40B4-BE49-F238E27FC236}">
-                <a16:creationId xmlns:a16="http://schemas.microsoft.com/office/drawing/2014/main" id="{A1577789-4B6D-4969-B5D3-5464F6723F37}"/>
+                <a16:creationId xmlns:a16="http://schemas.microsoft.com/office/drawing/2014/main" id="{211A2050-EF89-4732-AFD9-CAA63902A6E6}"/>
               </a:ext>
             </a:extLst>
           </p:cNvPr>
@@ -5927,7 +5927,7 @@
     </p:spTree>
     <p:extLst>
       <p:ext uri="{BB962C8B-B14F-4D97-AF65-F5344CB8AC3E}">
-        <p14:creationId xmlns:p14="http://schemas.microsoft.com/office/powerpoint/2010/main" val="819179579"/>
+        <p14:creationId xmlns:p14="http://schemas.microsoft.com/office/powerpoint/2010/main" val="1754960389"/>
       </p:ext>
     </p:extLst>
   </p:cSld>
@@ -5958,7 +5958,7 @@
           <p:cNvPr id="1" name="s3-rule">
             <a:extLst xmlns:a="http://schemas.openxmlformats.org/drawingml/2006/main">
               <a:ext uri="{FF2B5EF4-FFF2-40B4-BE49-F238E27FC236}">
-                <a16:creationId xmlns:a16="http://schemas.microsoft.com/office/drawing/2014/main" id="{C900350C-D942-4450-984E-1C0237025D88}"/>
+                <a16:creationId xmlns:a16="http://schemas.microsoft.com/office/drawing/2014/main" id="{3559B305-FD98-42B1-9461-2E0F14CF8953}"/>
               </a:ext>
             </a:extLst>
           </p:cNvPr>
@@ -5991,7 +5991,7 @@
           <p:cNvPr id="2" name="s3-eyebrow">
             <a:extLst xmlns:a="http://schemas.openxmlformats.org/drawingml/2006/main">
               <a:ext uri="{FF2B5EF4-FFF2-40B4-BE49-F238E27FC236}">
-                <a16:creationId xmlns:a16="http://schemas.microsoft.com/office/drawing/2014/main" id="{DD59A4AF-EBB3-4A34-9DA1-500374772094}"/>
+                <a16:creationId xmlns:a16="http://schemas.microsoft.com/office/drawing/2014/main" id="{795F3A31-8D29-4808-8113-58B26C34B2C4}"/>
               </a:ext>
             </a:extLst>
           </p:cNvPr>
@@ -6049,7 +6049,7 @@
           <p:cNvPr id="3" name="s3-title">
             <a:extLst xmlns:a="http://schemas.openxmlformats.org/drawingml/2006/main">
               <a:ext uri="{FF2B5EF4-FFF2-40B4-BE49-F238E27FC236}">
-                <a16:creationId xmlns:a16="http://schemas.microsoft.com/office/drawing/2014/main" id="{F94FBE2F-58D6-4531-B2D7-621932E4E67E}"/>
+                <a16:creationId xmlns:a16="http://schemas.microsoft.com/office/drawing/2014/main" id="{914C6F63-3C31-4433-A887-6A5199AE92D3}"/>
               </a:ext>
             </a:extLst>
           </p:cNvPr>
@@ -6107,7 +6107,7 @@
           <p:cNvPr id="4" name="s3-footer">
             <a:extLst xmlns:a="http://schemas.openxmlformats.org/drawingml/2006/main">
               <a:ext uri="{FF2B5EF4-FFF2-40B4-BE49-F238E27FC236}">
-                <a16:creationId xmlns:a16="http://schemas.microsoft.com/office/drawing/2014/main" id="{A7378D4C-F113-4FDE-BEEB-DD5DCD30345D}"/>
+                <a16:creationId xmlns:a16="http://schemas.microsoft.com/office/drawing/2014/main" id="{E83E7338-C882-468E-A0E4-549DA29FE7C2}"/>
               </a:ext>
             </a:extLst>
           </p:cNvPr>
@@ -6138,7 +6138,7 @@
           <p:cNvPr id="5" name="s3-identity">
             <a:extLst xmlns:a="http://schemas.openxmlformats.org/drawingml/2006/main">
               <a:ext uri="{FF2B5EF4-FFF2-40B4-BE49-F238E27FC236}">
-                <a16:creationId xmlns:a16="http://schemas.microsoft.com/office/drawing/2014/main" id="{50B5F6C9-2873-4BF9-A554-5968F59CF106}"/>
+                <a16:creationId xmlns:a16="http://schemas.microsoft.com/office/drawing/2014/main" id="{DD1B5EFC-6401-4FBA-A0B8-F70C86A7D415}"/>
               </a:ext>
             </a:extLst>
           </p:cNvPr>
@@ -6196,7 +6196,7 @@
           <p:cNvPr id="6" name="core-no-0">
             <a:extLst xmlns:a="http://schemas.openxmlformats.org/drawingml/2006/main">
               <a:ext uri="{FF2B5EF4-FFF2-40B4-BE49-F238E27FC236}">
-                <a16:creationId xmlns:a16="http://schemas.microsoft.com/office/drawing/2014/main" id="{B430C714-1911-4DBD-9778-DC92E06C4EB3}"/>
+                <a16:creationId xmlns:a16="http://schemas.microsoft.com/office/drawing/2014/main" id="{07346419-B926-4B53-AB34-D55F02508E27}"/>
               </a:ext>
             </a:extLst>
           </p:cNvPr>
@@ -6254,7 +6254,7 @@
           <p:cNvPr id="7" name="core-label-0">
             <a:extLst xmlns:a="http://schemas.openxmlformats.org/drawingml/2006/main">
               <a:ext uri="{FF2B5EF4-FFF2-40B4-BE49-F238E27FC236}">
-                <a16:creationId xmlns:a16="http://schemas.microsoft.com/office/drawing/2014/main" id="{4D8C620D-8E7D-4E93-995D-680888A65F5E}"/>
+                <a16:creationId xmlns:a16="http://schemas.microsoft.com/office/drawing/2014/main" id="{7F785FB7-3369-450A-BCBD-F3159DCE5A96}"/>
               </a:ext>
             </a:extLst>
           </p:cNvPr>
@@ -6312,7 +6312,7 @@
           <p:cNvPr id="8" name="core-body-0">
             <a:extLst xmlns:a="http://schemas.openxmlformats.org/drawingml/2006/main">
               <a:ext uri="{FF2B5EF4-FFF2-40B4-BE49-F238E27FC236}">
-                <a16:creationId xmlns:a16="http://schemas.microsoft.com/office/drawing/2014/main" id="{AD5B08DA-F97F-4D1F-A904-5566A8FA7784}"/>
+                <a16:creationId xmlns:a16="http://schemas.microsoft.com/office/drawing/2014/main" id="{1121B4F9-E5D5-4A37-8558-94679973D93C}"/>
               </a:ext>
             </a:extLst>
           </p:cNvPr>
@@ -6376,7 +6376,7 @@
           <p:cNvPr id="9" name="core-no-1">
             <a:extLst xmlns:a="http://schemas.openxmlformats.org/drawingml/2006/main">
               <a:ext uri="{FF2B5EF4-FFF2-40B4-BE49-F238E27FC236}">
-                <a16:creationId xmlns:a16="http://schemas.microsoft.com/office/drawing/2014/main" id="{6AB2D4AB-7AF5-4811-BFA7-ECE04BEEF85A}"/>
+                <a16:creationId xmlns:a16="http://schemas.microsoft.com/office/drawing/2014/main" id="{7613442E-CD00-4A38-9191-15633404FD68}"/>
               </a:ext>
             </a:extLst>
           </p:cNvPr>
@@ -6434,7 +6434,7 @@
           <p:cNvPr id="10" name="core-label-1">
             <a:extLst xmlns:a="http://schemas.openxmlformats.org/drawingml/2006/main">
               <a:ext uri="{FF2B5EF4-FFF2-40B4-BE49-F238E27FC236}">
-                <a16:creationId xmlns:a16="http://schemas.microsoft.com/office/drawing/2014/main" id="{1247B44F-6572-44A9-BD85-55B4B2170F37}"/>
+                <a16:creationId xmlns:a16="http://schemas.microsoft.com/office/drawing/2014/main" id="{59E1C776-03F9-4457-B4B1-FD6A1403301B}"/>
               </a:ext>
             </a:extLst>
           </p:cNvPr>
@@ -6492,7 +6492,7 @@
           <p:cNvPr id="11" name="core-body-1">
             <a:extLst xmlns:a="http://schemas.openxmlformats.org/drawingml/2006/main">
               <a:ext uri="{FF2B5EF4-FFF2-40B4-BE49-F238E27FC236}">
-                <a16:creationId xmlns:a16="http://schemas.microsoft.com/office/drawing/2014/main" id="{B3440619-FA07-461D-9186-70976EEAFF1E}"/>
+                <a16:creationId xmlns:a16="http://schemas.microsoft.com/office/drawing/2014/main" id="{11F64D0D-424E-4D31-B4BC-A246EE46A42F}"/>
               </a:ext>
             </a:extLst>
           </p:cNvPr>
@@ -6556,7 +6556,7 @@
           <p:cNvPr id="12" name="s3-takeaway-rule">
             <a:extLst xmlns:a="http://schemas.openxmlformats.org/drawingml/2006/main">
               <a:ext uri="{FF2B5EF4-FFF2-40B4-BE49-F238E27FC236}">
-                <a16:creationId xmlns:a16="http://schemas.microsoft.com/office/drawing/2014/main" id="{0B4279F8-5FF5-4C1F-80B4-25C742D084B4}"/>
+                <a16:creationId xmlns:a16="http://schemas.microsoft.com/office/drawing/2014/main" id="{DEDF8429-D68B-4197-9942-A3177F824102}"/>
               </a:ext>
             </a:extLst>
           </p:cNvPr>
@@ -6589,7 +6589,7 @@
           <p:cNvPr id="13" name="s3-takeaway">
             <a:extLst xmlns:a="http://schemas.openxmlformats.org/drawingml/2006/main">
               <a:ext uri="{FF2B5EF4-FFF2-40B4-BE49-F238E27FC236}">
-                <a16:creationId xmlns:a16="http://schemas.microsoft.com/office/drawing/2014/main" id="{CBA71891-51EB-4875-A80E-0B08E9F72CD3}"/>
+                <a16:creationId xmlns:a16="http://schemas.microsoft.com/office/drawing/2014/main" id="{9EB49410-6543-433C-924D-A2BBA50B31BE}"/>
               </a:ext>
             </a:extLst>
           </p:cNvPr>
@@ -6645,7 +6645,7 @@
     </p:spTree>
     <p:extLst>
       <p:ext uri="{BB962C8B-B14F-4D97-AF65-F5344CB8AC3E}">
-        <p14:creationId xmlns:p14="http://schemas.microsoft.com/office/powerpoint/2010/main" val="503803759"/>
+        <p14:creationId xmlns:p14="http://schemas.microsoft.com/office/powerpoint/2010/main" val="256575050"/>
       </p:ext>
     </p:extLst>
   </p:cSld>
@@ -6676,7 +6676,7 @@
           <p:cNvPr id="1" name="s4-rule">
             <a:extLst xmlns:a="http://schemas.openxmlformats.org/drawingml/2006/main">
               <a:ext uri="{FF2B5EF4-FFF2-40B4-BE49-F238E27FC236}">
-                <a16:creationId xmlns:a16="http://schemas.microsoft.com/office/drawing/2014/main" id="{402338A5-A09D-4A1F-A443-CB24841EE3ED}"/>
+                <a16:creationId xmlns:a16="http://schemas.microsoft.com/office/drawing/2014/main" id="{B680573E-3FF4-4671-9956-3267C04D4839}"/>
               </a:ext>
             </a:extLst>
           </p:cNvPr>
@@ -6709,7 +6709,7 @@
           <p:cNvPr id="2" name="s4-eyebrow">
             <a:extLst xmlns:a="http://schemas.openxmlformats.org/drawingml/2006/main">
               <a:ext uri="{FF2B5EF4-FFF2-40B4-BE49-F238E27FC236}">
-                <a16:creationId xmlns:a16="http://schemas.microsoft.com/office/drawing/2014/main" id="{019C6B27-7C1B-4F6D-A082-508E9A141ED1}"/>
+                <a16:creationId xmlns:a16="http://schemas.microsoft.com/office/drawing/2014/main" id="{9E8A72C6-A099-4E33-9127-4BC784264F92}"/>
               </a:ext>
             </a:extLst>
           </p:cNvPr>
@@ -6767,7 +6767,7 @@
           <p:cNvPr id="3" name="s4-title">
             <a:extLst xmlns:a="http://schemas.openxmlformats.org/drawingml/2006/main">
               <a:ext uri="{FF2B5EF4-FFF2-40B4-BE49-F238E27FC236}">
-                <a16:creationId xmlns:a16="http://schemas.microsoft.com/office/drawing/2014/main" id="{EA2425A0-2569-4C53-8687-2F7B65CC9200}"/>
+                <a16:creationId xmlns:a16="http://schemas.microsoft.com/office/drawing/2014/main" id="{785C37A5-B1C3-4B68-AECD-94B2073BA157}"/>
               </a:ext>
             </a:extLst>
           </p:cNvPr>
@@ -6825,7 +6825,7 @@
           <p:cNvPr id="4" name="s4-footer">
             <a:extLst xmlns:a="http://schemas.openxmlformats.org/drawingml/2006/main">
               <a:ext uri="{FF2B5EF4-FFF2-40B4-BE49-F238E27FC236}">
-                <a16:creationId xmlns:a16="http://schemas.microsoft.com/office/drawing/2014/main" id="{9F022D41-4AA7-4D70-A180-621E725EB5CA}"/>
+                <a16:creationId xmlns:a16="http://schemas.microsoft.com/office/drawing/2014/main" id="{07A9B9C6-A28E-4C28-9D9B-B499FDA6B287}"/>
               </a:ext>
             </a:extLst>
           </p:cNvPr>
@@ -6856,7 +6856,7 @@
           <p:cNvPr id="5" name="s4-identity">
             <a:extLst xmlns:a="http://schemas.openxmlformats.org/drawingml/2006/main">
               <a:ext uri="{FF2B5EF4-FFF2-40B4-BE49-F238E27FC236}">
-                <a16:creationId xmlns:a16="http://schemas.microsoft.com/office/drawing/2014/main" id="{8D3CC020-3EC2-4B16-AB81-0F626EC25977}"/>
+                <a16:creationId xmlns:a16="http://schemas.microsoft.com/office/drawing/2014/main" id="{8EDED039-181A-4E0B-9C3E-3F650E4F4BBD}"/>
               </a:ext>
             </a:extLst>
           </p:cNvPr>
@@ -6914,7 +6914,7 @@
           <p:cNvPr id="6" name="core-no-0">
             <a:extLst xmlns:a="http://schemas.openxmlformats.org/drawingml/2006/main">
               <a:ext uri="{FF2B5EF4-FFF2-40B4-BE49-F238E27FC236}">
-                <a16:creationId xmlns:a16="http://schemas.microsoft.com/office/drawing/2014/main" id="{8DF343E7-FE12-44C2-A30C-8C66FE17BCB8}"/>
+                <a16:creationId xmlns:a16="http://schemas.microsoft.com/office/drawing/2014/main" id="{D20F1BE6-4CDA-4467-A0FC-DDC4C1BE7230}"/>
               </a:ext>
             </a:extLst>
           </p:cNvPr>
@@ -6972,7 +6972,7 @@
           <p:cNvPr id="7" name="core-label-0">
             <a:extLst xmlns:a="http://schemas.openxmlformats.org/drawingml/2006/main">
               <a:ext uri="{FF2B5EF4-FFF2-40B4-BE49-F238E27FC236}">
-                <a16:creationId xmlns:a16="http://schemas.microsoft.com/office/drawing/2014/main" id="{EC3E2C0D-5D63-42A1-A894-C534A3DA2457}"/>
+                <a16:creationId xmlns:a16="http://schemas.microsoft.com/office/drawing/2014/main" id="{66802662-9841-4E24-B018-4D556858ED85}"/>
               </a:ext>
             </a:extLst>
           </p:cNvPr>
@@ -7030,7 +7030,7 @@
           <p:cNvPr id="8" name="core-body-0">
             <a:extLst xmlns:a="http://schemas.openxmlformats.org/drawingml/2006/main">
               <a:ext uri="{FF2B5EF4-FFF2-40B4-BE49-F238E27FC236}">
-                <a16:creationId xmlns:a16="http://schemas.microsoft.com/office/drawing/2014/main" id="{041F6BC9-96D9-491A-8B6E-51189C3EC8BA}"/>
+                <a16:creationId xmlns:a16="http://schemas.microsoft.com/office/drawing/2014/main" id="{54E9DE59-CA37-4C52-9811-F48E6676C5B4}"/>
               </a:ext>
             </a:extLst>
           </p:cNvPr>
@@ -7094,7 +7094,7 @@
           <p:cNvPr id="9" name="core-no-1">
             <a:extLst xmlns:a="http://schemas.openxmlformats.org/drawingml/2006/main">
               <a:ext uri="{FF2B5EF4-FFF2-40B4-BE49-F238E27FC236}">
-                <a16:creationId xmlns:a16="http://schemas.microsoft.com/office/drawing/2014/main" id="{92E99808-1990-4AD6-B9DA-9390202E8AB8}"/>
+                <a16:creationId xmlns:a16="http://schemas.microsoft.com/office/drawing/2014/main" id="{85802ED1-9AA1-4784-ACCA-30DB4FE8471E}"/>
               </a:ext>
             </a:extLst>
           </p:cNvPr>
@@ -7152,7 +7152,7 @@
           <p:cNvPr id="10" name="core-label-1">
             <a:extLst xmlns:a="http://schemas.openxmlformats.org/drawingml/2006/main">
               <a:ext uri="{FF2B5EF4-FFF2-40B4-BE49-F238E27FC236}">
-                <a16:creationId xmlns:a16="http://schemas.microsoft.com/office/drawing/2014/main" id="{40D0C35B-2D5F-4075-9A52-5CD9581B6008}"/>
+                <a16:creationId xmlns:a16="http://schemas.microsoft.com/office/drawing/2014/main" id="{A98414EB-31F4-4815-83AB-B5100521B130}"/>
               </a:ext>
             </a:extLst>
           </p:cNvPr>
@@ -7210,7 +7210,7 @@
           <p:cNvPr id="11" name="core-body-1">
             <a:extLst xmlns:a="http://schemas.openxmlformats.org/drawingml/2006/main">
               <a:ext uri="{FF2B5EF4-FFF2-40B4-BE49-F238E27FC236}">
-                <a16:creationId xmlns:a16="http://schemas.microsoft.com/office/drawing/2014/main" id="{97103242-2BEC-49A1-83B2-6FCCAA822D56}"/>
+                <a16:creationId xmlns:a16="http://schemas.microsoft.com/office/drawing/2014/main" id="{98695114-9484-49C9-BC02-82ED4475F2F8}"/>
               </a:ext>
             </a:extLst>
           </p:cNvPr>
@@ -7274,7 +7274,7 @@
           <p:cNvPr id="12" name="s4-takeaway-rule">
             <a:extLst xmlns:a="http://schemas.openxmlformats.org/drawingml/2006/main">
               <a:ext uri="{FF2B5EF4-FFF2-40B4-BE49-F238E27FC236}">
-                <a16:creationId xmlns:a16="http://schemas.microsoft.com/office/drawing/2014/main" id="{DC839DC5-DBF3-4486-AE0A-788631564C1E}"/>
+                <a16:creationId xmlns:a16="http://schemas.microsoft.com/office/drawing/2014/main" id="{4B45DA20-DCE8-4787-82A9-732DF3720669}"/>
               </a:ext>
             </a:extLst>
           </p:cNvPr>
@@ -7307,7 +7307,7 @@
           <p:cNvPr id="13" name="s4-takeaway">
             <a:extLst xmlns:a="http://schemas.openxmlformats.org/drawingml/2006/main">
               <a:ext uri="{FF2B5EF4-FFF2-40B4-BE49-F238E27FC236}">
-                <a16:creationId xmlns:a16="http://schemas.microsoft.com/office/drawing/2014/main" id="{FDB8E975-B5D4-45D3-B256-11AC566CA958}"/>
+                <a16:creationId xmlns:a16="http://schemas.microsoft.com/office/drawing/2014/main" id="{A34EDE1E-31D3-443F-8E01-B0C07A501E8B}"/>
               </a:ext>
             </a:extLst>
           </p:cNvPr>
@@ -7363,7 +7363,7 @@
     </p:spTree>
     <p:extLst>
       <p:ext uri="{BB962C8B-B14F-4D97-AF65-F5344CB8AC3E}">
-        <p14:creationId xmlns:p14="http://schemas.microsoft.com/office/powerpoint/2010/main" val="1842811645"/>
+        <p14:creationId xmlns:p14="http://schemas.microsoft.com/office/powerpoint/2010/main" val="1029392657"/>
       </p:ext>
     </p:extLst>
   </p:cSld>
@@ -7394,7 +7394,7 @@
           <p:cNvPr id="1" name="s5-rule">
             <a:extLst xmlns:a="http://schemas.openxmlformats.org/drawingml/2006/main">
               <a:ext uri="{FF2B5EF4-FFF2-40B4-BE49-F238E27FC236}">
-                <a16:creationId xmlns:a16="http://schemas.microsoft.com/office/drawing/2014/main" id="{263788F6-654D-4B73-AEE1-2CDC5170C214}"/>
+                <a16:creationId xmlns:a16="http://schemas.microsoft.com/office/drawing/2014/main" id="{7DD372EC-6238-4016-8A3F-52F6B9E39202}"/>
               </a:ext>
             </a:extLst>
           </p:cNvPr>
@@ -7427,7 +7427,7 @@
           <p:cNvPr id="2" name="s5-eyebrow">
             <a:extLst xmlns:a="http://schemas.openxmlformats.org/drawingml/2006/main">
               <a:ext uri="{FF2B5EF4-FFF2-40B4-BE49-F238E27FC236}">
-                <a16:creationId xmlns:a16="http://schemas.microsoft.com/office/drawing/2014/main" id="{7F761A86-8A60-4D4A-B9F8-53290FA65839}"/>
+                <a16:creationId xmlns:a16="http://schemas.microsoft.com/office/drawing/2014/main" id="{3A3A0256-2364-45B9-B75B-1B82FA7B25BB}"/>
               </a:ext>
             </a:extLst>
           </p:cNvPr>
@@ -7485,7 +7485,7 @@
           <p:cNvPr id="3" name="s5-title">
             <a:extLst xmlns:a="http://schemas.openxmlformats.org/drawingml/2006/main">
               <a:ext uri="{FF2B5EF4-FFF2-40B4-BE49-F238E27FC236}">
-                <a16:creationId xmlns:a16="http://schemas.microsoft.com/office/drawing/2014/main" id="{E731FB29-1A62-4730-A993-4114228614B4}"/>
+                <a16:creationId xmlns:a16="http://schemas.microsoft.com/office/drawing/2014/main" id="{1B429EAB-018A-44DF-9615-2708E8D5B3F7}"/>
               </a:ext>
             </a:extLst>
           </p:cNvPr>
@@ -7543,7 +7543,7 @@
           <p:cNvPr id="4" name="s5-footer">
             <a:extLst xmlns:a="http://schemas.openxmlformats.org/drawingml/2006/main">
               <a:ext uri="{FF2B5EF4-FFF2-40B4-BE49-F238E27FC236}">
-                <a16:creationId xmlns:a16="http://schemas.microsoft.com/office/drawing/2014/main" id="{47EAF6E7-B7E6-4E0C-A286-94B24C1DD4D9}"/>
+                <a16:creationId xmlns:a16="http://schemas.microsoft.com/office/drawing/2014/main" id="{D6ABBAF7-E801-4431-B52A-DD947C42D91F}"/>
               </a:ext>
             </a:extLst>
           </p:cNvPr>
@@ -7574,7 +7574,7 @@
           <p:cNvPr id="5" name="s5-identity">
             <a:extLst xmlns:a="http://schemas.openxmlformats.org/drawingml/2006/main">
               <a:ext uri="{FF2B5EF4-FFF2-40B4-BE49-F238E27FC236}">
-                <a16:creationId xmlns:a16="http://schemas.microsoft.com/office/drawing/2014/main" id="{244EE265-4084-41E3-864E-438B9872269D}"/>
+                <a16:creationId xmlns:a16="http://schemas.microsoft.com/office/drawing/2014/main" id="{07C9CEA5-491A-46DB-945A-1E3FD6DC7902}"/>
               </a:ext>
             </a:extLst>
           </p:cNvPr>
@@ -7632,7 +7632,7 @@
           <p:cNvPr id="6" name="core-no-0">
             <a:extLst xmlns:a="http://schemas.openxmlformats.org/drawingml/2006/main">
               <a:ext uri="{FF2B5EF4-FFF2-40B4-BE49-F238E27FC236}">
-                <a16:creationId xmlns:a16="http://schemas.microsoft.com/office/drawing/2014/main" id="{9F0DE45A-CA02-4F97-B9E0-C388AF911373}"/>
+                <a16:creationId xmlns:a16="http://schemas.microsoft.com/office/drawing/2014/main" id="{2E93F392-9CCC-4000-AA8F-930B4B23272D}"/>
               </a:ext>
             </a:extLst>
           </p:cNvPr>
@@ -7690,7 +7690,7 @@
           <p:cNvPr id="7" name="core-label-0">
             <a:extLst xmlns:a="http://schemas.openxmlformats.org/drawingml/2006/main">
               <a:ext uri="{FF2B5EF4-FFF2-40B4-BE49-F238E27FC236}">
-                <a16:creationId xmlns:a16="http://schemas.microsoft.com/office/drawing/2014/main" id="{DA670605-CA8D-429F-93EE-C862EC487E05}"/>
+                <a16:creationId xmlns:a16="http://schemas.microsoft.com/office/drawing/2014/main" id="{197ABD04-E7F8-403F-ACAA-0C8C40C0132D}"/>
               </a:ext>
             </a:extLst>
           </p:cNvPr>
@@ -7748,7 +7748,7 @@
           <p:cNvPr id="8" name="core-body-0">
             <a:extLst xmlns:a="http://schemas.openxmlformats.org/drawingml/2006/main">
               <a:ext uri="{FF2B5EF4-FFF2-40B4-BE49-F238E27FC236}">
-                <a16:creationId xmlns:a16="http://schemas.microsoft.com/office/drawing/2014/main" id="{32104FD9-E79A-429A-BFD0-4E091BBF2C93}"/>
+                <a16:creationId xmlns:a16="http://schemas.microsoft.com/office/drawing/2014/main" id="{2612F0C5-01E2-42CE-8F70-5DF732D40557}"/>
               </a:ext>
             </a:extLst>
           </p:cNvPr>
@@ -7812,7 +7812,7 @@
           <p:cNvPr id="9" name="s5-takeaway-rule">
             <a:extLst xmlns:a="http://schemas.openxmlformats.org/drawingml/2006/main">
               <a:ext uri="{FF2B5EF4-FFF2-40B4-BE49-F238E27FC236}">
-                <a16:creationId xmlns:a16="http://schemas.microsoft.com/office/drawing/2014/main" id="{093B4BFE-ADD8-4938-882D-958048382DF8}"/>
+                <a16:creationId xmlns:a16="http://schemas.microsoft.com/office/drawing/2014/main" id="{2CAF1A9D-696E-49BF-8A8E-9975F024F58E}"/>
               </a:ext>
             </a:extLst>
           </p:cNvPr>
@@ -7845,7 +7845,7 @@
           <p:cNvPr id="10" name="s5-takeaway">
             <a:extLst xmlns:a="http://schemas.openxmlformats.org/drawingml/2006/main">
               <a:ext uri="{FF2B5EF4-FFF2-40B4-BE49-F238E27FC236}">
-                <a16:creationId xmlns:a16="http://schemas.microsoft.com/office/drawing/2014/main" id="{7DA354F0-4CFD-4013-95F3-207FAE2DCCFD}"/>
+                <a16:creationId xmlns:a16="http://schemas.microsoft.com/office/drawing/2014/main" id="{5B2A5557-921F-4895-8026-D8DF011172D9}"/>
               </a:ext>
             </a:extLst>
           </p:cNvPr>
@@ -7901,7 +7901,7 @@
     </p:spTree>
     <p:extLst>
       <p:ext uri="{BB962C8B-B14F-4D97-AF65-F5344CB8AC3E}">
-        <p14:creationId xmlns:p14="http://schemas.microsoft.com/office/powerpoint/2010/main" val="46226017"/>
+        <p14:creationId xmlns:p14="http://schemas.microsoft.com/office/powerpoint/2010/main" val="26036054"/>
       </p:ext>
     </p:extLst>
   </p:cSld>
@@ -7932,7 +7932,7 @@
           <p:cNvPr id="1" name="s6-rule">
             <a:extLst xmlns:a="http://schemas.openxmlformats.org/drawingml/2006/main">
               <a:ext uri="{FF2B5EF4-FFF2-40B4-BE49-F238E27FC236}">
-                <a16:creationId xmlns:a16="http://schemas.microsoft.com/office/drawing/2014/main" id="{43487A6A-2A45-4AA5-9984-584F9D22E6BA}"/>
+                <a16:creationId xmlns:a16="http://schemas.microsoft.com/office/drawing/2014/main" id="{535C2E75-70B7-4297-ABF0-712AACF58B5A}"/>
               </a:ext>
             </a:extLst>
           </p:cNvPr>
@@ -7965,7 +7965,7 @@
           <p:cNvPr id="2" name="s6-eyebrow">
             <a:extLst xmlns:a="http://schemas.openxmlformats.org/drawingml/2006/main">
               <a:ext uri="{FF2B5EF4-FFF2-40B4-BE49-F238E27FC236}">
-                <a16:creationId xmlns:a16="http://schemas.microsoft.com/office/drawing/2014/main" id="{73F43377-5806-42F4-B011-ABA9EA9A9003}"/>
+                <a16:creationId xmlns:a16="http://schemas.microsoft.com/office/drawing/2014/main" id="{4798D6D8-34E0-4905-8D28-FC36D6E0960F}"/>
               </a:ext>
             </a:extLst>
           </p:cNvPr>
@@ -8023,7 +8023,7 @@
           <p:cNvPr id="3" name="s6-title">
             <a:extLst xmlns:a="http://schemas.openxmlformats.org/drawingml/2006/main">
               <a:ext uri="{FF2B5EF4-FFF2-40B4-BE49-F238E27FC236}">
-                <a16:creationId xmlns:a16="http://schemas.microsoft.com/office/drawing/2014/main" id="{E51FA957-DA54-402A-BA12-A034D6D74920}"/>
+                <a16:creationId xmlns:a16="http://schemas.microsoft.com/office/drawing/2014/main" id="{B0AB1B69-6FD1-4093-8BB8-79088899BE31}"/>
               </a:ext>
             </a:extLst>
           </p:cNvPr>
@@ -8081,7 +8081,7 @@
           <p:cNvPr id="4" name="s6-footer">
             <a:extLst xmlns:a="http://schemas.openxmlformats.org/drawingml/2006/main">
               <a:ext uri="{FF2B5EF4-FFF2-40B4-BE49-F238E27FC236}">
-                <a16:creationId xmlns:a16="http://schemas.microsoft.com/office/drawing/2014/main" id="{9B8134DE-427B-4956-A949-683A8A32A9FA}"/>
+                <a16:creationId xmlns:a16="http://schemas.microsoft.com/office/drawing/2014/main" id="{47AFD313-4F20-4F36-9F7B-87F856ABF719}"/>
               </a:ext>
             </a:extLst>
           </p:cNvPr>
@@ -8112,7 +8112,7 @@
           <p:cNvPr id="5" name="s6-identity">
             <a:extLst xmlns:a="http://schemas.openxmlformats.org/drawingml/2006/main">
               <a:ext uri="{FF2B5EF4-FFF2-40B4-BE49-F238E27FC236}">
-                <a16:creationId xmlns:a16="http://schemas.microsoft.com/office/drawing/2014/main" id="{2F82A1DC-284F-4E17-8120-7BA6B74DE570}"/>
+                <a16:creationId xmlns:a16="http://schemas.microsoft.com/office/drawing/2014/main" id="{BCE5FF79-EFA6-4095-BB8C-7F0486A1BC3B}"/>
               </a:ext>
             </a:extLst>
           </p:cNvPr>
@@ -8170,7 +8170,7 @@
           <p:cNvPr id="6" name="core-no-0">
             <a:extLst xmlns:a="http://schemas.openxmlformats.org/drawingml/2006/main">
               <a:ext uri="{FF2B5EF4-FFF2-40B4-BE49-F238E27FC236}">
-                <a16:creationId xmlns:a16="http://schemas.microsoft.com/office/drawing/2014/main" id="{77046D51-FF14-4583-8C57-C7DA8A03C6AA}"/>
+                <a16:creationId xmlns:a16="http://schemas.microsoft.com/office/drawing/2014/main" id="{696A2987-A022-4741-9363-21FE342CE838}"/>
               </a:ext>
             </a:extLst>
           </p:cNvPr>
@@ -8228,7 +8228,7 @@
           <p:cNvPr id="7" name="core-label-0">
             <a:extLst xmlns:a="http://schemas.openxmlformats.org/drawingml/2006/main">
               <a:ext uri="{FF2B5EF4-FFF2-40B4-BE49-F238E27FC236}">
-                <a16:creationId xmlns:a16="http://schemas.microsoft.com/office/drawing/2014/main" id="{8B373034-9CB3-4A51-9D42-308AA180DCE4}"/>
+                <a16:creationId xmlns:a16="http://schemas.microsoft.com/office/drawing/2014/main" id="{9767F014-F53A-45E1-AD70-463A8A211E5C}"/>
               </a:ext>
             </a:extLst>
           </p:cNvPr>
@@ -8286,7 +8286,7 @@
           <p:cNvPr id="8" name="core-body-0">
             <a:extLst xmlns:a="http://schemas.openxmlformats.org/drawingml/2006/main">
               <a:ext uri="{FF2B5EF4-FFF2-40B4-BE49-F238E27FC236}">
-                <a16:creationId xmlns:a16="http://schemas.microsoft.com/office/drawing/2014/main" id="{224D7D66-EC89-470B-9D55-25DC39A34008}"/>
+                <a16:creationId xmlns:a16="http://schemas.microsoft.com/office/drawing/2014/main" id="{89E82B57-3D2F-47E2-B9CE-42780F544023}"/>
               </a:ext>
             </a:extLst>
           </p:cNvPr>
@@ -8350,7 +8350,7 @@
           <p:cNvPr id="9" name="s6-takeaway-rule">
             <a:extLst xmlns:a="http://schemas.openxmlformats.org/drawingml/2006/main">
               <a:ext uri="{FF2B5EF4-FFF2-40B4-BE49-F238E27FC236}">
-                <a16:creationId xmlns:a16="http://schemas.microsoft.com/office/drawing/2014/main" id="{E283020B-972B-4750-BD34-354E1C19EE83}"/>
+                <a16:creationId xmlns:a16="http://schemas.microsoft.com/office/drawing/2014/main" id="{1B9EDE16-D598-4F07-852D-206241426E7C}"/>
               </a:ext>
             </a:extLst>
           </p:cNvPr>
@@ -8383,7 +8383,7 @@
           <p:cNvPr id="10" name="s6-takeaway">
             <a:extLst xmlns:a="http://schemas.openxmlformats.org/drawingml/2006/main">
               <a:ext uri="{FF2B5EF4-FFF2-40B4-BE49-F238E27FC236}">
-                <a16:creationId xmlns:a16="http://schemas.microsoft.com/office/drawing/2014/main" id="{CA95E723-7E85-4C87-81E8-BF233C63C93E}"/>
+                <a16:creationId xmlns:a16="http://schemas.microsoft.com/office/drawing/2014/main" id="{F860E51E-84EB-47A6-B184-7817BBF4A2D4}"/>
               </a:ext>
             </a:extLst>
           </p:cNvPr>
@@ -8439,7 +8439,7 @@
     </p:spTree>
     <p:extLst>
       <p:ext uri="{BB962C8B-B14F-4D97-AF65-F5344CB8AC3E}">
-        <p14:creationId xmlns:p14="http://schemas.microsoft.com/office/powerpoint/2010/main" val="1298974610"/>
+        <p14:creationId xmlns:p14="http://schemas.microsoft.com/office/powerpoint/2010/main" val="1341067477"/>
       </p:ext>
     </p:extLst>
   </p:cSld>
@@ -8470,7 +8470,7 @@
           <p:cNvPr id="1" name="s7-rule">
             <a:extLst xmlns:a="http://schemas.openxmlformats.org/drawingml/2006/main">
               <a:ext uri="{FF2B5EF4-FFF2-40B4-BE49-F238E27FC236}">
-                <a16:creationId xmlns:a16="http://schemas.microsoft.com/office/drawing/2014/main" id="{7DAFD1B8-274A-440F-86E5-24C57C48B4EA}"/>
+                <a16:creationId xmlns:a16="http://schemas.microsoft.com/office/drawing/2014/main" id="{D236B25B-F18A-4AC0-A92D-9FF38BFE2541}"/>
               </a:ext>
             </a:extLst>
           </p:cNvPr>
@@ -8503,7 +8503,7 @@
           <p:cNvPr id="2" name="s7-eyebrow">
             <a:extLst xmlns:a="http://schemas.openxmlformats.org/drawingml/2006/main">
               <a:ext uri="{FF2B5EF4-FFF2-40B4-BE49-F238E27FC236}">
-                <a16:creationId xmlns:a16="http://schemas.microsoft.com/office/drawing/2014/main" id="{FE4D602D-6C8B-4C8E-BC6E-94DAFCB08395}"/>
+                <a16:creationId xmlns:a16="http://schemas.microsoft.com/office/drawing/2014/main" id="{BA968932-05EA-4749-84AF-B5C104A5B6ED}"/>
               </a:ext>
             </a:extLst>
           </p:cNvPr>
@@ -8561,7 +8561,7 @@
           <p:cNvPr id="3" name="s7-title">
             <a:extLst xmlns:a="http://schemas.openxmlformats.org/drawingml/2006/main">
               <a:ext uri="{FF2B5EF4-FFF2-40B4-BE49-F238E27FC236}">
-                <a16:creationId xmlns:a16="http://schemas.microsoft.com/office/drawing/2014/main" id="{33067A6F-2D7C-40B8-9BBA-BE7593E07986}"/>
+                <a16:creationId xmlns:a16="http://schemas.microsoft.com/office/drawing/2014/main" id="{11325DAF-AA0A-4B81-A085-DE10BAB90B4B}"/>
               </a:ext>
             </a:extLst>
           </p:cNvPr>
@@ -8619,7 +8619,7 @@
           <p:cNvPr id="4" name="s7-footer">
             <a:extLst xmlns:a="http://schemas.openxmlformats.org/drawingml/2006/main">
               <a:ext uri="{FF2B5EF4-FFF2-40B4-BE49-F238E27FC236}">
-                <a16:creationId xmlns:a16="http://schemas.microsoft.com/office/drawing/2014/main" id="{E38E5596-A45F-4E87-975E-F0B3D486851E}"/>
+                <a16:creationId xmlns:a16="http://schemas.microsoft.com/office/drawing/2014/main" id="{D2A24E39-0C29-415E-A54A-8BC33DDA2397}"/>
               </a:ext>
             </a:extLst>
           </p:cNvPr>
@@ -8650,7 +8650,7 @@
           <p:cNvPr id="5" name="s7-identity">
             <a:extLst xmlns:a="http://schemas.openxmlformats.org/drawingml/2006/main">
               <a:ext uri="{FF2B5EF4-FFF2-40B4-BE49-F238E27FC236}">
-                <a16:creationId xmlns:a16="http://schemas.microsoft.com/office/drawing/2014/main" id="{2680DD7B-B8FE-440E-ABBF-772BACA9039E}"/>
+                <a16:creationId xmlns:a16="http://schemas.microsoft.com/office/drawing/2014/main" id="{18B74199-9718-4CE3-9B09-24AFE7764073}"/>
               </a:ext>
             </a:extLst>
           </p:cNvPr>
@@ -8708,7 +8708,7 @@
           <p:cNvPr id="6" name="core-no-0">
             <a:extLst xmlns:a="http://schemas.openxmlformats.org/drawingml/2006/main">
               <a:ext uri="{FF2B5EF4-FFF2-40B4-BE49-F238E27FC236}">
-                <a16:creationId xmlns:a16="http://schemas.microsoft.com/office/drawing/2014/main" id="{D67A9383-5205-495D-AC1B-11CFCC4B6AD8}"/>
+                <a16:creationId xmlns:a16="http://schemas.microsoft.com/office/drawing/2014/main" id="{C05B8A29-2560-4E5F-8564-D34BA5BCA38E}"/>
               </a:ext>
             </a:extLst>
           </p:cNvPr>
@@ -8766,7 +8766,7 @@
           <p:cNvPr id="7" name="core-label-0">
             <a:extLst xmlns:a="http://schemas.openxmlformats.org/drawingml/2006/main">
               <a:ext uri="{FF2B5EF4-FFF2-40B4-BE49-F238E27FC236}">
-                <a16:creationId xmlns:a16="http://schemas.microsoft.com/office/drawing/2014/main" id="{70A73789-B9B1-4BCA-8CD4-F1A9069C4835}"/>
+                <a16:creationId xmlns:a16="http://schemas.microsoft.com/office/drawing/2014/main" id="{6A4508C2-33CF-41B3-9875-5DF125DE497E}"/>
               </a:ext>
             </a:extLst>
           </p:cNvPr>
@@ -8824,7 +8824,7 @@
           <p:cNvPr id="8" name="core-body-0">
             <a:extLst xmlns:a="http://schemas.openxmlformats.org/drawingml/2006/main">
               <a:ext uri="{FF2B5EF4-FFF2-40B4-BE49-F238E27FC236}">
-                <a16:creationId xmlns:a16="http://schemas.microsoft.com/office/drawing/2014/main" id="{7C0C8297-1F66-4041-A5A8-2F8D050EA5DD}"/>
+                <a16:creationId xmlns:a16="http://schemas.microsoft.com/office/drawing/2014/main" id="{AFA18E9B-D5AF-43CE-BE8E-BE529C12810A}"/>
               </a:ext>
             </a:extLst>
           </p:cNvPr>
@@ -8888,7 +8888,7 @@
           <p:cNvPr id="9" name="core-no-1">
             <a:extLst xmlns:a="http://schemas.openxmlformats.org/drawingml/2006/main">
               <a:ext uri="{FF2B5EF4-FFF2-40B4-BE49-F238E27FC236}">
-                <a16:creationId xmlns:a16="http://schemas.microsoft.com/office/drawing/2014/main" id="{47F03373-0927-4899-B25A-2D700481AF91}"/>
+                <a16:creationId xmlns:a16="http://schemas.microsoft.com/office/drawing/2014/main" id="{6AA4E231-8C0B-4ED2-B034-3F46C095804A}"/>
               </a:ext>
             </a:extLst>
           </p:cNvPr>
@@ -8946,7 +8946,7 @@
           <p:cNvPr id="10" name="core-body-1">
             <a:extLst xmlns:a="http://schemas.openxmlformats.org/drawingml/2006/main">
               <a:ext uri="{FF2B5EF4-FFF2-40B4-BE49-F238E27FC236}">
-                <a16:creationId xmlns:a16="http://schemas.microsoft.com/office/drawing/2014/main" id="{34E30355-A291-4BC5-833D-825B52E8156C}"/>
+                <a16:creationId xmlns:a16="http://schemas.microsoft.com/office/drawing/2014/main" id="{0B04B091-20F9-478B-A6DB-B51DCC844D4C}"/>
               </a:ext>
             </a:extLst>
           </p:cNvPr>
@@ -9010,7 +9010,7 @@
           <p:cNvPr id="11" name="s7-takeaway-rule">
             <a:extLst xmlns:a="http://schemas.openxmlformats.org/drawingml/2006/main">
               <a:ext uri="{FF2B5EF4-FFF2-40B4-BE49-F238E27FC236}">
-                <a16:creationId xmlns:a16="http://schemas.microsoft.com/office/drawing/2014/main" id="{6ABA9A3C-D468-4051-A810-9DEE62FB486F}"/>
+                <a16:creationId xmlns:a16="http://schemas.microsoft.com/office/drawing/2014/main" id="{9987E484-D1C6-4CCA-8604-97D9B6454475}"/>
               </a:ext>
             </a:extLst>
           </p:cNvPr>
@@ -9043,7 +9043,7 @@
           <p:cNvPr id="12" name="s7-takeaway">
             <a:extLst xmlns:a="http://schemas.openxmlformats.org/drawingml/2006/main">
               <a:ext uri="{FF2B5EF4-FFF2-40B4-BE49-F238E27FC236}">
-                <a16:creationId xmlns:a16="http://schemas.microsoft.com/office/drawing/2014/main" id="{BD33B84C-AF1E-4A1E-8599-B98E1AA0B829}"/>
+                <a16:creationId xmlns:a16="http://schemas.microsoft.com/office/drawing/2014/main" id="{8BAF4FCE-FA5B-44DA-9243-70DC2E15BE08}"/>
               </a:ext>
             </a:extLst>
           </p:cNvPr>
@@ -9099,7 +9099,7 @@
     </p:spTree>
     <p:extLst>
       <p:ext uri="{BB962C8B-B14F-4D97-AF65-F5344CB8AC3E}">
-        <p14:creationId xmlns:p14="http://schemas.microsoft.com/office/powerpoint/2010/main" val="1459684632"/>
+        <p14:creationId xmlns:p14="http://schemas.microsoft.com/office/powerpoint/2010/main" val="1282087939"/>
       </p:ext>
     </p:extLst>
   </p:cSld>
@@ -9130,7 +9130,7 @@
           <p:cNvPr id="1" name="s8-rule">
             <a:extLst xmlns:a="http://schemas.openxmlformats.org/drawingml/2006/main">
               <a:ext uri="{FF2B5EF4-FFF2-40B4-BE49-F238E27FC236}">
-                <a16:creationId xmlns:a16="http://schemas.microsoft.com/office/drawing/2014/main" id="{0A19EF07-C7B4-42D7-BB91-D66A1BC8CF56}"/>
+                <a16:creationId xmlns:a16="http://schemas.microsoft.com/office/drawing/2014/main" id="{9715DF07-34EB-4111-B556-CBB22AC6260C}"/>
               </a:ext>
             </a:extLst>
           </p:cNvPr>
@@ -9163,7 +9163,7 @@
           <p:cNvPr id="2" name="s8-eyebrow">
             <a:extLst xmlns:a="http://schemas.openxmlformats.org/drawingml/2006/main">
               <a:ext uri="{FF2B5EF4-FFF2-40B4-BE49-F238E27FC236}">
-                <a16:creationId xmlns:a16="http://schemas.microsoft.com/office/drawing/2014/main" id="{6F6BE067-F1AB-4379-94B8-5C3F0D2E6232}"/>
+                <a16:creationId xmlns:a16="http://schemas.microsoft.com/office/drawing/2014/main" id="{8ABB316E-0300-4DDD-B75E-24F98A34511C}"/>
               </a:ext>
             </a:extLst>
           </p:cNvPr>
@@ -9221,7 +9221,7 @@
           <p:cNvPr id="3" name="s8-title">
             <a:extLst xmlns:a="http://schemas.openxmlformats.org/drawingml/2006/main">
               <a:ext uri="{FF2B5EF4-FFF2-40B4-BE49-F238E27FC236}">
-                <a16:creationId xmlns:a16="http://schemas.microsoft.com/office/drawing/2014/main" id="{6853E306-10C7-4F3A-8254-A04976AD4989}"/>
+                <a16:creationId xmlns:a16="http://schemas.microsoft.com/office/drawing/2014/main" id="{7FB1A3B4-060C-4008-8A0B-E104A68E430F}"/>
               </a:ext>
             </a:extLst>
           </p:cNvPr>
@@ -9279,7 +9279,7 @@
           <p:cNvPr id="4" name="s8-footer">
             <a:extLst xmlns:a="http://schemas.openxmlformats.org/drawingml/2006/main">
               <a:ext uri="{FF2B5EF4-FFF2-40B4-BE49-F238E27FC236}">
-                <a16:creationId xmlns:a16="http://schemas.microsoft.com/office/drawing/2014/main" id="{12D72A65-48AA-418C-9D32-4A203E90DCD5}"/>
+                <a16:creationId xmlns:a16="http://schemas.microsoft.com/office/drawing/2014/main" id="{6AA03184-5921-433B-9AB8-91E13C92D51E}"/>
               </a:ext>
             </a:extLst>
           </p:cNvPr>
@@ -9310,7 +9310,7 @@
           <p:cNvPr id="5" name="s8-identity">
             <a:extLst xmlns:a="http://schemas.openxmlformats.org/drawingml/2006/main">
               <a:ext uri="{FF2B5EF4-FFF2-40B4-BE49-F238E27FC236}">
-                <a16:creationId xmlns:a16="http://schemas.microsoft.com/office/drawing/2014/main" id="{1975602B-234A-4B3F-ADFB-9AEB1523360A}"/>
+                <a16:creationId xmlns:a16="http://schemas.microsoft.com/office/drawing/2014/main" id="{F7A0642B-A3A6-4131-B59C-DDD134F57429}"/>
               </a:ext>
             </a:extLst>
           </p:cNvPr>
@@ -9368,7 +9368,7 @@
           <p:cNvPr id="6" name="core-no-0">
             <a:extLst xmlns:a="http://schemas.openxmlformats.org/drawingml/2006/main">
               <a:ext uri="{FF2B5EF4-FFF2-40B4-BE49-F238E27FC236}">
-                <a16:creationId xmlns:a16="http://schemas.microsoft.com/office/drawing/2014/main" id="{02702D8D-0254-4673-86D2-6A8CA25933B4}"/>
+                <a16:creationId xmlns:a16="http://schemas.microsoft.com/office/drawing/2014/main" id="{1518A85F-006E-4CB0-81B1-A80333F12EF3}"/>
               </a:ext>
             </a:extLst>
           </p:cNvPr>
@@ -9426,7 +9426,7 @@
           <p:cNvPr id="7" name="core-label-0">
             <a:extLst xmlns:a="http://schemas.openxmlformats.org/drawingml/2006/main">
               <a:ext uri="{FF2B5EF4-FFF2-40B4-BE49-F238E27FC236}">
-                <a16:creationId xmlns:a16="http://schemas.microsoft.com/office/drawing/2014/main" id="{5EDDED66-3AC6-47AB-B83A-FA57D38AEC71}"/>
+                <a16:creationId xmlns:a16="http://schemas.microsoft.com/office/drawing/2014/main" id="{55F19E7C-CB8D-45E1-ACC5-6CC0642071CD}"/>
               </a:ext>
             </a:extLst>
           </p:cNvPr>
@@ -9484,7 +9484,7 @@
           <p:cNvPr id="8" name="core-body-0">
             <a:extLst xmlns:a="http://schemas.openxmlformats.org/drawingml/2006/main">
               <a:ext uri="{FF2B5EF4-FFF2-40B4-BE49-F238E27FC236}">
-                <a16:creationId xmlns:a16="http://schemas.microsoft.com/office/drawing/2014/main" id="{2A266319-67E5-4804-A8DA-59F935C4C05D}"/>
+                <a16:creationId xmlns:a16="http://schemas.microsoft.com/office/drawing/2014/main" id="{9F0F63DC-973B-447C-AF4C-26E7EEA8B1D4}"/>
               </a:ext>
             </a:extLst>
           </p:cNvPr>
@@ -9548,7 +9548,7 @@
           <p:cNvPr id="9" name="s8-takeaway-rule">
             <a:extLst xmlns:a="http://schemas.openxmlformats.org/drawingml/2006/main">
               <a:ext uri="{FF2B5EF4-FFF2-40B4-BE49-F238E27FC236}">
-                <a16:creationId xmlns:a16="http://schemas.microsoft.com/office/drawing/2014/main" id="{208E3861-3813-4487-90D3-7A22DF169A0C}"/>
+                <a16:creationId xmlns:a16="http://schemas.microsoft.com/office/drawing/2014/main" id="{83FB12DB-C16A-4B69-BB05-0241D04CB46A}"/>
               </a:ext>
             </a:extLst>
           </p:cNvPr>
@@ -9581,7 +9581,7 @@
           <p:cNvPr id="10" name="s8-takeaway">
             <a:extLst xmlns:a="http://schemas.openxmlformats.org/drawingml/2006/main">
               <a:ext uri="{FF2B5EF4-FFF2-40B4-BE49-F238E27FC236}">
-                <a16:creationId xmlns:a16="http://schemas.microsoft.com/office/drawing/2014/main" id="{66004D93-520A-49E7-A74B-EB3446E37D4B}"/>
+                <a16:creationId xmlns:a16="http://schemas.microsoft.com/office/drawing/2014/main" id="{A01104A0-B558-4F11-83EC-7C4BD9BA1260}"/>
               </a:ext>
             </a:extLst>
           </p:cNvPr>
@@ -9637,7 +9637,7 @@
     </p:spTree>
     <p:extLst>
       <p:ext uri="{BB962C8B-B14F-4D97-AF65-F5344CB8AC3E}">
-        <p14:creationId xmlns:p14="http://schemas.microsoft.com/office/powerpoint/2010/main" val="668492839"/>
+        <p14:creationId xmlns:p14="http://schemas.microsoft.com/office/powerpoint/2010/main" val="122919451"/>
       </p:ext>
     </p:extLst>
   </p:cSld>
@@ -9668,7 +9668,7 @@
           <p:cNvPr id="1" name="s9-rule">
             <a:extLst xmlns:a="http://schemas.openxmlformats.org/drawingml/2006/main">
               <a:ext uri="{FF2B5EF4-FFF2-40B4-BE49-F238E27FC236}">
-                <a16:creationId xmlns:a16="http://schemas.microsoft.com/office/drawing/2014/main" id="{DC9C6239-FFD4-4530-B76C-6BB57140009C}"/>
+                <a16:creationId xmlns:a16="http://schemas.microsoft.com/office/drawing/2014/main" id="{0052AA46-9C4C-4E04-B576-D5E4211F2E09}"/>
               </a:ext>
             </a:extLst>
           </p:cNvPr>
@@ -9701,7 +9701,7 @@
           <p:cNvPr id="2" name="s9-eyebrow">
             <a:extLst xmlns:a="http://schemas.openxmlformats.org/drawingml/2006/main">
               <a:ext uri="{FF2B5EF4-FFF2-40B4-BE49-F238E27FC236}">
-                <a16:creationId xmlns:a16="http://schemas.microsoft.com/office/drawing/2014/main" id="{4C5AF7E8-4E7D-4565-9BC6-D8E3A370E482}"/>
+                <a16:creationId xmlns:a16="http://schemas.microsoft.com/office/drawing/2014/main" id="{5329BE35-4C8E-4B32-A35E-40C3FF13939C}"/>
               </a:ext>
             </a:extLst>
           </p:cNvPr>
@@ -9759,7 +9759,7 @@
           <p:cNvPr id="3" name="s9-title">
             <a:extLst xmlns:a="http://schemas.openxmlformats.org/drawingml/2006/main">
               <a:ext uri="{FF2B5EF4-FFF2-40B4-BE49-F238E27FC236}">
-                <a16:creationId xmlns:a16="http://schemas.microsoft.com/office/drawing/2014/main" id="{6ECC642F-4A1E-474B-96A7-C10F4EB35FC7}"/>
+                <a16:creationId xmlns:a16="http://schemas.microsoft.com/office/drawing/2014/main" id="{4E595687-AB58-4FAC-B80C-20F84EB822ED}"/>
               </a:ext>
             </a:extLst>
           </p:cNvPr>
@@ -9817,7 +9817,7 @@
           <p:cNvPr id="4" name="s9-footer">
             <a:extLst xmlns:a="http://schemas.openxmlformats.org/drawingml/2006/main">
               <a:ext uri="{FF2B5EF4-FFF2-40B4-BE49-F238E27FC236}">
-                <a16:creationId xmlns:a16="http://schemas.microsoft.com/office/drawing/2014/main" id="{E99337B7-EFAC-4C2A-BFB1-AFC510D6E524}"/>
+                <a16:creationId xmlns:a16="http://schemas.microsoft.com/office/drawing/2014/main" id="{82C3C364-6D75-414A-92BF-1C836514A652}"/>
               </a:ext>
             </a:extLst>
           </p:cNvPr>
@@ -9848,7 +9848,7 @@
           <p:cNvPr id="5" name="s9-identity">
             <a:extLst xmlns:a="http://schemas.openxmlformats.org/drawingml/2006/main">
               <a:ext uri="{FF2B5EF4-FFF2-40B4-BE49-F238E27FC236}">
-                <a16:creationId xmlns:a16="http://schemas.microsoft.com/office/drawing/2014/main" id="{4AFEECE9-06C7-427B-8C9D-9CB162021CD6}"/>
+                <a16:creationId xmlns:a16="http://schemas.microsoft.com/office/drawing/2014/main" id="{96251314-E8CD-4377-BFBF-66C66830703E}"/>
               </a:ext>
             </a:extLst>
           </p:cNvPr>
@@ -9906,7 +9906,7 @@
           <p:cNvPr id="6" name="core-no-0">
             <a:extLst xmlns:a="http://schemas.openxmlformats.org/drawingml/2006/main">
               <a:ext uri="{FF2B5EF4-FFF2-40B4-BE49-F238E27FC236}">
-                <a16:creationId xmlns:a16="http://schemas.microsoft.com/office/drawing/2014/main" id="{58E64934-7D03-4240-9DC4-D1B452255883}"/>
+                <a16:creationId xmlns:a16="http://schemas.microsoft.com/office/drawing/2014/main" id="{D0B45620-CD36-42A9-8671-7C0F15B04DD7}"/>
               </a:ext>
             </a:extLst>
           </p:cNvPr>
@@ -9964,7 +9964,7 @@
           <p:cNvPr id="7" name="core-label-0">
             <a:extLst xmlns:a="http://schemas.openxmlformats.org/drawingml/2006/main">
               <a:ext uri="{FF2B5EF4-FFF2-40B4-BE49-F238E27FC236}">
-                <a16:creationId xmlns:a16="http://schemas.microsoft.com/office/drawing/2014/main" id="{5E038E2E-F366-452A-A98C-3A9704A73CA8}"/>
+                <a16:creationId xmlns:a16="http://schemas.microsoft.com/office/drawing/2014/main" id="{9FDD0ED5-207A-4165-A8A5-04E6D2477368}"/>
               </a:ext>
             </a:extLst>
           </p:cNvPr>
@@ -10022,7 +10022,7 @@
           <p:cNvPr id="8" name="core-body-0">
             <a:extLst xmlns:a="http://schemas.openxmlformats.org/drawingml/2006/main">
               <a:ext uri="{FF2B5EF4-FFF2-40B4-BE49-F238E27FC236}">
-                <a16:creationId xmlns:a16="http://schemas.microsoft.com/office/drawing/2014/main" id="{A7D2D375-EE81-45E9-B786-3203DDF058AE}"/>
+                <a16:creationId xmlns:a16="http://schemas.microsoft.com/office/drawing/2014/main" id="{B293082D-F9F5-43E9-94C7-CAFBBB64B559}"/>
               </a:ext>
             </a:extLst>
           </p:cNvPr>
@@ -10086,7 +10086,7 @@
           <p:cNvPr id="9" name="core-no-1">
             <a:extLst xmlns:a="http://schemas.openxmlformats.org/drawingml/2006/main">
               <a:ext uri="{FF2B5EF4-FFF2-40B4-BE49-F238E27FC236}">
-                <a16:creationId xmlns:a16="http://schemas.microsoft.com/office/drawing/2014/main" id="{3573E417-7A65-4ED2-91BE-70A458B618D2}"/>
+                <a16:creationId xmlns:a16="http://schemas.microsoft.com/office/drawing/2014/main" id="{BEF7F6EE-261D-4B9E-A820-5B8E6393278A}"/>
               </a:ext>
             </a:extLst>
           </p:cNvPr>
@@ -10144,7 +10144,7 @@
           <p:cNvPr id="10" name="core-body-1">
             <a:extLst xmlns:a="http://schemas.openxmlformats.org/drawingml/2006/main">
               <a:ext uri="{FF2B5EF4-FFF2-40B4-BE49-F238E27FC236}">
-                <a16:creationId xmlns:a16="http://schemas.microsoft.com/office/drawing/2014/main" id="{6395DAF6-3F55-4BF0-AABA-02554207802C}"/>
+                <a16:creationId xmlns:a16="http://schemas.microsoft.com/office/drawing/2014/main" id="{7263741C-25FE-49A8-8FD4-166ECFD91FAF}"/>
               </a:ext>
             </a:extLst>
           </p:cNvPr>
@@ -10208,7 +10208,7 @@
           <p:cNvPr id="11" name="s9-takeaway-rule">
             <a:extLst xmlns:a="http://schemas.openxmlformats.org/drawingml/2006/main">
               <a:ext uri="{FF2B5EF4-FFF2-40B4-BE49-F238E27FC236}">
-                <a16:creationId xmlns:a16="http://schemas.microsoft.com/office/drawing/2014/main" id="{75A9649C-4CB6-4D8C-BACD-4561AA60C2E6}"/>
+                <a16:creationId xmlns:a16="http://schemas.microsoft.com/office/drawing/2014/main" id="{3C0BF80D-666D-4E68-98C3-544B712A873C}"/>
               </a:ext>
             </a:extLst>
           </p:cNvPr>
@@ -10241,7 +10241,7 @@
           <p:cNvPr id="12" name="s9-takeaway">
             <a:extLst xmlns:a="http://schemas.openxmlformats.org/drawingml/2006/main">
               <a:ext uri="{FF2B5EF4-FFF2-40B4-BE49-F238E27FC236}">
-                <a16:creationId xmlns:a16="http://schemas.microsoft.com/office/drawing/2014/main" id="{A8A2C236-F32D-42C7-9A0B-2848586F82F8}"/>
+                <a16:creationId xmlns:a16="http://schemas.microsoft.com/office/drawing/2014/main" id="{0561C8B2-E17C-40BD-94B9-29F5B8A52BDB}"/>
               </a:ext>
             </a:extLst>
           </p:cNvPr>
@@ -10297,7 +10297,7 @@
     </p:spTree>
     <p:extLst>
       <p:ext uri="{BB962C8B-B14F-4D97-AF65-F5344CB8AC3E}">
-        <p14:creationId xmlns:p14="http://schemas.microsoft.com/office/powerpoint/2010/main" val="2001862482"/>
+        <p14:creationId xmlns:p14="http://schemas.microsoft.com/office/powerpoint/2010/main" val="2030014570"/>
       </p:ext>
     </p:extLst>
   </p:cSld>

</xml_diff>